<commit_message>
Add concise overview variants as second poster slides
</commit_message>
<xml_diff>
--- a/posters/36x48.pptx
+++ b/posters/36x48.pptx
@@ -9,6 +9,7 @@
   </p:notesMasterIdLst>
   <p:sldIdLst>
     <p:sldId id="260" r:id="rId2"/>
+    <p:sldId id="261" r:id="rIdOverview"/>
   </p:sldIdLst>
   <p:sldSz cx="32918400" cy="43891200"/>
   <p:notesSz cx="6858000" cy="9144000"/>
@@ -839,6 +840,133 @@
 </file>
 
 <file path=ppt/notesSlides/notesSlide1.xml><?xml version="1.0" encoding="utf-8"?>
+<p:notes xmlns:a="http://schemas.openxmlformats.org/drawingml/2006/main" xmlns:r="http://schemas.openxmlformats.org/officeDocument/2006/relationships" xmlns:p="http://schemas.openxmlformats.org/presentationml/2006/main">
+  <p:cSld>
+    <p:spTree>
+      <p:nvGrpSpPr>
+        <p:cNvPr id="1" name="">
+          <a:extLst>
+            <a:ext uri="{FF2B5EF4-FFF2-40B4-BE49-F238E27FC236}">
+              <a16:creationId xmlns:a16="http://schemas.microsoft.com/office/drawing/2014/main" id="{9FC4C11B-3281-61F5-AEEC-E5F2B2984717}"/>
+            </a:ext>
+          </a:extLst>
+        </p:cNvPr>
+        <p:cNvGrpSpPr/>
+        <p:nvPr/>
+      </p:nvGrpSpPr>
+      <p:grpSpPr>
+        <a:xfrm>
+          <a:off x="0" y="0"/>
+          <a:ext cx="0" cy="0"/>
+          <a:chOff x="0" y="0"/>
+          <a:chExt cx="0" cy="0"/>
+        </a:xfrm>
+      </p:grpSpPr>
+      <p:sp>
+        <p:nvSpPr>
+          <p:cNvPr id="2" name="Slide Image Placeholder 1">
+            <a:extLst>
+              <a:ext uri="{FF2B5EF4-FFF2-40B4-BE49-F238E27FC236}">
+                <a16:creationId xmlns:a16="http://schemas.microsoft.com/office/drawing/2014/main" id="{C975FC8B-F564-04EA-26FD-6F8FBA438751}"/>
+              </a:ext>
+            </a:extLst>
+          </p:cNvPr>
+          <p:cNvSpPr>
+            <a:spLocks noGrp="1" noRot="1" noChangeAspect="1"/>
+          </p:cNvSpPr>
+          <p:nvPr>
+            <p:ph type="sldImg"/>
+          </p:nvPr>
+        </p:nvSpPr>
+        <p:spPr>
+          <a:xfrm>
+            <a:off x="2271713" y="1143000"/>
+            <a:ext cx="2314575" cy="3086100"/>
+          </a:xfrm>
+        </p:spPr>
+      </p:sp>
+      <p:sp>
+        <p:nvSpPr>
+          <p:cNvPr id="3" name="Notes Placeholder 2">
+            <a:extLst>
+              <a:ext uri="{FF2B5EF4-FFF2-40B4-BE49-F238E27FC236}">
+                <a16:creationId xmlns:a16="http://schemas.microsoft.com/office/drawing/2014/main" id="{78ACB9E4-9956-85CD-1D61-2F397B472319}"/>
+              </a:ext>
+            </a:extLst>
+          </p:cNvPr>
+          <p:cNvSpPr>
+            <a:spLocks noGrp="1"/>
+          </p:cNvSpPr>
+          <p:nvPr>
+            <p:ph type="body" idx="1"/>
+          </p:nvPr>
+        </p:nvSpPr>
+        <p:spPr/>
+        <p:txBody>
+          <a:bodyPr/>
+          <a:lstStyle/>
+          <a:p>
+            <a:endParaRPr lang="en-US"/>
+          </a:p>
+          <a:p>
+            <a:pPr>
+              <a:spcAft>
+                <a:spcPts val="800"/>
+              </a:spcAft>
+              <a:buNone/>
+            </a:pPr>
+            <a:r>
+              <a:rPr lang="en-CA" sz="1200" b="0">
+                <a:latin typeface="Aptos"/>
+              </a:rPr>
+              <a:t>Poster figure inputs: results/manuscript/tables/publication_object_selection.csv; mass_offset_object_sensitivity.csv; results/v3/tables/v3_object_point_ranking.csv and v3_object_uncertainty_ranking.csv; results/v4/tables/v4_minimum_seed_mass.csv. Controlled growth comparison uses src.models.predicted_log_mbh with mean ratio 1, z_seed=30, B_merge=1 and efficiencies 0.1 and 1-sqrt(8/9). Independent dynamical mass: https://arxiv.org/abs/2508.21748.</a:t>
+            </a:r>
+          </a:p>
+        </p:txBody>
+      </p:sp>
+      <p:sp>
+        <p:nvSpPr>
+          <p:cNvPr id="4" name="Slide Number Placeholder 3">
+            <a:extLst>
+              <a:ext uri="{FF2B5EF4-FFF2-40B4-BE49-F238E27FC236}">
+                <a16:creationId xmlns:a16="http://schemas.microsoft.com/office/drawing/2014/main" id="{A8B3E2F2-BDDF-9490-DE7B-11CDCE91017C}"/>
+              </a:ext>
+            </a:extLst>
+          </p:cNvPr>
+          <p:cNvSpPr>
+            <a:spLocks noGrp="1"/>
+          </p:cNvSpPr>
+          <p:nvPr>
+            <p:ph type="sldNum" sz="quarter" idx="5"/>
+          </p:nvPr>
+        </p:nvSpPr>
+        <p:spPr/>
+        <p:txBody>
+          <a:bodyPr/>
+          <a:lstStyle/>
+          <a:p>
+            <a:fld id="{490DA246-DE01-5046-81A0-D7E93C87400D}" type="slidenum">
+              <a:rPr lang="en-US" smtClean="0"/>
+              <a:t>1</a:t>
+            </a:fld>
+            <a:endParaRPr lang="en-US"/>
+          </a:p>
+        </p:txBody>
+      </p:sp>
+    </p:spTree>
+    <p:extLst>
+      <p:ext uri="{BB962C8B-B14F-4D97-AF65-F5344CB8AC3E}">
+        <p14:creationId xmlns:p14="http://schemas.microsoft.com/office/powerpoint/2010/main" val="3600152407"/>
+      </p:ext>
+    </p:extLst>
+  </p:cSld>
+  <p:clrMapOvr>
+    <a:masterClrMapping/>
+  </p:clrMapOvr>
+</p:notes>
+</file>
+
+<file path=ppt/notesSlides/notesSlide2.xml><?xml version="1.0" encoding="utf-8"?>
 <p:notes xmlns:a="http://schemas.openxmlformats.org/drawingml/2006/main" xmlns:r="http://schemas.openxmlformats.org/officeDocument/2006/relationships" xmlns:p="http://schemas.openxmlformats.org/presentationml/2006/main">
   <p:cSld>
     <p:spTree>
@@ -7172,6 +7300,1872 @@
 </p:sld>
 </file>
 
+<file path=ppt/slides/slide2.xml><?xml version="1.0" encoding="utf-8"?>
+<p:sld xmlns:a="http://schemas.openxmlformats.org/drawingml/2006/main" xmlns:r="http://schemas.openxmlformats.org/officeDocument/2006/relationships" xmlns:p="http://schemas.openxmlformats.org/presentationml/2006/main">
+  <p:cSld>
+    <p:spTree>
+      <p:nvGrpSpPr>
+        <p:cNvPr id="1" name="">
+          <a:extLst>
+            <a:ext uri="{FF2B5EF4-FFF2-40B4-BE49-F238E27FC236}">
+              <a16:creationId xmlns:a16="http://schemas.microsoft.com/office/drawing/2014/main" id="{D9B17601-38BA-EEC6-B535-6199F2F271C7}"/>
+            </a:ext>
+          </a:extLst>
+        </p:cNvPr>
+        <p:cNvGrpSpPr/>
+        <p:nvPr/>
+      </p:nvGrpSpPr>
+      <p:grpSpPr>
+        <a:xfrm>
+          <a:off x="0" y="0"/>
+          <a:ext cx="0" cy="0"/>
+          <a:chOff x="0" y="0"/>
+          <a:chExt cx="0" cy="0"/>
+        </a:xfrm>
+      </p:grpSpPr>
+      <p:pic>
+        <p:nvPicPr>
+          <p:cNvPr id="3" name="Picture 2">
+            <a:extLst>
+              <a:ext uri="{FF2B5EF4-FFF2-40B4-BE49-F238E27FC236}">
+                <a16:creationId xmlns:a16="http://schemas.microsoft.com/office/drawing/2014/main" id="{535E2EF0-72FB-E9D0-1E82-C65E26ED9E91}"/>
+              </a:ext>
+            </a:extLst>
+          </p:cNvPr>
+          <p:cNvPicPr>
+            <a:picLocks noChangeAspect="1"/>
+          </p:cNvPicPr>
+          <p:nvPr/>
+        </p:nvPicPr>
+        <p:blipFill>
+          <a:blip r:embed="rId3"/>
+          <a:stretch>
+            <a:fillRect/>
+          </a:stretch>
+        </p:blipFill>
+        <p:spPr>
+          <a:xfrm>
+            <a:off x="1005840" y="26251523"/>
+            <a:ext cx="15087600" cy="10515600"/>
+          </a:xfrm>
+          <a:prstGeom prst="rect">
+            <a:avLst/>
+          </a:prstGeom>
+        </p:spPr>
+      </p:pic>
+      <p:pic>
+        <p:nvPicPr>
+          <p:cNvPr id="14" name="Minimum seed mass versus accretion onset" descr="Manuscript minimum seed masses under fixed growth caps for UNCOVER-20466, COSMOS3D-13852, RUBIES-EGS-55604, and GN-z11.">
+            <a:extLst>
+              <a:ext uri="{FF2B5EF4-FFF2-40B4-BE49-F238E27FC236}">
+                <a16:creationId xmlns:a16="http://schemas.microsoft.com/office/drawing/2014/main" id="{C3CA3027-10C5-D39A-05B0-82DB2540F9D3}"/>
+              </a:ext>
+            </a:extLst>
+          </p:cNvPr>
+          <p:cNvPicPr>
+            <a:picLocks noChangeAspect="1"/>
+          </p:cNvPicPr>
+          <p:nvPr/>
+        </p:nvPicPr>
+        <p:blipFill>
+          <a:blip r:embed="rId4"/>
+          <a:stretch>
+            <a:fillRect/>
+          </a:stretch>
+        </p:blipFill>
+        <p:spPr>
+          <a:xfrm>
+            <a:off x="16962120" y="22287711"/>
+            <a:ext cx="14630400" cy="9875520"/>
+          </a:xfrm>
+          <a:prstGeom prst="rect">
+            <a:avLst/>
+          </a:prstGeom>
+        </p:spPr>
+      </p:pic>
+      <p:sp>
+        <p:nvSpPr>
+          <p:cNvPr id="32" name="Title 18">
+            <a:extLst>
+              <a:ext uri="{FF2B5EF4-FFF2-40B4-BE49-F238E27FC236}">
+                <a16:creationId xmlns:a16="http://schemas.microsoft.com/office/drawing/2014/main" id="{F8D50A2A-9B61-AD34-B9C2-8944BB27426C}"/>
+              </a:ext>
+            </a:extLst>
+          </p:cNvPr>
+          <p:cNvSpPr>
+            <a:spLocks noGrp="1"/>
+          </p:cNvSpPr>
+          <p:nvPr>
+            <p:ph type="title" idx="4294967295"/>
+          </p:nvPr>
+        </p:nvSpPr>
+        <p:spPr>
+          <a:xfrm>
+            <a:off x="-384048" y="-168958"/>
+            <a:ext cx="33686496" cy="4842334"/>
+          </a:xfrm>
+          <a:solidFill>
+            <a:srgbClr val="002A5C"/>
+          </a:solidFill>
+          <a:ln>
+            <a:solidFill>
+              <a:srgbClr val="09306B"/>
+            </a:solidFill>
+          </a:ln>
+        </p:spPr>
+        <p:txBody>
+          <a:bodyPr lIns="7680960" tIns="457200" rIns="8869680">
+            <a:normAutofit/>
+          </a:bodyPr>
+          <a:lstStyle/>
+          <a:p>
+            <a:pPr algn="ctr"/>
+            <a:br>
+              <a:rPr lang="en-US" sz="4200" b="0" dirty="0">
+                <a:solidFill>
+                  <a:schemeClr val="bg1"/>
+                </a:solidFill>
+                <a:latin typeface="Arial" panose="020B0604020202020204" pitchFamily="34" charset="0"/>
+                <a:cs typeface="Arial" panose="020B0604020202020204" pitchFamily="34" charset="0"/>
+              </a:rPr>
+            </a:br>
+            <a:r>
+              <a:rPr lang="en-US" sz="6800" b="1" dirty="0">
+                <a:solidFill>
+                  <a:schemeClr val="bg1"/>
+                </a:solidFill>
+                <a:latin typeface="Arial" panose="020B0604020202020204" pitchFamily="34" charset="0"/>
+                <a:cs typeface="Arial" panose="020B0604020202020204" pitchFamily="34" charset="0"/>
+              </a:rPr>
+              <a:t>Early Black-Hole Growth
+Constraints from JWST</a:t>
+            </a:r>
+            <a:br>
+              <a:rPr lang="en-US" sz="6800" b="0" dirty="0">
+                <a:solidFill>
+                  <a:schemeClr val="bg1"/>
+                </a:solidFill>
+                <a:latin typeface="Arial" panose="020B0604020202020204" pitchFamily="34" charset="0"/>
+                <a:cs typeface="Arial" panose="020B0604020202020204" pitchFamily="34" charset="0"/>
+              </a:rPr>
+            </a:br>
+            <a:r>
+              <a:rPr lang="en-US" sz="6800" b="0" dirty="0">
+                <a:solidFill>
+                  <a:schemeClr val="bg1"/>
+                </a:solidFill>
+                <a:latin typeface="Arial" panose="020B0604020202020204" pitchFamily="34" charset="0"/>
+                <a:cs typeface="Arial" panose="020B0604020202020204" pitchFamily="34" charset="0"/>
+              </a:rPr>
+              <a:t>Nicole Jiang; University of Toronto</a:t>
+            </a:r>
+            <a:br>
+              <a:rPr lang="en-US" sz="4200" b="0" dirty="0">
+                <a:solidFill>
+                  <a:schemeClr val="bg1"/>
+                </a:solidFill>
+                <a:latin typeface="Arial" panose="020B0604020202020204" pitchFamily="34" charset="0"/>
+                <a:cs typeface="Arial" panose="020B0604020202020204" pitchFamily="34" charset="0"/>
+              </a:rPr>
+            </a:br>
+            <a:endParaRPr lang="en-US" sz="6800" b="0" dirty="0">
+              <a:solidFill>
+                <a:schemeClr val="bg1"/>
+              </a:solidFill>
+              <a:latin typeface="Arial" panose="020B0604020202020204" pitchFamily="34" charset="0"/>
+              <a:cs typeface="Arial" panose="020B0604020202020204" pitchFamily="34" charset="0"/>
+            </a:endParaRPr>
+          </a:p>
+        </p:txBody>
+      </p:sp>
+      <p:pic>
+        <p:nvPicPr>
+          <p:cNvPr id="33" name="Picture 32" descr="University of Toronto - Wikipedia">
+            <a:extLst>
+              <a:ext uri="{FF2B5EF4-FFF2-40B4-BE49-F238E27FC236}">
+                <a16:creationId xmlns:a16="http://schemas.microsoft.com/office/drawing/2014/main" id="{42BD33B9-86B6-8B04-8AA1-E72E85543563}"/>
+              </a:ext>
+            </a:extLst>
+          </p:cNvPr>
+          <p:cNvPicPr>
+            <a:picLocks noChangeAspect="1"/>
+          </p:cNvPicPr>
+          <p:nvPr/>
+        </p:nvPicPr>
+        <p:blipFill>
+          <a:blip r:embed="rId5"/>
+          <a:stretch>
+            <a:fillRect/>
+          </a:stretch>
+        </p:blipFill>
+        <p:spPr>
+          <a:xfrm>
+            <a:off x="914400" y="774808"/>
+            <a:ext cx="2377440" cy="2377440"/>
+          </a:xfrm>
+          <a:prstGeom prst="rect">
+            <a:avLst/>
+          </a:prstGeom>
+        </p:spPr>
+      </p:pic>
+      <p:pic>
+        <p:nvPicPr>
+          <p:cNvPr id="36" name="Picture 35" descr="University of Toronto profile | Powered by Inpart">
+            <a:extLst>
+              <a:ext uri="{FF2B5EF4-FFF2-40B4-BE49-F238E27FC236}">
+                <a16:creationId xmlns:a16="http://schemas.microsoft.com/office/drawing/2014/main" id="{8C2E503F-9CF2-EBE6-29B0-458691A7DFB1}"/>
+              </a:ext>
+            </a:extLst>
+          </p:cNvPr>
+          <p:cNvPicPr>
+            <a:picLocks noChangeAspect="1"/>
+          </p:cNvPicPr>
+          <p:nvPr/>
+        </p:nvPicPr>
+        <p:blipFill>
+          <a:blip r:embed="rId6"/>
+          <a:srcRect l="23902" t="38725" b="33824"/>
+          <a:stretch>
+            <a:fillRect/>
+          </a:stretch>
+        </p:blipFill>
+        <p:spPr>
+          <a:xfrm>
+            <a:off x="2961848" y="1118870"/>
+            <a:ext cx="4937760" cy="1781207"/>
+          </a:xfrm>
+          <a:prstGeom prst="rect">
+            <a:avLst/>
+          </a:prstGeom>
+        </p:spPr>
+      </p:pic>
+      <p:pic>
+        <p:nvPicPr>
+          <p:cNvPr id="37" name="Picture 36">
+            <a:extLst>
+              <a:ext uri="{FF2B5EF4-FFF2-40B4-BE49-F238E27FC236}">
+                <a16:creationId xmlns:a16="http://schemas.microsoft.com/office/drawing/2014/main" id="{2C65ED58-816C-A2B5-F6CB-4326B0858DDD}"/>
+              </a:ext>
+            </a:extLst>
+          </p:cNvPr>
+          <p:cNvPicPr>
+            <a:picLocks noChangeAspect="1"/>
+          </p:cNvPicPr>
+          <p:nvPr/>
+        </p:nvPicPr>
+        <p:blipFill>
+          <a:blip r:embed="rId7"/>
+          <a:stretch>
+            <a:fillRect/>
+          </a:stretch>
+        </p:blipFill>
+        <p:spPr>
+          <a:xfrm>
+            <a:off x="29443680" y="502920"/>
+            <a:ext cx="2743200" cy="2743200"/>
+          </a:xfrm>
+          <a:prstGeom prst="rect">
+            <a:avLst/>
+          </a:prstGeom>
+        </p:spPr>
+      </p:pic>
+      <p:sp>
+        <p:nvSpPr>
+          <p:cNvPr id="69" name="Title 18">
+            <a:extLst>
+              <a:ext uri="{FF2B5EF4-FFF2-40B4-BE49-F238E27FC236}">
+                <a16:creationId xmlns:a16="http://schemas.microsoft.com/office/drawing/2014/main" id="{D8B6836B-DAF1-F68F-D717-73D3A454BC2E}"/>
+              </a:ext>
+            </a:extLst>
+          </p:cNvPr>
+          <p:cNvSpPr txBox="1">
+            <a:spLocks/>
+          </p:cNvSpPr>
+          <p:nvPr/>
+        </p:nvSpPr>
+        <p:spPr>
+          <a:xfrm>
+            <a:off x="914400" y="5362478"/>
+            <a:ext cx="15087600" cy="960120"/>
+          </a:xfrm>
+          <a:prstGeom prst="rect">
+            <a:avLst/>
+          </a:prstGeom>
+          <a:solidFill>
+            <a:srgbClr val="002A5C"/>
+          </a:solidFill>
+          <a:ln>
+            <a:solidFill>
+              <a:srgbClr val="09306B"/>
+            </a:solidFill>
+          </a:ln>
+        </p:spPr>
+        <p:txBody>
+          <a:bodyPr vert="horz" lIns="78373" tIns="39187" rIns="78373" bIns="39187" rtlCol="0" anchor="ctr" anchorCtr="1">
+            <a:normAutofit/>
+          </a:bodyPr>
+          <a:lstStyle>
+            <a:lvl1pPr algn="l" defTabSz="4389120" rtl="0" eaLnBrk="1" latinLnBrk="0" hangingPunct="1">
+              <a:lnSpc>
+                <a:spcPct val="90000"/>
+              </a:lnSpc>
+              <a:spcBef>
+                <a:spcPct val="0"/>
+              </a:spcBef>
+              <a:buNone/>
+              <a:defRPr sz="6200" b="1" kern="1200">
+                <a:solidFill>
+                  <a:schemeClr val="bg1"/>
+                </a:solidFill>
+                <a:latin typeface="Arial"/>
+                <a:ea typeface="+mj-ea"/>
+                <a:cs typeface="Arial"/>
+              </a:defRPr>
+            </a:lvl1pPr>
+          </a:lstStyle>
+          <a:p>
+            <a:pPr algn="ctr"/>
+            <a:r>
+              <a:rPr lang="en-US" sz="5000" dirty="0"/>
+              <a:t>Introduction</a:t>
+            </a:r>
+          </a:p>
+        </p:txBody>
+      </p:sp>
+      <p:sp>
+        <p:nvSpPr>
+          <p:cNvPr id="70" name="TextBox 69">
+            <a:extLst>
+              <a:ext uri="{FF2B5EF4-FFF2-40B4-BE49-F238E27FC236}">
+                <a16:creationId xmlns:a16="http://schemas.microsoft.com/office/drawing/2014/main" id="{7842EAEC-0FF9-516A-6712-19E0D19D0354}"/>
+              </a:ext>
+            </a:extLst>
+          </p:cNvPr>
+          <p:cNvSpPr txBox="1"/>
+          <p:nvPr/>
+        </p:nvSpPr>
+        <p:spPr>
+          <a:xfrm>
+            <a:off x="1371600" y="6642638"/>
+            <a:ext cx="14173200" cy="2631490"/>
+          </a:xfrm>
+          <a:prstGeom prst="rect">
+            <a:avLst/>
+          </a:prstGeom>
+          <a:noFill/>
+        </p:spPr>
+        <p:txBody>
+          <a:bodyPr wrap="square" lIns="91440" tIns="45720" rIns="91440" bIns="45720" rtlCol="0" anchor="t">
+            <a:spAutoFit/>
+          </a:bodyPr>
+          <a:lstStyle/>
+          <a:p>
+            <a:pPr>
+              <a:buNone/>
+            </a:pPr>
+            <a:r>
+              <a:rPr lang="en-CA" sz="3300" b="1">
+                <a:latin typeface="Aptos"/>
+              </a:rPr>
+              <a:t>How did early black holes grow so big, so fast? </a:t>
+            </a:r>
+            <a:r>
+              <a:rPr lang="en-CA" sz="3300" b="0">
+                <a:latin typeface="Aptos"/>
+              </a:rPr>
+              <a:t>The James Webb Space Telescope (JWST) has revealed massive black holes with little time to grow. I compiled published mass estimates and calculated the average accretion needed to reach each mass under different seed masses (initial masses), start times, and radiative efficiencies.</a:t>
+            </a:r>
+          </a:p>
+        </p:txBody>
+      </p:sp>
+      <p:sp>
+        <p:nvSpPr>
+          <p:cNvPr id="71" name="Rectangle 70">
+            <a:extLst>
+              <a:ext uri="{FF2B5EF4-FFF2-40B4-BE49-F238E27FC236}">
+                <a16:creationId xmlns:a16="http://schemas.microsoft.com/office/drawing/2014/main" id="{ABB03D82-A209-1440-3180-9DD4419EFCBF}"/>
+              </a:ext>
+            </a:extLst>
+          </p:cNvPr>
+          <p:cNvSpPr/>
+          <p:nvPr/>
+        </p:nvSpPr>
+        <p:spPr>
+          <a:xfrm>
+            <a:off x="914400" y="5362479"/>
+            <a:ext cx="15087600" cy="4322460"/>
+          </a:xfrm>
+          <a:prstGeom prst="rect">
+            <a:avLst/>
+          </a:prstGeom>
+          <a:noFill/>
+          <a:ln>
+            <a:solidFill>
+              <a:srgbClr val="002A5C"/>
+            </a:solidFill>
+          </a:ln>
+        </p:spPr>
+        <p:style>
+          <a:lnRef idx="2">
+            <a:schemeClr val="accent1">
+              <a:shade val="15000"/>
+            </a:schemeClr>
+          </a:lnRef>
+          <a:fillRef idx="1">
+            <a:schemeClr val="accent1"/>
+          </a:fillRef>
+          <a:effectRef idx="0">
+            <a:schemeClr val="accent1"/>
+          </a:effectRef>
+          <a:fontRef idx="minor">
+            <a:schemeClr val="lt1"/>
+          </a:fontRef>
+        </p:style>
+        <p:txBody>
+          <a:bodyPr rtlCol="0" anchor="ctr"/>
+          <a:lstStyle/>
+          <a:p>
+            <a:pPr algn="ctr"/>
+            <a:endParaRPr lang="en-US"/>
+          </a:p>
+        </p:txBody>
+      </p:sp>
+      <p:sp>
+        <p:nvSpPr>
+          <p:cNvPr id="72" name="Title 18">
+            <a:extLst>
+              <a:ext uri="{FF2B5EF4-FFF2-40B4-BE49-F238E27FC236}">
+                <a16:creationId xmlns:a16="http://schemas.microsoft.com/office/drawing/2014/main" id="{6D9DC137-E8CF-8FC7-F26F-A7759AD2C396}"/>
+              </a:ext>
+            </a:extLst>
+          </p:cNvPr>
+          <p:cNvSpPr txBox="1">
+            <a:spLocks/>
+          </p:cNvSpPr>
+          <p:nvPr/>
+        </p:nvSpPr>
+        <p:spPr>
+          <a:xfrm>
+            <a:off x="914400" y="10184457"/>
+            <a:ext cx="15087600" cy="960120"/>
+          </a:xfrm>
+          <a:prstGeom prst="rect">
+            <a:avLst/>
+          </a:prstGeom>
+          <a:solidFill>
+            <a:srgbClr val="002A5C"/>
+          </a:solidFill>
+          <a:ln>
+            <a:solidFill>
+              <a:srgbClr val="09306B"/>
+            </a:solidFill>
+          </a:ln>
+        </p:spPr>
+        <p:txBody>
+          <a:bodyPr vert="horz" lIns="78373" tIns="39187" rIns="78373" bIns="39187" rtlCol="0" anchor="ctr" anchorCtr="1">
+            <a:normAutofit/>
+          </a:bodyPr>
+          <a:lstStyle>
+            <a:lvl1pPr algn="l" defTabSz="4389120" rtl="0" eaLnBrk="1" latinLnBrk="0" hangingPunct="1">
+              <a:lnSpc>
+                <a:spcPct val="90000"/>
+              </a:lnSpc>
+              <a:spcBef>
+                <a:spcPct val="0"/>
+              </a:spcBef>
+              <a:buNone/>
+              <a:defRPr sz="6200" b="1" kern="1200">
+                <a:solidFill>
+                  <a:schemeClr val="bg1"/>
+                </a:solidFill>
+                <a:latin typeface="Arial"/>
+                <a:ea typeface="+mj-ea"/>
+                <a:cs typeface="Arial"/>
+              </a:defRPr>
+            </a:lvl1pPr>
+          </a:lstStyle>
+          <a:p>
+            <a:pPr algn="ctr"/>
+            <a:r>
+              <a:rPr lang="en-US" sz="5000" dirty="0"/>
+              <a:t>Methods</a:t>
+            </a:r>
+          </a:p>
+        </p:txBody>
+      </p:sp>
+      <p:sp xmlns:a14="http://schemas.microsoft.com/office/drawing/2010/main">
+        <p:nvSpPr>
+          <p:cNvPr id="73" name="TextBox 72">
+            <a:extLst>
+              <a:ext uri="{FF2B5EF4-FFF2-40B4-BE49-F238E27FC236}">
+                <a16:creationId xmlns:a16="http://schemas.microsoft.com/office/drawing/2014/main" id="{88C51BF9-B81A-ECF4-F01D-305CA1CE9DD1}"/>
+              </a:ext>
+            </a:extLst>
+          </p:cNvPr>
+          <p:cNvSpPr txBox="1"/>
+          <p:nvPr/>
+        </p:nvSpPr>
+        <p:spPr>
+          <a:xfrm>
+            <a:off x="1463040" y="11559248"/>
+            <a:ext cx="14173200" cy="12808443"/>
+          </a:xfrm>
+          <a:prstGeom prst="rect">
+            <a:avLst/>
+          </a:prstGeom>
+          <a:noFill/>
+        </p:spPr>
+        <p:txBody>
+          <a:bodyPr wrap="square" rtlCol="0">
+            <a:spAutoFit/>
+          </a:bodyPr>
+          <a:lstStyle/>
+          <a:p>
+            <a:pPr>
+              <a:lnSpc>
+                <a:spcPct val="120000"/>
+              </a:lnSpc>
+              <a:spcAft>
+                <a:spcPts val="1600"/>
+              </a:spcAft>
+              <a:buNone/>
+            </a:pPr>
+            <a:r>
+              <a:rPr sz="3300" b="1" lang="en-CA">
+                <a:latin typeface="Aptos"/>
+              </a:rPr>
+              <a:t>Catalogue: </a:t>
+            </a:r>
+            <a:r>
+              <a:rPr sz="3300" b="0" lang="en-CA">
+                <a:latin typeface="Aptos"/>
+              </a:rPr>
+              <a:t>Compiled 350 measurements at z ≥ 4. Used 1 mass per object: 220 primary objects with broad Balmer-line masses and 234 expanded objects, including tentative candidates and GN-z11 [1,2].</a:t>
+            </a:r>
+          </a:p>
+          <a:p>
+            <a:pPr>
+              <a:lnSpc>
+                <a:spcPct val="120000"/>
+              </a:lnSpc>
+              <a:spcAft>
+                <a:spcPts val="1600"/>
+              </a:spcAft>
+              <a:buNone/>
+            </a:pPr>
+            <a:r>
+              <a:rPr sz="3300" b="1" lang="en-CA">
+                <a:latin typeface="Aptos"/>
+              </a:rPr>
+              <a:t>Reference model: </a:t>
+            </a:r>
+            <a:r>
+              <a:rPr sz="3300" b="0" lang="en-CA">
+                <a:latin typeface="Aptos"/>
+              </a:rPr>
+              <a:t>Assumed 100 M⊙ seeds at z = 30, radiative efficiency ε = 0.1 and no mergers [3].</a:t>
+            </a:r>
+          </a:p>
+          <a:p>
+            <a:pPr>
+              <a:lnSpc>
+                <a:spcPct val="120000"/>
+              </a:lnSpc>
+              <a:spcAft>
+                <a:spcPts val="1600"/>
+              </a:spcAft>
+              <a:buNone/>
+            </a:pPr>
+            <a:r>
+              <a:rPr sz="3300" b="1" lang="en-CA">
+                <a:latin typeface="Aptos"/>
+              </a:rPr>
+              <a:t>Growth test: </a:t>
+            </a:r>
+            <a:r>
+              <a:rPr sz="3300" b="0" lang="en-CA">
+                <a:latin typeface="Aptos"/>
+              </a:rPr>
+              <a:t>Ranked objects by f̄</a:t>
+            </a:r>
+            <a:r>
+              <a:rPr sz="2200" b="0" lang="en-CA" baseline="-25000">
+                <a:latin typeface="Aptos"/>
+              </a:rPr>
+              <a:t>Edd,req</a:t>
+            </a:r>
+            <a:r>
+              <a:rPr sz="3300" b="0" lang="en-CA">
+                <a:latin typeface="Aptos"/>
+              </a:rPr>
+              <a:t>, the required lifetime-average Eddington ratio, including inactive periods. Compared it with an assumed maximum of 1.</a:t>
+            </a:r>
+          </a:p>
+          <a:p>
+            <a:pPr>
+              <a:lnSpc>
+                <a:spcPct val="120000"/>
+              </a:lnSpc>
+              <a:spcAft>
+                <a:spcPts val="1600"/>
+              </a:spcAft>
+              <a:buNone/>
+            </a:pPr>
+            <a:r>
+              <a:rPr sz="3300" b="1" lang="en-CA">
+                <a:latin typeface="Aptos"/>
+              </a:rPr>
+              <a:t>Eddington ratio: </a:t>
+            </a:r>
+            <a:r>
+              <a:rPr sz="3300" b="0" lang="en-CA">
+                <a:latin typeface="Aptos"/>
+              </a:rPr>
+              <a:t>f</a:t>
+            </a:r>
+            <a:r>
+              <a:rPr sz="2200" b="0" lang="en-CA" baseline="-25000">
+                <a:latin typeface="Aptos"/>
+              </a:rPr>
+              <a:t>Edd</a:t>
+            </a:r>
+            <a:r>
+              <a:rPr sz="3300" b="0" lang="en-CA">
+                <a:latin typeface="Aptos"/>
+              </a:rPr>
+              <a:t> = luminosity/Eddington luminosity, where radiation force balances gravity. Averages above 1 require periods of super-Eddington accretion.</a:t>
+            </a:r>
+          </a:p>
+          <a:p>
+            <a:pPr>
+              <a:lnSpc>
+                <a:spcPct val="120000"/>
+              </a:lnSpc>
+              <a:spcAft>
+                <a:spcPts val="1600"/>
+              </a:spcAft>
+              <a:buNone/>
+            </a:pPr>
+            <a:r>
+              <a:rPr sz="3300" b="1" lang="en-CA">
+                <a:latin typeface="Aptos"/>
+              </a:rPr>
+              <a:t>Uncertainty: </a:t>
+            </a:r>
+            <a:r>
+              <a:rPr sz="3300" b="0" lang="en-CA">
+                <a:latin typeface="Aptos"/>
+              </a:rPr>
+              <a:t>Sampled reported mass errors 10,000 times per object. Used central estimates for objects without errors. Varied mass scale, seed mass, start time and efficiency separately. Reported errors may omit calibration scatter.</a:t>
+            </a:r>
+          </a:p>
+          <a:p>
+            <a:pPr>
+              <a:lnSpc>
+                <a:spcPct val="120000"/>
+              </a:lnSpc>
+              <a:spcAft>
+                <a:spcPts val="1600"/>
+              </a:spcAft>
+              <a:buNone/>
+            </a:pPr>
+            <a:r>
+              <a:rPr sz="3300" b="1" lang="en-CA">
+                <a:latin typeface="Aptos"/>
+              </a:rPr>
+              <a:t>Earlier growth: </a:t>
+            </a:r>
+            <a:r>
+              <a:rPr sz="3300" b="0" lang="en-CA">
+                <a:latin typeface="Aptos"/>
+              </a:rPr>
+              <a:t>Found minimum seed masses for the 4 targets across start redshifts 20–3,400. Included radiation in cosmic ages. Assumed gas was available for accretion.</a:t>
+            </a:r>
+          </a:p>
+        </p:txBody>
+      </p:sp>
+      <p:sp>
+        <p:nvSpPr>
+          <p:cNvPr id="74" name="Rectangle 73">
+            <a:extLst>
+              <a:ext uri="{FF2B5EF4-FFF2-40B4-BE49-F238E27FC236}">
+                <a16:creationId xmlns:a16="http://schemas.microsoft.com/office/drawing/2014/main" id="{F5F0E6D1-7308-2846-C555-5A8981E84E43}"/>
+              </a:ext>
+            </a:extLst>
+          </p:cNvPr>
+          <p:cNvSpPr/>
+          <p:nvPr/>
+        </p:nvSpPr>
+        <p:spPr>
+          <a:xfrm>
+            <a:off x="914400" y="10184458"/>
+            <a:ext cx="15087600" cy="14810682"/>
+          </a:xfrm>
+          <a:prstGeom prst="rect">
+            <a:avLst/>
+          </a:prstGeom>
+          <a:noFill/>
+          <a:ln>
+            <a:solidFill>
+              <a:srgbClr val="002A5C"/>
+            </a:solidFill>
+          </a:ln>
+        </p:spPr>
+        <p:style>
+          <a:lnRef idx="2">
+            <a:schemeClr val="accent1">
+              <a:shade val="15000"/>
+            </a:schemeClr>
+          </a:lnRef>
+          <a:fillRef idx="1">
+            <a:schemeClr val="accent1"/>
+          </a:fillRef>
+          <a:effectRef idx="0">
+            <a:schemeClr val="accent1"/>
+          </a:effectRef>
+          <a:fontRef idx="minor">
+            <a:schemeClr val="lt1"/>
+          </a:fontRef>
+        </p:style>
+        <p:txBody>
+          <a:bodyPr rtlCol="0" anchor="ctr"/>
+          <a:lstStyle/>
+          <a:p>
+            <a:pPr algn="ctr"/>
+            <a:endParaRPr lang="en-US"/>
+          </a:p>
+        </p:txBody>
+      </p:sp>
+      <p:sp>
+        <p:nvSpPr>
+          <p:cNvPr id="78" name="Title 18">
+            <a:extLst>
+              <a:ext uri="{FF2B5EF4-FFF2-40B4-BE49-F238E27FC236}">
+                <a16:creationId xmlns:a16="http://schemas.microsoft.com/office/drawing/2014/main" id="{D50205E6-BF86-6F08-991C-43F597FDF8DD}"/>
+              </a:ext>
+            </a:extLst>
+          </p:cNvPr>
+          <p:cNvSpPr txBox="1">
+            <a:spLocks/>
+          </p:cNvSpPr>
+          <p:nvPr/>
+        </p:nvSpPr>
+        <p:spPr>
+          <a:xfrm>
+            <a:off x="16550640" y="35503691"/>
+            <a:ext cx="15453360" cy="960120"/>
+          </a:xfrm>
+          <a:prstGeom prst="rect">
+            <a:avLst/>
+          </a:prstGeom>
+          <a:solidFill>
+            <a:srgbClr val="002A5C"/>
+          </a:solidFill>
+          <a:ln>
+            <a:solidFill>
+              <a:srgbClr val="09306B"/>
+            </a:solidFill>
+          </a:ln>
+        </p:spPr>
+        <p:txBody>
+          <a:bodyPr vert="horz" lIns="78373" tIns="39187" rIns="78373" bIns="39187" rtlCol="0" anchor="ctr" anchorCtr="1">
+            <a:normAutofit/>
+          </a:bodyPr>
+          <a:lstStyle>
+            <a:lvl1pPr algn="l" defTabSz="4389120" rtl="0" eaLnBrk="1" latinLnBrk="0" hangingPunct="1">
+              <a:lnSpc>
+                <a:spcPct val="90000"/>
+              </a:lnSpc>
+              <a:spcBef>
+                <a:spcPct val="0"/>
+              </a:spcBef>
+              <a:buNone/>
+              <a:defRPr sz="6200" b="1" kern="1200">
+                <a:solidFill>
+                  <a:schemeClr val="bg1"/>
+                </a:solidFill>
+                <a:latin typeface="Arial"/>
+                <a:ea typeface="+mj-ea"/>
+                <a:cs typeface="Arial"/>
+              </a:defRPr>
+            </a:lvl1pPr>
+          </a:lstStyle>
+          <a:p>
+            <a:pPr algn="ctr"/>
+            <a:r>
+              <a:rPr lang="en-US" sz="5000"/>
+              <a:t>Conclusions</a:t>
+            </a:r>
+          </a:p>
+        </p:txBody>
+      </p:sp>
+      <p:sp>
+        <p:nvSpPr>
+          <p:cNvPr id="79" name="TextBox 78">
+            <a:extLst>
+              <a:ext uri="{FF2B5EF4-FFF2-40B4-BE49-F238E27FC236}">
+                <a16:creationId xmlns:a16="http://schemas.microsoft.com/office/drawing/2014/main" id="{3DD5B540-2EC8-A5A1-200C-994C1D7C8BFD}"/>
+              </a:ext>
+            </a:extLst>
+          </p:cNvPr>
+          <p:cNvSpPr txBox="1"/>
+          <p:nvPr/>
+        </p:nvSpPr>
+        <p:spPr>
+          <a:xfrm>
+            <a:off x="16916402" y="36944923"/>
+            <a:ext cx="14996160" cy="6583680"/>
+          </a:xfrm>
+          <a:prstGeom prst="rect">
+            <a:avLst/>
+          </a:prstGeom>
+          <a:noFill/>
+        </p:spPr>
+        <p:txBody>
+          <a:bodyPr wrap="square" lIns="91440" tIns="45720" rIns="91440" bIns="45720" rtlCol="0" anchor="t">
+            <a:spAutoFit/>
+          </a:bodyPr>
+          <a:lstStyle/>
+          <a:p>
+            <a:pPr marL="285750" indent="-228600">
+              <a:spcAft>
+                <a:spcPts val="800"/>
+              </a:spcAft>
+              <a:buChar char="•"/>
+            </a:pPr>
+            <a:r>
+              <a:rPr lang="en-CA" sz="3300" b="1">
+                <a:latin typeface="Aptos"/>
+              </a:rPr>
+              <a:t>Seed masses: </a:t>
+            </a:r>
+            <a:r>
+              <a:rPr lang="en-CA" sz="3300" b="0">
+                <a:latin typeface="Aptos"/>
+              </a:rPr>
+              <a:t>Most adopted masses are compatible with growth from small stellar seeds under the reference assumptions.</a:t>
+            </a:r>
+          </a:p>
+          <a:p>
+            <a:pPr marL="285750" indent="-228600">
+              <a:spcAft>
+                <a:spcPts val="800"/>
+              </a:spcAft>
+              <a:buChar char="•"/>
+            </a:pPr>
+            <a:r>
+              <a:rPr lang="en-CA" sz="3300" b="1">
+                <a:latin typeface="Aptos"/>
+              </a:rPr>
+              <a:t>Accretion physics: </a:t>
+            </a:r>
+            <a:r>
+              <a:rPr lang="en-CA" sz="3300" b="0">
+                <a:latin typeface="Aptos"/>
+              </a:rPr>
+              <a:t>Lower radiative efficiency allows faster mass growth at the same Eddington ratio. Seed-mass requirements therefore depend on how efficiently accretion produces radiation.</a:t>
+            </a:r>
+          </a:p>
+          <a:p>
+            <a:pPr marL="285750" indent="-228600">
+              <a:spcAft>
+                <a:spcPts val="800"/>
+              </a:spcAft>
+              <a:buChar char="•"/>
+            </a:pPr>
+            <a:r>
+              <a:rPr lang="en-CA" sz="3300" b="1">
+                <a:latin typeface="Aptos"/>
+              </a:rPr>
+              <a:t>Earlier growth: </a:t>
+            </a:r>
+            <a:r>
+              <a:rPr lang="en-CA" sz="3300" b="0">
+                <a:latin typeface="Aptos"/>
+              </a:rPr>
+              <a:t>Even the earliest tested start leaves 100 M⊙ seeds insufficient for the 4 targets at ε = 0.1 and average ratio ≤ 1. Larger seeds or super-Eddington episodes remain possible.</a:t>
+            </a:r>
+          </a:p>
+          <a:p>
+            <a:pPr marL="285750" indent="-228600">
+              <a:spcAft>
+                <a:spcPts val="800"/>
+              </a:spcAft>
+              <a:buChar char="•"/>
+            </a:pPr>
+            <a:r>
+              <a:rPr lang="en-CA" sz="3300" b="1">
+                <a:latin typeface="Aptos"/>
+              </a:rPr>
+              <a:t>Further observations: </a:t>
+            </a:r>
+            <a:r>
+              <a:rPr lang="en-CA" sz="3300" b="0">
+                <a:latin typeface="Aptos"/>
+              </a:rPr>
+              <a:t>Independent mass measurements could change which objects require averages above 1. Counts from different surveys cannot establish how common these black holes are.</a:t>
+            </a:r>
+          </a:p>
+        </p:txBody>
+      </p:sp>
+      <p:sp>
+        <p:nvSpPr>
+          <p:cNvPr id="80" name="Rectangle 79">
+            <a:extLst>
+              <a:ext uri="{FF2B5EF4-FFF2-40B4-BE49-F238E27FC236}">
+                <a16:creationId xmlns:a16="http://schemas.microsoft.com/office/drawing/2014/main" id="{BBD5C8AB-335C-2E4D-00F6-4B0BF74BB013}"/>
+              </a:ext>
+            </a:extLst>
+          </p:cNvPr>
+          <p:cNvSpPr/>
+          <p:nvPr/>
+        </p:nvSpPr>
+        <p:spPr>
+          <a:xfrm>
+            <a:off x="16550640" y="35503691"/>
+            <a:ext cx="15453360" cy="7930309"/>
+          </a:xfrm>
+          <a:prstGeom prst="rect">
+            <a:avLst/>
+          </a:prstGeom>
+          <a:noFill/>
+          <a:ln>
+            <a:solidFill>
+              <a:srgbClr val="002A5C"/>
+            </a:solidFill>
+          </a:ln>
+        </p:spPr>
+        <p:style>
+          <a:lnRef idx="2">
+            <a:schemeClr val="accent1">
+              <a:shade val="15000"/>
+            </a:schemeClr>
+          </a:lnRef>
+          <a:fillRef idx="1">
+            <a:schemeClr val="accent1"/>
+          </a:fillRef>
+          <a:effectRef idx="0">
+            <a:schemeClr val="accent1"/>
+          </a:effectRef>
+          <a:fontRef idx="minor">
+            <a:schemeClr val="lt1"/>
+          </a:fontRef>
+        </p:style>
+        <p:txBody>
+          <a:bodyPr rtlCol="0" anchor="ctr"/>
+          <a:lstStyle/>
+          <a:p>
+            <a:pPr algn="ctr"/>
+            <a:endParaRPr lang="en-US"/>
+          </a:p>
+        </p:txBody>
+      </p:sp>
+      <p:sp>
+        <p:nvSpPr>
+          <p:cNvPr id="81" name="Title 18">
+            <a:extLst>
+              <a:ext uri="{FF2B5EF4-FFF2-40B4-BE49-F238E27FC236}">
+                <a16:creationId xmlns:a16="http://schemas.microsoft.com/office/drawing/2014/main" id="{8E773A53-2851-D565-B46F-D419BA57021E}"/>
+              </a:ext>
+            </a:extLst>
+          </p:cNvPr>
+          <p:cNvSpPr txBox="1">
+            <a:spLocks/>
+          </p:cNvSpPr>
+          <p:nvPr/>
+        </p:nvSpPr>
+        <p:spPr>
+          <a:xfrm>
+            <a:off x="914400" y="38218254"/>
+            <a:ext cx="15087600" cy="960120"/>
+          </a:xfrm>
+          <a:prstGeom prst="rect">
+            <a:avLst/>
+          </a:prstGeom>
+          <a:solidFill>
+            <a:srgbClr val="002A5C"/>
+          </a:solidFill>
+          <a:ln>
+            <a:solidFill>
+              <a:srgbClr val="09306B"/>
+            </a:solidFill>
+          </a:ln>
+        </p:spPr>
+        <p:txBody>
+          <a:bodyPr vert="horz" lIns="78373" tIns="39187" rIns="78373" bIns="39187" rtlCol="0" anchor="ctr" anchorCtr="1">
+            <a:normAutofit/>
+          </a:bodyPr>
+          <a:lstStyle>
+            <a:lvl1pPr algn="l" defTabSz="4389120" rtl="0" eaLnBrk="1" latinLnBrk="0" hangingPunct="1">
+              <a:lnSpc>
+                <a:spcPct val="90000"/>
+              </a:lnSpc>
+              <a:spcBef>
+                <a:spcPct val="0"/>
+              </a:spcBef>
+              <a:buNone/>
+              <a:defRPr sz="6200" b="1" kern="1200">
+                <a:solidFill>
+                  <a:schemeClr val="bg1"/>
+                </a:solidFill>
+                <a:latin typeface="Arial"/>
+                <a:ea typeface="+mj-ea"/>
+                <a:cs typeface="Arial"/>
+              </a:defRPr>
+            </a:lvl1pPr>
+          </a:lstStyle>
+          <a:p>
+            <a:pPr algn="ctr"/>
+            <a:r>
+              <a:rPr lang="en-US" sz="5000"/>
+              <a:t>References</a:t>
+            </a:r>
+          </a:p>
+        </p:txBody>
+      </p:sp>
+      <p:sp>
+        <p:nvSpPr>
+          <p:cNvPr id="82" name="TextBox 81">
+            <a:extLst>
+              <a:ext uri="{FF2B5EF4-FFF2-40B4-BE49-F238E27FC236}">
+                <a16:creationId xmlns:a16="http://schemas.microsoft.com/office/drawing/2014/main" id="{82B57F9D-B4AF-1E4D-7FBC-B8680CB4CAB8}"/>
+              </a:ext>
+            </a:extLst>
+          </p:cNvPr>
+          <p:cNvSpPr txBox="1"/>
+          <p:nvPr/>
+        </p:nvSpPr>
+        <p:spPr>
+          <a:xfrm>
+            <a:off x="1371600" y="39363981"/>
+            <a:ext cx="13898880" cy="3395801"/>
+          </a:xfrm>
+          <a:prstGeom prst="rect">
+            <a:avLst/>
+          </a:prstGeom>
+          <a:noFill/>
+        </p:spPr>
+        <p:txBody>
+          <a:bodyPr wrap="square" rtlCol="0">
+            <a:spAutoFit/>
+          </a:bodyPr>
+          <a:lstStyle/>
+          <a:p>
+            <a:pPr>
+              <a:spcBef>
+                <a:spcPts val="600"/>
+              </a:spcBef>
+            </a:pPr>
+            <a:r>
+              <a:rPr lang="en-CA" sz="3300" dirty="0"/>
+              <a:t>[1] Shen (2013), BASI, 41, 61.</a:t>
+            </a:r>
+            <a:endParaRPr lang="en-US" sz="3300" dirty="0"/>
+          </a:p>
+          <a:p>
+            <a:r>
+              <a:rPr lang="en-CA" sz="3300" dirty="0"/>
+              <a:t>[2] </a:t>
+            </a:r>
+            <a:r>
+              <a:rPr lang="en-CA" sz="3300" dirty="0" err="1"/>
+              <a:t>Maiolino</a:t>
+            </a:r>
+            <a:r>
+              <a:rPr lang="en-CA" sz="3300" dirty="0"/>
+              <a:t> et al. (2024), Nature, 627, 59.</a:t>
+            </a:r>
+          </a:p>
+          <a:p>
+            <a:r>
+              <a:rPr lang="en-CA" sz="3300" dirty="0"/>
+              <a:t>[3] Dayal (2024), A&amp;A, 690, A182.</a:t>
+            </a:r>
+            <a:endParaRPr lang="en-US" sz="3300" dirty="0"/>
+          </a:p>
+          <a:p>
+            <a:pPr>
+              <a:spcBef>
+                <a:spcPts val="600"/>
+              </a:spcBef>
+            </a:pPr>
+            <a:r>
+              <a:rPr lang="en-CA" sz="3300" dirty="0"/>
+              <a:t>[4] Bardeen et al. (1972), </a:t>
+            </a:r>
+            <a:r>
+              <a:rPr lang="en-CA" sz="3300" dirty="0" err="1"/>
+              <a:t>ApJ</a:t>
+            </a:r>
+            <a:r>
+              <a:rPr lang="en-CA" sz="3300" dirty="0"/>
+              <a:t>, 178, 347.</a:t>
+            </a:r>
+            <a:endParaRPr lang="en-US" sz="3300" dirty="0"/>
+          </a:p>
+          <a:p>
+            <a:pPr>
+              <a:spcAft>
+                <a:spcPts val="800"/>
+              </a:spcAft>
+              <a:buNone/>
+            </a:pPr>
+            <a:r>
+              <a:rPr lang="en-CA" sz="3300" b="0" dirty="0">
+                <a:latin typeface="Aptos"/>
+              </a:rPr>
+              <a:t>[5] </a:t>
+            </a:r>
+            <a:r>
+              <a:rPr lang="en-CA" sz="3300" b="0" dirty="0" err="1">
+                <a:latin typeface="Aptos"/>
+              </a:rPr>
+              <a:t>Juodzbalis</a:t>
+            </a:r>
+            <a:r>
+              <a:rPr lang="en-CA" sz="3300" b="0" dirty="0">
+                <a:latin typeface="Aptos"/>
+              </a:rPr>
+              <a:t> et al. (2025), arXiv:2508.21748.</a:t>
+            </a:r>
+          </a:p>
+          <a:p>
+            <a:pPr>
+              <a:spcBef>
+                <a:spcPts val="600"/>
+              </a:spcBef>
+            </a:pPr>
+            <a:r>
+              <a:rPr lang="en-CA" sz="3300" dirty="0"/>
+              <a:t>Catalogue sources and code: QR link above.</a:t>
+            </a:r>
+            <a:endParaRPr lang="en-US" sz="3300" dirty="0"/>
+          </a:p>
+        </p:txBody>
+      </p:sp>
+      <p:sp>
+        <p:nvSpPr>
+          <p:cNvPr id="83" name="Rectangle 82">
+            <a:extLst>
+              <a:ext uri="{FF2B5EF4-FFF2-40B4-BE49-F238E27FC236}">
+                <a16:creationId xmlns:a16="http://schemas.microsoft.com/office/drawing/2014/main" id="{7156AF1B-4C0F-9637-8495-BA5941742B85}"/>
+              </a:ext>
+            </a:extLst>
+          </p:cNvPr>
+          <p:cNvSpPr/>
+          <p:nvPr/>
+        </p:nvSpPr>
+        <p:spPr>
+          <a:xfrm>
+            <a:off x="914400" y="38218254"/>
+            <a:ext cx="15087600" cy="5215746"/>
+          </a:xfrm>
+          <a:prstGeom prst="rect">
+            <a:avLst/>
+          </a:prstGeom>
+          <a:noFill/>
+          <a:ln>
+            <a:solidFill>
+              <a:srgbClr val="002A5C"/>
+            </a:solidFill>
+          </a:ln>
+        </p:spPr>
+        <p:style>
+          <a:lnRef idx="2">
+            <a:schemeClr val="accent1">
+              <a:shade val="15000"/>
+            </a:schemeClr>
+          </a:lnRef>
+          <a:fillRef idx="1">
+            <a:schemeClr val="accent1"/>
+          </a:fillRef>
+          <a:effectRef idx="0">
+            <a:schemeClr val="accent1"/>
+          </a:effectRef>
+          <a:fontRef idx="minor">
+            <a:schemeClr val="lt1"/>
+          </a:fontRef>
+        </p:style>
+        <p:txBody>
+          <a:bodyPr rtlCol="0" anchor="ctr"/>
+          <a:lstStyle/>
+          <a:p>
+            <a:pPr algn="ctr"/>
+            <a:endParaRPr lang="en-US"/>
+          </a:p>
+        </p:txBody>
+      </p:sp>
+      <p:pic>
+        <p:nvPicPr>
+          <p:cNvPr id="4" name="Picture 3">
+            <a:extLst>
+              <a:ext uri="{FF2B5EF4-FFF2-40B4-BE49-F238E27FC236}">
+                <a16:creationId xmlns:a16="http://schemas.microsoft.com/office/drawing/2014/main" id="{C4337658-2539-7C1B-497A-E1769149148E}"/>
+              </a:ext>
+            </a:extLst>
+          </p:cNvPr>
+          <p:cNvPicPr>
+            <a:picLocks noChangeAspect="1"/>
+          </p:cNvPicPr>
+          <p:nvPr/>
+        </p:nvPicPr>
+        <p:blipFill>
+          <a:blip r:embed="rId9"/>
+          <a:stretch>
+            <a:fillRect/>
+          </a:stretch>
+        </p:blipFill>
+        <p:spPr>
+          <a:xfrm>
+            <a:off x="16962120" y="12298680"/>
+            <a:ext cx="14630400" cy="7863840"/>
+          </a:xfrm>
+          <a:prstGeom prst="rect">
+            <a:avLst/>
+          </a:prstGeom>
+        </p:spPr>
+      </p:pic>
+      <p:pic>
+        <p:nvPicPr>
+          <p:cNvPr id="5" name="Picture 4" descr="File:JWST spacecraft model 1.png - Wikimedia Commons">
+            <a:extLst>
+              <a:ext uri="{FF2B5EF4-FFF2-40B4-BE49-F238E27FC236}">
+                <a16:creationId xmlns:a16="http://schemas.microsoft.com/office/drawing/2014/main" id="{0BD845B3-DC16-6DC6-BFC8-2D65D247678D}"/>
+              </a:ext>
+            </a:extLst>
+          </p:cNvPr>
+          <p:cNvPicPr>
+            <a:picLocks noChangeAspect="1"/>
+          </p:cNvPicPr>
+          <p:nvPr/>
+        </p:nvPicPr>
+        <p:blipFill>
+          <a:blip r:embed="rId10"/>
+          <a:stretch>
+            <a:fillRect/>
+          </a:stretch>
+        </p:blipFill>
+        <p:spPr>
+          <a:xfrm>
+            <a:off x="22512863" y="2212116"/>
+            <a:ext cx="3968969" cy="2975113"/>
+          </a:xfrm>
+          <a:prstGeom prst="rect">
+            <a:avLst/>
+          </a:prstGeom>
+        </p:spPr>
+      </p:pic>
+      <p:pic>
+        <p:nvPicPr>
+          <p:cNvPr id="6" name="Picture 5" descr="Eyes open clipart clipground #31495 - Free Transparent PNG Logos">
+            <a:extLst>
+              <a:ext uri="{FF2B5EF4-FFF2-40B4-BE49-F238E27FC236}">
+                <a16:creationId xmlns:a16="http://schemas.microsoft.com/office/drawing/2014/main" id="{9D3E6E2E-04C2-513B-0EE5-8C40F5B8F46A}"/>
+              </a:ext>
+            </a:extLst>
+          </p:cNvPr>
+          <p:cNvPicPr>
+            <a:picLocks noChangeAspect="1"/>
+          </p:cNvPicPr>
+          <p:nvPr/>
+        </p:nvPicPr>
+        <p:blipFill>
+          <a:blip r:embed="rId11"/>
+          <a:stretch>
+            <a:fillRect/>
+          </a:stretch>
+        </p:blipFill>
+        <p:spPr>
+          <a:xfrm rot="20443004">
+            <a:off x="23071504" y="2606120"/>
+            <a:ext cx="1527081" cy="735074"/>
+          </a:xfrm>
+          <a:prstGeom prst="rect">
+            <a:avLst/>
+          </a:prstGeom>
+        </p:spPr>
+      </p:pic>
+      <p:pic>
+        <p:nvPicPr>
+          <p:cNvPr id="10" name="Picture 9" descr="Nebula overlay color 26548388 PNG">
+            <a:extLst>
+              <a:ext uri="{FF2B5EF4-FFF2-40B4-BE49-F238E27FC236}">
+                <a16:creationId xmlns:a16="http://schemas.microsoft.com/office/drawing/2014/main" id="{FB4EBB94-758E-75A7-659C-BF66DBB0AEF6}"/>
+              </a:ext>
+            </a:extLst>
+          </p:cNvPr>
+          <p:cNvPicPr>
+            <a:picLocks noChangeAspect="1"/>
+          </p:cNvPicPr>
+          <p:nvPr/>
+        </p:nvPicPr>
+        <p:blipFill>
+          <a:blip r:embed="rId12"/>
+          <a:stretch>
+            <a:fillRect/>
+          </a:stretch>
+        </p:blipFill>
+        <p:spPr>
+          <a:xfrm rot="2098715">
+            <a:off x="23425759" y="-141307"/>
+            <a:ext cx="6097999" cy="3431350"/>
+          </a:xfrm>
+          <a:prstGeom prst="rect">
+            <a:avLst/>
+          </a:prstGeom>
+        </p:spPr>
+      </p:pic>
+      <p:sp>
+        <p:nvSpPr>
+          <p:cNvPr id="76" name="TextBox 75">
+            <a:extLst>
+              <a:ext uri="{FF2B5EF4-FFF2-40B4-BE49-F238E27FC236}">
+                <a16:creationId xmlns:a16="http://schemas.microsoft.com/office/drawing/2014/main" id="{8F4057E1-F618-63B3-DF3A-8B3B4948305D}"/>
+              </a:ext>
+            </a:extLst>
+          </p:cNvPr>
+          <p:cNvSpPr txBox="1"/>
+          <p:nvPr/>
+        </p:nvSpPr>
+        <p:spPr>
+          <a:xfrm>
+            <a:off x="17145000" y="20885748"/>
+            <a:ext cx="14630400" cy="1615827"/>
+          </a:xfrm>
+          <a:prstGeom prst="rect">
+            <a:avLst/>
+          </a:prstGeom>
+          <a:noFill/>
+        </p:spPr>
+        <p:txBody>
+          <a:bodyPr wrap="square" lIns="91440" tIns="45720" rIns="91440" bIns="45720" rtlCol="0" anchor="t">
+            <a:spAutoFit/>
+          </a:bodyPr>
+          <a:lstStyle/>
+          <a:p>
+            <a:pPr marL="457200" indent="-457200">
+              <a:spcAft>
+                <a:spcPts val="400"/>
+              </a:spcAft>
+              <a:buFont typeface="Arial" panose="020B0604020202020204" pitchFamily="34" charset="0"/>
+              <a:buChar char="•"/>
+            </a:pPr>
+            <a:r>
+              <a:rPr lang="en-CA" sz="3300" b="1" dirty="0">
+                <a:latin typeface="Aptos"/>
+              </a:rPr>
+              <a:t>Earlier-onset test: </a:t>
+            </a:r>
+            <a:r>
+              <a:rPr lang="en-CA" sz="3300" b="0" dirty="0">
+                <a:latin typeface="Aptos"/>
+              </a:rPr>
+              <a:t>Starting growth at z = 3,400 (matter–radiation equality) requires 270–1,200 M⊙ seeds for the 4 plotted objects (</a:t>
+            </a:r>
+            <a:r>
+              <a:rPr lang="en-CA" sz="3300" b="0" dirty="0" err="1">
+                <a:latin typeface="Aptos"/>
+              </a:rPr>
+              <a:t>ε</a:t>
+            </a:r>
+            <a:r>
+              <a:rPr lang="en-CA" sz="3300" b="0" dirty="0">
+                <a:latin typeface="Aptos"/>
+              </a:rPr>
+              <a:t> = 0.1, average ratio ≤ 1, no mergers).</a:t>
+            </a:r>
+          </a:p>
+        </p:txBody>
+      </p:sp>
+      <p:sp>
+        <p:nvSpPr>
+          <p:cNvPr id="2" name="TextBox 1">
+            <a:extLst>
+              <a:ext uri="{FF2B5EF4-FFF2-40B4-BE49-F238E27FC236}">
+                <a16:creationId xmlns:a16="http://schemas.microsoft.com/office/drawing/2014/main" id="{6F669F8B-BE33-0C82-515C-AF8D3B759FB3}"/>
+              </a:ext>
+            </a:extLst>
+          </p:cNvPr>
+          <p:cNvSpPr txBox="1"/>
+          <p:nvPr/>
+        </p:nvSpPr>
+        <p:spPr>
+          <a:xfrm>
+            <a:off x="17007840" y="6642638"/>
+            <a:ext cx="14767560" cy="5170646"/>
+          </a:xfrm>
+          <a:prstGeom prst="rect">
+            <a:avLst/>
+          </a:prstGeom>
+          <a:noFill/>
+        </p:spPr>
+        <p:txBody>
+          <a:bodyPr rot="0" spcFirstLastPara="0" vertOverflow="overflow" horzOverflow="overflow" vert="horz" wrap="square" lIns="91440" tIns="45720" rIns="91440" bIns="45720" numCol="1" spcCol="0" rtlCol="0" fromWordArt="0" anchor="t" anchorCtr="0" forceAA="0" compatLnSpc="1">
+            <a:prstTxWarp prst="textNoShape">
+              <a:avLst/>
+            </a:prstTxWarp>
+            <a:spAutoFit/>
+          </a:bodyPr>
+          <a:lstStyle/>
+          <a:p>
+            <a:pPr marL="285750" indent="-228600">
+              <a:buChar char="•"/>
+            </a:pPr>
+            <a:r>
+              <a:rPr lang="en-CA" sz="3300" b="1">
+                <a:latin typeface="Aptos"/>
+              </a:rPr>
+              <a:t>Reference: </a:t>
+            </a:r>
+            <a:r>
+              <a:rPr lang="en-CA" sz="3300" b="0">
+                <a:latin typeface="Aptos"/>
+              </a:rPr>
+              <a:t>212/220 primary objects require average Eddington ratios ≤ 1. The other 8 require averages above 1, including 5 in ≥ 95% of mass-error draws.</a:t>
+            </a:r>
+          </a:p>
+          <a:p>
+            <a:pPr marL="285750" indent="-228600">
+              <a:buChar char="•"/>
+            </a:pPr>
+            <a:r>
+              <a:rPr lang="en-CA" sz="3300" b="1">
+                <a:latin typeface="Aptos"/>
+              </a:rPr>
+              <a:t>Mass sensitivity: </a:t>
+            </a:r>
+            <a:r>
+              <a:rPr lang="en-CA" sz="3300" b="0">
+                <a:latin typeface="Aptos"/>
+              </a:rPr>
+              <a:t>After reducing masses by a factor of 3.2 (0.5 dex), UNCOVER-20466, COSMOS3D-13852, and RUBIES-EGS-55604 still require averages above 1 in ≥ 95% of mass-error draws.</a:t>
+            </a:r>
+          </a:p>
+          <a:p>
+            <a:pPr marL="285750" indent="-228600">
+              <a:buChar char="•"/>
+            </a:pPr>
+            <a:r>
+              <a:rPr lang="en-CA" sz="3300" b="1">
+                <a:latin typeface="Aptos"/>
+              </a:rPr>
+              <a:t>Seed mass: </a:t>
+            </a:r>
+            <a:r>
+              <a:rPr lang="en-CA" sz="3300" b="0">
+                <a:latin typeface="Aptos"/>
+              </a:rPr>
+              <a:t>1,000 M⊙ seeds leave 3/220 above 1. With 100,000 M⊙ seeds, no objects in either sample require averages above 1.</a:t>
+            </a:r>
+          </a:p>
+          <a:p>
+            <a:pPr marL="285750" indent="-228600">
+              <a:buChar char="•"/>
+            </a:pPr>
+            <a:r>
+              <a:rPr lang="en-CA" sz="3300" b="1">
+                <a:latin typeface="Aptos"/>
+              </a:rPr>
+              <a:t>Growth start time: </a:t>
+            </a:r>
+            <a:r>
+              <a:rPr lang="en-CA" sz="3300" b="0">
+                <a:latin typeface="Aptos"/>
+              </a:rPr>
+              <a:t>Starting later (z = 20) increases the primary count above 1 to 18/220. GN-z11 requires the highest average in the expanded sample.</a:t>
+            </a:r>
+          </a:p>
+          <a:p>
+            <a:pPr marL="285750" indent="-228600">
+              <a:buChar char="•"/>
+            </a:pPr>
+            <a:r>
+              <a:rPr lang="en-CA" sz="3300" b="1">
+                <a:latin typeface="Aptos"/>
+              </a:rPr>
+              <a:t>Efficiency: </a:t>
+            </a:r>
+            <a:r>
+              <a:rPr lang="en-CA" sz="3300" b="0">
+                <a:latin typeface="Aptos"/>
+              </a:rPr>
+              <a:t>At ε = 0.05719 (non-spinning thin disc) [4], all 234 central mass estimates require averages below 1 from 100 M⊙ seeds at z = 30.</a:t>
+            </a:r>
+          </a:p>
+        </p:txBody>
+      </p:sp>
+      <p:sp>
+        <p:nvSpPr>
+          <p:cNvPr id="7" name="Title 18">
+            <a:extLst>
+              <a:ext uri="{FF2B5EF4-FFF2-40B4-BE49-F238E27FC236}">
+                <a16:creationId xmlns:a16="http://schemas.microsoft.com/office/drawing/2014/main" id="{3AC78928-AF13-E1B9-F802-F1FD39D07D33}"/>
+              </a:ext>
+            </a:extLst>
+          </p:cNvPr>
+          <p:cNvSpPr txBox="1">
+            <a:spLocks/>
+          </p:cNvSpPr>
+          <p:nvPr/>
+        </p:nvSpPr>
+        <p:spPr>
+          <a:xfrm>
+            <a:off x="16550640" y="5362478"/>
+            <a:ext cx="15453360" cy="960120"/>
+          </a:xfrm>
+          <a:prstGeom prst="rect">
+            <a:avLst/>
+          </a:prstGeom>
+          <a:solidFill>
+            <a:srgbClr val="002A5C"/>
+          </a:solidFill>
+          <a:ln>
+            <a:solidFill>
+              <a:srgbClr val="09306B"/>
+            </a:solidFill>
+          </a:ln>
+        </p:spPr>
+        <p:txBody>
+          <a:bodyPr vert="horz" lIns="78373" tIns="39187" rIns="78373" bIns="39187" rtlCol="0" anchor="ctr" anchorCtr="1">
+            <a:normAutofit/>
+          </a:bodyPr>
+          <a:lstStyle>
+            <a:lvl1pPr algn="l" defTabSz="4389120" rtl="0" eaLnBrk="1" latinLnBrk="0" hangingPunct="1">
+              <a:lnSpc>
+                <a:spcPct val="90000"/>
+              </a:lnSpc>
+              <a:spcBef>
+                <a:spcPct val="0"/>
+              </a:spcBef>
+              <a:buNone/>
+              <a:defRPr sz="6200" b="1" kern="1200">
+                <a:solidFill>
+                  <a:schemeClr val="bg1"/>
+                </a:solidFill>
+                <a:latin typeface="Arial"/>
+                <a:ea typeface="+mj-ea"/>
+                <a:cs typeface="Arial"/>
+              </a:defRPr>
+            </a:lvl1pPr>
+          </a:lstStyle>
+          <a:p>
+            <a:pPr algn="ctr"/>
+            <a:r>
+              <a:rPr lang="en-US" sz="5000"/>
+              <a:t>Results</a:t>
+            </a:r>
+            <a:endParaRPr lang="en-US"/>
+          </a:p>
+        </p:txBody>
+      </p:sp>
+      <p:sp>
+        <p:nvSpPr>
+          <p:cNvPr id="11" name="Rectangle 10">
+            <a:extLst>
+              <a:ext uri="{FF2B5EF4-FFF2-40B4-BE49-F238E27FC236}">
+                <a16:creationId xmlns:a16="http://schemas.microsoft.com/office/drawing/2014/main" id="{AF7EDC07-606F-DD66-5973-0AE0D673B23B}"/>
+              </a:ext>
+            </a:extLst>
+          </p:cNvPr>
+          <p:cNvSpPr/>
+          <p:nvPr/>
+        </p:nvSpPr>
+        <p:spPr>
+          <a:xfrm>
+            <a:off x="16550640" y="5344777"/>
+            <a:ext cx="15453360" cy="29905343"/>
+          </a:xfrm>
+          <a:prstGeom prst="rect">
+            <a:avLst/>
+          </a:prstGeom>
+          <a:noFill/>
+          <a:ln>
+            <a:solidFill>
+              <a:srgbClr val="002A5C"/>
+            </a:solidFill>
+          </a:ln>
+        </p:spPr>
+        <p:style>
+          <a:lnRef idx="2">
+            <a:schemeClr val="accent1">
+              <a:shade val="15000"/>
+            </a:schemeClr>
+          </a:lnRef>
+          <a:fillRef idx="1">
+            <a:schemeClr val="accent1"/>
+          </a:fillRef>
+          <a:effectRef idx="0">
+            <a:schemeClr val="accent1"/>
+          </a:effectRef>
+          <a:fontRef idx="minor">
+            <a:schemeClr val="lt1"/>
+          </a:fontRef>
+        </p:style>
+        <p:txBody>
+          <a:bodyPr rtlCol="0" anchor="ctr"/>
+          <a:lstStyle/>
+          <a:p>
+            <a:pPr algn="ctr"/>
+            <a:endParaRPr lang="en-US"/>
+          </a:p>
+        </p:txBody>
+      </p:sp>
+      <p:sp>
+        <p:nvSpPr>
+          <p:cNvPr id="110" name="Figure takeaway 110"/>
+          <p:cNvSpPr txBox="1"/>
+          <p:nvPr/>
+        </p:nvSpPr>
+        <p:spPr>
+          <a:xfrm>
+            <a:off x="17190720" y="20162520"/>
+            <a:ext cx="14447520" cy="914400"/>
+          </a:xfrm>
+          <a:prstGeom prst="rect">
+            <a:avLst/>
+          </a:prstGeom>
+          <a:noFill/>
+        </p:spPr>
+        <p:txBody>
+          <a:bodyPr wrap="square" lIns="91440" tIns="45720" rIns="91440" bIns="45720" rtlCol="0" anchor="t">
+            <a:spAutoFit/>
+          </a:bodyPr>
+          <a:lstStyle/>
+          <a:p>
+            <a:pPr>
+              <a:spcAft>
+                <a:spcPts val="800"/>
+              </a:spcAft>
+              <a:buNone/>
+            </a:pPr>
+            <a:r>
+              <a:rPr lang="en-CA" sz="2400" b="0">
+                <a:latin typeface="Aptos"/>
+              </a:rPr>
+              <a:t>After lowering masses by 0.5 dex, 3 targets require averages above 1 in ≥ 95% of mass-error draws.</a:t>
+            </a:r>
+          </a:p>
+        </p:txBody>
+      </p:sp>
+      <p:sp>
+        <p:nvSpPr>
+          <p:cNvPr id="111" name="Figure takeaway 111"/>
+          <p:cNvSpPr txBox="1"/>
+          <p:nvPr/>
+        </p:nvSpPr>
+        <p:spPr>
+          <a:xfrm>
+            <a:off x="1188720" y="36859926"/>
+            <a:ext cx="14356080" cy="1051560"/>
+          </a:xfrm>
+          <a:prstGeom prst="rect">
+            <a:avLst/>
+          </a:prstGeom>
+          <a:noFill/>
+        </p:spPr>
+        <p:txBody>
+          <a:bodyPr wrap="square" lIns="91440" tIns="45720" rIns="91440" bIns="45720" rtlCol="0" anchor="t">
+            <a:spAutoFit/>
+          </a:bodyPr>
+          <a:lstStyle/>
+          <a:p>
+            <a:pPr>
+              <a:spcAft>
+                <a:spcPts val="800"/>
+              </a:spcAft>
+              <a:buNone/>
+            </a:pPr>
+            <a:r>
+              <a:rPr lang="en-CA" sz="2400" b="0" dirty="0">
+                <a:latin typeface="Aptos"/>
+              </a:rPr>
+              <a:t>Only efficiency changes between panels. Points below a curve can be reached with a lower average Eddington ratio.</a:t>
+            </a:r>
+          </a:p>
+        </p:txBody>
+      </p:sp>
+      <p:sp>
+        <p:nvSpPr>
+          <p:cNvPr id="112" name="Figure takeaway 112"/>
+          <p:cNvSpPr txBox="1"/>
+          <p:nvPr/>
+        </p:nvSpPr>
+        <p:spPr>
+          <a:xfrm>
+            <a:off x="17190720" y="32207899"/>
+            <a:ext cx="14447520" cy="548640"/>
+          </a:xfrm>
+          <a:prstGeom prst="rect">
+            <a:avLst/>
+          </a:prstGeom>
+          <a:noFill/>
+        </p:spPr>
+        <p:txBody>
+          <a:bodyPr wrap="square" lIns="91440" tIns="45720" rIns="91440" bIns="45720" rtlCol="0" anchor="t">
+            <a:spAutoFit/>
+          </a:bodyPr>
+          <a:lstStyle/>
+          <a:p>
+            <a:pPr>
+              <a:buNone/>
+            </a:pPr>
+            <a:r>
+              <a:rPr lang="en-CA" sz="2400" b="0" dirty="0">
+                <a:latin typeface="Aptos"/>
+              </a:rPr>
+              <a:t>Earlier starts lower the required seed mass, but the decrease becomes smaller.</a:t>
+            </a:r>
+          </a:p>
+        </p:txBody>
+      </p:sp>
+      <p:sp>
+        <p:nvSpPr>
+          <p:cNvPr id="15" name="TextBox 14">
+            <a:extLst>
+              <a:ext uri="{FF2B5EF4-FFF2-40B4-BE49-F238E27FC236}">
+                <a16:creationId xmlns:a16="http://schemas.microsoft.com/office/drawing/2014/main" id="{B71483CE-2A7E-6438-7E3B-E605C17C7099}"/>
+              </a:ext>
+            </a:extLst>
+          </p:cNvPr>
+          <p:cNvSpPr txBox="1"/>
+          <p:nvPr/>
+        </p:nvSpPr>
+        <p:spPr>
+          <a:xfrm>
+            <a:off x="17007840" y="32779973"/>
+            <a:ext cx="14767560" cy="2286000"/>
+          </a:xfrm>
+          <a:prstGeom prst="rect">
+            <a:avLst/>
+          </a:prstGeom>
+          <a:noFill/>
+        </p:spPr>
+        <p:txBody>
+          <a:bodyPr wrap="square">
+            <a:spAutoFit/>
+          </a:bodyPr>
+          <a:lstStyle/>
+          <a:p>
+            <a:pPr marL="457200" indent="-457200">
+              <a:spcAft>
+                <a:spcPts val="400"/>
+              </a:spcAft>
+              <a:buFont typeface="Arial" panose="020B0604020202020204" pitchFamily="34" charset="0"/>
+              <a:buChar char="•"/>
+            </a:pPr>
+            <a:r>
+              <a:rPr lang="en-CA" sz="3300" b="1" dirty="0">
+                <a:latin typeface="Aptos"/>
+              </a:rPr>
+              <a:t>Independent mass check: </a:t>
+            </a:r>
+            <a:r>
+              <a:rPr lang="en-CA" sz="3300" b="0" dirty="0">
+                <a:latin typeface="Aptos"/>
+              </a:rPr>
+              <a:t>Under the reference model, A2744-QSO1’s broad-line mass (2.0 × 10</a:t>
+            </a:r>
+            <a:r>
+              <a:rPr lang="en-CA" sz="2200" b="0" baseline="30000" dirty="0">
+                <a:latin typeface="Aptos"/>
+              </a:rPr>
+              <a:t>7</a:t>
+            </a:r>
+            <a:r>
+              <a:rPr lang="en-CA" sz="3300" b="0" dirty="0">
+                <a:latin typeface="Aptos"/>
+              </a:rPr>
+              <a:t> M⊙) requires an average Eddington ratio of 0.929. Its dynamical mass (5.0 × 10</a:t>
+            </a:r>
+            <a:r>
+              <a:rPr lang="en-CA" sz="2200" b="0" baseline="30000" dirty="0">
+                <a:latin typeface="Aptos"/>
+              </a:rPr>
+              <a:t>7</a:t>
+            </a:r>
+            <a:r>
+              <a:rPr lang="en-CA" sz="3300" b="0" dirty="0">
+                <a:latin typeface="Aptos"/>
+              </a:rPr>
+              <a:t> M⊙) requires 0.9996 (ratio’s 16th–84th percentiles: 0.947–1.052) [5]. This interval includes 1.</a:t>
+            </a:r>
+          </a:p>
+        </p:txBody>
+      </p:sp>
+      <p:sp>
+        <p:nvSpPr>
+          <p:cNvPr id="120" name="Efficiency comparison heading">
+            <a:extLst>
+              <a:ext uri="{FF2B5EF4-FFF2-40B4-BE49-F238E27FC236}">
+                <a16:creationId xmlns:a16="http://schemas.microsoft.com/office/drawing/2014/main" id="{3A05E1FE-512D-49F3-9C39-22D275F0EE18}"/>
+              </a:ext>
+            </a:extLst>
+          </p:cNvPr>
+          <p:cNvSpPr>
+            <a:spLocks noGrp="1"/>
+          </p:cNvSpPr>
+          <p:nvPr/>
+        </p:nvSpPr>
+        <p:spPr>
+          <a:xfrm>
+            <a:off x="1280160" y="25453836"/>
+            <a:ext cx="14356080" cy="640080"/>
+          </a:xfrm>
+          <a:prstGeom prst="rect">
+            <a:avLst/>
+          </a:prstGeom>
+          <a:noFill/>
+        </p:spPr>
+        <p:txBody>
+          <a:bodyPr wrap="square" lIns="91440" tIns="45720" rIns="91440" bIns="45720" anchor="t">
+            <a:spAutoFit/>
+          </a:bodyPr>
+          <a:lstStyle>
+            <a:defPPr>
+              <a:defRPr b="1">
+                <a:solidFill>
+                  <a:srgbClr val="002A5C"/>
+                </a:solidFill>
+              </a:defRPr>
+            </a:defPPr>
+          </a:lstStyle>
+          <a:p>
+            <a:pPr>
+              <a:spcAft>
+                <a:spcPts val="800"/>
+              </a:spcAft>
+              <a:buNone/>
+              <a:defRPr b="1">
+                <a:solidFill>
+                  <a:srgbClr val="002A5C"/>
+                </a:solidFill>
+              </a:defRPr>
+            </a:pPr>
+            <a:r>
+              <a:rPr lang="en-CA" sz="3600" b="1">
+                <a:solidFill>
+                  <a:srgbClr val="002A5C"/>
+                </a:solidFill>
+                <a:latin typeface="Aptos"/>
+              </a:rPr>
+              <a:t>Growth at two radiative efficiencies</a:t>
+            </a:r>
+          </a:p>
+        </p:txBody>
+      </p:sp>
+    </p:spTree>
+    <p:extLst>
+      <p:ext uri="{BB962C8B-B14F-4D97-AF65-F5344CB8AC3E}">
+        <p14:creationId xmlns:p14="http://schemas.microsoft.com/office/powerpoint/2010/main" val="868487171"/>
+      </p:ext>
+    </p:extLst>
+  </p:cSld>
+  <p:clrMapOvr>
+    <a:masterClrMapping/>
+  </p:clrMapOvr>
+</p:sld>
+</file>
+
 <file path=ppt/theme/theme1.xml><?xml version="1.0" encoding="utf-8"?>
 <a:theme xmlns:a="http://schemas.openxmlformats.org/drawingml/2006/main" name="Office Theme">
   <a:themeElements>

</xml_diff>

<commit_message>
Condense overview poster results in both orientations
</commit_message>
<xml_diff>
--- a/posters/36x48.pptx
+++ b/posters/36x48.pptx
@@ -8660,19 +8660,7 @@
               <a:rPr lang="en-CA" sz="3300" b="0" dirty="0">
                 <a:latin typeface="Aptos"/>
               </a:rPr>
-              <a:t>Starting growth at z = 3,400 (matter–radiation equality) requires 270–1,200 M⊙ seeds for the 4 plotted objects (</a:t>
-            </a:r>
-            <a:r>
-              <a:rPr lang="en-CA" sz="3300" b="0" dirty="0" err="1">
-                <a:latin typeface="Aptos"/>
-              </a:rPr>
-              <a:t>ε</a:t>
-            </a:r>
-            <a:r>
-              <a:rPr lang="en-CA" sz="3300" b="0" dirty="0">
-                <a:latin typeface="Aptos"/>
-              </a:rPr>
-              <a:t> = 0.1, average ratio ≤ 1, no mergers).</a:t>
+              <a:t>Even starting at z = 3,400 requires 270–1,200 M⊙ seeds for the 4 plotted objects (ε = 0.1, average ratio ≤ 1, no mergers).</a:t>
             </a:r>
           </a:p>
         </p:txBody>
@@ -8721,7 +8709,7 @@
               <a:rPr lang="en-CA" sz="3300" b="0">
                 <a:latin typeface="Aptos"/>
               </a:rPr>
-              <a:t>212/220 primary objects require average Eddington ratios ≤ 1. The other 8 require averages above 1, including 5 in ≥ 95% of mass-error draws.</a:t>
+              <a:t>8/220 primary objects require average Eddington ratios above 1, including 5 in ≥ 95% of mass-error draws.</a:t>
             </a:r>
           </a:p>
           <a:p>
@@ -8738,7 +8726,7 @@
               <a:rPr lang="en-CA" sz="3300" b="0">
                 <a:latin typeface="Aptos"/>
               </a:rPr>
-              <a:t>After reducing masses by a factor of 3.2 (0.5 dex), UNCOVER-20466, COSMOS3D-13852, and RUBIES-EGS-55604 still require averages above 1 in ≥ 95% of mass-error draws.</a:t>
+              <a:t>Lowering masses by a factor of 3.2 leaves 3 objects above 1 in ≥ 95% of draws.</a:t>
             </a:r>
           </a:p>
           <a:p>
@@ -8755,7 +8743,7 @@
               <a:rPr lang="en-CA" sz="3300" b="0">
                 <a:latin typeface="Aptos"/>
               </a:rPr>
-              <a:t>1,000 M⊙ seeds leave 3/220 above 1. With 100,000 M⊙ seeds, no objects in either sample require averages above 1.</a:t>
+              <a:t>1,000 M⊙ seeds leave 3/220 above 1. With 100,000 M⊙ seeds, neither sample has objects above 1.</a:t>
             </a:r>
           </a:p>
           <a:p>
@@ -8772,7 +8760,7 @@
               <a:rPr lang="en-CA" sz="3300" b="0">
                 <a:latin typeface="Aptos"/>
               </a:rPr>
-              <a:t>Starting later (z = 20) increases the primary count above 1 to 18/220. GN-z11 requires the highest average in the expanded sample.</a:t>
+              <a:t>Starting at z = 20 raises the primary count above 1 to 18/220. GN-z11 requires the highest average in the expanded sample.</a:t>
             </a:r>
           </a:p>
           <a:p>
@@ -8789,7 +8777,7 @@
               <a:rPr lang="en-CA" sz="3300" b="0">
                 <a:latin typeface="Aptos"/>
               </a:rPr>
-              <a:t>At ε = 0.05719 (non-spinning thin disc) [4], all 234 central mass estimates require averages below 1 from 100 M⊙ seeds at z = 30.</a:t>
+              <a:t>At ε = 0.05719 [4], all 234 central mass estimates require averages below 1 under the other reference assumptions.</a:t>
             </a:r>
           </a:p>
         </p:txBody>
@@ -8942,7 +8930,7 @@
               <a:rPr lang="en-CA" sz="2400" b="0">
                 <a:latin typeface="Aptos"/>
               </a:rPr>
-              <a:t>After lowering masses by 0.5 dex, 3 targets require averages above 1 in ≥ 95% of mass-error draws.</a:t>
+              <a:t>Orange points show the same objects after lowering masses by a factor of 3.2.</a:t>
             </a:r>
           </a:p>
         </p:txBody>
@@ -9063,10 +9051,10 @@
               <a:rPr lang="en-CA" sz="3300" b="0" dirty="0">
                 <a:latin typeface="Aptos"/>
               </a:rPr>
-              <a:t>Under the reference model, A2744-QSO1’s broad-line mass (2.0 × 10</a:t>
-            </a:r>
-            <a:r>
-              <a:rPr lang="en-CA" sz="2200" b="0" baseline="30000" dirty="0">
+              <a:t>A2744-QSO1’s broad-line mass (2.0 × 10</a:t>
+            </a:r>
+            <a:r>
+              <a:rPr lang="en-CA" sz="2200" b="0" dirty="0" baseline="30000">
                 <a:latin typeface="Aptos"/>
               </a:rPr>
               <a:t>7</a:t>
@@ -9075,10 +9063,10 @@
               <a:rPr lang="en-CA" sz="3300" b="0" dirty="0">
                 <a:latin typeface="Aptos"/>
               </a:rPr>
-              <a:t> M⊙) requires an average Eddington ratio of 0.929. Its dynamical mass (5.0 × 10</a:t>
-            </a:r>
-            <a:r>
-              <a:rPr lang="en-CA" sz="2200" b="0" baseline="30000" dirty="0">
+              <a:t> M⊙) requires an average of 0.929 under the reference model. Its dynamical mass (5.0 × 10</a:t>
+            </a:r>
+            <a:r>
+              <a:rPr lang="en-CA" sz="2200" b="0" dirty="0" baseline="30000">
                 <a:latin typeface="Aptos"/>
               </a:rPr>
               <a:t>7</a:t>
@@ -9087,7 +9075,7 @@
               <a:rPr lang="en-CA" sz="3300" b="0" dirty="0">
                 <a:latin typeface="Aptos"/>
               </a:rPr>
-              <a:t> M⊙) requires 0.9996 (ratio’s 16th–84th percentiles: 0.947–1.052) [5]. This interval includes 1.</a:t>
+              <a:t> M⊙) requires 0.9996 [5]. Its required average spans 0.947–1.052 (16th–84th percentiles), including 1.</a:t>
             </a:r>
           </a:p>
         </p:txBody>

</xml_diff>

<commit_message>
Clarify overview poster definitions and scientific interpretation
</commit_message>
<xml_diff>
--- a/posters/36x48.pptx
+++ b/posters/36x48.pptx
@@ -7840,7 +7840,7 @@
               <a:rPr sz="3300" b="0" lang="en-CA">
                 <a:latin typeface="Aptos"/>
               </a:rPr>
-              <a:t>Compiled 350 measurements at z ≥ 4. Used 1 mass per object: 220 primary objects with broad Balmer-line masses and 234 expanded objects, including tentative candidates and GN-z11 [1,2].</a:t>
+              <a:t>Compiled 350 measurements at z ≥ 4. Selected 220 primary objects with broad hydrogen (Balmer) line masses. Expanded sample: 234 objects, including these 220, tentative candidates and GN-z11 [1,2].</a:t>
             </a:r>
           </a:p>
           <a:p>
@@ -7863,7 +7863,7 @@
               <a:rPr sz="3300" b="0" lang="en-CA">
                 <a:latin typeface="Aptos"/>
               </a:rPr>
-              <a:t>Assumed 100 M⊙ seeds at z = 30, radiative efficiency ε = 0.1 and no mergers [3].</a:t>
+              <a:t>Assumed 100 M⊙ seeds at z = 30, ε = 0.1, no mergers [3]. M⊙ denotes solar mass. Higher redshift z means earlier times. ε is the radiated fraction of accreted rest-mass energy.</a:t>
             </a:r>
           </a:p>
           <a:p>
@@ -7898,7 +7898,7 @@
               <a:rPr sz="3300" b="0" lang="en-CA">
                 <a:latin typeface="Aptos"/>
               </a:rPr>
-              <a:t>, the required lifetime-average Eddington ratio, including inactive periods. Compared it with an assumed maximum of 1.</a:t>
+              <a:t>, the required lifetime-average Eddington ratio, including inactive periods. Tested against an assumed maximum of 1.</a:t>
             </a:r>
           </a:p>
           <a:p>
@@ -7933,7 +7933,7 @@
               <a:rPr sz="3300" b="0" lang="en-CA">
                 <a:latin typeface="Aptos"/>
               </a:rPr>
-              <a:t> = luminosity/Eddington luminosity, where radiation force balances gravity. Averages above 1 require periods of super-Eddington accretion.</a:t>
+              <a:t> = luminosity/Eddington luminosity. At this limit, radiation force balances gravity. Averages above 1 require super-Eddington episodes.</a:t>
             </a:r>
           </a:p>
           <a:p>
@@ -7956,7 +7956,7 @@
               <a:rPr sz="3300" b="0" lang="en-CA">
                 <a:latin typeface="Aptos"/>
               </a:rPr>
-              <a:t>Sampled reported mass errors 10,000 times per object. Used central estimates for objects without errors. Varied mass scale, seed mass, start time and efficiency separately. Reported errors may omit calibration scatter.</a:t>
+              <a:t>Sampled reported mass errors 10,000 times each. Missing errors yielded central estimates only. Reported errors may omit calibration scatter.</a:t>
             </a:r>
           </a:p>
           <a:p>
@@ -7979,7 +7979,7 @@
               <a:rPr sz="3300" b="0" lang="en-CA">
                 <a:latin typeface="Aptos"/>
               </a:rPr>
-              <a:t>Found minimum seed masses for the 4 targets across start redshifts 20–3,400. Included radiation in cosmic ages. Assumed gas was available for accretion.</a:t>
+              <a:t>Calculated minimum seed masses for 4 targets at start redshifts 20–3,400. Included radiation in cosmic ages and assumed gas availability.</a:t>
             </a:r>
           </a:p>
         </p:txBody>
@@ -8137,13 +8137,19 @@
               <a:rPr lang="en-CA" sz="3300" b="1">
                 <a:latin typeface="Aptos"/>
               </a:rPr>
-              <a:t>Seed masses: </a:t>
+              <a:t>Main finding: </a:t>
+            </a:r>
+            <a:r>
+              <a:rPr lang="en-CA" sz="3300" b="1">
+                <a:latin typeface="Aptos"/>
+              </a:rPr>
+              <a:t>Most adopted masses allow growth from 100 M⊙ seeds under the reference assumptions. </a:t>
             </a:r>
             <a:r>
               <a:rPr lang="en-CA" sz="3300" b="0">
                 <a:latin typeface="Aptos"/>
               </a:rPr>
-              <a:t>Most adopted masses are compatible with growth from small stellar seeds under the reference assumptions.</a:t>
+              <a:t>Seed requirements depend on mass estimates and accretion efficiency.</a:t>
             </a:r>
           </a:p>
           <a:p>
@@ -8163,7 +8169,7 @@
               <a:rPr lang="en-CA" sz="3300" b="0">
                 <a:latin typeface="Aptos"/>
               </a:rPr>
-              <a:t>Lower radiative efficiency allows faster mass growth at the same Eddington ratio. Seed-mass requirements therefore depend on how efficiently accretion produces radiation.</a:t>
+              <a:t>Lower radiative efficiency leaves more accreted mass in the black hole, allowing faster growth at the same Eddington ratio.</a:t>
             </a:r>
           </a:p>
           <a:p>
@@ -8660,7 +8666,7 @@
               <a:rPr lang="en-CA" sz="3300" b="0" dirty="0">
                 <a:latin typeface="Aptos"/>
               </a:rPr>
-              <a:t>Even starting at z = 3,400 requires 270–1,200 M⊙ seeds for the 4 plotted objects (ε = 0.1, average ratio ≤ 1, no mergers).</a:t>
+              <a:t>Starting at matter–radiation equality (z = 3,400) still requires 270–1,200 M⊙ seeds for the 4 plotted objects (ε = 0.1, average ratio ≤ 1, no mergers).</a:t>
             </a:r>
           </a:p>
         </p:txBody>
@@ -8760,7 +8766,7 @@
               <a:rPr lang="en-CA" sz="3300" b="0">
                 <a:latin typeface="Aptos"/>
               </a:rPr>
-              <a:t>Starting at z = 20 raises the primary count above 1 to 18/220. GN-z11 requires the highest average in the expanded sample.</a:t>
+              <a:t>Starting at z = 20 raises the primary count above 1 to 18/220. At this start, GN-z11 requires the highest average in the expanded sample.</a:t>
             </a:r>
           </a:p>
           <a:p>

</xml_diff>

<commit_message>
Replace overview methods prose with catalogue and growth workflows
</commit_message>
<xml_diff>
--- a/posters/36x48.pptx
+++ b/posters/36x48.pptx
@@ -7325,36 +7325,6 @@
       </p:grpSpPr>
       <p:pic>
         <p:nvPicPr>
-          <p:cNvPr id="3" name="Picture 2">
-            <a:extLst>
-              <a:ext uri="{FF2B5EF4-FFF2-40B4-BE49-F238E27FC236}">
-                <a16:creationId xmlns:a16="http://schemas.microsoft.com/office/drawing/2014/main" id="{535E2EF0-72FB-E9D0-1E82-C65E26ED9E91}"/>
-              </a:ext>
-            </a:extLst>
-          </p:cNvPr>
-          <p:cNvPicPr>
-            <a:picLocks noChangeAspect="1"/>
-          </p:cNvPicPr>
-          <p:nvPr/>
-        </p:nvPicPr>
-        <p:blipFill>
-          <a:blip r:embed="rId3"/>
-          <a:stretch>
-            <a:fillRect/>
-          </a:stretch>
-        </p:blipFill>
-        <p:spPr>
-          <a:xfrm>
-            <a:off x="1005840" y="26251523"/>
-            <a:ext cx="15087600" cy="10515600"/>
-          </a:xfrm>
-          <a:prstGeom prst="rect">
-            <a:avLst/>
-          </a:prstGeom>
-        </p:spPr>
-      </p:pic>
-      <p:pic>
-        <p:nvPicPr>
           <p:cNvPr id="14" name="Minimum seed mass versus accretion onset" descr="Manuscript minimum seed masses under fixed growth caps for UNCOVER-20466, COSMOS3D-13852, RUBIES-EGS-55604, and GN-z11.">
             <a:extLst>
               <a:ext uri="{FF2B5EF4-FFF2-40B4-BE49-F238E27FC236}">
@@ -7807,8 +7777,8 @@
         </p:nvSpPr>
         <p:spPr>
           <a:xfrm>
-            <a:off x="1463040" y="11559248"/>
-            <a:ext cx="14173200" cy="12808443"/>
+            <a:off x="1463040" y="20116800"/>
+            <a:ext cx="13990320" cy="4114800"/>
           </a:xfrm>
           <a:prstGeom prst="rect">
             <a:avLst/>
@@ -7834,13 +7804,13 @@
               <a:rPr sz="3300" b="1" lang="en-CA">
                 <a:latin typeface="Aptos"/>
               </a:rPr>
-              <a:t>Catalogue: </a:t>
+              <a:t>Symbols: </a:t>
             </a:r>
             <a:r>
               <a:rPr sz="3300" b="0" lang="en-CA">
                 <a:latin typeface="Aptos"/>
               </a:rPr>
-              <a:t>Compiled 350 measurements at z ≥ 4. Selected 220 primary objects with broad hydrogen (Balmer) line masses. Expanded sample: 234 objects, including these 220, tentative candidates and GN-z11 [1,2].</a:t>
+              <a:t>M⊙ denotes solar mass. Higher redshift z means earlier times. ε is the radiated fraction of accreted rest-mass energy.</a:t>
             </a:r>
           </a:p>
           <a:p>
@@ -7857,129 +7827,25 @@
               <a:rPr sz="3300" b="1" lang="en-CA">
                 <a:latin typeface="Aptos"/>
               </a:rPr>
-              <a:t>Reference model: </a:t>
+              <a:t>Eddington ratio: </a:t>
             </a:r>
             <a:r>
               <a:rPr sz="3300" b="0" lang="en-CA">
                 <a:latin typeface="Aptos"/>
               </a:rPr>
-              <a:t>Assumed 100 M⊙ seeds at z = 30, ε = 0.1, no mergers [3]. M⊙ denotes solar mass. Higher redshift z means earlier times. ε is the radiated fraction of accreted rest-mass energy.</a:t>
-            </a:r>
-          </a:p>
-          <a:p>
-            <a:pPr>
-              <a:lnSpc>
-                <a:spcPct val="120000"/>
-              </a:lnSpc>
-              <a:spcAft>
-                <a:spcPts val="1600"/>
-              </a:spcAft>
-              <a:buNone/>
-            </a:pPr>
-            <a:r>
-              <a:rPr sz="3300" b="1" lang="en-CA">
-                <a:latin typeface="Aptos"/>
-              </a:rPr>
-              <a:t>Growth test: </a:t>
+              <a:t>f</a:t>
+            </a:r>
+            <a:r>
+              <a:rPr sz="2200" b="0" lang="en-CA" baseline="-25000">
+                <a:latin typeface="Aptos"/>
+              </a:rPr>
+              <a:t>Edd</a:t>
             </a:r>
             <a:r>
               <a:rPr sz="3300" b="0" lang="en-CA">
                 <a:latin typeface="Aptos"/>
               </a:rPr>
-              <a:t>Ranked objects by f̄</a:t>
-            </a:r>
-            <a:r>
-              <a:rPr sz="2200" b="0" lang="en-CA" baseline="-25000">
-                <a:latin typeface="Aptos"/>
-              </a:rPr>
-              <a:t>Edd,req</a:t>
-            </a:r>
-            <a:r>
-              <a:rPr sz="3300" b="0" lang="en-CA">
-                <a:latin typeface="Aptos"/>
-              </a:rPr>
-              <a:t>, the required lifetime-average Eddington ratio, including inactive periods. Tested against an assumed maximum of 1.</a:t>
-            </a:r>
-          </a:p>
-          <a:p>
-            <a:pPr>
-              <a:lnSpc>
-                <a:spcPct val="120000"/>
-              </a:lnSpc>
-              <a:spcAft>
-                <a:spcPts val="1600"/>
-              </a:spcAft>
-              <a:buNone/>
-            </a:pPr>
-            <a:r>
-              <a:rPr sz="3300" b="1" lang="en-CA">
-                <a:latin typeface="Aptos"/>
-              </a:rPr>
-              <a:t>Eddington ratio: </a:t>
-            </a:r>
-            <a:r>
-              <a:rPr sz="3300" b="0" lang="en-CA">
-                <a:latin typeface="Aptos"/>
-              </a:rPr>
-              <a:t>f</a:t>
-            </a:r>
-            <a:r>
-              <a:rPr sz="2200" b="0" lang="en-CA" baseline="-25000">
-                <a:latin typeface="Aptos"/>
-              </a:rPr>
-              <a:t>Edd</a:t>
-            </a:r>
-            <a:r>
-              <a:rPr sz="3300" b="0" lang="en-CA">
-                <a:latin typeface="Aptos"/>
-              </a:rPr>
-              <a:t> = luminosity/Eddington luminosity. At this limit, radiation force balances gravity. Averages above 1 require super-Eddington episodes.</a:t>
-            </a:r>
-          </a:p>
-          <a:p>
-            <a:pPr>
-              <a:lnSpc>
-                <a:spcPct val="120000"/>
-              </a:lnSpc>
-              <a:spcAft>
-                <a:spcPts val="1600"/>
-              </a:spcAft>
-              <a:buNone/>
-            </a:pPr>
-            <a:r>
-              <a:rPr sz="3300" b="1" lang="en-CA">
-                <a:latin typeface="Aptos"/>
-              </a:rPr>
-              <a:t>Uncertainty: </a:t>
-            </a:r>
-            <a:r>
-              <a:rPr sz="3300" b="0" lang="en-CA">
-                <a:latin typeface="Aptos"/>
-              </a:rPr>
-              <a:t>Sampled reported mass errors 10,000 times each. Missing errors yielded central estimates only. Reported errors may omit calibration scatter.</a:t>
-            </a:r>
-          </a:p>
-          <a:p>
-            <a:pPr>
-              <a:lnSpc>
-                <a:spcPct val="120000"/>
-              </a:lnSpc>
-              <a:spcAft>
-                <a:spcPts val="1600"/>
-              </a:spcAft>
-              <a:buNone/>
-            </a:pPr>
-            <a:r>
-              <a:rPr sz="3300" b="1" lang="en-CA">
-                <a:latin typeface="Aptos"/>
-              </a:rPr>
-              <a:t>Earlier growth: </a:t>
-            </a:r>
-            <a:r>
-              <a:rPr sz="3300" b="0" lang="en-CA">
-                <a:latin typeface="Aptos"/>
-              </a:rPr>
-              <a:t>Calculated minimum seed masses for 4 targets at start redshifts 20–3,400. Included radiation in cosmic ages and assumed gas availability.</a:t>
+              <a:t> = luminosity/Eddington luminosity, where radiation force balances gravity. Averages above 1 require super-Eddington episodes.</a:t>
             </a:r>
           </a:p>
         </p:txBody>
@@ -8943,43 +8809,6 @@
       </p:sp>
       <p:sp>
         <p:nvSpPr>
-          <p:cNvPr id="111" name="Figure takeaway 111"/>
-          <p:cNvSpPr txBox="1"/>
-          <p:nvPr/>
-        </p:nvSpPr>
-        <p:spPr>
-          <a:xfrm>
-            <a:off x="1188720" y="36859926"/>
-            <a:ext cx="14356080" cy="1051560"/>
-          </a:xfrm>
-          <a:prstGeom prst="rect">
-            <a:avLst/>
-          </a:prstGeom>
-          <a:noFill/>
-        </p:spPr>
-        <p:txBody>
-          <a:bodyPr wrap="square" lIns="91440" tIns="45720" rIns="91440" bIns="45720" rtlCol="0" anchor="t">
-            <a:spAutoFit/>
-          </a:bodyPr>
-          <a:lstStyle/>
-          <a:p>
-            <a:pPr>
-              <a:spcAft>
-                <a:spcPts val="800"/>
-              </a:spcAft>
-              <a:buNone/>
-            </a:pPr>
-            <a:r>
-              <a:rPr lang="en-CA" sz="2400" b="0" dirty="0">
-                <a:latin typeface="Aptos"/>
-              </a:rPr>
-              <a:t>Only efficiency changes between panels. Points below a curve can be reached with a lower average Eddington ratio.</a:t>
-            </a:r>
-          </a:p>
-        </p:txBody>
-      </p:sp>
-      <p:sp>
-        <p:nvSpPr>
           <p:cNvPr id="112" name="Figure takeaway 112"/>
           <p:cNvSpPr txBox="1"/>
           <p:nvPr/>
@@ -9142,7 +8971,1635 @@
                 </a:solidFill>
                 <a:latin typeface="Aptos"/>
               </a:rPr>
-              <a:t>Growth at two radiative efficiencies</a:t>
+              <a:t>Growth test and uncertainty</a:t>
+            </a:r>
+          </a:p>
+        </p:txBody>
+      </p:sp>
+      <p:sp>
+        <p:nvSpPr>
+          <p:cNvPr id="200" name="Poster diagram 200">
+            <a:extLst>
+              <a:ext uri="{FF2B5EF4-FFF2-40B4-BE49-F238E27FC236}">
+                <a16:creationId xmlns:a16="http://schemas.microsoft.com/office/drawing/2014/main" id="{F979C9B9-C3CA-480F-BB52-CC7D4B02CE22}"/>
+              </a:ext>
+            </a:extLst>
+          </p:cNvPr>
+          <p:cNvSpPr>
+            <a:spLocks noGrp="1"/>
+          </p:cNvSpPr>
+          <p:nvPr/>
+        </p:nvSpPr>
+        <p:spPr>
+          <a:xfrm>
+            <a:off x="1463040" y="11612880"/>
+            <a:ext cx="13990320" cy="1143000"/>
+          </a:xfrm>
+          <a:prstGeom prst="rect">
+            <a:avLst/>
+          </a:prstGeom>
+          <a:noFill/>
+          <a:ln w="0">
+            <a:noFill/>
+          </a:ln>
+        </p:spPr>
+        <p:txBody>
+          <a:bodyPr lIns="114300" tIns="76200" rIns="114300" bIns="76200" anchor="ctr"/>
+          <a:lstStyle>
+            <a:defPPr algn="ctr">
+              <a:defRPr sz="3300" b="1">
+                <a:solidFill>
+                  <a:srgbClr val="111111"/>
+                </a:solidFill>
+                <a:latin typeface="Aptos"/>
+              </a:defRPr>
+            </a:defPPr>
+          </a:lstStyle>
+          <a:p>
+            <a:pPr algn="ctr">
+              <a:defRPr sz="3300" b="1">
+                <a:solidFill>
+                  <a:srgbClr val="111111"/>
+                </a:solidFill>
+                <a:latin typeface="Aptos"/>
+              </a:defRPr>
+            </a:pPr>
+            <a:r>
+              <a:rPr sz="3300" b="1">
+                <a:solidFill>
+                  <a:srgbClr val="111111"/>
+                </a:solidFill>
+                <a:latin typeface="Aptos"/>
+              </a:rPr>
+              <a:t>350 measurements from 32 source families</a:t>
+            </a:r>
+          </a:p>
+          <a:p>
+            <a:pPr algn="ctr">
+              <a:defRPr sz="3300" b="1">
+                <a:solidFill>
+                  <a:srgbClr val="111111"/>
+                </a:solidFill>
+                <a:latin typeface="Aptos"/>
+              </a:defRPr>
+            </a:pPr>
+            <a:r>
+              <a:rPr sz="3300" b="1">
+                <a:solidFill>
+                  <a:srgbClr val="111111"/>
+                </a:solidFill>
+                <a:latin typeface="Aptos"/>
+              </a:rPr>
+              <a:t>Redshift z ≥ 4</a:t>
+            </a:r>
+          </a:p>
+        </p:txBody>
+      </p:sp>
+      <p:sp>
+        <p:nvSpPr>
+          <p:cNvPr id="201" name="Poster diagram 201">
+            <a:extLst>
+              <a:ext uri="{FF2B5EF4-FFF2-40B4-BE49-F238E27FC236}">
+                <a16:creationId xmlns:a16="http://schemas.microsoft.com/office/drawing/2014/main" id="{A5654399-0386-420B-B69B-49326884E1BD}"/>
+              </a:ext>
+            </a:extLst>
+          </p:cNvPr>
+          <p:cNvSpPr>
+            <a:spLocks noGrp="1"/>
+          </p:cNvSpPr>
+          <p:nvPr/>
+        </p:nvSpPr>
+        <p:spPr>
+          <a:xfrm>
+            <a:off x="8284464" y="12838176"/>
+            <a:ext cx="347472" cy="329184"/>
+          </a:xfrm>
+          <a:prstGeom prst="downArrow">
+            <a:avLst/>
+          </a:prstGeom>
+          <a:solidFill>
+            <a:srgbClr val="526477"/>
+          </a:solidFill>
+          <a:ln w="0">
+            <a:noFill/>
+          </a:ln>
+        </p:spPr>
+      </p:sp>
+      <p:sp>
+        <p:nvSpPr>
+          <p:cNvPr id="202" name="Poster diagram 202">
+            <a:extLst>
+              <a:ext uri="{FF2B5EF4-FFF2-40B4-BE49-F238E27FC236}">
+                <a16:creationId xmlns:a16="http://schemas.microsoft.com/office/drawing/2014/main" id="{A4F32B50-A70B-4AAD-866D-8A9AFB77BA97}"/>
+              </a:ext>
+            </a:extLst>
+          </p:cNvPr>
+          <p:cNvSpPr>
+            <a:spLocks noGrp="1"/>
+          </p:cNvSpPr>
+          <p:nvPr/>
+        </p:nvSpPr>
+        <p:spPr>
+          <a:xfrm>
+            <a:off x="1463040" y="13286232"/>
+            <a:ext cx="13990320" cy="914400"/>
+          </a:xfrm>
+          <a:prstGeom prst="rect">
+            <a:avLst/>
+          </a:prstGeom>
+          <a:solidFill>
+            <a:srgbClr val="F1F4F7"/>
+          </a:solidFill>
+          <a:ln w="17145">
+            <a:solidFill>
+              <a:srgbClr val="526477"/>
+            </a:solidFill>
+          </a:ln>
+        </p:spPr>
+        <p:txBody>
+          <a:bodyPr lIns="114300" tIns="76200" rIns="114300" bIns="76200" anchor="ctr"/>
+          <a:lstStyle>
+            <a:defPPr algn="ctr">
+              <a:defRPr sz="3300" b="1">
+                <a:solidFill>
+                  <a:srgbClr val="111111"/>
+                </a:solidFill>
+                <a:latin typeface="Aptos"/>
+              </a:defRPr>
+            </a:defPPr>
+          </a:lstStyle>
+          <a:p>
+            <a:pPr algn="ctr">
+              <a:defRPr sz="3300" b="1">
+                <a:solidFill>
+                  <a:srgbClr val="111111"/>
+                </a:solidFill>
+                <a:latin typeface="Aptos"/>
+              </a:defRPr>
+            </a:pPr>
+            <a:r>
+              <a:rPr sz="3300" b="1">
+                <a:solidFill>
+                  <a:srgbClr val="111111"/>
+                </a:solidFill>
+                <a:latin typeface="Aptos"/>
+              </a:rPr>
+              <a:t>338 provisional objects</a:t>
+            </a:r>
+          </a:p>
+        </p:txBody>
+      </p:sp>
+      <p:sp>
+        <p:nvSpPr>
+          <p:cNvPr id="203" name="Poster diagram 203">
+            <a:extLst>
+              <a:ext uri="{FF2B5EF4-FFF2-40B4-BE49-F238E27FC236}">
+                <a16:creationId xmlns:a16="http://schemas.microsoft.com/office/drawing/2014/main" id="{4B9D32E4-35CC-401A-84F3-9B0E93812FF3}"/>
+              </a:ext>
+            </a:extLst>
+          </p:cNvPr>
+          <p:cNvSpPr>
+            <a:spLocks noGrp="1"/>
+          </p:cNvSpPr>
+          <p:nvPr/>
+        </p:nvSpPr>
+        <p:spPr>
+          <a:xfrm>
+            <a:off x="5626303" y="14310360"/>
+            <a:ext cx="347472" cy="329184"/>
+          </a:xfrm>
+          <a:prstGeom prst="downArrow">
+            <a:avLst/>
+          </a:prstGeom>
+          <a:solidFill>
+            <a:srgbClr val="526477"/>
+          </a:solidFill>
+          <a:ln w="0">
+            <a:noFill/>
+          </a:ln>
+        </p:spPr>
+      </p:sp>
+      <p:sp>
+        <p:nvSpPr>
+          <p:cNvPr id="204" name="Poster diagram 204">
+            <a:extLst>
+              <a:ext uri="{FF2B5EF4-FFF2-40B4-BE49-F238E27FC236}">
+                <a16:creationId xmlns:a16="http://schemas.microsoft.com/office/drawing/2014/main" id="{D840C234-8C7B-423E-87DF-1C2EC82BD5EA}"/>
+              </a:ext>
+            </a:extLst>
+          </p:cNvPr>
+          <p:cNvSpPr>
+            <a:spLocks noGrp="1"/>
+          </p:cNvSpPr>
+          <p:nvPr/>
+        </p:nvSpPr>
+        <p:spPr>
+          <a:xfrm>
+            <a:off x="12827203" y="14310360"/>
+            <a:ext cx="347472" cy="329184"/>
+          </a:xfrm>
+          <a:prstGeom prst="downArrow">
+            <a:avLst/>
+          </a:prstGeom>
+          <a:solidFill>
+            <a:srgbClr val="526477"/>
+          </a:solidFill>
+          <a:ln w="0">
+            <a:noFill/>
+          </a:ln>
+        </p:spPr>
+      </p:sp>
+      <p:sp>
+        <p:nvSpPr>
+          <p:cNvPr id="205" name="Poster diagram 205">
+            <a:extLst>
+              <a:ext uri="{FF2B5EF4-FFF2-40B4-BE49-F238E27FC236}">
+                <a16:creationId xmlns:a16="http://schemas.microsoft.com/office/drawing/2014/main" id="{B0440D7D-E739-420F-ABED-4E5D214838EC}"/>
+              </a:ext>
+            </a:extLst>
+          </p:cNvPr>
+          <p:cNvSpPr>
+            <a:spLocks noGrp="1"/>
+          </p:cNvSpPr>
+          <p:nvPr/>
+        </p:nvSpPr>
+        <p:spPr>
+          <a:xfrm>
+            <a:off x="1463040" y="14813280"/>
+            <a:ext cx="8673998" cy="4709160"/>
+          </a:xfrm>
+          <a:prstGeom prst="rect">
+            <a:avLst/>
+          </a:prstGeom>
+          <a:noFill/>
+          <a:ln w="17145">
+            <a:solidFill>
+              <a:srgbClr val="073463"/>
+            </a:solidFill>
+          </a:ln>
+        </p:spPr>
+      </p:sp>
+      <p:sp>
+        <p:nvSpPr>
+          <p:cNvPr id="206" name="Poster diagram 206">
+            <a:extLst>
+              <a:ext uri="{FF2B5EF4-FFF2-40B4-BE49-F238E27FC236}">
+                <a16:creationId xmlns:a16="http://schemas.microsoft.com/office/drawing/2014/main" id="{C0DEFAC9-EF02-4B42-B474-17FA97D60021}"/>
+              </a:ext>
+            </a:extLst>
+          </p:cNvPr>
+          <p:cNvSpPr>
+            <a:spLocks noGrp="1"/>
+          </p:cNvSpPr>
+          <p:nvPr/>
+        </p:nvSpPr>
+        <p:spPr>
+          <a:xfrm>
+            <a:off x="1517904" y="14886432"/>
+            <a:ext cx="8564270" cy="822960"/>
+          </a:xfrm>
+          <a:prstGeom prst="rect">
+            <a:avLst/>
+          </a:prstGeom>
+          <a:noFill/>
+          <a:ln w="0">
+            <a:noFill/>
+          </a:ln>
+        </p:spPr>
+        <p:txBody>
+          <a:bodyPr lIns="114300" tIns="76200" rIns="114300" bIns="76200" anchor="ctr"/>
+          <a:lstStyle>
+            <a:defPPr algn="ctr">
+              <a:defRPr sz="3100" b="1">
+                <a:solidFill>
+                  <a:srgbClr val="073463"/>
+                </a:solidFill>
+                <a:latin typeface="Aptos"/>
+              </a:defRPr>
+            </a:defPPr>
+          </a:lstStyle>
+          <a:p>
+            <a:pPr algn="ctr">
+              <a:defRPr sz="3100" b="1">
+                <a:solidFill>
+                  <a:srgbClr val="073463"/>
+                </a:solidFill>
+                <a:latin typeface="Aptos"/>
+              </a:defRPr>
+            </a:pPr>
+            <a:r>
+              <a:rPr sz="3100" b="1">
+                <a:solidFill>
+                  <a:srgbClr val="073463"/>
+                </a:solidFill>
+                <a:latin typeface="Aptos"/>
+              </a:rPr>
+              <a:t>234 expanded-sample objects</a:t>
+            </a:r>
+          </a:p>
+        </p:txBody>
+      </p:sp>
+      <p:sp>
+        <p:nvSpPr>
+          <p:cNvPr id="207" name="Poster diagram 207">
+            <a:extLst>
+              <a:ext uri="{FF2B5EF4-FFF2-40B4-BE49-F238E27FC236}">
+                <a16:creationId xmlns:a16="http://schemas.microsoft.com/office/drawing/2014/main" id="{0810806D-B188-4E18-8185-C1F9716B0663}"/>
+              </a:ext>
+            </a:extLst>
+          </p:cNvPr>
+          <p:cNvSpPr>
+            <a:spLocks noGrp="1"/>
+          </p:cNvSpPr>
+          <p:nvPr/>
+        </p:nvSpPr>
+        <p:spPr>
+          <a:xfrm>
+            <a:off x="1645920" y="15892272"/>
+            <a:ext cx="8308238" cy="1261872"/>
+          </a:xfrm>
+          <a:prstGeom prst="rect">
+            <a:avLst/>
+          </a:prstGeom>
+          <a:solidFill>
+            <a:srgbClr val="F1F4F7"/>
+          </a:solidFill>
+          <a:ln w="0">
+            <a:noFill/>
+          </a:ln>
+        </p:spPr>
+        <p:txBody>
+          <a:bodyPr lIns="114300" tIns="76200" rIns="114300" bIns="76200" anchor="ctr"/>
+          <a:lstStyle>
+            <a:defPPr algn="ctr">
+              <a:defRPr sz="3000" b="1">
+                <a:solidFill>
+                  <a:srgbClr val="111111"/>
+                </a:solidFill>
+                <a:latin typeface="Aptos"/>
+              </a:defRPr>
+            </a:defPPr>
+          </a:lstStyle>
+          <a:p>
+            <a:pPr algn="ctr">
+              <a:defRPr sz="3000" b="1">
+                <a:solidFill>
+                  <a:srgbClr val="111111"/>
+                </a:solidFill>
+                <a:latin typeface="Aptos"/>
+              </a:defRPr>
+            </a:pPr>
+            <a:r>
+              <a:rPr sz="3000" b="1">
+                <a:solidFill>
+                  <a:srgbClr val="111111"/>
+                </a:solidFill>
+                <a:latin typeface="Aptos"/>
+              </a:rPr>
+              <a:t>220 primary</a:t>
+            </a:r>
+          </a:p>
+          <a:p>
+            <a:pPr algn="ctr">
+              <a:defRPr sz="3000" b="1">
+                <a:solidFill>
+                  <a:srgbClr val="111111"/>
+                </a:solidFill>
+                <a:latin typeface="Aptos"/>
+              </a:defRPr>
+            </a:pPr>
+            <a:r>
+              <a:rPr sz="3000" b="1">
+                <a:solidFill>
+                  <a:srgbClr val="111111"/>
+                </a:solidFill>
+                <a:latin typeface="Aptos"/>
+              </a:rPr>
+              <a:t>Broad hydrogen (Balmer) line masses</a:t>
+            </a:r>
+          </a:p>
+        </p:txBody>
+      </p:sp>
+      <p:sp>
+        <p:nvSpPr>
+          <p:cNvPr id="208" name="Poster diagram 208">
+            <a:extLst>
+              <a:ext uri="{FF2B5EF4-FFF2-40B4-BE49-F238E27FC236}">
+                <a16:creationId xmlns:a16="http://schemas.microsoft.com/office/drawing/2014/main" id="{FAA325B6-AF3F-4391-B001-5CEA6C0D3BA1}"/>
+              </a:ext>
+            </a:extLst>
+          </p:cNvPr>
+          <p:cNvSpPr>
+            <a:spLocks noGrp="1"/>
+          </p:cNvSpPr>
+          <p:nvPr/>
+        </p:nvSpPr>
+        <p:spPr>
+          <a:xfrm>
+            <a:off x="1645920" y="17309592"/>
+            <a:ext cx="8308238" cy="1920240"/>
+          </a:xfrm>
+          <a:prstGeom prst="rect">
+            <a:avLst/>
+          </a:prstGeom>
+          <a:solidFill>
+            <a:srgbClr val="F4F0F8"/>
+          </a:solidFill>
+          <a:ln w="0">
+            <a:noFill/>
+          </a:ln>
+        </p:spPr>
+        <p:txBody>
+          <a:bodyPr lIns="114300" tIns="76200" rIns="114300" bIns="76200" anchor="ctr"/>
+          <a:lstStyle>
+            <a:defPPr algn="ctr">
+              <a:defRPr sz="2700" b="0">
+                <a:solidFill>
+                  <a:srgbClr val="111111"/>
+                </a:solidFill>
+                <a:latin typeface="Aptos"/>
+              </a:defRPr>
+            </a:defPPr>
+          </a:lstStyle>
+          <a:p>
+            <a:pPr algn="ctr">
+              <a:defRPr sz="2700" b="0">
+                <a:solidFill>
+                  <a:srgbClr val="111111"/>
+                </a:solidFill>
+                <a:latin typeface="Aptos"/>
+              </a:defRPr>
+            </a:pPr>
+            <a:r>
+              <a:rPr sz="2700" b="0">
+                <a:solidFill>
+                  <a:srgbClr val="111111"/>
+                </a:solidFill>
+                <a:latin typeface="Aptos"/>
+              </a:rPr>
+              <a:t>14 additional</a:t>
+            </a:r>
+          </a:p>
+          <a:p>
+            <a:pPr algn="ctr">
+              <a:defRPr sz="2700" b="0">
+                <a:solidFill>
+                  <a:srgbClr val="111111"/>
+                </a:solidFill>
+                <a:latin typeface="Aptos"/>
+              </a:defRPr>
+            </a:pPr>
+            <a:r>
+              <a:rPr sz="2700" b="0">
+                <a:solidFill>
+                  <a:srgbClr val="111111"/>
+                </a:solidFill>
+                <a:latin typeface="Aptos"/>
+              </a:rPr>
+              <a:t>7 masses conditional on a broad-line-region interpretation</a:t>
+            </a:r>
+          </a:p>
+          <a:p>
+            <a:pPr algn="ctr">
+              <a:defRPr sz="2700" b="0">
+                <a:solidFill>
+                  <a:srgbClr val="111111"/>
+                </a:solidFill>
+                <a:latin typeface="Aptos"/>
+              </a:defRPr>
+            </a:pPr>
+            <a:r>
+              <a:rPr sz="2700" b="0">
+                <a:solidFill>
+                  <a:srgbClr val="111111"/>
+                </a:solidFill>
+                <a:latin typeface="Aptos"/>
+              </a:rPr>
+              <a:t>6 tentative broad-line detections</a:t>
+            </a:r>
+          </a:p>
+          <a:p>
+            <a:pPr algn="ctr">
+              <a:defRPr sz="2700" b="0">
+                <a:solidFill>
+                  <a:srgbClr val="111111"/>
+                </a:solidFill>
+                <a:latin typeface="Aptos"/>
+              </a:defRPr>
+            </a:pPr>
+            <a:r>
+              <a:rPr sz="2700" b="0">
+                <a:solidFill>
+                  <a:srgbClr val="111111"/>
+                </a:solidFill>
+                <a:latin typeface="Aptos"/>
+              </a:rPr>
+              <a:t>GN-z11: ultraviolet-line mass [2]</a:t>
+            </a:r>
+          </a:p>
+        </p:txBody>
+      </p:sp>
+      <p:sp>
+        <p:nvSpPr>
+          <p:cNvPr id="209" name="Poster diagram 209">
+            <a:extLst>
+              <a:ext uri="{FF2B5EF4-FFF2-40B4-BE49-F238E27FC236}">
+                <a16:creationId xmlns:a16="http://schemas.microsoft.com/office/drawing/2014/main" id="{67E72EF7-28FB-420D-A9DC-6606EEB93072}"/>
+              </a:ext>
+            </a:extLst>
+          </p:cNvPr>
+          <p:cNvSpPr>
+            <a:spLocks noGrp="1"/>
+          </p:cNvSpPr>
+          <p:nvPr/>
+        </p:nvSpPr>
+        <p:spPr>
+          <a:xfrm>
+            <a:off x="10548518" y="14813280"/>
+            <a:ext cx="4904842" cy="4709160"/>
+          </a:xfrm>
+          <a:prstGeom prst="rect">
+            <a:avLst/>
+          </a:prstGeom>
+          <a:solidFill>
+            <a:srgbClr val="F5F5F5"/>
+          </a:solidFill>
+          <a:ln w="17145">
+            <a:solidFill>
+              <a:srgbClr val="AAAEB3"/>
+            </a:solidFill>
+          </a:ln>
+        </p:spPr>
+        <p:txBody>
+          <a:bodyPr lIns="114300" tIns="76200" rIns="114300" bIns="76200" anchor="ctr"/>
+          <a:lstStyle>
+            <a:defPPr algn="ctr">
+              <a:defRPr sz="2900" b="0">
+                <a:solidFill>
+                  <a:srgbClr val="111111"/>
+                </a:solidFill>
+                <a:latin typeface="Aptos"/>
+              </a:defRPr>
+            </a:defPPr>
+          </a:lstStyle>
+          <a:p>
+            <a:pPr algn="ctr">
+              <a:defRPr sz="2900" b="0">
+                <a:solidFill>
+                  <a:srgbClr val="111111"/>
+                </a:solidFill>
+                <a:latin typeface="Aptos"/>
+              </a:defRPr>
+            </a:pPr>
+            <a:r>
+              <a:rPr sz="2900" b="0">
+                <a:solidFill>
+                  <a:srgbClr val="111111"/>
+                </a:solidFill>
+                <a:latin typeface="Aptos"/>
+              </a:rPr>
+              <a:t>Outside the</a:t>
+            </a:r>
+          </a:p>
+          <a:p>
+            <a:pPr algn="ctr">
+              <a:defRPr sz="2900" b="0">
+                <a:solidFill>
+                  <a:srgbClr val="111111"/>
+                </a:solidFill>
+                <a:latin typeface="Aptos"/>
+              </a:defRPr>
+            </a:pPr>
+            <a:r>
+              <a:rPr sz="2900" b="0">
+                <a:solidFill>
+                  <a:srgbClr val="111111"/>
+                </a:solidFill>
+                <a:latin typeface="Aptos"/>
+              </a:rPr>
+              <a:t>growth sample</a:t>
+            </a:r>
+          </a:p>
+          <a:p>
+            <a:r>
+              <a:rPr sz="2900">
+                <a:latin typeface="Aptos"/>
+              </a:rPr>
+              <a:t/>
+            </a:r>
+          </a:p>
+          <a:p>
+            <a:pPr algn="ctr">
+              <a:defRPr sz="2900" b="0">
+                <a:solidFill>
+                  <a:srgbClr val="111111"/>
+                </a:solidFill>
+                <a:latin typeface="Aptos"/>
+              </a:defRPr>
+            </a:pPr>
+            <a:r>
+              <a:rPr sz="2900" b="0">
+                <a:solidFill>
+                  <a:srgbClr val="111111"/>
+                </a:solidFill>
+                <a:latin typeface="Aptos"/>
+              </a:rPr>
+              <a:t>98 without an</a:t>
+            </a:r>
+          </a:p>
+          <a:p>
+            <a:pPr algn="ctr">
+              <a:defRPr sz="2900" b="0">
+                <a:solidFill>
+                  <a:srgbClr val="111111"/>
+                </a:solidFill>
+                <a:latin typeface="Aptos"/>
+              </a:defRPr>
+            </a:pPr>
+            <a:r>
+              <a:rPr sz="2900" b="0">
+                <a:solidFill>
+                  <a:srgbClr val="111111"/>
+                </a:solidFill>
+                <a:latin typeface="Aptos"/>
+              </a:rPr>
+              <a:t>eligible mass</a:t>
+            </a:r>
+          </a:p>
+          <a:p>
+            <a:r>
+              <a:rPr sz="2900">
+                <a:latin typeface="Aptos"/>
+              </a:rPr>
+              <a:t/>
+            </a:r>
+          </a:p>
+          <a:p>
+            <a:pPr algn="ctr">
+              <a:defRPr sz="2900" b="0">
+                <a:solidFill>
+                  <a:srgbClr val="111111"/>
+                </a:solidFill>
+                <a:latin typeface="Aptos"/>
+              </a:defRPr>
+            </a:pPr>
+            <a:r>
+              <a:rPr sz="2900" b="0">
+                <a:solidFill>
+                  <a:srgbClr val="111111"/>
+                </a:solidFill>
+                <a:latin typeface="Aptos"/>
+              </a:rPr>
+              <a:t>6 with uncertain</a:t>
+            </a:r>
+          </a:p>
+          <a:p>
+            <a:pPr algn="ctr">
+              <a:defRPr sz="2900" b="0">
+                <a:solidFill>
+                  <a:srgbClr val="111111"/>
+                </a:solidFill>
+                <a:latin typeface="Aptos"/>
+              </a:defRPr>
+            </a:pPr>
+            <a:r>
+              <a:rPr sz="2900" b="0">
+                <a:solidFill>
+                  <a:srgbClr val="111111"/>
+                </a:solidFill>
+                <a:latin typeface="Aptos"/>
+              </a:rPr>
+              <a:t>identity</a:t>
+            </a:r>
+          </a:p>
+        </p:txBody>
+      </p:sp>
+      <p:sp>
+        <p:nvSpPr>
+          <p:cNvPr id="210" name="Poster diagram 210">
+            <a:extLst>
+              <a:ext uri="{FF2B5EF4-FFF2-40B4-BE49-F238E27FC236}">
+                <a16:creationId xmlns:a16="http://schemas.microsoft.com/office/drawing/2014/main" id="{7A12F45B-766A-479C-A513-DC305E768B18}"/>
+              </a:ext>
+            </a:extLst>
+          </p:cNvPr>
+          <p:cNvSpPr>
+            <a:spLocks noGrp="1"/>
+          </p:cNvSpPr>
+          <p:nvPr/>
+        </p:nvSpPr>
+        <p:spPr>
+          <a:xfrm>
+            <a:off x="1371600" y="26471880"/>
+            <a:ext cx="14173200" cy="1051560"/>
+          </a:xfrm>
+          <a:prstGeom prst="rect">
+            <a:avLst/>
+          </a:prstGeom>
+          <a:noFill/>
+          <a:ln w="0">
+            <a:noFill/>
+          </a:ln>
+        </p:spPr>
+        <p:txBody>
+          <a:bodyPr lIns="114300" tIns="76200" rIns="114300" bIns="76200" anchor="ctr"/>
+          <a:lstStyle>
+            <a:defPPr algn="ctr">
+              <a:defRPr sz="3000" b="1">
+                <a:solidFill>
+                  <a:srgbClr val="111111"/>
+                </a:solidFill>
+                <a:latin typeface="Aptos"/>
+              </a:defRPr>
+            </a:defPPr>
+          </a:lstStyle>
+          <a:p>
+            <a:pPr algn="ctr">
+              <a:defRPr sz="3000" b="1">
+                <a:solidFill>
+                  <a:srgbClr val="111111"/>
+                </a:solidFill>
+                <a:latin typeface="Aptos"/>
+              </a:defRPr>
+            </a:pPr>
+            <a:r>
+              <a:rPr sz="3000" b="1">
+                <a:solidFill>
+                  <a:srgbClr val="111111"/>
+                </a:solidFill>
+                <a:latin typeface="Aptos"/>
+              </a:rPr>
+              <a:t>Standardized mass, redshift and reported errors</a:t>
+            </a:r>
+          </a:p>
+          <a:p>
+            <a:pPr algn="ctr">
+              <a:defRPr sz="3000" b="1">
+                <a:solidFill>
+                  <a:srgbClr val="111111"/>
+                </a:solidFill>
+                <a:latin typeface="Aptos"/>
+              </a:defRPr>
+            </a:pPr>
+            <a:r>
+              <a:rPr sz="3000" b="1">
+                <a:solidFill>
+                  <a:srgbClr val="111111"/>
+                </a:solidFill>
+                <a:latin typeface="Aptos"/>
+              </a:rPr>
+              <a:t>Checked identity, adopted one mass per object, retained alternatives</a:t>
+            </a:r>
+          </a:p>
+        </p:txBody>
+      </p:sp>
+      <p:sp>
+        <p:nvSpPr>
+          <p:cNvPr id="211" name="Poster diagram 211">
+            <a:extLst>
+              <a:ext uri="{FF2B5EF4-FFF2-40B4-BE49-F238E27FC236}">
+                <a16:creationId xmlns:a16="http://schemas.microsoft.com/office/drawing/2014/main" id="{7CA63206-32AF-4739-9D5D-3109B2CFE243}"/>
+              </a:ext>
+            </a:extLst>
+          </p:cNvPr>
+          <p:cNvSpPr>
+            <a:spLocks noGrp="1"/>
+          </p:cNvSpPr>
+          <p:nvPr/>
+        </p:nvSpPr>
+        <p:spPr>
+          <a:xfrm>
+            <a:off x="4604004" y="27569160"/>
+            <a:ext cx="347472" cy="329184"/>
+          </a:xfrm>
+          <a:prstGeom prst="downArrow">
+            <a:avLst/>
+          </a:prstGeom>
+          <a:solidFill>
+            <a:srgbClr val="526477"/>
+          </a:solidFill>
+          <a:ln w="0">
+            <a:noFill/>
+          </a:ln>
+        </p:spPr>
+      </p:sp>
+      <p:sp>
+        <p:nvSpPr>
+          <p:cNvPr id="212" name="Poster diagram 212">
+            <a:extLst>
+              <a:ext uri="{FF2B5EF4-FFF2-40B4-BE49-F238E27FC236}">
+                <a16:creationId xmlns:a16="http://schemas.microsoft.com/office/drawing/2014/main" id="{F0E4059E-8B12-4811-AB13-DD1F53C26AA3}"/>
+              </a:ext>
+            </a:extLst>
+          </p:cNvPr>
+          <p:cNvSpPr>
+            <a:spLocks noGrp="1"/>
+          </p:cNvSpPr>
+          <p:nvPr/>
+        </p:nvSpPr>
+        <p:spPr>
+          <a:xfrm>
+            <a:off x="11964924" y="27569160"/>
+            <a:ext cx="347472" cy="329184"/>
+          </a:xfrm>
+          <a:prstGeom prst="downArrow">
+            <a:avLst/>
+          </a:prstGeom>
+          <a:solidFill>
+            <a:srgbClr val="526477"/>
+          </a:solidFill>
+          <a:ln w="0">
+            <a:noFill/>
+          </a:ln>
+        </p:spPr>
+      </p:sp>
+      <p:sp>
+        <p:nvSpPr>
+          <p:cNvPr id="213" name="Poster diagram 213">
+            <a:extLst>
+              <a:ext uri="{FF2B5EF4-FFF2-40B4-BE49-F238E27FC236}">
+                <a16:creationId xmlns:a16="http://schemas.microsoft.com/office/drawing/2014/main" id="{58F78FE0-91A9-45C2-B422-70C8CA0D6647}"/>
+              </a:ext>
+            </a:extLst>
+          </p:cNvPr>
+          <p:cNvSpPr>
+            <a:spLocks noGrp="1"/>
+          </p:cNvSpPr>
+          <p:nvPr/>
+        </p:nvSpPr>
+        <p:spPr>
+          <a:xfrm>
+            <a:off x="1371600" y="28044648"/>
+            <a:ext cx="6812280" cy="914400"/>
+          </a:xfrm>
+          <a:prstGeom prst="rect">
+            <a:avLst/>
+          </a:prstGeom>
+          <a:solidFill>
+            <a:srgbClr val="F1F4F7"/>
+          </a:solidFill>
+          <a:ln w="17145">
+            <a:solidFill>
+              <a:srgbClr val="526477"/>
+            </a:solidFill>
+          </a:ln>
+        </p:spPr>
+        <p:txBody>
+          <a:bodyPr lIns="114300" tIns="76200" rIns="114300" bIns="76200" anchor="ctr"/>
+          <a:lstStyle>
+            <a:defPPr algn="ctr">
+              <a:defRPr sz="3000" b="0">
+                <a:solidFill>
+                  <a:srgbClr val="111111"/>
+                </a:solidFill>
+                <a:latin typeface="Aptos"/>
+              </a:defRPr>
+            </a:defPPr>
+          </a:lstStyle>
+          <a:p>
+            <a:pPr algn="ctr">
+              <a:defRPr sz="3000" b="0">
+                <a:solidFill>
+                  <a:srgbClr val="111111"/>
+                </a:solidFill>
+                <a:latin typeface="Aptos"/>
+              </a:defRPr>
+            </a:pPr>
+            <a:r>
+              <a:rPr sz="3000" b="0">
+                <a:solidFill>
+                  <a:srgbClr val="111111"/>
+                </a:solidFill>
+                <a:latin typeface="Aptos"/>
+              </a:rPr>
+              <a:t>Central mass estimate</a:t>
+            </a:r>
+          </a:p>
+        </p:txBody>
+      </p:sp>
+      <p:sp>
+        <p:nvSpPr>
+          <p:cNvPr id="214" name="Poster diagram 214">
+            <a:extLst>
+              <a:ext uri="{FF2B5EF4-FFF2-40B4-BE49-F238E27FC236}">
+                <a16:creationId xmlns:a16="http://schemas.microsoft.com/office/drawing/2014/main" id="{E0DF1478-840F-4BDD-B29E-A5B229B3783E}"/>
+              </a:ext>
+            </a:extLst>
+          </p:cNvPr>
+          <p:cNvSpPr>
+            <a:spLocks noGrp="1"/>
+          </p:cNvSpPr>
+          <p:nvPr/>
+        </p:nvSpPr>
+        <p:spPr>
+          <a:xfrm>
+            <a:off x="8732520" y="28044648"/>
+            <a:ext cx="6812280" cy="914400"/>
+          </a:xfrm>
+          <a:prstGeom prst="rect">
+            <a:avLst/>
+          </a:prstGeom>
+          <a:solidFill>
+            <a:srgbClr val="F1F4F7"/>
+          </a:solidFill>
+          <a:ln w="17145">
+            <a:solidFill>
+              <a:srgbClr val="526477"/>
+            </a:solidFill>
+          </a:ln>
+        </p:spPr>
+        <p:txBody>
+          <a:bodyPr lIns="114300" tIns="76200" rIns="114300" bIns="76200" anchor="ctr"/>
+          <a:lstStyle>
+            <a:defPPr algn="ctr">
+              <a:defRPr sz="2800" b="0">
+                <a:solidFill>
+                  <a:srgbClr val="111111"/>
+                </a:solidFill>
+                <a:latin typeface="Aptos"/>
+              </a:defRPr>
+            </a:defPPr>
+          </a:lstStyle>
+          <a:p>
+            <a:pPr algn="ctr">
+              <a:defRPr sz="2800" b="0">
+                <a:solidFill>
+                  <a:srgbClr val="111111"/>
+                </a:solidFill>
+                <a:latin typeface="Aptos"/>
+              </a:defRPr>
+            </a:pPr>
+            <a:r>
+              <a:rPr sz="2800" b="0">
+                <a:solidFill>
+                  <a:srgbClr val="111111"/>
+                </a:solidFill>
+                <a:latin typeface="Aptos"/>
+              </a:rPr>
+              <a:t>10,000 mass-error draws</a:t>
+            </a:r>
+          </a:p>
+          <a:p>
+            <a:pPr algn="ctr">
+              <a:defRPr sz="2800" b="0">
+                <a:solidFill>
+                  <a:srgbClr val="111111"/>
+                </a:solidFill>
+                <a:latin typeface="Aptos"/>
+              </a:defRPr>
+            </a:pPr>
+            <a:r>
+              <a:rPr sz="2800" b="0">
+                <a:solidFill>
+                  <a:srgbClr val="111111"/>
+                </a:solidFill>
+                <a:latin typeface="Aptos"/>
+              </a:rPr>
+              <a:t>per object with reported errors</a:t>
+            </a:r>
+          </a:p>
+        </p:txBody>
+      </p:sp>
+      <p:sp>
+        <p:nvSpPr>
+          <p:cNvPr id="215" name="Poster diagram 215">
+            <a:extLst>
+              <a:ext uri="{FF2B5EF4-FFF2-40B4-BE49-F238E27FC236}">
+                <a16:creationId xmlns:a16="http://schemas.microsoft.com/office/drawing/2014/main" id="{F3106931-3BF4-4F12-9726-6C63FA258C0A}"/>
+              </a:ext>
+            </a:extLst>
+          </p:cNvPr>
+          <p:cNvSpPr>
+            <a:spLocks noGrp="1"/>
+          </p:cNvSpPr>
+          <p:nvPr/>
+        </p:nvSpPr>
+        <p:spPr>
+          <a:xfrm>
+            <a:off x="4604004" y="29096208"/>
+            <a:ext cx="347472" cy="329184"/>
+          </a:xfrm>
+          <a:prstGeom prst="downArrow">
+            <a:avLst/>
+          </a:prstGeom>
+          <a:solidFill>
+            <a:srgbClr val="526477"/>
+          </a:solidFill>
+          <a:ln w="0">
+            <a:noFill/>
+          </a:ln>
+        </p:spPr>
+      </p:sp>
+      <p:sp>
+        <p:nvSpPr>
+          <p:cNvPr id="216" name="Poster diagram 216">
+            <a:extLst>
+              <a:ext uri="{FF2B5EF4-FFF2-40B4-BE49-F238E27FC236}">
+                <a16:creationId xmlns:a16="http://schemas.microsoft.com/office/drawing/2014/main" id="{336C5316-EC48-42CE-8537-8453628B7D8C}"/>
+              </a:ext>
+            </a:extLst>
+          </p:cNvPr>
+          <p:cNvSpPr>
+            <a:spLocks noGrp="1"/>
+          </p:cNvSpPr>
+          <p:nvPr/>
+        </p:nvSpPr>
+        <p:spPr>
+          <a:xfrm>
+            <a:off x="11964924" y="29096208"/>
+            <a:ext cx="347472" cy="329184"/>
+          </a:xfrm>
+          <a:prstGeom prst="downArrow">
+            <a:avLst/>
+          </a:prstGeom>
+          <a:solidFill>
+            <a:srgbClr val="526477"/>
+          </a:solidFill>
+          <a:ln w="0">
+            <a:noFill/>
+          </a:ln>
+        </p:spPr>
+      </p:sp>
+      <p:sp>
+        <p:nvSpPr>
+          <p:cNvPr id="217" name="Poster diagram 217">
+            <a:extLst>
+              <a:ext uri="{FF2B5EF4-FFF2-40B4-BE49-F238E27FC236}">
+                <a16:creationId xmlns:a16="http://schemas.microsoft.com/office/drawing/2014/main" id="{971DBA1A-D2E6-408F-AF7C-16AF667673EA}"/>
+              </a:ext>
+            </a:extLst>
+          </p:cNvPr>
+          <p:cNvSpPr>
+            <a:spLocks noGrp="1"/>
+          </p:cNvSpPr>
+          <p:nvPr/>
+        </p:nvSpPr>
+        <p:spPr>
+          <a:xfrm>
+            <a:off x="1371600" y="29599128"/>
+            <a:ext cx="14173200" cy="2057400"/>
+          </a:xfrm>
+          <a:prstGeom prst="rect">
+            <a:avLst/>
+          </a:prstGeom>
+          <a:solidFill>
+            <a:srgbClr val="EAF1F8"/>
+          </a:solidFill>
+          <a:ln w="17145">
+            <a:solidFill>
+              <a:srgbClr val="073463"/>
+            </a:solidFill>
+          </a:ln>
+        </p:spPr>
+        <p:txBody>
+          <a:bodyPr lIns="114300" tIns="76200" rIns="114300" bIns="76200" anchor="t"/>
+          <a:lstStyle>
+            <a:defPPr algn="ctr">
+              <a:defRPr sz="3100" b="1">
+                <a:solidFill>
+                  <a:srgbClr val="111111"/>
+                </a:solidFill>
+                <a:latin typeface="Aptos"/>
+              </a:defRPr>
+            </a:defPPr>
+          </a:lstStyle>
+          <a:p>
+            <a:pPr algn="ctr">
+              <a:defRPr sz="3100" b="1">
+                <a:solidFill>
+                  <a:srgbClr val="111111"/>
+                </a:solidFill>
+                <a:latin typeface="Aptos"/>
+              </a:defRPr>
+            </a:pPr>
+            <a:r>
+              <a:rPr sz="3100" b="1">
+                <a:solidFill>
+                  <a:srgbClr val="111111"/>
+                </a:solidFill>
+                <a:latin typeface="Aptos"/>
+              </a:rPr>
+              <a:t>Calculated the required lifetime-average</a:t>
+            </a:r>
+          </a:p>
+          <a:p>
+            <a:pPr algn="ctr">
+              <a:defRPr sz="3100" b="1">
+                <a:solidFill>
+                  <a:srgbClr val="111111"/>
+                </a:solidFill>
+                <a:latin typeface="Aptos"/>
+              </a:defRPr>
+            </a:pPr>
+            <a:r>
+              <a:rPr sz="3100" b="1">
+                <a:solidFill>
+                  <a:srgbClr val="111111"/>
+                </a:solidFill>
+                <a:latin typeface="Aptos"/>
+              </a:rPr>
+              <a:t>Eddington ratio, including inactive periods</a:t>
+            </a:r>
+          </a:p>
+        </p:txBody>
+      </p:sp>
+      <p:sp>
+        <p:nvSpPr>
+          <p:cNvPr id="218" name="Poster diagram 218">
+            <a:extLst>
+              <a:ext uri="{FF2B5EF4-FFF2-40B4-BE49-F238E27FC236}">
+                <a16:creationId xmlns:a16="http://schemas.microsoft.com/office/drawing/2014/main" id="{C320C512-3791-4B48-9B61-7FD45A4601D4}"/>
+              </a:ext>
+            </a:extLst>
+          </p:cNvPr>
+          <p:cNvSpPr>
+            <a:spLocks noGrp="1"/>
+          </p:cNvSpPr>
+          <p:nvPr/>
+        </p:nvSpPr>
+        <p:spPr>
+          <a:xfrm>
+            <a:off x="1371600" y="30742128"/>
+            <a:ext cx="14173200" cy="914400"/>
+          </a:xfrm>
+          <a:prstGeom prst="rect">
+            <a:avLst/>
+          </a:prstGeom>
+          <a:noFill/>
+          <a:ln w="0">
+            <a:noFill/>
+          </a:ln>
+        </p:spPr>
+        <p:txBody>
+          <a:bodyPr lIns="114300" tIns="76200" rIns="114300" bIns="76200" anchor="ctr"/>
+          <a:lstStyle>
+            <a:defPPr algn="ctr">
+              <a:defRPr sz="3000" b="0">
+                <a:solidFill>
+                  <a:srgbClr val="111111"/>
+                </a:solidFill>
+                <a:latin typeface="Aptos"/>
+              </a:defRPr>
+            </a:defPPr>
+          </a:lstStyle>
+          <a:p>
+            <a:pPr algn="ctr">
+              <a:defRPr sz="3000" b="0">
+                <a:solidFill>
+                  <a:srgbClr val="111111"/>
+                </a:solidFill>
+                <a:latin typeface="Aptos"/>
+              </a:defRPr>
+            </a:pPr>
+            <a:r>
+              <a:rPr sz="3000" b="0">
+                <a:solidFill>
+                  <a:srgbClr val="111111"/>
+                </a:solidFill>
+                <a:latin typeface="Aptos"/>
+              </a:rPr>
+              <a:t>Reference: 100 M⊙ seeds at z = 30</a:t>
+            </a:r>
+          </a:p>
+          <a:p>
+            <a:pPr algn="ctr">
+              <a:defRPr sz="3000" b="0">
+                <a:solidFill>
+                  <a:srgbClr val="111111"/>
+                </a:solidFill>
+                <a:latin typeface="Aptos"/>
+              </a:defRPr>
+            </a:pPr>
+            <a:r>
+              <a:rPr sz="3000" b="0">
+                <a:solidFill>
+                  <a:srgbClr val="111111"/>
+                </a:solidFill>
+                <a:latin typeface="Aptos"/>
+              </a:rPr>
+              <a:t>ε = 0.1, no mergers [3]</a:t>
+            </a:r>
+          </a:p>
+        </p:txBody>
+      </p:sp>
+      <p:sp>
+        <p:nvSpPr>
+          <p:cNvPr id="219" name="Poster diagram 219">
+            <a:extLst>
+              <a:ext uri="{FF2B5EF4-FFF2-40B4-BE49-F238E27FC236}">
+                <a16:creationId xmlns:a16="http://schemas.microsoft.com/office/drawing/2014/main" id="{A3C5BCD3-C05E-4CC3-AF1A-0840F4394EE3}"/>
+              </a:ext>
+            </a:extLst>
+          </p:cNvPr>
+          <p:cNvSpPr>
+            <a:spLocks noGrp="1"/>
+          </p:cNvSpPr>
+          <p:nvPr/>
+        </p:nvSpPr>
+        <p:spPr>
+          <a:xfrm>
+            <a:off x="4604004" y="31757112"/>
+            <a:ext cx="347472" cy="329184"/>
+          </a:xfrm>
+          <a:prstGeom prst="downArrow">
+            <a:avLst/>
+          </a:prstGeom>
+          <a:solidFill>
+            <a:srgbClr val="526477"/>
+          </a:solidFill>
+          <a:ln w="0">
+            <a:noFill/>
+          </a:ln>
+        </p:spPr>
+      </p:sp>
+      <p:sp>
+        <p:nvSpPr>
+          <p:cNvPr id="220" name="Poster diagram 220">
+            <a:extLst>
+              <a:ext uri="{FF2B5EF4-FFF2-40B4-BE49-F238E27FC236}">
+                <a16:creationId xmlns:a16="http://schemas.microsoft.com/office/drawing/2014/main" id="{8529AA9E-ACC8-495E-8075-1D2F4EF9602E}"/>
+              </a:ext>
+            </a:extLst>
+          </p:cNvPr>
+          <p:cNvSpPr>
+            <a:spLocks noGrp="1"/>
+          </p:cNvSpPr>
+          <p:nvPr/>
+        </p:nvSpPr>
+        <p:spPr>
+          <a:xfrm>
+            <a:off x="11964924" y="31757112"/>
+            <a:ext cx="347472" cy="329184"/>
+          </a:xfrm>
+          <a:prstGeom prst="downArrow">
+            <a:avLst/>
+          </a:prstGeom>
+          <a:solidFill>
+            <a:srgbClr val="526477"/>
+          </a:solidFill>
+          <a:ln w="0">
+            <a:noFill/>
+          </a:ln>
+        </p:spPr>
+      </p:sp>
+      <p:sp>
+        <p:nvSpPr>
+          <p:cNvPr id="221" name="Poster diagram 221">
+            <a:extLst>
+              <a:ext uri="{FF2B5EF4-FFF2-40B4-BE49-F238E27FC236}">
+                <a16:creationId xmlns:a16="http://schemas.microsoft.com/office/drawing/2014/main" id="{03BB0CC6-89F0-4BB8-91C2-A18697FB4691}"/>
+              </a:ext>
+            </a:extLst>
+          </p:cNvPr>
+          <p:cNvSpPr>
+            <a:spLocks noGrp="1"/>
+          </p:cNvSpPr>
+          <p:nvPr/>
+        </p:nvSpPr>
+        <p:spPr>
+          <a:xfrm>
+            <a:off x="1371600" y="32232600"/>
+            <a:ext cx="6812280" cy="1143000"/>
+          </a:xfrm>
+          <a:prstGeom prst="rect">
+            <a:avLst/>
+          </a:prstGeom>
+          <a:solidFill>
+            <a:srgbClr val="F1F4F7"/>
+          </a:solidFill>
+          <a:ln w="17145">
+            <a:solidFill>
+              <a:srgbClr val="526477"/>
+            </a:solidFill>
+          </a:ln>
+        </p:spPr>
+        <p:txBody>
+          <a:bodyPr lIns="114300" tIns="76200" rIns="114300" bIns="76200" anchor="ctr"/>
+          <a:lstStyle>
+            <a:defPPr algn="ctr">
+              <a:defRPr sz="2900" b="0">
+                <a:solidFill>
+                  <a:srgbClr val="111111"/>
+                </a:solidFill>
+                <a:latin typeface="Aptos"/>
+              </a:defRPr>
+            </a:defPPr>
+          </a:lstStyle>
+          <a:p>
+            <a:pPr algn="ctr">
+              <a:defRPr sz="2900" b="0">
+                <a:solidFill>
+                  <a:srgbClr val="111111"/>
+                </a:solidFill>
+                <a:latin typeface="Aptos"/>
+              </a:defRPr>
+            </a:pPr>
+            <a:r>
+              <a:rPr sz="2900" b="0">
+                <a:solidFill>
+                  <a:srgbClr val="111111"/>
+                </a:solidFill>
+                <a:latin typeface="Aptos"/>
+              </a:rPr>
+              <a:t>Ranked central estimates</a:t>
+            </a:r>
+          </a:p>
+          <a:p>
+            <a:pPr algn="ctr">
+              <a:defRPr sz="2900" b="0">
+                <a:solidFill>
+                  <a:srgbClr val="111111"/>
+                </a:solidFill>
+                <a:latin typeface="Aptos"/>
+              </a:defRPr>
+            </a:pPr>
+            <a:r>
+              <a:rPr sz="2900" b="0">
+                <a:solidFill>
+                  <a:srgbClr val="111111"/>
+                </a:solidFill>
+                <a:latin typeface="Aptos"/>
+              </a:rPr>
+              <a:t>Compared required average with 1</a:t>
+            </a:r>
+          </a:p>
+        </p:txBody>
+      </p:sp>
+      <p:sp>
+        <p:nvSpPr>
+          <p:cNvPr id="222" name="Poster diagram 222">
+            <a:extLst>
+              <a:ext uri="{FF2B5EF4-FFF2-40B4-BE49-F238E27FC236}">
+                <a16:creationId xmlns:a16="http://schemas.microsoft.com/office/drawing/2014/main" id="{28773224-ED00-4347-B2C6-7FB30A5D9C9B}"/>
+              </a:ext>
+            </a:extLst>
+          </p:cNvPr>
+          <p:cNvSpPr>
+            <a:spLocks noGrp="1"/>
+          </p:cNvSpPr>
+          <p:nvPr/>
+        </p:nvSpPr>
+        <p:spPr>
+          <a:xfrm>
+            <a:off x="8732520" y="32232600"/>
+            <a:ext cx="6812280" cy="1143000"/>
+          </a:xfrm>
+          <a:prstGeom prst="rect">
+            <a:avLst/>
+          </a:prstGeom>
+          <a:solidFill>
+            <a:srgbClr val="F1F4F7"/>
+          </a:solidFill>
+          <a:ln w="17145">
+            <a:solidFill>
+              <a:srgbClr val="526477"/>
+            </a:solidFill>
+          </a:ln>
+        </p:spPr>
+        <p:txBody>
+          <a:bodyPr lIns="114300" tIns="76200" rIns="114300" bIns="76200" anchor="ctr"/>
+          <a:lstStyle>
+            <a:defPPr algn="ctr">
+              <a:defRPr sz="2900" b="0">
+                <a:solidFill>
+                  <a:srgbClr val="111111"/>
+                </a:solidFill>
+                <a:latin typeface="Aptos"/>
+              </a:defRPr>
+            </a:defPPr>
+          </a:lstStyle>
+          <a:p>
+            <a:pPr algn="ctr">
+              <a:defRPr sz="2900" b="0">
+                <a:solidFill>
+                  <a:srgbClr val="111111"/>
+                </a:solidFill>
+                <a:latin typeface="Aptos"/>
+              </a:defRPr>
+            </a:pPr>
+            <a:r>
+              <a:rPr sz="2900" b="0">
+                <a:solidFill>
+                  <a:srgbClr val="111111"/>
+                </a:solidFill>
+                <a:latin typeface="Aptos"/>
+              </a:rPr>
+              <a:t>Calculated the fraction of</a:t>
+            </a:r>
+          </a:p>
+          <a:p>
+            <a:pPr algn="ctr">
+              <a:defRPr sz="2900" b="0">
+                <a:solidFill>
+                  <a:srgbClr val="111111"/>
+                </a:solidFill>
+                <a:latin typeface="Aptos"/>
+              </a:defRPr>
+            </a:pPr>
+            <a:r>
+              <a:rPr sz="2900" b="0">
+                <a:solidFill>
+                  <a:srgbClr val="111111"/>
+                </a:solidFill>
+                <a:latin typeface="Aptos"/>
+              </a:rPr>
+              <a:t>mass-error draws above 1</a:t>
+            </a:r>
+          </a:p>
+        </p:txBody>
+      </p:sp>
+      <p:sp>
+        <p:nvSpPr>
+          <p:cNvPr id="223" name="Poster diagram 223">
+            <a:extLst>
+              <a:ext uri="{FF2B5EF4-FFF2-40B4-BE49-F238E27FC236}">
+                <a16:creationId xmlns:a16="http://schemas.microsoft.com/office/drawing/2014/main" id="{86A37956-8DA5-40AE-A03E-2CE429C5454A}"/>
+              </a:ext>
+            </a:extLst>
+          </p:cNvPr>
+          <p:cNvSpPr>
+            <a:spLocks noGrp="1"/>
+          </p:cNvSpPr>
+          <p:nvPr/>
+        </p:nvSpPr>
+        <p:spPr>
+          <a:xfrm>
+            <a:off x="1371600" y="33531048"/>
+            <a:ext cx="14173200" cy="1280160"/>
+          </a:xfrm>
+          <a:prstGeom prst="rect">
+            <a:avLst/>
+          </a:prstGeom>
+          <a:noFill/>
+          <a:ln w="0">
+            <a:noFill/>
+          </a:ln>
+        </p:spPr>
+        <p:txBody>
+          <a:bodyPr lIns="114300" tIns="76200" rIns="114300" bIns="76200" anchor="ctr"/>
+          <a:lstStyle>
+            <a:defPPr algn="ctr">
+              <a:defRPr sz="2700" b="0">
+                <a:solidFill>
+                  <a:srgbClr val="111111"/>
+                </a:solidFill>
+                <a:latin typeface="Aptos"/>
+              </a:defRPr>
+            </a:defPPr>
+          </a:lstStyle>
+          <a:p>
+            <a:pPr algn="ctr">
+              <a:defRPr sz="2700" b="0">
+                <a:solidFill>
+                  <a:srgbClr val="111111"/>
+                </a:solidFill>
+                <a:latin typeface="Aptos"/>
+              </a:defRPr>
+            </a:pPr>
+            <a:r>
+              <a:rPr sz="2700" b="0">
+                <a:solidFill>
+                  <a:srgbClr val="111111"/>
+                </a:solidFill>
+                <a:latin typeface="Aptos"/>
+              </a:rPr>
+              <a:t>Uncertainty: 208 primary / 222 expanded objects.</a:t>
+            </a:r>
+          </a:p>
+          <a:p>
+            <a:pPr algn="ctr">
+              <a:defRPr sz="2700" b="0">
+                <a:solidFill>
+                  <a:srgbClr val="111111"/>
+                </a:solidFill>
+                <a:latin typeface="Aptos"/>
+              </a:defRPr>
+            </a:pPr>
+            <a:r>
+              <a:rPr sz="2700" b="0">
+                <a:solidFill>
+                  <a:srgbClr val="111111"/>
+                </a:solidFill>
+                <a:latin typeface="Aptos"/>
+              </a:rPr>
+              <a:t>The other 12 enter central-mass tests only.</a:t>
+            </a:r>
+          </a:p>
+          <a:p>
+            <a:pPr algn="ctr">
+              <a:defRPr sz="2700" b="0">
+                <a:solidFill>
+                  <a:srgbClr val="111111"/>
+                </a:solidFill>
+                <a:latin typeface="Aptos"/>
+              </a:defRPr>
+            </a:pPr>
+            <a:r>
+              <a:rPr sz="2700" b="0">
+                <a:solidFill>
+                  <a:srgbClr val="111111"/>
+                </a:solidFill>
+                <a:latin typeface="Aptos"/>
+              </a:rPr>
+              <a:t>Reported errors may omit calibration scatter.</a:t>
+            </a:r>
+          </a:p>
+        </p:txBody>
+      </p:sp>
+      <p:sp>
+        <p:nvSpPr>
+          <p:cNvPr id="224" name="Poster diagram 224">
+            <a:extLst>
+              <a:ext uri="{FF2B5EF4-FFF2-40B4-BE49-F238E27FC236}">
+                <a16:creationId xmlns:a16="http://schemas.microsoft.com/office/drawing/2014/main" id="{39DA12D1-0D37-445A-9028-17994BB6BD07}"/>
+              </a:ext>
+            </a:extLst>
+          </p:cNvPr>
+          <p:cNvSpPr>
+            <a:spLocks noGrp="1"/>
+          </p:cNvSpPr>
+          <p:nvPr/>
+        </p:nvSpPr>
+        <p:spPr>
+          <a:xfrm>
+            <a:off x="1371600" y="34930080"/>
+            <a:ext cx="14173200" cy="1371600"/>
+          </a:xfrm>
+          <a:prstGeom prst="rect">
+            <a:avLst/>
+          </a:prstGeom>
+          <a:noFill/>
+          <a:ln w="0">
+            <a:noFill/>
+          </a:ln>
+        </p:spPr>
+        <p:txBody>
+          <a:bodyPr lIns="114300" tIns="76200" rIns="114300" bIns="76200" anchor="ctr"/>
+          <a:lstStyle>
+            <a:defPPr algn="ctr">
+              <a:defRPr sz="2700" b="0">
+                <a:solidFill>
+                  <a:srgbClr val="111111"/>
+                </a:solidFill>
+                <a:latin typeface="Aptos"/>
+              </a:defRPr>
+            </a:defPPr>
+          </a:lstStyle>
+          <a:p>
+            <a:pPr algn="ctr">
+              <a:defRPr sz="2700" b="0">
+                <a:solidFill>
+                  <a:srgbClr val="111111"/>
+                </a:solidFill>
+                <a:latin typeface="Aptos"/>
+              </a:defRPr>
+            </a:pPr>
+            <a:r>
+              <a:rPr sz="2700" b="0">
+                <a:solidFill>
+                  <a:srgbClr val="111111"/>
+                </a:solidFill>
+                <a:latin typeface="Aptos"/>
+              </a:rPr>
+              <a:t>Earlier growth: Inverted the growth law for 4 targets at</a:t>
+            </a:r>
+          </a:p>
+          <a:p>
+            <a:pPr algn="ctr">
+              <a:defRPr sz="2700" b="0">
+                <a:solidFill>
+                  <a:srgbClr val="111111"/>
+                </a:solidFill>
+                <a:latin typeface="Aptos"/>
+              </a:defRPr>
+            </a:pPr>
+            <a:r>
+              <a:rPr sz="2700" b="0">
+                <a:solidFill>
+                  <a:srgbClr val="111111"/>
+                </a:solidFill>
+                <a:latin typeface="Aptos"/>
+              </a:rPr>
+              <a:t>start redshifts 20–3,400. Included radiation in cosmic ages</a:t>
+            </a:r>
+          </a:p>
+          <a:p>
+            <a:pPr algn="ctr">
+              <a:defRPr sz="2700" b="0">
+                <a:solidFill>
+                  <a:srgbClr val="111111"/>
+                </a:solidFill>
+                <a:latin typeface="Aptos"/>
+              </a:defRPr>
+            </a:pPr>
+            <a:r>
+              <a:rPr sz="2700" b="0">
+                <a:solidFill>
+                  <a:srgbClr val="111111"/>
+                </a:solidFill>
+                <a:latin typeface="Aptos"/>
+              </a:rPr>
+              <a:t>and assumed gas was available.</a:t>
             </a:r>
           </a:p>
         </p:txBody>

</xml_diff>

<commit_message>
Restore overview poster narrative and consistent body formatting
</commit_message>
<xml_diff>
--- a/posters/36x48.pptx
+++ b/posters/36x48.pptx
@@ -5,11 +5,11 @@
     <p:sldMasterId id="2147483660" r:id="rId1"/>
   </p:sldMasterIdLst>
   <p:notesMasterIdLst>
-    <p:notesMasterId r:id="rId3"/>
+    <p:notesMasterId r:id="rId4"/>
   </p:notesMasterIdLst>
   <p:sldIdLst>
     <p:sldId id="260" r:id="rId2"/>
-    <p:sldId id="261" r:id="rIdOverview"/>
+    <p:sldId id="261" r:id="rId3"/>
   </p:sldIdLst>
   <p:sldSz cx="32918400" cy="43891200"/>
   <p:notesSz cx="6858000" cy="9144000"/>
@@ -130,7 +130,7 @@
   <pc:docChgLst>
     <pc:chgData name="Nicole Jiang" userId="09ef0fc0f6f473b5" providerId="LiveId" clId="{EB8F4A53-0964-5BF1-90AD-931457E28E1A}"/>
     <pc:docChg chg="undo redo custSel addSld delSld modSld">
-      <pc:chgData name="Nicole Jiang" userId="09ef0fc0f6f473b5" providerId="LiveId" clId="{EB8F4A53-0964-5BF1-90AD-931457E28E1A}" dt="2026-10-14T03:43:03.391" v="2688" actId="1076"/>
+      <pc:chgData name="Nicole Jiang" userId="09ef0fc0f6f473b5" providerId="LiveId" clId="{EB8F4A53-0964-5BF1-90AD-931457E28E1A}" dt="2026-10-14T18:47:41.278" v="2704" actId="1076"/>
       <pc:docMkLst>
         <pc:docMk/>
       </pc:docMkLst>
@@ -452,6 +452,117 @@
           </ac:picMkLst>
         </pc:picChg>
       </pc:sldChg>
+      <pc:sldChg chg="modSp mod">
+        <pc:chgData name="Nicole Jiang" userId="09ef0fc0f6f473b5" providerId="LiveId" clId="{EB8F4A53-0964-5BF1-90AD-931457E28E1A}" dt="2026-10-14T18:47:41.278" v="2704" actId="1076"/>
+        <pc:sldMkLst>
+          <pc:docMk/>
+          <pc:sldMk cId="868487171" sldId="261"/>
+        </pc:sldMkLst>
+        <pc:spChg chg="mod">
+          <ac:chgData name="Nicole Jiang" userId="09ef0fc0f6f473b5" providerId="LiveId" clId="{EB8F4A53-0964-5BF1-90AD-931457E28E1A}" dt="2026-10-14T18:45:31.649" v="2689" actId="14100"/>
+          <ac:spMkLst>
+            <pc:docMk/>
+            <pc:sldMk cId="868487171" sldId="261"/>
+            <ac:spMk id="74" creationId="{F5F0E6D1-7308-2846-C555-5A8981E84E43}"/>
+          </ac:spMkLst>
+        </pc:spChg>
+        <pc:spChg chg="mod">
+          <ac:chgData name="Nicole Jiang" userId="09ef0fc0f6f473b5" providerId="LiveId" clId="{EB8F4A53-0964-5BF1-90AD-931457E28E1A}" dt="2026-10-14T18:46:21.938" v="2690" actId="1076"/>
+          <ac:spMkLst>
+            <pc:docMk/>
+            <pc:sldMk cId="868487171" sldId="261"/>
+            <ac:spMk id="120" creationId="{3A05E1FE-512D-49F3-9C39-22D275F0EE18}"/>
+          </ac:spMkLst>
+        </pc:spChg>
+        <pc:spChg chg="mod">
+          <ac:chgData name="Nicole Jiang" userId="09ef0fc0f6f473b5" providerId="LiveId" clId="{EB8F4A53-0964-5BF1-90AD-931457E28E1A}" dt="2026-10-14T18:46:31.761" v="2693" actId="20577"/>
+          <ac:spMkLst>
+            <pc:docMk/>
+            <pc:sldMk cId="868487171" sldId="261"/>
+            <ac:spMk id="200" creationId="{F979C9B9-C3CA-480F-BB52-CC7D4B02CE22}"/>
+          </ac:spMkLst>
+        </pc:spChg>
+        <pc:spChg chg="mod">
+          <ac:chgData name="Nicole Jiang" userId="09ef0fc0f6f473b5" providerId="LiveId" clId="{EB8F4A53-0964-5BF1-90AD-931457E28E1A}" dt="2026-10-14T18:46:21.938" v="2690" actId="1076"/>
+          <ac:spMkLst>
+            <pc:docMk/>
+            <pc:sldMk cId="868487171" sldId="261"/>
+            <ac:spMk id="210" creationId="{7A12F45B-766A-479C-A513-DC305E768B18}"/>
+          </ac:spMkLst>
+        </pc:spChg>
+        <pc:spChg chg="mod">
+          <ac:chgData name="Nicole Jiang" userId="09ef0fc0f6f473b5" providerId="LiveId" clId="{EB8F4A53-0964-5BF1-90AD-931457E28E1A}" dt="2026-10-14T18:46:21.938" v="2690" actId="1076"/>
+          <ac:spMkLst>
+            <pc:docMk/>
+            <pc:sldMk cId="868487171" sldId="261"/>
+            <ac:spMk id="211" creationId="{7CA63206-32AF-4739-9D5D-3109B2CFE243}"/>
+          </ac:spMkLst>
+        </pc:spChg>
+        <pc:spChg chg="mod">
+          <ac:chgData name="Nicole Jiang" userId="09ef0fc0f6f473b5" providerId="LiveId" clId="{EB8F4A53-0964-5BF1-90AD-931457E28E1A}" dt="2026-10-14T18:46:21.938" v="2690" actId="1076"/>
+          <ac:spMkLst>
+            <pc:docMk/>
+            <pc:sldMk cId="868487171" sldId="261"/>
+            <ac:spMk id="212" creationId="{F0E4059E-8B12-4811-AB13-DD1F53C26AA3}"/>
+          </ac:spMkLst>
+        </pc:spChg>
+        <pc:spChg chg="mod">
+          <ac:chgData name="Nicole Jiang" userId="09ef0fc0f6f473b5" providerId="LiveId" clId="{EB8F4A53-0964-5BF1-90AD-931457E28E1A}" dt="2026-10-14T18:46:21.938" v="2690" actId="1076"/>
+          <ac:spMkLst>
+            <pc:docMk/>
+            <pc:sldMk cId="868487171" sldId="261"/>
+            <ac:spMk id="216" creationId="{336C5316-EC48-42CE-8537-8453628B7D8C}"/>
+          </ac:spMkLst>
+        </pc:spChg>
+        <pc:spChg chg="mod">
+          <ac:chgData name="Nicole Jiang" userId="09ef0fc0f6f473b5" providerId="LiveId" clId="{EB8F4A53-0964-5BF1-90AD-931457E28E1A}" dt="2026-10-14T18:46:21.938" v="2690" actId="1076"/>
+          <ac:spMkLst>
+            <pc:docMk/>
+            <pc:sldMk cId="868487171" sldId="261"/>
+            <ac:spMk id="217" creationId="{971DBA1A-D2E6-408F-AF7C-16AF667673EA}"/>
+          </ac:spMkLst>
+        </pc:spChg>
+        <pc:spChg chg="mod">
+          <ac:chgData name="Nicole Jiang" userId="09ef0fc0f6f473b5" providerId="LiveId" clId="{EB8F4A53-0964-5BF1-90AD-931457E28E1A}" dt="2026-10-14T18:47:07.676" v="2695" actId="1076"/>
+          <ac:spMkLst>
+            <pc:docMk/>
+            <pc:sldMk cId="868487171" sldId="261"/>
+            <ac:spMk id="218" creationId="{C320C512-3791-4B48-9B61-7FD45A4601D4}"/>
+          </ac:spMkLst>
+        </pc:spChg>
+        <pc:spChg chg="mod">
+          <ac:chgData name="Nicole Jiang" userId="09ef0fc0f6f473b5" providerId="LiveId" clId="{EB8F4A53-0964-5BF1-90AD-931457E28E1A}" dt="2026-10-14T18:46:21.938" v="2690" actId="1076"/>
+          <ac:spMkLst>
+            <pc:docMk/>
+            <pc:sldMk cId="868487171" sldId="261"/>
+            <ac:spMk id="219" creationId="{A3C5BCD3-C05E-4CC3-AF1A-0840F4394EE3}"/>
+          </ac:spMkLst>
+        </pc:spChg>
+        <pc:spChg chg="mod">
+          <ac:chgData name="Nicole Jiang" userId="09ef0fc0f6f473b5" providerId="LiveId" clId="{EB8F4A53-0964-5BF1-90AD-931457E28E1A}" dt="2026-10-14T18:46:21.938" v="2690" actId="1076"/>
+          <ac:spMkLst>
+            <pc:docMk/>
+            <pc:sldMk cId="868487171" sldId="261"/>
+            <ac:spMk id="220" creationId="{8529AA9E-ACC8-495E-8075-1D2F4EF9602E}"/>
+          </ac:spMkLst>
+        </pc:spChg>
+        <pc:spChg chg="mod">
+          <ac:chgData name="Nicole Jiang" userId="09ef0fc0f6f473b5" providerId="LiveId" clId="{EB8F4A53-0964-5BF1-90AD-931457E28E1A}" dt="2026-10-14T18:47:41.278" v="2704" actId="1076"/>
+          <ac:spMkLst>
+            <pc:docMk/>
+            <pc:sldMk cId="868487171" sldId="261"/>
+            <ac:spMk id="223" creationId="{86A37956-8DA5-40AE-A03E-2CE429C5454A}"/>
+          </ac:spMkLst>
+        </pc:spChg>
+        <pc:spChg chg="mod">
+          <ac:chgData name="Nicole Jiang" userId="09ef0fc0f6f473b5" providerId="LiveId" clId="{EB8F4A53-0964-5BF1-90AD-931457E28E1A}" dt="2026-10-14T18:47:35.204" v="2703" actId="20577"/>
+          <ac:spMkLst>
+            <pc:docMk/>
+            <pc:sldMk cId="868487171" sldId="261"/>
+            <ac:spMk id="224" creationId="{39DA12D1-0D37-445A-9028-17994BB6BD07}"/>
+          </ac:spMkLst>
+        </pc:spChg>
+      </pc:sldChg>
       <pc:sldChg chg="modSp add del mod">
         <pc:chgData name="Nicole Jiang" userId="09ef0fc0f6f473b5" providerId="LiveId" clId="{EB8F4A53-0964-5BF1-90AD-931457E28E1A}" dt="2026-10-13T17:35:40.898" v="2607" actId="2696"/>
         <pc:sldMkLst>
@@ -572,7 +683,7 @@
           <a:p>
             <a:fld id="{88D8F461-2A77-BA43-9B12-25195C3EB239}" type="datetimeFigureOut">
               <a:rPr lang="en-US" smtClean="0"/>
-              <a:t>10/13/26</a:t>
+              <a:t>10/14/26</a:t>
             </a:fld>
             <a:endParaRPr lang="en-US"/>
           </a:p>
@@ -1074,7 +1185,7 @@
           <a:p>
             <a:fld id="{490DA246-DE01-5046-81A0-D7E93C87400D}" type="slidenum">
               <a:rPr lang="en-US" smtClean="0"/>
-              <a:t>1</a:t>
+              <a:t>2</a:t>
             </a:fld>
             <a:endParaRPr lang="en-US"/>
           </a:p>
@@ -1222,7 +1333,7 @@
           <a:p>
             <a:fld id="{9ED62D96-B761-444F-9627-07D69EF59102}" type="datetimeFigureOut">
               <a:rPr lang="en-US" smtClean="0"/>
-              <a:t>10/13/26</a:t>
+              <a:t>10/14/26</a:t>
             </a:fld>
             <a:endParaRPr lang="en-US"/>
           </a:p>
@@ -1390,7 +1501,7 @@
           <a:p>
             <a:fld id="{9ED62D96-B761-444F-9627-07D69EF59102}" type="datetimeFigureOut">
               <a:rPr lang="en-US" smtClean="0"/>
-              <a:t>10/13/26</a:t>
+              <a:t>10/14/26</a:t>
             </a:fld>
             <a:endParaRPr lang="en-US"/>
           </a:p>
@@ -1568,7 +1679,7 @@
           <a:p>
             <a:fld id="{9ED62D96-B761-444F-9627-07D69EF59102}" type="datetimeFigureOut">
               <a:rPr lang="en-US" smtClean="0"/>
-              <a:t>10/13/26</a:t>
+              <a:t>10/14/26</a:t>
             </a:fld>
             <a:endParaRPr lang="en-US"/>
           </a:p>
@@ -2726,7 +2837,7 @@
           <a:p>
             <a:fld id="{9ED62D96-B761-444F-9627-07D69EF59102}" type="datetimeFigureOut">
               <a:rPr lang="en-US" smtClean="0"/>
-              <a:t>10/13/26</a:t>
+              <a:t>10/14/26</a:t>
             </a:fld>
             <a:endParaRPr lang="en-US"/>
           </a:p>
@@ -2971,7 +3082,7 @@
           <a:p>
             <a:fld id="{9ED62D96-B761-444F-9627-07D69EF59102}" type="datetimeFigureOut">
               <a:rPr lang="en-US" smtClean="0"/>
-              <a:t>10/13/26</a:t>
+              <a:t>10/14/26</a:t>
             </a:fld>
             <a:endParaRPr lang="en-US"/>
           </a:p>
@@ -3200,7 +3311,7 @@
           <a:p>
             <a:fld id="{9ED62D96-B761-444F-9627-07D69EF59102}" type="datetimeFigureOut">
               <a:rPr lang="en-US" smtClean="0"/>
-              <a:t>10/13/26</a:t>
+              <a:t>10/14/26</a:t>
             </a:fld>
             <a:endParaRPr lang="en-US"/>
           </a:p>
@@ -3564,7 +3675,7 @@
           <a:p>
             <a:fld id="{9ED62D96-B761-444F-9627-07D69EF59102}" type="datetimeFigureOut">
               <a:rPr lang="en-US" smtClean="0"/>
-              <a:t>10/13/26</a:t>
+              <a:t>10/14/26</a:t>
             </a:fld>
             <a:endParaRPr lang="en-US"/>
           </a:p>
@@ -3681,7 +3792,7 @@
           <a:p>
             <a:fld id="{9ED62D96-B761-444F-9627-07D69EF59102}" type="datetimeFigureOut">
               <a:rPr lang="en-US" smtClean="0"/>
-              <a:t>10/13/26</a:t>
+              <a:t>10/14/26</a:t>
             </a:fld>
             <a:endParaRPr lang="en-US"/>
           </a:p>
@@ -3776,7 +3887,7 @@
           <a:p>
             <a:fld id="{9ED62D96-B761-444F-9627-07D69EF59102}" type="datetimeFigureOut">
               <a:rPr lang="en-US" smtClean="0"/>
-              <a:t>10/13/26</a:t>
+              <a:t>10/14/26</a:t>
             </a:fld>
             <a:endParaRPr lang="en-US"/>
           </a:p>
@@ -4051,7 +4162,7 @@
           <a:p>
             <a:fld id="{9ED62D96-B761-444F-9627-07D69EF59102}" type="datetimeFigureOut">
               <a:rPr lang="en-US" smtClean="0"/>
-              <a:t>10/13/26</a:t>
+              <a:t>10/14/26</a:t>
             </a:fld>
             <a:endParaRPr lang="en-US"/>
           </a:p>
@@ -4303,7 +4414,7 @@
           <a:p>
             <a:fld id="{9ED62D96-B761-444F-9627-07D69EF59102}" type="datetimeFigureOut">
               <a:rPr lang="en-US" smtClean="0"/>
-              <a:t>10/13/26</a:t>
+              <a:t>10/14/26</a:t>
             </a:fld>
             <a:endParaRPr lang="en-US"/>
           </a:p>
@@ -4514,7 +4625,7 @@
           <a:p>
             <a:fld id="{9ED62D96-B761-444F-9627-07D69EF59102}" type="datetimeFigureOut">
               <a:rPr lang="en-US" smtClean="0"/>
-              <a:t>10/13/26</a:t>
+              <a:t>10/14/26</a:t>
             </a:fld>
             <a:endParaRPr lang="en-US"/>
           </a:p>
@@ -5396,8 +5507,8 @@
           </a:p>
         </p:txBody>
       </p:sp>
-      <mc:AlternateContent xmlns:mc="http://schemas.openxmlformats.org/markup-compatibility/2006">
-        <mc:Choice xmlns:a14="http://schemas.microsoft.com/office/drawing/2010/main" Requires="a14">
+      <mc:AlternateContent xmlns:mc="http://schemas.openxmlformats.org/markup-compatibility/2006" xmlns:a14="http://schemas.microsoft.com/office/drawing/2010/main">
+        <mc:Choice Requires="a14">
           <p:sp>
             <p:nvSpPr>
               <p:cNvPr id="73" name="TextBox 72">
@@ -6073,7 +6184,7 @@
             </p:txBody>
           </p:sp>
         </mc:Choice>
-        <mc:Fallback>
+        <mc:Fallback xmlns="">
           <p:sp>
             <p:nvSpPr>
               <p:cNvPr id="73" name="TextBox 72">
@@ -7338,7 +7449,7 @@
           <p:nvPr/>
         </p:nvPicPr>
         <p:blipFill>
-          <a:blip r:embed="rId4"/>
+          <a:blip r:embed="rId3"/>
           <a:stretch>
             <a:fillRect/>
           </a:stretch>
@@ -7463,7 +7574,7 @@
           <p:nvPr/>
         </p:nvPicPr>
         <p:blipFill>
-          <a:blip r:embed="rId5"/>
+          <a:blip r:embed="rId4"/>
           <a:stretch>
             <a:fillRect/>
           </a:stretch>
@@ -7493,7 +7604,7 @@
           <p:nvPr/>
         </p:nvPicPr>
         <p:blipFill>
-          <a:blip r:embed="rId6"/>
+          <a:blip r:embed="rId5"/>
           <a:srcRect l="23902" t="38725" b="33824"/>
           <a:stretch>
             <a:fillRect/>
@@ -7524,7 +7635,7 @@
           <p:nvPr/>
         </p:nvPicPr>
         <p:blipFill>
-          <a:blip r:embed="rId7"/>
+          <a:blip r:embed="rId6"/>
           <a:stretch>
             <a:fillRect/>
           </a:stretch>
@@ -7763,7 +7874,7 @@
           </a:p>
         </p:txBody>
       </p:sp>
-      <p:sp xmlns:a14="http://schemas.microsoft.com/office/drawing/2010/main">
+      <p:sp>
         <p:nvSpPr>
           <p:cNvPr id="73" name="TextBox 72">
             <a:extLst>
@@ -7801,16 +7912,28 @@
               <a:buNone/>
             </a:pPr>
             <a:r>
-              <a:rPr sz="3300" b="1" lang="en-CA">
+              <a:rPr lang="en-CA" sz="3300" b="1" dirty="0">
                 <a:latin typeface="Aptos"/>
               </a:rPr>
               <a:t>Symbols: </a:t>
             </a:r>
             <a:r>
-              <a:rPr sz="3300" b="0" lang="en-CA">
-                <a:latin typeface="Aptos"/>
-              </a:rPr>
-              <a:t>M⊙ denotes solar mass. Higher redshift z means earlier times. ε is the radiated fraction of accreted rest-mass energy.</a:t>
+              <a:rPr lang="en-CA" sz="3300" b="0" dirty="0">
+                <a:latin typeface="Aptos"/>
+              </a:rPr>
+              <a:t>M⊙ denotes solar mass. Higher redshift z means earlier times. </a:t>
+            </a:r>
+            <a:r>
+              <a:rPr lang="en-CA" sz="3300" b="0" dirty="0" err="1">
+                <a:latin typeface="Aptos"/>
+              </a:rPr>
+              <a:t>ε</a:t>
+            </a:r>
+            <a:r>
+              <a:rPr lang="en-CA" sz="3300" b="0" dirty="0">
+                <a:latin typeface="Aptos"/>
+              </a:rPr>
+              <a:t> is the radiated fraction of accreted rest-mass energy.</a:t>
             </a:r>
           </a:p>
           <a:p>
@@ -7824,25 +7947,25 @@
               <a:buNone/>
             </a:pPr>
             <a:r>
-              <a:rPr sz="3300" b="1" lang="en-CA">
+              <a:rPr lang="en-CA" sz="3300" b="1" dirty="0">
                 <a:latin typeface="Aptos"/>
               </a:rPr>
               <a:t>Eddington ratio: </a:t>
             </a:r>
             <a:r>
-              <a:rPr sz="3300" b="0" lang="en-CA">
+              <a:rPr lang="en-CA" sz="3300" b="0" dirty="0" err="1">
                 <a:latin typeface="Aptos"/>
               </a:rPr>
               <a:t>f</a:t>
             </a:r>
             <a:r>
-              <a:rPr sz="2200" b="0" lang="en-CA" baseline="-25000">
+              <a:rPr lang="en-CA" sz="2200" b="0" baseline="-25000" dirty="0" err="1">
                 <a:latin typeface="Aptos"/>
               </a:rPr>
               <a:t>Edd</a:t>
             </a:r>
             <a:r>
-              <a:rPr sz="3300" b="0" lang="en-CA">
+              <a:rPr lang="en-CA" sz="3300" b="0" dirty="0">
                 <a:latin typeface="Aptos"/>
               </a:rPr>
               <a:t> = luminosity/Eddington luminosity, where radiation force balances gravity. Averages above 1 require super-Eddington episodes.</a:t>
@@ -7865,7 +7988,7 @@
         <p:spPr>
           <a:xfrm>
             <a:off x="914400" y="10184458"/>
-            <a:ext cx="15087600" cy="14810682"/>
+            <a:ext cx="15087600" cy="27359578"/>
           </a:xfrm>
           <a:prstGeom prst="rect">
             <a:avLst/>
@@ -8000,22 +8123,22 @@
               <a:buChar char="•"/>
             </a:pPr>
             <a:r>
-              <a:rPr lang="en-CA" sz="3300" b="1">
-                <a:latin typeface="Aptos"/>
-              </a:rPr>
-              <a:t>Main finding: </a:t>
-            </a:r>
-            <a:r>
-              <a:rPr lang="en-CA" sz="3300" b="1">
-                <a:latin typeface="Aptos"/>
-              </a:rPr>
-              <a:t>Most adopted masses allow growth from 100 M⊙ seeds under the reference assumptions. </a:t>
-            </a:r>
-            <a:r>
-              <a:rPr lang="en-CA" sz="3300" b="0">
-                <a:latin typeface="Aptos"/>
-              </a:rPr>
-              <a:t>Seed requirements depend on mass estimates and accretion efficiency.</a:t>
+              <a:rPr sz="3300" b="1" lang="en-CA">
+                <a:solidFill>
+                  <a:srgbClr val="000000"/>
+                </a:solidFill>
+                <a:latin typeface="Aptos"/>
+              </a:rPr>
+              <a:t>Seed masses: </a:t>
+            </a:r>
+            <a:r>
+              <a:rPr sz="3300" b="0" lang="en-CA">
+                <a:solidFill>
+                  <a:srgbClr val="000000"/>
+                </a:solidFill>
+                <a:latin typeface="Aptos"/>
+              </a:rPr>
+              <a:t>Most adopted masses allow growth from 100 M⊙ seeds under the reference assumptions.</a:t>
             </a:r>
           </a:p>
           <a:p>
@@ -8026,13 +8149,19 @@
               <a:buChar char="•"/>
             </a:pPr>
             <a:r>
-              <a:rPr lang="en-CA" sz="3300" b="1">
+              <a:rPr sz="3300" b="1" lang="en-CA">
+                <a:solidFill>
+                  <a:srgbClr val="000000"/>
+                </a:solidFill>
                 <a:latin typeface="Aptos"/>
               </a:rPr>
               <a:t>Accretion physics: </a:t>
             </a:r>
             <a:r>
-              <a:rPr lang="en-CA" sz="3300" b="0">
+              <a:rPr sz="3300" b="0" lang="en-CA">
+                <a:solidFill>
+                  <a:srgbClr val="000000"/>
+                </a:solidFill>
                 <a:latin typeface="Aptos"/>
               </a:rPr>
               <a:t>Lower radiative efficiency leaves more accreted mass in the black hole, allowing faster growth at the same Eddington ratio.</a:t>
@@ -8046,13 +8175,19 @@
               <a:buChar char="•"/>
             </a:pPr>
             <a:r>
-              <a:rPr lang="en-CA" sz="3300" b="1">
+              <a:rPr sz="3300" b="1" lang="en-CA">
+                <a:solidFill>
+                  <a:srgbClr val="000000"/>
+                </a:solidFill>
                 <a:latin typeface="Aptos"/>
               </a:rPr>
               <a:t>Earlier growth: </a:t>
             </a:r>
             <a:r>
-              <a:rPr lang="en-CA" sz="3300" b="0">
+              <a:rPr sz="3300" b="0" lang="en-CA">
+                <a:solidFill>
+                  <a:srgbClr val="000000"/>
+                </a:solidFill>
                 <a:latin typeface="Aptos"/>
               </a:rPr>
               <a:t>Even the earliest tested start leaves 100 M⊙ seeds insufficient for the 4 targets at ε = 0.1 and average ratio ≤ 1. Larger seeds or super-Eddington episodes remain possible.</a:t>
@@ -8066,13 +8201,19 @@
               <a:buChar char="•"/>
             </a:pPr>
             <a:r>
-              <a:rPr lang="en-CA" sz="3300" b="1">
+              <a:rPr sz="3300" b="1" lang="en-CA">
+                <a:solidFill>
+                  <a:srgbClr val="000000"/>
+                </a:solidFill>
                 <a:latin typeface="Aptos"/>
               </a:rPr>
               <a:t>Further observations: </a:t>
             </a:r>
             <a:r>
-              <a:rPr lang="en-CA" sz="3300" b="0">
+              <a:rPr sz="3300" b="0" lang="en-CA">
+                <a:solidFill>
+                  <a:srgbClr val="000000"/>
+                </a:solidFill>
                 <a:latin typeface="Aptos"/>
               </a:rPr>
               <a:t>Independent mass measurements could change which objects require averages above 1. Counts from different surveys cannot establish how common these black holes are.</a:t>
@@ -8382,7 +8523,7 @@
           <p:nvPr/>
         </p:nvPicPr>
         <p:blipFill>
-          <a:blip r:embed="rId9"/>
+          <a:blip r:embed="rId7"/>
           <a:stretch>
             <a:fillRect/>
           </a:stretch>
@@ -8412,7 +8553,7 @@
           <p:nvPr/>
         </p:nvPicPr>
         <p:blipFill>
-          <a:blip r:embed="rId10"/>
+          <a:blip r:embed="rId8"/>
           <a:stretch>
             <a:fillRect/>
           </a:stretch>
@@ -8442,7 +8583,7 @@
           <p:nvPr/>
         </p:nvPicPr>
         <p:blipFill>
-          <a:blip r:embed="rId11"/>
+          <a:blip r:embed="rId9"/>
           <a:stretch>
             <a:fillRect/>
           </a:stretch>
@@ -8472,7 +8613,7 @@
           <p:nvPr/>
         </p:nvPicPr>
         <p:blipFill>
-          <a:blip r:embed="rId12"/>
+          <a:blip r:embed="rId10"/>
           <a:stretch>
             <a:fillRect/>
           </a:stretch>
@@ -8572,13 +8713,19 @@
               <a:buChar char="•"/>
             </a:pPr>
             <a:r>
-              <a:rPr lang="en-CA" sz="3300" b="1">
+              <a:rPr sz="3300" b="1" lang="en-CA">
+                <a:solidFill>
+                  <a:srgbClr val="000000"/>
+                </a:solidFill>
                 <a:latin typeface="Aptos"/>
               </a:rPr>
               <a:t>Reference: </a:t>
             </a:r>
             <a:r>
-              <a:rPr lang="en-CA" sz="3300" b="0">
+              <a:rPr sz="3300" b="0" lang="en-CA">
+                <a:solidFill>
+                  <a:srgbClr val="000000"/>
+                </a:solidFill>
                 <a:latin typeface="Aptos"/>
               </a:rPr>
               <a:t>8/220 primary objects require average Eddington ratios above 1, including 5 in ≥ 95% of mass-error draws.</a:t>
@@ -8589,16 +8736,22 @@
               <a:buChar char="•"/>
             </a:pPr>
             <a:r>
-              <a:rPr lang="en-CA" sz="3300" b="1">
+              <a:rPr sz="3300" b="1" lang="en-CA">
+                <a:solidFill>
+                  <a:srgbClr val="000000"/>
+                </a:solidFill>
                 <a:latin typeface="Aptos"/>
               </a:rPr>
               <a:t>Mass sensitivity: </a:t>
             </a:r>
             <a:r>
-              <a:rPr lang="en-CA" sz="3300" b="0">
-                <a:latin typeface="Aptos"/>
-              </a:rPr>
-              <a:t>Lowering masses by a factor of 3.2 leaves 3 objects above 1 in ≥ 95% of draws.</a:t>
+              <a:rPr sz="3300" b="0" lang="en-CA">
+                <a:solidFill>
+                  <a:srgbClr val="000000"/>
+                </a:solidFill>
+                <a:latin typeface="Aptos"/>
+              </a:rPr>
+              <a:t>Lowering masses by a factor of 3.2 leaves 3 primary objects requiring averages above 1 in ≥ 95% of draws.</a:t>
             </a:r>
           </a:p>
           <a:p>
@@ -8606,13 +8759,19 @@
               <a:buChar char="•"/>
             </a:pPr>
             <a:r>
-              <a:rPr lang="en-CA" sz="3300" b="1">
+              <a:rPr sz="3300" b="1" lang="en-CA">
+                <a:solidFill>
+                  <a:srgbClr val="000000"/>
+                </a:solidFill>
                 <a:latin typeface="Aptos"/>
               </a:rPr>
               <a:t>Seed mass: </a:t>
             </a:r>
             <a:r>
-              <a:rPr lang="en-CA" sz="3300" b="0">
+              <a:rPr sz="3300" b="0" lang="en-CA">
+                <a:solidFill>
+                  <a:srgbClr val="000000"/>
+                </a:solidFill>
                 <a:latin typeface="Aptos"/>
               </a:rPr>
               <a:t>1,000 M⊙ seeds leave 3/220 above 1. With 100,000 M⊙ seeds, neither sample has objects above 1.</a:t>
@@ -8623,16 +8782,22 @@
               <a:buChar char="•"/>
             </a:pPr>
             <a:r>
-              <a:rPr lang="en-CA" sz="3300" b="1">
+              <a:rPr sz="3300" b="1" lang="en-CA">
+                <a:solidFill>
+                  <a:srgbClr val="000000"/>
+                </a:solidFill>
                 <a:latin typeface="Aptos"/>
               </a:rPr>
               <a:t>Growth start time: </a:t>
             </a:r>
             <a:r>
-              <a:rPr lang="en-CA" sz="3300" b="0">
-                <a:latin typeface="Aptos"/>
-              </a:rPr>
-              <a:t>Starting at z = 20 raises the primary count above 1 to 18/220. At this start, GN-z11 requires the highest average in the expanded sample.</a:t>
+              <a:rPr sz="3300" b="0" lang="en-CA">
+                <a:solidFill>
+                  <a:srgbClr val="000000"/>
+                </a:solidFill>
+                <a:latin typeface="Aptos"/>
+              </a:rPr>
+              <a:t>At z = 20, 18/220 primary objects require averages above 1, and GN-z11 requires the highest average in the expanded sample.</a:t>
             </a:r>
           </a:p>
           <a:p>
@@ -8640,16 +8805,22 @@
               <a:buChar char="•"/>
             </a:pPr>
             <a:r>
-              <a:rPr lang="en-CA" sz="3300" b="1">
+              <a:rPr sz="3300" b="1" lang="en-CA">
+                <a:solidFill>
+                  <a:srgbClr val="000000"/>
+                </a:solidFill>
                 <a:latin typeface="Aptos"/>
               </a:rPr>
               <a:t>Efficiency: </a:t>
             </a:r>
             <a:r>
-              <a:rPr lang="en-CA" sz="3300" b="0">
-                <a:latin typeface="Aptos"/>
-              </a:rPr>
-              <a:t>At ε = 0.05719 [4], all 234 central mass estimates require averages below 1 under the other reference assumptions.</a:t>
+              <a:rPr sz="3300" b="0" lang="en-CA">
+                <a:solidFill>
+                  <a:srgbClr val="000000"/>
+                </a:solidFill>
+                <a:latin typeface="Aptos"/>
+              </a:rPr>
+              <a:t>At ε = 0.05719 (non-spinning thin disc) [4], all 234 central mass estimates require averages below 1 under the other reference assumptions.</a:t>
             </a:r>
           </a:p>
         </p:txBody>
@@ -8889,7 +9060,7 @@
               <a:t>A2744-QSO1’s broad-line mass (2.0 × 10</a:t>
             </a:r>
             <a:r>
-              <a:rPr lang="en-CA" sz="2200" b="0" dirty="0" baseline="30000">
+              <a:rPr lang="en-CA" sz="2200" b="0" baseline="30000" dirty="0">
                 <a:latin typeface="Aptos"/>
               </a:rPr>
               <a:t>7</a:t>
@@ -8901,7 +9072,7 @@
               <a:t> M⊙) requires an average of 0.929 under the reference model. Its dynamical mass (5.0 × 10</a:t>
             </a:r>
             <a:r>
-              <a:rPr lang="en-CA" sz="2200" b="0" dirty="0" baseline="30000">
+              <a:rPr lang="en-CA" sz="2200" b="0" baseline="30000" dirty="0">
                 <a:latin typeface="Aptos"/>
               </a:rPr>
               <a:t>7</a:t>
@@ -8931,7 +9102,7 @@
         </p:nvSpPr>
         <p:spPr>
           <a:xfrm>
-            <a:off x="1280160" y="25453836"/>
+            <a:off x="1371600" y="23400083"/>
             <a:ext cx="14356080" cy="640080"/>
           </a:xfrm>
           <a:prstGeom prst="rect">
@@ -8965,7 +9136,7 @@
               </a:defRPr>
             </a:pPr>
             <a:r>
-              <a:rPr lang="en-CA" sz="3600" b="1">
+              <a:rPr lang="en-CA" sz="3600" b="1" dirty="0">
                 <a:solidFill>
                   <a:srgbClr val="002A5C"/>
                 </a:solidFill>
@@ -9025,32 +9196,13 @@
               </a:defRPr>
             </a:pPr>
             <a:r>
-              <a:rPr sz="3300" b="1">
+              <a:rPr sz="3300" b="1" dirty="0">
                 <a:solidFill>
                   <a:srgbClr val="111111"/>
                 </a:solidFill>
                 <a:latin typeface="Aptos"/>
               </a:rPr>
-              <a:t>350 measurements from 32 source families</a:t>
-            </a:r>
-          </a:p>
-          <a:p>
-            <a:pPr algn="ctr">
-              <a:defRPr sz="3300" b="1">
-                <a:solidFill>
-                  <a:srgbClr val="111111"/>
-                </a:solidFill>
-                <a:latin typeface="Aptos"/>
-              </a:defRPr>
-            </a:pPr>
-            <a:r>
-              <a:rPr sz="3300" b="1">
-                <a:solidFill>
-                  <a:srgbClr val="111111"/>
-                </a:solidFill>
-                <a:latin typeface="Aptos"/>
-              </a:rPr>
-              <a:t>Redshift z ≥ 4</a:t>
+              <a:t>350 measurements from 32 source families at z ≥ 4</a:t>
             </a:r>
           </a:p>
         </p:txBody>
@@ -9084,6 +9236,13 @@
             <a:noFill/>
           </a:ln>
         </p:spPr>
+        <p:txBody>
+          <a:bodyPr/>
+          <a:lstStyle/>
+          <a:p>
+            <a:endParaRPr lang="en-US"/>
+          </a:p>
+        </p:txBody>
       </p:sp>
       <p:sp>
         <p:nvSpPr>
@@ -9178,6 +9337,13 @@
             <a:noFill/>
           </a:ln>
         </p:spPr>
+        <p:txBody>
+          <a:bodyPr/>
+          <a:lstStyle/>
+          <a:p>
+            <a:endParaRPr lang="en-US"/>
+          </a:p>
+        </p:txBody>
       </p:sp>
       <p:sp>
         <p:nvSpPr>
@@ -9208,6 +9374,13 @@
             <a:noFill/>
           </a:ln>
         </p:spPr>
+        <p:txBody>
+          <a:bodyPr/>
+          <a:lstStyle/>
+          <a:p>
+            <a:endParaRPr lang="en-US"/>
+          </a:p>
+        </p:txBody>
       </p:sp>
       <p:sp>
         <p:nvSpPr>
@@ -9238,6 +9411,13 @@
             </a:solidFill>
           </a:ln>
         </p:spPr>
+        <p:txBody>
+          <a:bodyPr/>
+          <a:lstStyle/>
+          <a:p>
+            <a:endParaRPr lang="en-US"/>
+          </a:p>
+        </p:txBody>
       </p:sp>
       <p:sp>
         <p:nvSpPr>
@@ -9456,7 +9636,7 @@
                 </a:solidFill>
                 <a:latin typeface="Aptos"/>
               </a:rPr>
-              <a:t>7 masses conditional on a broad-line-region interpretation</a:t>
+              <a:t>7 masses with uncertain line origins, assuming gas orbiting the black hole</a:t>
             </a:r>
           </a:p>
           <a:p>
@@ -9581,12 +9761,12 @@
             </a:r>
           </a:p>
           <a:p>
-            <a:r>
-              <a:rPr sz="2900">
-                <a:latin typeface="Aptos"/>
-              </a:rPr>
-              <a:t/>
-            </a:r>
+            <a:endParaRPr sz="2900" b="0">
+              <a:solidFill>
+                <a:srgbClr val="111111"/>
+              </a:solidFill>
+              <a:latin typeface="Aptos"/>
+            </a:endParaRPr>
           </a:p>
           <a:p>
             <a:pPr algn="ctr">
@@ -9627,12 +9807,12 @@
             </a:r>
           </a:p>
           <a:p>
-            <a:r>
-              <a:rPr sz="2900">
-                <a:latin typeface="Aptos"/>
-              </a:rPr>
-              <a:t/>
-            </a:r>
+            <a:endParaRPr sz="2900" b="0">
+              <a:solidFill>
+                <a:srgbClr val="111111"/>
+              </a:solidFill>
+              <a:latin typeface="Aptos"/>
+            </a:endParaRPr>
           </a:p>
           <a:p>
             <a:pPr algn="ctr">
@@ -9690,7 +9870,7 @@
         </p:nvSpPr>
         <p:spPr>
           <a:xfrm>
-            <a:off x="1371600" y="26471880"/>
+            <a:off x="1463040" y="24418127"/>
             <a:ext cx="14173200" cy="1051560"/>
           </a:xfrm>
           <a:prstGeom prst="rect">
@@ -9723,7 +9903,7 @@
               </a:defRPr>
             </a:pPr>
             <a:r>
-              <a:rPr sz="3000" b="1">
+              <a:rPr sz="3000" b="1" dirty="0">
                 <a:solidFill>
                   <a:srgbClr val="111111"/>
                 </a:solidFill>
@@ -9742,7 +9922,7 @@
               </a:defRPr>
             </a:pPr>
             <a:r>
-              <a:rPr sz="3000" b="1">
+              <a:rPr sz="3000" b="1" dirty="0">
                 <a:solidFill>
                   <a:srgbClr val="111111"/>
                 </a:solidFill>
@@ -9769,7 +9949,7 @@
         </p:nvSpPr>
         <p:spPr>
           <a:xfrm>
-            <a:off x="4604004" y="27569160"/>
+            <a:off x="4695444" y="25515407"/>
             <a:ext cx="347472" cy="329184"/>
           </a:xfrm>
           <a:prstGeom prst="downArrow">
@@ -9782,6 +9962,13 @@
             <a:noFill/>
           </a:ln>
         </p:spPr>
+        <p:txBody>
+          <a:bodyPr/>
+          <a:lstStyle/>
+          <a:p>
+            <a:endParaRPr lang="en-US"/>
+          </a:p>
+        </p:txBody>
       </p:sp>
       <p:sp>
         <p:nvSpPr>
@@ -9799,7 +9986,7 @@
         </p:nvSpPr>
         <p:spPr>
           <a:xfrm>
-            <a:off x="11964924" y="27569160"/>
+            <a:off x="12056364" y="25515407"/>
             <a:ext cx="347472" cy="329184"/>
           </a:xfrm>
           <a:prstGeom prst="downArrow">
@@ -9812,6 +9999,13 @@
             <a:noFill/>
           </a:ln>
         </p:spPr>
+        <p:txBody>
+          <a:bodyPr/>
+          <a:lstStyle/>
+          <a:p>
+            <a:endParaRPr lang="en-US"/>
+          </a:p>
+        </p:txBody>
       </p:sp>
       <p:sp>
         <p:nvSpPr>
@@ -9829,7 +10023,7 @@
         </p:nvSpPr>
         <p:spPr>
           <a:xfrm>
-            <a:off x="1371600" y="28044648"/>
+            <a:off x="1463040" y="25990895"/>
             <a:ext cx="6812280" cy="914400"/>
           </a:xfrm>
           <a:prstGeom prst="rect">
@@ -9893,7 +10087,7 @@
         </p:nvSpPr>
         <p:spPr>
           <a:xfrm>
-            <a:off x="8732520" y="28044648"/>
+            <a:off x="8823960" y="25990895"/>
             <a:ext cx="6812280" cy="914400"/>
           </a:xfrm>
           <a:prstGeom prst="rect">
@@ -9976,7 +10170,7 @@
         </p:nvSpPr>
         <p:spPr>
           <a:xfrm>
-            <a:off x="4604004" y="29096208"/>
+            <a:off x="4695444" y="27042455"/>
             <a:ext cx="347472" cy="329184"/>
           </a:xfrm>
           <a:prstGeom prst="downArrow">
@@ -9989,6 +10183,13 @@
             <a:noFill/>
           </a:ln>
         </p:spPr>
+        <p:txBody>
+          <a:bodyPr/>
+          <a:lstStyle/>
+          <a:p>
+            <a:endParaRPr lang="en-US"/>
+          </a:p>
+        </p:txBody>
       </p:sp>
       <p:sp>
         <p:nvSpPr>
@@ -10006,7 +10207,7 @@
         </p:nvSpPr>
         <p:spPr>
           <a:xfrm>
-            <a:off x="11964924" y="29096208"/>
+            <a:off x="12056364" y="27042455"/>
             <a:ext cx="347472" cy="329184"/>
           </a:xfrm>
           <a:prstGeom prst="downArrow">
@@ -10019,6 +10220,13 @@
             <a:noFill/>
           </a:ln>
         </p:spPr>
+        <p:txBody>
+          <a:bodyPr/>
+          <a:lstStyle/>
+          <a:p>
+            <a:endParaRPr lang="en-US"/>
+          </a:p>
+        </p:txBody>
       </p:sp>
       <p:sp>
         <p:nvSpPr>
@@ -10036,7 +10244,7 @@
         </p:nvSpPr>
         <p:spPr>
           <a:xfrm>
-            <a:off x="1371600" y="29599128"/>
+            <a:off x="1463040" y="27545375"/>
             <a:ext cx="14173200" cy="2057400"/>
           </a:xfrm>
           <a:prstGeom prst="rect">
@@ -10119,7 +10327,7 @@
         </p:nvSpPr>
         <p:spPr>
           <a:xfrm>
-            <a:off x="1371600" y="30742128"/>
+            <a:off x="1463040" y="28642655"/>
             <a:ext cx="14173200" cy="914400"/>
           </a:xfrm>
           <a:prstGeom prst="rect">
@@ -10152,7 +10360,7 @@
               </a:defRPr>
             </a:pPr>
             <a:r>
-              <a:rPr sz="3000" b="0">
+              <a:rPr sz="3000" b="0" dirty="0">
                 <a:solidFill>
                   <a:srgbClr val="111111"/>
                 </a:solidFill>
@@ -10171,13 +10379,22 @@
               </a:defRPr>
             </a:pPr>
             <a:r>
-              <a:rPr sz="3000" b="0">
+              <a:rPr sz="3000" b="0" dirty="0" err="1">
                 <a:solidFill>
                   <a:srgbClr val="111111"/>
                 </a:solidFill>
                 <a:latin typeface="Aptos"/>
               </a:rPr>
-              <a:t>ε = 0.1, no mergers [3]</a:t>
+              <a:t>ε</a:t>
+            </a:r>
+            <a:r>
+              <a:rPr sz="3000" b="0" dirty="0">
+                <a:solidFill>
+                  <a:srgbClr val="111111"/>
+                </a:solidFill>
+                <a:latin typeface="Aptos"/>
+              </a:rPr>
+              <a:t> = 0.1, no mergers [3]</a:t>
             </a:r>
           </a:p>
         </p:txBody>
@@ -10198,7 +10415,7 @@
         </p:nvSpPr>
         <p:spPr>
           <a:xfrm>
-            <a:off x="4604004" y="31757112"/>
+            <a:off x="4695444" y="29703359"/>
             <a:ext cx="347472" cy="329184"/>
           </a:xfrm>
           <a:prstGeom prst="downArrow">
@@ -10211,6 +10428,13 @@
             <a:noFill/>
           </a:ln>
         </p:spPr>
+        <p:txBody>
+          <a:bodyPr/>
+          <a:lstStyle/>
+          <a:p>
+            <a:endParaRPr lang="en-US"/>
+          </a:p>
+        </p:txBody>
       </p:sp>
       <p:sp>
         <p:nvSpPr>
@@ -10228,7 +10452,7 @@
         </p:nvSpPr>
         <p:spPr>
           <a:xfrm>
-            <a:off x="11964924" y="31757112"/>
+            <a:off x="12056364" y="29703359"/>
             <a:ext cx="347472" cy="329184"/>
           </a:xfrm>
           <a:prstGeom prst="downArrow">
@@ -10241,6 +10465,13 @@
             <a:noFill/>
           </a:ln>
         </p:spPr>
+        <p:txBody>
+          <a:bodyPr/>
+          <a:lstStyle/>
+          <a:p>
+            <a:endParaRPr lang="en-US"/>
+          </a:p>
+        </p:txBody>
       </p:sp>
       <p:sp>
         <p:nvSpPr>
@@ -10258,7 +10489,7 @@
         </p:nvSpPr>
         <p:spPr>
           <a:xfrm>
-            <a:off x="1371600" y="32232600"/>
+            <a:off x="1463040" y="30178847"/>
             <a:ext cx="6812280" cy="1143000"/>
           </a:xfrm>
           <a:prstGeom prst="rect">
@@ -10341,7 +10572,7 @@
         </p:nvSpPr>
         <p:spPr>
           <a:xfrm>
-            <a:off x="8732520" y="32232600"/>
+            <a:off x="8823960" y="30178847"/>
             <a:ext cx="6812280" cy="1143000"/>
           </a:xfrm>
           <a:prstGeom prst="rect">
@@ -10424,8 +10655,8 @@
         </p:nvSpPr>
         <p:spPr>
           <a:xfrm>
-            <a:off x="1371600" y="33531048"/>
-            <a:ext cx="14173200" cy="1280160"/>
+            <a:off x="1463040" y="31964970"/>
+            <a:ext cx="14173200" cy="1600200"/>
           </a:xfrm>
           <a:prstGeom prst="rect">
             <a:avLst/>
@@ -10436,72 +10667,32 @@
           </a:ln>
         </p:spPr>
         <p:txBody>
-          <a:bodyPr lIns="114300" tIns="76200" rIns="114300" bIns="76200" anchor="ctr"/>
-          <a:lstStyle>
-            <a:defPPr algn="ctr">
-              <a:defRPr sz="2700" b="0">
-                <a:solidFill>
-                  <a:srgbClr val="111111"/>
-                </a:solidFill>
-                <a:latin typeface="Aptos"/>
-              </a:defRPr>
-            </a:defPPr>
-          </a:lstStyle>
-          <a:p>
-            <a:pPr algn="ctr">
-              <a:defRPr sz="2700" b="0">
-                <a:solidFill>
-                  <a:srgbClr val="111111"/>
-                </a:solidFill>
-                <a:latin typeface="Aptos"/>
-              </a:defRPr>
+          <a:bodyPr lIns="0" tIns="27432" rIns="0" bIns="27432" anchor="t"/>
+          <a:lstStyle/>
+          <a:p>
+            <a:pPr algn="l">
+              <a:lnSpc>
+                <a:spcPct val="100000"/>
+              </a:lnSpc>
+              <a:buNone/>
             </a:pPr>
             <a:r>
-              <a:rPr sz="2700" b="0">
-                <a:solidFill>
-                  <a:srgbClr val="111111"/>
-                </a:solidFill>
-                <a:latin typeface="Aptos"/>
-              </a:rPr>
-              <a:t>Uncertainty: 208 primary / 222 expanded objects.</a:t>
-            </a:r>
-          </a:p>
-          <a:p>
-            <a:pPr algn="ctr">
-              <a:defRPr sz="2700" b="0">
-                <a:solidFill>
-                  <a:srgbClr val="111111"/>
-                </a:solidFill>
-                <a:latin typeface="Aptos"/>
-              </a:defRPr>
-            </a:pPr>
-            <a:r>
-              <a:rPr sz="2700" b="0">
-                <a:solidFill>
-                  <a:srgbClr val="111111"/>
-                </a:solidFill>
-                <a:latin typeface="Aptos"/>
-              </a:rPr>
-              <a:t>The other 12 enter central-mass tests only.</a:t>
-            </a:r>
-          </a:p>
-          <a:p>
-            <a:pPr algn="ctr">
-              <a:defRPr sz="2700" b="0">
-                <a:solidFill>
-                  <a:srgbClr val="111111"/>
-                </a:solidFill>
-                <a:latin typeface="Aptos"/>
-              </a:defRPr>
-            </a:pPr>
-            <a:r>
-              <a:rPr sz="2700" b="0">
-                <a:solidFill>
-                  <a:srgbClr val="111111"/>
-                </a:solidFill>
-                <a:latin typeface="Aptos"/>
-              </a:rPr>
-              <a:t>Reported errors may omit calibration scatter.</a:t>
+              <a:rPr sz="3300" b="1" lang="en-CA">
+                <a:solidFill>
+                  <a:srgbClr val="000000"/>
+                </a:solidFill>
+                <a:latin typeface="Aptos"/>
+              </a:rPr>
+              <a:t>Uncertainty: </a:t>
+            </a:r>
+            <a:r>
+              <a:rPr sz="3300" b="0" lang="en-CA">
+                <a:solidFill>
+                  <a:srgbClr val="000000"/>
+                </a:solidFill>
+                <a:latin typeface="Aptos"/>
+              </a:rPr>
+              <a:t>208 primary / 222 expanded objects. The other 12 enter central-mass tests only. Reported errors may omit calibration scatter.</a:t>
             </a:r>
           </a:p>
         </p:txBody>
@@ -10522,8 +10713,8 @@
         </p:nvSpPr>
         <p:spPr>
           <a:xfrm>
-            <a:off x="1371600" y="34930080"/>
-            <a:ext cx="14173200" cy="1371600"/>
+            <a:off x="1371600" y="33966423"/>
+            <a:ext cx="14173200" cy="1600200"/>
           </a:xfrm>
           <a:prstGeom prst="rect">
             <a:avLst/>
@@ -10534,72 +10725,32 @@
           </a:ln>
         </p:spPr>
         <p:txBody>
-          <a:bodyPr lIns="114300" tIns="76200" rIns="114300" bIns="76200" anchor="ctr"/>
-          <a:lstStyle>
-            <a:defPPr algn="ctr">
-              <a:defRPr sz="2700" b="0">
-                <a:solidFill>
-                  <a:srgbClr val="111111"/>
-                </a:solidFill>
-                <a:latin typeface="Aptos"/>
-              </a:defRPr>
-            </a:defPPr>
-          </a:lstStyle>
-          <a:p>
-            <a:pPr algn="ctr">
-              <a:defRPr sz="2700" b="0">
-                <a:solidFill>
-                  <a:srgbClr val="111111"/>
-                </a:solidFill>
-                <a:latin typeface="Aptos"/>
-              </a:defRPr>
+          <a:bodyPr lIns="0" tIns="27432" rIns="0" bIns="27432" anchor="t"/>
+          <a:lstStyle/>
+          <a:p>
+            <a:pPr algn="l">
+              <a:lnSpc>
+                <a:spcPct val="100000"/>
+              </a:lnSpc>
+              <a:buNone/>
             </a:pPr>
             <a:r>
-              <a:rPr sz="2700" b="0">
-                <a:solidFill>
-                  <a:srgbClr val="111111"/>
-                </a:solidFill>
-                <a:latin typeface="Aptos"/>
-              </a:rPr>
-              <a:t>Earlier growth: Inverted the growth law for 4 targets at</a:t>
-            </a:r>
-          </a:p>
-          <a:p>
-            <a:pPr algn="ctr">
-              <a:defRPr sz="2700" b="0">
-                <a:solidFill>
-                  <a:srgbClr val="111111"/>
-                </a:solidFill>
-                <a:latin typeface="Aptos"/>
-              </a:defRPr>
-            </a:pPr>
-            <a:r>
-              <a:rPr sz="2700" b="0">
-                <a:solidFill>
-                  <a:srgbClr val="111111"/>
-                </a:solidFill>
-                <a:latin typeface="Aptos"/>
-              </a:rPr>
-              <a:t>start redshifts 20–3,400. Included radiation in cosmic ages</a:t>
-            </a:r>
-          </a:p>
-          <a:p>
-            <a:pPr algn="ctr">
-              <a:defRPr sz="2700" b="0">
-                <a:solidFill>
-                  <a:srgbClr val="111111"/>
-                </a:solidFill>
-                <a:latin typeface="Aptos"/>
-              </a:defRPr>
-            </a:pPr>
-            <a:r>
-              <a:rPr sz="2700" b="0">
-                <a:solidFill>
-                  <a:srgbClr val="111111"/>
-                </a:solidFill>
-                <a:latin typeface="Aptos"/>
-              </a:rPr>
-              <a:t>and assumed gas was available.</a:t>
+              <a:rPr sz="3300" b="1" lang="en-CA">
+                <a:solidFill>
+                  <a:srgbClr val="000000"/>
+                </a:solidFill>
+                <a:latin typeface="Aptos"/>
+              </a:rPr>
+              <a:t>Earlier onset: </a:t>
+            </a:r>
+            <a:r>
+              <a:rPr sz="3300" b="0" lang="en-CA">
+                <a:solidFill>
+                  <a:srgbClr val="000000"/>
+                </a:solidFill>
+                <a:latin typeface="Aptos"/>
+              </a:rPr>
+              <a:t>Solved minimum seed masses for 4 targets at start redshifts 20–3,400. Included radiation in cosmic ages and assumed gas was available.</a:t>
             </a:r>
           </a:p>
         </p:txBody>

</xml_diff>

<commit_message>
Align final poster content and superscript citations
</commit_message>
<xml_diff>
--- a/posters/36x48.pptx
+++ b/posters/36x48.pptx
@@ -5,11 +5,10 @@
     <p:sldMasterId id="2147483660" r:id="rId1"/>
   </p:sldMasterIdLst>
   <p:notesMasterIdLst>
-    <p:notesMasterId r:id="rId4"/>
+    <p:notesMasterId r:id="rId3"/>
   </p:notesMasterIdLst>
   <p:sldIdLst>
-    <p:sldId id="260" r:id="rId2"/>
-    <p:sldId id="261" r:id="rId3"/>
+    <p:sldId id="261" r:id="rId2"/>
   </p:sldIdLst>
   <p:sldSz cx="32918400" cy="43891200"/>
   <p:notesSz cx="6858000" cy="9144000"/>
@@ -130,7 +129,7 @@
   <pc:docChgLst>
     <pc:chgData name="Nicole Jiang" userId="09ef0fc0f6f473b5" providerId="LiveId" clId="{EB8F4A53-0964-5BF1-90AD-931457E28E1A}"/>
     <pc:docChg chg="undo redo custSel addSld delSld modSld">
-      <pc:chgData name="Nicole Jiang" userId="09ef0fc0f6f473b5" providerId="LiveId" clId="{EB8F4A53-0964-5BF1-90AD-931457E28E1A}" dt="2026-10-14T18:47:41.278" v="2704" actId="1076"/>
+      <pc:chgData name="Nicole Jiang" userId="09ef0fc0f6f473b5" providerId="LiveId" clId="{EB8F4A53-0964-5BF1-90AD-931457E28E1A}" dt="2026-10-14T20:17:12.227" v="2827" actId="2696"/>
       <pc:docMkLst>
         <pc:docMk/>
       </pc:docMkLst>
@@ -141,8 +140,8 @@
           <pc:sldMk cId="868487171" sldId="259"/>
         </pc:sldMkLst>
       </pc:sldChg>
-      <pc:sldChg chg="addSp delSp modSp mod">
-        <pc:chgData name="Nicole Jiang" userId="09ef0fc0f6f473b5" providerId="LiveId" clId="{EB8F4A53-0964-5BF1-90AD-931457E28E1A}" dt="2026-10-14T03:43:03.391" v="2688" actId="1076"/>
+      <pc:sldChg chg="addSp delSp modSp del mod">
+        <pc:chgData name="Nicole Jiang" userId="09ef0fc0f6f473b5" providerId="LiveId" clId="{EB8F4A53-0964-5BF1-90AD-931457E28E1A}" dt="2026-10-14T20:17:12.227" v="2827" actId="2696"/>
         <pc:sldMkLst>
           <pc:docMk/>
           <pc:sldMk cId="868487171" sldId="260"/>
@@ -452,14 +451,38 @@
           </ac:picMkLst>
         </pc:picChg>
       </pc:sldChg>
-      <pc:sldChg chg="modSp mod">
-        <pc:chgData name="Nicole Jiang" userId="09ef0fc0f6f473b5" providerId="LiveId" clId="{EB8F4A53-0964-5BF1-90AD-931457E28E1A}" dt="2026-10-14T18:47:41.278" v="2704" actId="1076"/>
+      <pc:sldChg chg="addSp delSp modSp mod">
+        <pc:chgData name="Nicole Jiang" userId="09ef0fc0f6f473b5" providerId="LiveId" clId="{EB8F4A53-0964-5BF1-90AD-931457E28E1A}" dt="2026-10-14T20:15:48.652" v="2826" actId="20577"/>
         <pc:sldMkLst>
           <pc:docMk/>
           <pc:sldMk cId="868487171" sldId="261"/>
         </pc:sldMkLst>
         <pc:spChg chg="mod">
-          <ac:chgData name="Nicole Jiang" userId="09ef0fc0f6f473b5" providerId="LiveId" clId="{EB8F4A53-0964-5BF1-90AD-931457E28E1A}" dt="2026-10-14T18:45:31.649" v="2689" actId="14100"/>
+          <ac:chgData name="Nicole Jiang" userId="09ef0fc0f6f473b5" providerId="LiveId" clId="{EB8F4A53-0964-5BF1-90AD-931457E28E1A}" dt="2026-10-14T19:44:29.395" v="2809" actId="113"/>
+          <ac:spMkLst>
+            <pc:docMk/>
+            <pc:sldMk cId="868487171" sldId="261"/>
+            <ac:spMk id="2" creationId="{6F669F8B-BE33-0C82-515C-AF8D3B759FB3}"/>
+          </ac:spMkLst>
+        </pc:spChg>
+        <pc:spChg chg="add mod">
+          <ac:chgData name="Nicole Jiang" userId="09ef0fc0f6f473b5" providerId="LiveId" clId="{EB8F4A53-0964-5BF1-90AD-931457E28E1A}" dt="2026-10-14T19:36:26.018" v="2769" actId="1076"/>
+          <ac:spMkLst>
+            <pc:docMk/>
+            <pc:sldMk cId="868487171" sldId="261"/>
+            <ac:spMk id="3" creationId="{9C7CDCE8-5361-4FEF-24D8-015D90D4280A}"/>
+          </ac:spMkLst>
+        </pc:spChg>
+        <pc:spChg chg="mod">
+          <ac:chgData name="Nicole Jiang" userId="09ef0fc0f6f473b5" providerId="LiveId" clId="{EB8F4A53-0964-5BF1-90AD-931457E28E1A}" dt="2026-10-14T19:37:10.349" v="2776" actId="14100"/>
+          <ac:spMkLst>
+            <pc:docMk/>
+            <pc:sldMk cId="868487171" sldId="261"/>
+            <ac:spMk id="11" creationId="{AF7EDC07-606F-DD66-5973-0AE0D673B23B}"/>
+          </ac:spMkLst>
+        </pc:spChg>
+        <pc:spChg chg="mod">
+          <ac:chgData name="Nicole Jiang" userId="09ef0fc0f6f473b5" providerId="LiveId" clId="{EB8F4A53-0964-5BF1-90AD-931457E28E1A}" dt="2026-10-14T19:47:28.525" v="2819" actId="14100"/>
           <ac:spMkLst>
             <pc:docMk/>
             <pc:sldMk cId="868487171" sldId="261"/>
@@ -467,7 +490,71 @@
           </ac:spMkLst>
         </pc:spChg>
         <pc:spChg chg="mod">
-          <ac:chgData name="Nicole Jiang" userId="09ef0fc0f6f473b5" providerId="LiveId" clId="{EB8F4A53-0964-5BF1-90AD-931457E28E1A}" dt="2026-10-14T18:46:21.938" v="2690" actId="1076"/>
+          <ac:chgData name="Nicole Jiang" userId="09ef0fc0f6f473b5" providerId="LiveId" clId="{EB8F4A53-0964-5BF1-90AD-931457E28E1A}" dt="2026-10-14T19:45:57.461" v="2814" actId="1076"/>
+          <ac:spMkLst>
+            <pc:docMk/>
+            <pc:sldMk cId="868487171" sldId="261"/>
+            <ac:spMk id="76" creationId="{8F4057E1-F618-63B3-DF3A-8B3B4948305D}"/>
+          </ac:spMkLst>
+        </pc:spChg>
+        <pc:spChg chg="mod">
+          <ac:chgData name="Nicole Jiang" userId="09ef0fc0f6f473b5" providerId="LiveId" clId="{EB8F4A53-0964-5BF1-90AD-931457E28E1A}" dt="2026-10-14T19:37:04.582" v="2774" actId="1076"/>
+          <ac:spMkLst>
+            <pc:docMk/>
+            <pc:sldMk cId="868487171" sldId="261"/>
+            <ac:spMk id="78" creationId="{D50205E6-BF86-6F08-991C-43F597FDF8DD}"/>
+          </ac:spMkLst>
+        </pc:spChg>
+        <pc:spChg chg="mod">
+          <ac:chgData name="Nicole Jiang" userId="09ef0fc0f6f473b5" providerId="LiveId" clId="{EB8F4A53-0964-5BF1-90AD-931457E28E1A}" dt="2026-10-14T19:46:59.840" v="2818" actId="20577"/>
+          <ac:spMkLst>
+            <pc:docMk/>
+            <pc:sldMk cId="868487171" sldId="261"/>
+            <ac:spMk id="79" creationId="{3DD5B540-2EC8-A5A1-200C-994C1D7C8BFD}"/>
+          </ac:spMkLst>
+        </pc:spChg>
+        <pc:spChg chg="mod">
+          <ac:chgData name="Nicole Jiang" userId="09ef0fc0f6f473b5" providerId="LiveId" clId="{EB8F4A53-0964-5BF1-90AD-931457E28E1A}" dt="2026-10-14T19:37:07.538" v="2775" actId="14100"/>
+          <ac:spMkLst>
+            <pc:docMk/>
+            <pc:sldMk cId="868487171" sldId="261"/>
+            <ac:spMk id="80" creationId="{BBD5C8AB-335C-2E4D-00F6-4B0BF74BB013}"/>
+          </ac:spMkLst>
+        </pc:spChg>
+        <pc:spChg chg="mod">
+          <ac:chgData name="Nicole Jiang" userId="09ef0fc0f6f473b5" providerId="LiveId" clId="{EB8F4A53-0964-5BF1-90AD-931457E28E1A}" dt="2026-10-14T19:34:03.726" v="2719" actId="1076"/>
+          <ac:spMkLst>
+            <pc:docMk/>
+            <pc:sldMk cId="868487171" sldId="261"/>
+            <ac:spMk id="81" creationId="{8E773A53-2851-D565-B46F-D419BA57021E}"/>
+          </ac:spMkLst>
+        </pc:spChg>
+        <pc:spChg chg="mod">
+          <ac:chgData name="Nicole Jiang" userId="09ef0fc0f6f473b5" providerId="LiveId" clId="{EB8F4A53-0964-5BF1-90AD-931457E28E1A}" dt="2026-10-14T19:34:17.017" v="2721" actId="1076"/>
+          <ac:spMkLst>
+            <pc:docMk/>
+            <pc:sldMk cId="868487171" sldId="261"/>
+            <ac:spMk id="82" creationId="{82B57F9D-B4AF-1E4D-7FBC-B8680CB4CAB8}"/>
+          </ac:spMkLst>
+        </pc:spChg>
+        <pc:spChg chg="mod">
+          <ac:chgData name="Nicole Jiang" userId="09ef0fc0f6f473b5" providerId="LiveId" clId="{EB8F4A53-0964-5BF1-90AD-931457E28E1A}" dt="2026-10-14T19:34:13.753" v="2720" actId="14100"/>
+          <ac:spMkLst>
+            <pc:docMk/>
+            <pc:sldMk cId="868487171" sldId="261"/>
+            <ac:spMk id="83" creationId="{7156AF1B-4C0F-9637-8495-BA5941742B85}"/>
+          </ac:spMkLst>
+        </pc:spChg>
+        <pc:spChg chg="del">
+          <ac:chgData name="Nicole Jiang" userId="09ef0fc0f6f473b5" providerId="LiveId" clId="{EB8F4A53-0964-5BF1-90AD-931457E28E1A}" dt="2026-10-14T19:45:53.892" v="2813" actId="478"/>
+          <ac:spMkLst>
+            <pc:docMk/>
+            <pc:sldMk cId="868487171" sldId="261"/>
+            <ac:spMk id="110" creationId="{00000000-0000-0000-0000-000000000000}"/>
+          </ac:spMkLst>
+        </pc:spChg>
+        <pc:spChg chg="mod">
+          <ac:chgData name="Nicole Jiang" userId="09ef0fc0f6f473b5" providerId="LiveId" clId="{EB8F4A53-0964-5BF1-90AD-931457E28E1A}" dt="2026-10-14T19:35:44.272" v="2765" actId="1076"/>
           <ac:spMkLst>
             <pc:docMk/>
             <pc:sldMk cId="868487171" sldId="261"/>
@@ -475,7 +562,7 @@
           </ac:spMkLst>
         </pc:spChg>
         <pc:spChg chg="mod">
-          <ac:chgData name="Nicole Jiang" userId="09ef0fc0f6f473b5" providerId="LiveId" clId="{EB8F4A53-0964-5BF1-90AD-931457E28E1A}" dt="2026-10-14T18:46:31.761" v="2693" actId="20577"/>
+          <ac:chgData name="Nicole Jiang" userId="09ef0fc0f6f473b5" providerId="LiveId" clId="{EB8F4A53-0964-5BF1-90AD-931457E28E1A}" dt="2026-10-14T19:48:25.703" v="2821" actId="1076"/>
           <ac:spMkLst>
             <pc:docMk/>
             <pc:sldMk cId="868487171" sldId="261"/>
@@ -483,7 +570,55 @@
           </ac:spMkLst>
         </pc:spChg>
         <pc:spChg chg="mod">
-          <ac:chgData name="Nicole Jiang" userId="09ef0fc0f6f473b5" providerId="LiveId" clId="{EB8F4A53-0964-5BF1-90AD-931457E28E1A}" dt="2026-10-14T18:46:21.938" v="2690" actId="1076"/>
+          <ac:chgData name="Nicole Jiang" userId="09ef0fc0f6f473b5" providerId="LiveId" clId="{EB8F4A53-0964-5BF1-90AD-931457E28E1A}" dt="2026-10-14T19:36:43.521" v="2771" actId="1076"/>
+          <ac:spMkLst>
+            <pc:docMk/>
+            <pc:sldMk cId="868487171" sldId="261"/>
+            <ac:spMk id="201" creationId="{A5654399-0386-420B-B69B-49326884E1BD}"/>
+          </ac:spMkLst>
+        </pc:spChg>
+        <pc:spChg chg="mod">
+          <ac:chgData name="Nicole Jiang" userId="09ef0fc0f6f473b5" providerId="LiveId" clId="{EB8F4A53-0964-5BF1-90AD-931457E28E1A}" dt="2026-10-14T19:36:46.392" v="2772" actId="1076"/>
+          <ac:spMkLst>
+            <pc:docMk/>
+            <pc:sldMk cId="868487171" sldId="261"/>
+            <ac:spMk id="202" creationId="{A4F32B50-A70B-4AAD-866D-8A9AFB77BA97}"/>
+          </ac:spMkLst>
+        </pc:spChg>
+        <pc:spChg chg="mod">
+          <ac:chgData name="Nicole Jiang" userId="09ef0fc0f6f473b5" providerId="LiveId" clId="{EB8F4A53-0964-5BF1-90AD-931457E28E1A}" dt="2026-10-14T19:48:25.703" v="2821" actId="1076"/>
+          <ac:spMkLst>
+            <pc:docMk/>
+            <pc:sldMk cId="868487171" sldId="261"/>
+            <ac:spMk id="203" creationId="{4B9D32E4-35CC-401A-84F3-9B0E93812FF3}"/>
+          </ac:spMkLst>
+        </pc:spChg>
+        <pc:spChg chg="mod">
+          <ac:chgData name="Nicole Jiang" userId="09ef0fc0f6f473b5" providerId="LiveId" clId="{EB8F4A53-0964-5BF1-90AD-931457E28E1A}" dt="2026-10-14T19:48:25.703" v="2821" actId="1076"/>
+          <ac:spMkLst>
+            <pc:docMk/>
+            <pc:sldMk cId="868487171" sldId="261"/>
+            <ac:spMk id="205" creationId="{B0440D7D-E739-420F-ABED-4E5D214838EC}"/>
+          </ac:spMkLst>
+        </pc:spChg>
+        <pc:spChg chg="mod">
+          <ac:chgData name="Nicole Jiang" userId="09ef0fc0f6f473b5" providerId="LiveId" clId="{EB8F4A53-0964-5BF1-90AD-931457E28E1A}" dt="2026-10-14T20:15:48.652" v="2826" actId="20577"/>
+          <ac:spMkLst>
+            <pc:docMk/>
+            <pc:sldMk cId="868487171" sldId="261"/>
+            <ac:spMk id="207" creationId="{0810806D-B188-4E18-8185-C1F9716B0663}"/>
+          </ac:spMkLst>
+        </pc:spChg>
+        <pc:spChg chg="mod">
+          <ac:chgData name="Nicole Jiang" userId="09ef0fc0f6f473b5" providerId="LiveId" clId="{EB8F4A53-0964-5BF1-90AD-931457E28E1A}" dt="2026-10-14T19:32:05.427" v="2710" actId="14100"/>
+          <ac:spMkLst>
+            <pc:docMk/>
+            <pc:sldMk cId="868487171" sldId="261"/>
+            <ac:spMk id="208" creationId="{FAA325B6-AF3F-4391-B001-5CEA6C0D3BA1}"/>
+          </ac:spMkLst>
+        </pc:spChg>
+        <pc:spChg chg="mod">
+          <ac:chgData name="Nicole Jiang" userId="09ef0fc0f6f473b5" providerId="LiveId" clId="{EB8F4A53-0964-5BF1-90AD-931457E28E1A}" dt="2026-10-14T19:33:10.244" v="2714" actId="20577"/>
           <ac:spMkLst>
             <pc:docMk/>
             <pc:sldMk cId="868487171" sldId="261"/>
@@ -491,7 +626,7 @@
           </ac:spMkLst>
         </pc:spChg>
         <pc:spChg chg="mod">
-          <ac:chgData name="Nicole Jiang" userId="09ef0fc0f6f473b5" providerId="LiveId" clId="{EB8F4A53-0964-5BF1-90AD-931457E28E1A}" dt="2026-10-14T18:46:21.938" v="2690" actId="1076"/>
+          <ac:chgData name="Nicole Jiang" userId="09ef0fc0f6f473b5" providerId="LiveId" clId="{EB8F4A53-0964-5BF1-90AD-931457E28E1A}" dt="2026-10-14T19:35:44.272" v="2765" actId="1076"/>
           <ac:spMkLst>
             <pc:docMk/>
             <pc:sldMk cId="868487171" sldId="261"/>
@@ -499,11 +634,27 @@
           </ac:spMkLst>
         </pc:spChg>
         <pc:spChg chg="mod">
-          <ac:chgData name="Nicole Jiang" userId="09ef0fc0f6f473b5" providerId="LiveId" clId="{EB8F4A53-0964-5BF1-90AD-931457E28E1A}" dt="2026-10-14T18:46:21.938" v="2690" actId="1076"/>
+          <ac:chgData name="Nicole Jiang" userId="09ef0fc0f6f473b5" providerId="LiveId" clId="{EB8F4A53-0964-5BF1-90AD-931457E28E1A}" dt="2026-10-14T19:48:25.703" v="2821" actId="1076"/>
           <ac:spMkLst>
             <pc:docMk/>
             <pc:sldMk cId="868487171" sldId="261"/>
             <ac:spMk id="212" creationId="{F0E4059E-8B12-4811-AB13-DD1F53C26AA3}"/>
+          </ac:spMkLst>
+        </pc:spChg>
+        <pc:spChg chg="mod">
+          <ac:chgData name="Nicole Jiang" userId="09ef0fc0f6f473b5" providerId="LiveId" clId="{EB8F4A53-0964-5BF1-90AD-931457E28E1A}" dt="2026-10-14T19:48:25.703" v="2821" actId="1076"/>
+          <ac:spMkLst>
+            <pc:docMk/>
+            <pc:sldMk cId="868487171" sldId="261"/>
+            <ac:spMk id="214" creationId="{E0DF1478-840F-4BDD-B29E-A5B229B3783E}"/>
+          </ac:spMkLst>
+        </pc:spChg>
+        <pc:spChg chg="mod">
+          <ac:chgData name="Nicole Jiang" userId="09ef0fc0f6f473b5" providerId="LiveId" clId="{EB8F4A53-0964-5BF1-90AD-931457E28E1A}" dt="2026-10-14T19:48:25.703" v="2821" actId="1076"/>
+          <ac:spMkLst>
+            <pc:docMk/>
+            <pc:sldMk cId="868487171" sldId="261"/>
+            <ac:spMk id="215" creationId="{F3106931-3BF4-4F12-9726-6C63FA258C0A}"/>
           </ac:spMkLst>
         </pc:spChg>
         <pc:spChg chg="mod">
@@ -515,7 +666,7 @@
           </ac:spMkLst>
         </pc:spChg>
         <pc:spChg chg="mod">
-          <ac:chgData name="Nicole Jiang" userId="09ef0fc0f6f473b5" providerId="LiveId" clId="{EB8F4A53-0964-5BF1-90AD-931457E28E1A}" dt="2026-10-14T18:46:21.938" v="2690" actId="1076"/>
+          <ac:chgData name="Nicole Jiang" userId="09ef0fc0f6f473b5" providerId="LiveId" clId="{EB8F4A53-0964-5BF1-90AD-931457E28E1A}" dt="2026-10-14T19:48:25.703" v="2821" actId="1076"/>
           <ac:spMkLst>
             <pc:docMk/>
             <pc:sldMk cId="868487171" sldId="261"/>
@@ -523,7 +674,7 @@
           </ac:spMkLst>
         </pc:spChg>
         <pc:spChg chg="mod">
-          <ac:chgData name="Nicole Jiang" userId="09ef0fc0f6f473b5" providerId="LiveId" clId="{EB8F4A53-0964-5BF1-90AD-931457E28E1A}" dt="2026-10-14T18:47:07.676" v="2695" actId="1076"/>
+          <ac:chgData name="Nicole Jiang" userId="09ef0fc0f6f473b5" providerId="LiveId" clId="{EB8F4A53-0964-5BF1-90AD-931457E28E1A}" dt="2026-10-14T19:48:25.703" v="2821" actId="1076"/>
           <ac:spMkLst>
             <pc:docMk/>
             <pc:sldMk cId="868487171" sldId="261"/>
@@ -539,7 +690,7 @@
           </ac:spMkLst>
         </pc:spChg>
         <pc:spChg chg="mod">
-          <ac:chgData name="Nicole Jiang" userId="09ef0fc0f6f473b5" providerId="LiveId" clId="{EB8F4A53-0964-5BF1-90AD-931457E28E1A}" dt="2026-10-14T18:46:21.938" v="2690" actId="1076"/>
+          <ac:chgData name="Nicole Jiang" userId="09ef0fc0f6f473b5" providerId="LiveId" clId="{EB8F4A53-0964-5BF1-90AD-931457E28E1A}" dt="2026-10-14T19:48:25.703" v="2821" actId="1076"/>
           <ac:spMkLst>
             <pc:docMk/>
             <pc:sldMk cId="868487171" sldId="261"/>
@@ -547,7 +698,7 @@
           </ac:spMkLst>
         </pc:spChg>
         <pc:spChg chg="mod">
-          <ac:chgData name="Nicole Jiang" userId="09ef0fc0f6f473b5" providerId="LiveId" clId="{EB8F4A53-0964-5BF1-90AD-931457E28E1A}" dt="2026-10-14T18:47:41.278" v="2704" actId="1076"/>
+          <ac:chgData name="Nicole Jiang" userId="09ef0fc0f6f473b5" providerId="LiveId" clId="{EB8F4A53-0964-5BF1-90AD-931457E28E1A}" dt="2026-10-14T19:48:25.703" v="2821" actId="1076"/>
           <ac:spMkLst>
             <pc:docMk/>
             <pc:sldMk cId="868487171" sldId="261"/>
@@ -555,13 +706,29 @@
           </ac:spMkLst>
         </pc:spChg>
         <pc:spChg chg="mod">
-          <ac:chgData name="Nicole Jiang" userId="09ef0fc0f6f473b5" providerId="LiveId" clId="{EB8F4A53-0964-5BF1-90AD-931457E28E1A}" dt="2026-10-14T18:47:35.204" v="2703" actId="20577"/>
+          <ac:chgData name="Nicole Jiang" userId="09ef0fc0f6f473b5" providerId="LiveId" clId="{EB8F4A53-0964-5BF1-90AD-931457E28E1A}" dt="2026-10-14T19:33:45.038" v="2717" actId="1076"/>
           <ac:spMkLst>
             <pc:docMk/>
             <pc:sldMk cId="868487171" sldId="261"/>
             <ac:spMk id="224" creationId="{39DA12D1-0D37-445A-9028-17994BB6BD07}"/>
           </ac:spMkLst>
         </pc:spChg>
+        <pc:picChg chg="mod modCrop">
+          <ac:chgData name="Nicole Jiang" userId="09ef0fc0f6f473b5" providerId="LiveId" clId="{EB8F4A53-0964-5BF1-90AD-931457E28E1A}" dt="2026-10-14T19:45:30.344" v="2812" actId="732"/>
+          <ac:picMkLst>
+            <pc:docMk/>
+            <pc:sldMk cId="868487171" sldId="261"/>
+            <ac:picMk id="4" creationId="{C4337658-2539-7C1B-497A-E1769149148E}"/>
+          </ac:picMkLst>
+        </pc:picChg>
+        <pc:picChg chg="mod">
+          <ac:chgData name="Nicole Jiang" userId="09ef0fc0f6f473b5" providerId="LiveId" clId="{EB8F4A53-0964-5BF1-90AD-931457E28E1A}" dt="2026-10-14T20:14:50.438" v="2822" actId="1076"/>
+          <ac:picMkLst>
+            <pc:docMk/>
+            <pc:sldMk cId="868487171" sldId="261"/>
+            <ac:picMk id="14" creationId="{C3CA3027-10C5-D39A-05B0-82DB2540F9D3}"/>
+          </ac:picMkLst>
+        </pc:picChg>
       </pc:sldChg>
       <pc:sldChg chg="modSp add del mod">
         <pc:chgData name="Nicole Jiang" userId="09ef0fc0f6f473b5" providerId="LiveId" clId="{EB8F4A53-0964-5BF1-90AD-931457E28E1A}" dt="2026-10-13T17:35:40.898" v="2607" actId="2696"/>
@@ -951,257 +1118,149 @@
 </file>
 
 <file path=ppt/notesSlides/notesSlide1.xml><?xml version="1.0" encoding="utf-8"?>
-<p:notes xmlns:a="http://schemas.openxmlformats.org/drawingml/2006/main" xmlns:r="http://schemas.openxmlformats.org/officeDocument/2006/relationships" xmlns:p="http://schemas.openxmlformats.org/presentationml/2006/main">
-  <p:cSld>
-    <p:spTree>
-      <p:nvGrpSpPr>
-        <p:cNvPr id="1" name="">
-          <a:extLst>
-            <a:ext uri="{FF2B5EF4-FFF2-40B4-BE49-F238E27FC236}">
-              <a16:creationId xmlns:a16="http://schemas.microsoft.com/office/drawing/2014/main" id="{9FC4C11B-3281-61F5-AEEC-E5F2B2984717}"/>
-            </a:ext>
-          </a:extLst>
-        </p:cNvPr>
-        <p:cNvGrpSpPr/>
-        <p:nvPr/>
-      </p:nvGrpSpPr>
-      <p:grpSpPr>
-        <a:xfrm>
-          <a:off x="0" y="0"/>
-          <a:ext cx="0" cy="0"/>
-          <a:chOff x="0" y="0"/>
-          <a:chExt cx="0" cy="0"/>
-        </a:xfrm>
-      </p:grpSpPr>
-      <p:sp>
-        <p:nvSpPr>
-          <p:cNvPr id="2" name="Slide Image Placeholder 1">
-            <a:extLst>
-              <a:ext uri="{FF2B5EF4-FFF2-40B4-BE49-F238E27FC236}">
-                <a16:creationId xmlns:a16="http://schemas.microsoft.com/office/drawing/2014/main" id="{C975FC8B-F564-04EA-26FD-6F8FBA438751}"/>
-              </a:ext>
-            </a:extLst>
-          </p:cNvPr>
-          <p:cNvSpPr>
-            <a:spLocks noGrp="1" noRot="1" noChangeAspect="1"/>
-          </p:cNvSpPr>
-          <p:nvPr>
-            <p:ph type="sldImg"/>
-          </p:nvPr>
-        </p:nvSpPr>
-        <p:spPr>
-          <a:xfrm>
-            <a:off x="2271713" y="1143000"/>
-            <a:ext cx="2314575" cy="3086100"/>
-          </a:xfrm>
-        </p:spPr>
-      </p:sp>
-      <p:sp>
-        <p:nvSpPr>
-          <p:cNvPr id="3" name="Notes Placeholder 2">
-            <a:extLst>
-              <a:ext uri="{FF2B5EF4-FFF2-40B4-BE49-F238E27FC236}">
-                <a16:creationId xmlns:a16="http://schemas.microsoft.com/office/drawing/2014/main" id="{78ACB9E4-9956-85CD-1D61-2F397B472319}"/>
-              </a:ext>
-            </a:extLst>
-          </p:cNvPr>
-          <p:cNvSpPr>
-            <a:spLocks noGrp="1"/>
-          </p:cNvSpPr>
-          <p:nvPr>
-            <p:ph type="body" idx="1"/>
-          </p:nvPr>
-        </p:nvSpPr>
-        <p:spPr/>
-        <p:txBody>
-          <a:bodyPr/>
-          <a:lstStyle/>
-          <a:p>
-            <a:endParaRPr lang="en-US"/>
-          </a:p>
-          <a:p>
-            <a:pPr>
-              <a:spcAft>
-                <a:spcPts val="800"/>
-              </a:spcAft>
-              <a:buNone/>
-            </a:pPr>
-            <a:r>
-              <a:rPr lang="en-CA" sz="1200" b="0">
-                <a:latin typeface="Aptos"/>
-              </a:rPr>
-              <a:t>Poster figure inputs: results/manuscript/tables/publication_object_selection.csv; mass_offset_object_sensitivity.csv; results/v3/tables/v3_object_point_ranking.csv and v3_object_uncertainty_ranking.csv; results/v4/tables/v4_minimum_seed_mass.csv. Controlled growth comparison uses src.models.predicted_log_mbh with mean ratio 1, z_seed=30, B_merge=1 and efficiencies 0.1 and 1-sqrt(8/9). Independent dynamical mass: https://arxiv.org/abs/2508.21748.</a:t>
-            </a:r>
-          </a:p>
-        </p:txBody>
-      </p:sp>
-      <p:sp>
-        <p:nvSpPr>
-          <p:cNvPr id="4" name="Slide Number Placeholder 3">
-            <a:extLst>
-              <a:ext uri="{FF2B5EF4-FFF2-40B4-BE49-F238E27FC236}">
-                <a16:creationId xmlns:a16="http://schemas.microsoft.com/office/drawing/2014/main" id="{A8B3E2F2-BDDF-9490-DE7B-11CDCE91017C}"/>
-              </a:ext>
-            </a:extLst>
-          </p:cNvPr>
-          <p:cNvSpPr>
-            <a:spLocks noGrp="1"/>
-          </p:cNvSpPr>
-          <p:nvPr>
-            <p:ph type="sldNum" sz="quarter" idx="5"/>
-          </p:nvPr>
-        </p:nvSpPr>
-        <p:spPr/>
-        <p:txBody>
-          <a:bodyPr/>
-          <a:lstStyle/>
-          <a:p>
-            <a:fld id="{490DA246-DE01-5046-81A0-D7E93C87400D}" type="slidenum">
-              <a:rPr lang="en-US" smtClean="0"/>
-              <a:t>1</a:t>
-            </a:fld>
-            <a:endParaRPr lang="en-US"/>
-          </a:p>
-        </p:txBody>
-      </p:sp>
-    </p:spTree>
-    <p:extLst>
-      <p:ext uri="{BB962C8B-B14F-4D97-AF65-F5344CB8AC3E}">
-        <p14:creationId xmlns:p14="http://schemas.microsoft.com/office/powerpoint/2010/main" val="3600152407"/>
-      </p:ext>
-    </p:extLst>
-  </p:cSld>
-  <p:clrMapOvr>
-    <a:masterClrMapping/>
-  </p:clrMapOvr>
-</p:notes>
-</file>
-
-<file path=ppt/notesSlides/notesSlide2.xml><?xml version="1.0" encoding="utf-8"?>
-<p:notes xmlns:a="http://schemas.openxmlformats.org/drawingml/2006/main" xmlns:r="http://schemas.openxmlformats.org/officeDocument/2006/relationships" xmlns:p="http://schemas.openxmlformats.org/presentationml/2006/main">
-  <p:cSld>
-    <p:spTree>
-      <p:nvGrpSpPr>
-        <p:cNvPr id="1" name="">
-          <a:extLst>
-            <a:ext uri="{FF2B5EF4-FFF2-40B4-BE49-F238E27FC236}">
-              <a16:creationId xmlns:a16="http://schemas.microsoft.com/office/drawing/2014/main" id="{9FC4C11B-3281-61F5-AEEC-E5F2B2984717}"/>
-            </a:ext>
-          </a:extLst>
-        </p:cNvPr>
-        <p:cNvGrpSpPr/>
-        <p:nvPr/>
-      </p:nvGrpSpPr>
-      <p:grpSpPr>
-        <a:xfrm>
-          <a:off x="0" y="0"/>
-          <a:ext cx="0" cy="0"/>
-          <a:chOff x="0" y="0"/>
-          <a:chExt cx="0" cy="0"/>
-        </a:xfrm>
-      </p:grpSpPr>
-      <p:sp>
-        <p:nvSpPr>
-          <p:cNvPr id="2" name="Slide Image Placeholder 1">
-            <a:extLst>
-              <a:ext uri="{FF2B5EF4-FFF2-40B4-BE49-F238E27FC236}">
-                <a16:creationId xmlns:a16="http://schemas.microsoft.com/office/drawing/2014/main" id="{C975FC8B-F564-04EA-26FD-6F8FBA438751}"/>
-              </a:ext>
-            </a:extLst>
-          </p:cNvPr>
-          <p:cNvSpPr>
-            <a:spLocks noGrp="1" noRot="1" noChangeAspect="1"/>
-          </p:cNvSpPr>
-          <p:nvPr>
-            <p:ph type="sldImg"/>
-          </p:nvPr>
-        </p:nvSpPr>
-        <p:spPr>
-          <a:xfrm>
-            <a:off x="2271713" y="1143000"/>
-            <a:ext cx="2314575" cy="3086100"/>
-          </a:xfrm>
-        </p:spPr>
-      </p:sp>
-      <p:sp>
-        <p:nvSpPr>
-          <p:cNvPr id="3" name="Notes Placeholder 2">
-            <a:extLst>
-              <a:ext uri="{FF2B5EF4-FFF2-40B4-BE49-F238E27FC236}">
-                <a16:creationId xmlns:a16="http://schemas.microsoft.com/office/drawing/2014/main" id="{78ACB9E4-9956-85CD-1D61-2F397B472319}"/>
-              </a:ext>
-            </a:extLst>
-          </p:cNvPr>
-          <p:cNvSpPr>
-            <a:spLocks noGrp="1"/>
-          </p:cNvSpPr>
-          <p:nvPr>
-            <p:ph type="body" idx="1"/>
-          </p:nvPr>
-        </p:nvSpPr>
-        <p:spPr/>
-        <p:txBody>
-          <a:bodyPr/>
-          <a:lstStyle/>
-          <a:p>
-            <a:endParaRPr lang="en-US"/>
-          </a:p>
-          <a:p>
-            <a:pPr>
-              <a:spcAft>
-                <a:spcPts val="800"/>
-              </a:spcAft>
-              <a:buNone/>
-            </a:pPr>
-            <a:r>
-              <a:rPr lang="en-CA" sz="1200" b="0">
-                <a:latin typeface="Aptos"/>
-              </a:rPr>
-              <a:t>Poster figure inputs: results/manuscript/tables/publication_object_selection.csv; mass_offset_object_sensitivity.csv; results/v3/tables/v3_object_point_ranking.csv and v3_object_uncertainty_ranking.csv; results/v4/tables/v4_minimum_seed_mass.csv. Controlled growth comparison uses src.models.predicted_log_mbh with mean ratio 1, z_seed=30, B_merge=1 and efficiencies 0.1 and 1-sqrt(8/9). Independent dynamical mass: https://arxiv.org/abs/2508.21748.</a:t>
-            </a:r>
-          </a:p>
-        </p:txBody>
-      </p:sp>
-      <p:sp>
-        <p:nvSpPr>
-          <p:cNvPr id="4" name="Slide Number Placeholder 3">
-            <a:extLst>
-              <a:ext uri="{FF2B5EF4-FFF2-40B4-BE49-F238E27FC236}">
-                <a16:creationId xmlns:a16="http://schemas.microsoft.com/office/drawing/2014/main" id="{A8B3E2F2-BDDF-9490-DE7B-11CDCE91017C}"/>
-              </a:ext>
-            </a:extLst>
-          </p:cNvPr>
-          <p:cNvSpPr>
-            <a:spLocks noGrp="1"/>
-          </p:cNvSpPr>
-          <p:nvPr>
-            <p:ph type="sldNum" sz="quarter" idx="5"/>
-          </p:nvPr>
-        </p:nvSpPr>
-        <p:spPr/>
-        <p:txBody>
-          <a:bodyPr/>
-          <a:lstStyle/>
-          <a:p>
-            <a:fld id="{490DA246-DE01-5046-81A0-D7E93C87400D}" type="slidenum">
-              <a:rPr lang="en-US" smtClean="0"/>
-              <a:t>2</a:t>
-            </a:fld>
-            <a:endParaRPr lang="en-US"/>
-          </a:p>
-        </p:txBody>
-      </p:sp>
-    </p:spTree>
-    <p:extLst>
-      <p:ext uri="{BB962C8B-B14F-4D97-AF65-F5344CB8AC3E}">
-        <p14:creationId xmlns:p14="http://schemas.microsoft.com/office/powerpoint/2010/main" val="3600152407"/>
-      </p:ext>
-    </p:extLst>
-  </p:cSld>
-  <p:clrMapOvr>
-    <a:masterClrMapping/>
-  </p:clrMapOvr>
-</p:notes>
+<ns0:notes xmlns:ns0="http://schemas.openxmlformats.org/presentationml/2006/main" xmlns:ns1="http://schemas.openxmlformats.org/drawingml/2006/main" xmlns:ns2="http://schemas.microsoft.com/office/drawing/2014/main" xmlns:ns3="http://schemas.microsoft.com/office/powerpoint/2010/main">
+  <ns0:cSld>
+    <ns0:spTree>
+      <ns0:nvGrpSpPr>
+        <ns0:cNvPr id="1" name="">
+          <ns1:extLst>
+            <ns1:ext uri="{FF2B5EF4-FFF2-40B4-BE49-F238E27FC236}">
+              <ns2:creationId id="{9FC4C11B-3281-61F5-AEEC-E5F2B2984717}"/>
+            </ns1:ext>
+          </ns1:extLst>
+        </ns0:cNvPr>
+        <ns0:cNvGrpSpPr/>
+        <ns0:nvPr/>
+      </ns0:nvGrpSpPr>
+      <ns0:grpSpPr>
+        <ns1:xfrm>
+          <ns1:off x="0" y="0"/>
+          <ns1:ext cx="0" cy="0"/>
+          <ns1:chOff x="0" y="0"/>
+          <ns1:chExt cx="0" cy="0"/>
+        </ns1:xfrm>
+      </ns0:grpSpPr>
+      <ns0:sp>
+        <ns0:nvSpPr>
+          <ns0:cNvPr id="2" name="Slide Image Placeholder 1">
+            <ns1:extLst>
+              <ns1:ext uri="{FF2B5EF4-FFF2-40B4-BE49-F238E27FC236}">
+                <ns2:creationId id="{C975FC8B-F564-04EA-26FD-6F8FBA438751}"/>
+              </ns1:ext>
+            </ns1:extLst>
+          </ns0:cNvPr>
+          <ns0:cNvSpPr>
+            <ns1:spLocks noGrp="1" noRot="1" noChangeAspect="1"/>
+          </ns0:cNvSpPr>
+          <ns0:nvPr>
+            <ns0:ph type="sldImg"/>
+          </ns0:nvPr>
+        </ns0:nvSpPr>
+        <ns0:spPr>
+          <ns1:xfrm>
+            <ns1:off x="2271713" y="1143000"/>
+            <ns1:ext cx="2314575" cy="3086100"/>
+          </ns1:xfrm>
+        </ns0:spPr>
+      </ns0:sp>
+      <ns0:sp>
+        <ns0:nvSpPr>
+          <ns0:cNvPr id="3" name="Notes Placeholder 2">
+            <ns1:extLst>
+              <ns1:ext uri="{FF2B5EF4-FFF2-40B4-BE49-F238E27FC236}">
+                <ns2:creationId id="{78ACB9E4-9956-85CD-1D61-2F397B472319}"/>
+              </ns1:ext>
+            </ns1:extLst>
+          </ns0:cNvPr>
+          <ns0:cNvSpPr>
+            <ns1:spLocks noGrp="1"/>
+          </ns0:cNvSpPr>
+          <ns0:nvPr>
+            <ns0:ph type="body" idx="1"/>
+          </ns0:nvPr>
+        </ns0:nvSpPr>
+        <ns0:spPr/>
+        <ns0:txBody>
+          <ns1:bodyPr/>
+          <ns1:lstStyle/>
+          <ns1:p>
+            <ns1:r>
+              <ns1:rPr sz="1200"/>
+              <ns1:t>Poster figure inputs: results/for_manuscript/tables/publication_object_selection.csv; results/for_manuscript/tables/mass_offset_object_sensitivity.csv; results/v3/tables/v3_object_point_ranking.csv; results/v3/tables/v3_object_uncertainty_ranking.csv; results/v4/tables/v4_minimum_seed_mass.csv. Scientific inputs are pinned in data/poster_inputs.json. The uncertainty panel is generated by src.internal.poster_figures. The earlier-onset panel holds the stated average cap and radiative efficiency constant along each track. The external dynamical comparison uses the adopted arXiv v2 measurement; the required ratios and intervals are calculated by this project.</ns1:t>
+            </ns1:r>
+          </ns1:p>
+          <ns1:p>
+            <ns1:r>
+              <ns1:rPr sz="1200"/>
+              <ns1:t>[1] Shen (2013), The Mass of Quasars: https://arxiv.org/abs/1302.2643 — broad-line virial mass methods and calibration scatter.</ns1:t>
+            </ns1:r>
+          </ns1:p>
+          <ns1:p>
+            <ns1:r>
+              <ns1:rPr sz="1200"/>
+              <ns1:t>[2] Maiolino et al. (2024), A small and vigorous black hole in the early Universe: https://doi.org/10.1038/s41586-024-07052-5 — GN-z11 ultraviolet-line mass and early JWST context.</ns1:t>
+            </ns1:r>
+          </ns1:p>
+          <ns1:p>
+            <ns1:r>
+              <ns1:rPr sz="1200"/>
+              <ns1:t>[3] Dayal (2024), Exploring a primordial solution for early black holes detected with JWST: https://doi.org/10.1051/0004-6361/202451481 — exponential accretion growth relation. The project inverts the growth relation; its reference seed and growth-test thresholds are analysis assumptions.</ns1:t>
+            </ns1:r>
+          </ns1:p>
+          <ns1:p>
+            <ns1:r>
+              <ns1:rPr sz="1200"/>
+              <ns1:t>[4] Bardeen, Press &amp; Teukolsky (1972): https://doi.org/10.1086/151796 — ideal thin-disc efficiency for a non-spinning black hole, 1-sqrt(8/9).</ns1:t>
+            </ns1:r>
+          </ns1:p>
+          <ns1:p>
+            <ns1:r>
+              <ns1:rPr sz="1200"/>
+              <ns1:t>[5] Juodzbalis et al. (2025): https://arxiv.org/abs/2508.21748v2 — adopted independent A2744-QSO1 dynamical mass. The poster's average Eddington ratios are project calculations, not measurements quoted from this paper.</ns1:t>
+            </ns1:r>
+          </ns1:p>
+        </ns0:txBody>
+      </ns0:sp>
+      <ns0:sp>
+        <ns0:nvSpPr>
+          <ns0:cNvPr id="4" name="Slide Number Placeholder 3">
+            <ns1:extLst>
+              <ns1:ext uri="{FF2B5EF4-FFF2-40B4-BE49-F238E27FC236}">
+                <ns2:creationId id="{A8B3E2F2-BDDF-9490-DE7B-11CDCE91017C}"/>
+              </ns1:ext>
+            </ns1:extLst>
+          </ns0:cNvPr>
+          <ns0:cNvSpPr>
+            <ns1:spLocks noGrp="1"/>
+          </ns0:cNvSpPr>
+          <ns0:nvPr>
+            <ns0:ph type="sldNum" sz="quarter" idx="5"/>
+          </ns0:nvPr>
+        </ns0:nvSpPr>
+        <ns0:spPr/>
+        <ns0:txBody>
+          <ns1:bodyPr/>
+          <ns1:lstStyle/>
+          <ns1:p>
+            <ns1:fld id="{490DA246-DE01-5046-81A0-D7E93C87400D}" type="slidenum">
+              <ns1:rPr lang="en-US" smtClean="0"/>
+              <ns1:t>1</ns1:t>
+            </ns1:fld>
+            <ns1:endParaRPr lang="en-US"/>
+          </ns1:p>
+        </ns0:txBody>
+      </ns0:sp>
+    </ns0:spTree>
+    <ns0:extLst>
+      <ns0:ext uri="{BB962C8B-B14F-4D97-AF65-F5344CB8AC3E}">
+        <ns3:creationId val="3600152407"/>
+      </ns0:ext>
+    </ns0:extLst>
+  </ns0:cSld>
+  <ns0:clrMapOvr>
+    <ns1:masterClrMapping/>
+  </ns0:clrMapOvr>
+</ns0:notes>
 </file>
 
 <file path=ppt/slideLayouts/slideLayout1.xml><?xml version="1.0" encoding="utf-8"?>
@@ -5039,2403 +5098,6 @@
       </p:grpSpPr>
       <p:pic>
         <p:nvPicPr>
-          <p:cNvPr id="3" name="Picture 2">
-            <a:extLst>
-              <a:ext uri="{FF2B5EF4-FFF2-40B4-BE49-F238E27FC236}">
-                <a16:creationId xmlns:a16="http://schemas.microsoft.com/office/drawing/2014/main" id="{535E2EF0-72FB-E9D0-1E82-C65E26ED9E91}"/>
-              </a:ext>
-            </a:extLst>
-          </p:cNvPr>
-          <p:cNvPicPr>
-            <a:picLocks noChangeAspect="1"/>
-          </p:cNvPicPr>
-          <p:nvPr/>
-        </p:nvPicPr>
-        <p:blipFill>
-          <a:blip r:embed="rId3"/>
-          <a:stretch>
-            <a:fillRect/>
-          </a:stretch>
-        </p:blipFill>
-        <p:spPr>
-          <a:xfrm>
-            <a:off x="1005840" y="26251523"/>
-            <a:ext cx="15087600" cy="10515600"/>
-          </a:xfrm>
-          <a:prstGeom prst="rect">
-            <a:avLst/>
-          </a:prstGeom>
-        </p:spPr>
-      </p:pic>
-      <p:pic>
-        <p:nvPicPr>
-          <p:cNvPr id="14" name="Minimum seed mass versus accretion onset" descr="Manuscript minimum seed masses under fixed growth caps for UNCOVER-20466, COSMOS3D-13852, RUBIES-EGS-55604, and GN-z11.">
-            <a:extLst>
-              <a:ext uri="{FF2B5EF4-FFF2-40B4-BE49-F238E27FC236}">
-                <a16:creationId xmlns:a16="http://schemas.microsoft.com/office/drawing/2014/main" id="{C3CA3027-10C5-D39A-05B0-82DB2540F9D3}"/>
-              </a:ext>
-            </a:extLst>
-          </p:cNvPr>
-          <p:cNvPicPr>
-            <a:picLocks noChangeAspect="1"/>
-          </p:cNvPicPr>
-          <p:nvPr/>
-        </p:nvPicPr>
-        <p:blipFill>
-          <a:blip r:embed="rId4"/>
-          <a:stretch>
-            <a:fillRect/>
-          </a:stretch>
-        </p:blipFill>
-        <p:spPr>
-          <a:xfrm>
-            <a:off x="16962120" y="22287711"/>
-            <a:ext cx="14630400" cy="9875520"/>
-          </a:xfrm>
-          <a:prstGeom prst="rect">
-            <a:avLst/>
-          </a:prstGeom>
-        </p:spPr>
-      </p:pic>
-      <p:sp>
-        <p:nvSpPr>
-          <p:cNvPr id="32" name="Title 18">
-            <a:extLst>
-              <a:ext uri="{FF2B5EF4-FFF2-40B4-BE49-F238E27FC236}">
-                <a16:creationId xmlns:a16="http://schemas.microsoft.com/office/drawing/2014/main" id="{F8D50A2A-9B61-AD34-B9C2-8944BB27426C}"/>
-              </a:ext>
-            </a:extLst>
-          </p:cNvPr>
-          <p:cNvSpPr>
-            <a:spLocks noGrp="1"/>
-          </p:cNvSpPr>
-          <p:nvPr>
-            <p:ph type="title" idx="4294967295"/>
-          </p:nvPr>
-        </p:nvSpPr>
-        <p:spPr>
-          <a:xfrm>
-            <a:off x="-384048" y="-168958"/>
-            <a:ext cx="33686496" cy="4842334"/>
-          </a:xfrm>
-          <a:solidFill>
-            <a:srgbClr val="002A5C"/>
-          </a:solidFill>
-          <a:ln>
-            <a:solidFill>
-              <a:srgbClr val="09306B"/>
-            </a:solidFill>
-          </a:ln>
-        </p:spPr>
-        <p:txBody>
-          <a:bodyPr lIns="7680960" tIns="457200" rIns="8869680">
-            <a:normAutofit/>
-          </a:bodyPr>
-          <a:lstStyle/>
-          <a:p>
-            <a:pPr algn="ctr"/>
-            <a:br>
-              <a:rPr lang="en-US" sz="4200" b="0" dirty="0">
-                <a:solidFill>
-                  <a:schemeClr val="bg1"/>
-                </a:solidFill>
-                <a:latin typeface="Arial" panose="020B0604020202020204" pitchFamily="34" charset="0"/>
-                <a:cs typeface="Arial" panose="020B0604020202020204" pitchFamily="34" charset="0"/>
-              </a:rPr>
-            </a:br>
-            <a:r>
-              <a:rPr lang="en-US" sz="6800" b="1" dirty="0">
-                <a:solidFill>
-                  <a:schemeClr val="bg1"/>
-                </a:solidFill>
-                <a:latin typeface="Arial" panose="020B0604020202020204" pitchFamily="34" charset="0"/>
-                <a:cs typeface="Arial" panose="020B0604020202020204" pitchFamily="34" charset="0"/>
-              </a:rPr>
-              <a:t>Early Black-Hole Growth
-Constraints from JWST</a:t>
-            </a:r>
-            <a:br>
-              <a:rPr lang="en-US" sz="6800" b="0" dirty="0">
-                <a:solidFill>
-                  <a:schemeClr val="bg1"/>
-                </a:solidFill>
-                <a:latin typeface="Arial" panose="020B0604020202020204" pitchFamily="34" charset="0"/>
-                <a:cs typeface="Arial" panose="020B0604020202020204" pitchFamily="34" charset="0"/>
-              </a:rPr>
-            </a:br>
-            <a:r>
-              <a:rPr lang="en-US" sz="6800" b="0" dirty="0">
-                <a:solidFill>
-                  <a:schemeClr val="bg1"/>
-                </a:solidFill>
-                <a:latin typeface="Arial" panose="020B0604020202020204" pitchFamily="34" charset="0"/>
-                <a:cs typeface="Arial" panose="020B0604020202020204" pitchFamily="34" charset="0"/>
-              </a:rPr>
-              <a:t>Nicole Jiang; University of Toronto</a:t>
-            </a:r>
-            <a:br>
-              <a:rPr lang="en-US" sz="4200" b="0" dirty="0">
-                <a:solidFill>
-                  <a:schemeClr val="bg1"/>
-                </a:solidFill>
-                <a:latin typeface="Arial" panose="020B0604020202020204" pitchFamily="34" charset="0"/>
-                <a:cs typeface="Arial" panose="020B0604020202020204" pitchFamily="34" charset="0"/>
-              </a:rPr>
-            </a:br>
-            <a:endParaRPr lang="en-US" sz="6800" b="0" dirty="0">
-              <a:solidFill>
-                <a:schemeClr val="bg1"/>
-              </a:solidFill>
-              <a:latin typeface="Arial" panose="020B0604020202020204" pitchFamily="34" charset="0"/>
-              <a:cs typeface="Arial" panose="020B0604020202020204" pitchFamily="34" charset="0"/>
-            </a:endParaRPr>
-          </a:p>
-        </p:txBody>
-      </p:sp>
-      <p:pic>
-        <p:nvPicPr>
-          <p:cNvPr id="33" name="Picture 32" descr="University of Toronto - Wikipedia">
-            <a:extLst>
-              <a:ext uri="{FF2B5EF4-FFF2-40B4-BE49-F238E27FC236}">
-                <a16:creationId xmlns:a16="http://schemas.microsoft.com/office/drawing/2014/main" id="{42BD33B9-86B6-8B04-8AA1-E72E85543563}"/>
-              </a:ext>
-            </a:extLst>
-          </p:cNvPr>
-          <p:cNvPicPr>
-            <a:picLocks noChangeAspect="1"/>
-          </p:cNvPicPr>
-          <p:nvPr/>
-        </p:nvPicPr>
-        <p:blipFill>
-          <a:blip r:embed="rId5"/>
-          <a:stretch>
-            <a:fillRect/>
-          </a:stretch>
-        </p:blipFill>
-        <p:spPr>
-          <a:xfrm>
-            <a:off x="914400" y="774808"/>
-            <a:ext cx="2377440" cy="2377440"/>
-          </a:xfrm>
-          <a:prstGeom prst="rect">
-            <a:avLst/>
-          </a:prstGeom>
-        </p:spPr>
-      </p:pic>
-      <p:pic>
-        <p:nvPicPr>
-          <p:cNvPr id="36" name="Picture 35" descr="University of Toronto profile | Powered by Inpart">
-            <a:extLst>
-              <a:ext uri="{FF2B5EF4-FFF2-40B4-BE49-F238E27FC236}">
-                <a16:creationId xmlns:a16="http://schemas.microsoft.com/office/drawing/2014/main" id="{8C2E503F-9CF2-EBE6-29B0-458691A7DFB1}"/>
-              </a:ext>
-            </a:extLst>
-          </p:cNvPr>
-          <p:cNvPicPr>
-            <a:picLocks noChangeAspect="1"/>
-          </p:cNvPicPr>
-          <p:nvPr/>
-        </p:nvPicPr>
-        <p:blipFill>
-          <a:blip r:embed="rId6"/>
-          <a:srcRect l="23902" t="38725" b="33824"/>
-          <a:stretch>
-            <a:fillRect/>
-          </a:stretch>
-        </p:blipFill>
-        <p:spPr>
-          <a:xfrm>
-            <a:off x="2961848" y="1118870"/>
-            <a:ext cx="4937760" cy="1781207"/>
-          </a:xfrm>
-          <a:prstGeom prst="rect">
-            <a:avLst/>
-          </a:prstGeom>
-        </p:spPr>
-      </p:pic>
-      <p:pic>
-        <p:nvPicPr>
-          <p:cNvPr id="37" name="Picture 36">
-            <a:extLst>
-              <a:ext uri="{FF2B5EF4-FFF2-40B4-BE49-F238E27FC236}">
-                <a16:creationId xmlns:a16="http://schemas.microsoft.com/office/drawing/2014/main" id="{2C65ED58-816C-A2B5-F6CB-4326B0858DDD}"/>
-              </a:ext>
-            </a:extLst>
-          </p:cNvPr>
-          <p:cNvPicPr>
-            <a:picLocks noChangeAspect="1"/>
-          </p:cNvPicPr>
-          <p:nvPr/>
-        </p:nvPicPr>
-        <p:blipFill>
-          <a:blip r:embed="rId7"/>
-          <a:stretch>
-            <a:fillRect/>
-          </a:stretch>
-        </p:blipFill>
-        <p:spPr>
-          <a:xfrm>
-            <a:off x="29443680" y="502920"/>
-            <a:ext cx="2743200" cy="2743200"/>
-          </a:xfrm>
-          <a:prstGeom prst="rect">
-            <a:avLst/>
-          </a:prstGeom>
-        </p:spPr>
-      </p:pic>
-      <p:sp>
-        <p:nvSpPr>
-          <p:cNvPr id="69" name="Title 18">
-            <a:extLst>
-              <a:ext uri="{FF2B5EF4-FFF2-40B4-BE49-F238E27FC236}">
-                <a16:creationId xmlns:a16="http://schemas.microsoft.com/office/drawing/2014/main" id="{D8B6836B-DAF1-F68F-D717-73D3A454BC2E}"/>
-              </a:ext>
-            </a:extLst>
-          </p:cNvPr>
-          <p:cNvSpPr txBox="1">
-            <a:spLocks/>
-          </p:cNvSpPr>
-          <p:nvPr/>
-        </p:nvSpPr>
-        <p:spPr>
-          <a:xfrm>
-            <a:off x="914400" y="5362478"/>
-            <a:ext cx="15087600" cy="960120"/>
-          </a:xfrm>
-          <a:prstGeom prst="rect">
-            <a:avLst/>
-          </a:prstGeom>
-          <a:solidFill>
-            <a:srgbClr val="002A5C"/>
-          </a:solidFill>
-          <a:ln>
-            <a:solidFill>
-              <a:srgbClr val="09306B"/>
-            </a:solidFill>
-          </a:ln>
-        </p:spPr>
-        <p:txBody>
-          <a:bodyPr vert="horz" lIns="78373" tIns="39187" rIns="78373" bIns="39187" rtlCol="0" anchor="ctr" anchorCtr="1">
-            <a:normAutofit/>
-          </a:bodyPr>
-          <a:lstStyle>
-            <a:lvl1pPr algn="l" defTabSz="4389120" rtl="0" eaLnBrk="1" latinLnBrk="0" hangingPunct="1">
-              <a:lnSpc>
-                <a:spcPct val="90000"/>
-              </a:lnSpc>
-              <a:spcBef>
-                <a:spcPct val="0"/>
-              </a:spcBef>
-              <a:buNone/>
-              <a:defRPr sz="6200" b="1" kern="1200">
-                <a:solidFill>
-                  <a:schemeClr val="bg1"/>
-                </a:solidFill>
-                <a:latin typeface="Arial"/>
-                <a:ea typeface="+mj-ea"/>
-                <a:cs typeface="Arial"/>
-              </a:defRPr>
-            </a:lvl1pPr>
-          </a:lstStyle>
-          <a:p>
-            <a:pPr algn="ctr"/>
-            <a:r>
-              <a:rPr lang="en-US" sz="5000" dirty="0"/>
-              <a:t>Introduction</a:t>
-            </a:r>
-          </a:p>
-        </p:txBody>
-      </p:sp>
-      <p:sp>
-        <p:nvSpPr>
-          <p:cNvPr id="70" name="TextBox 69">
-            <a:extLst>
-              <a:ext uri="{FF2B5EF4-FFF2-40B4-BE49-F238E27FC236}">
-                <a16:creationId xmlns:a16="http://schemas.microsoft.com/office/drawing/2014/main" id="{7842EAEC-0FF9-516A-6712-19E0D19D0354}"/>
-              </a:ext>
-            </a:extLst>
-          </p:cNvPr>
-          <p:cNvSpPr txBox="1"/>
-          <p:nvPr/>
-        </p:nvSpPr>
-        <p:spPr>
-          <a:xfrm>
-            <a:off x="1371600" y="6642638"/>
-            <a:ext cx="14173200" cy="2631490"/>
-          </a:xfrm>
-          <a:prstGeom prst="rect">
-            <a:avLst/>
-          </a:prstGeom>
-          <a:noFill/>
-        </p:spPr>
-        <p:txBody>
-          <a:bodyPr wrap="square" lIns="91440" tIns="45720" rIns="91440" bIns="45720" rtlCol="0" anchor="t">
-            <a:spAutoFit/>
-          </a:bodyPr>
-          <a:lstStyle/>
-          <a:p>
-            <a:pPr>
-              <a:buNone/>
-            </a:pPr>
-            <a:r>
-              <a:rPr lang="en-CA" sz="3300" b="1">
-                <a:latin typeface="Aptos"/>
-              </a:rPr>
-              <a:t>How did early black holes grow so big, so fast? </a:t>
-            </a:r>
-            <a:r>
-              <a:rPr lang="en-CA" sz="3300" b="0">
-                <a:latin typeface="Aptos"/>
-              </a:rPr>
-              <a:t>The James Webb Space Telescope (JWST) has revealed massive black holes with little time to grow. I compiled published mass estimates and calculated the average accretion needed to reach each mass under different seed masses (initial masses), start times, and radiative efficiencies.</a:t>
-            </a:r>
-          </a:p>
-        </p:txBody>
-      </p:sp>
-      <p:sp>
-        <p:nvSpPr>
-          <p:cNvPr id="71" name="Rectangle 70">
-            <a:extLst>
-              <a:ext uri="{FF2B5EF4-FFF2-40B4-BE49-F238E27FC236}">
-                <a16:creationId xmlns:a16="http://schemas.microsoft.com/office/drawing/2014/main" id="{ABB03D82-A209-1440-3180-9DD4419EFCBF}"/>
-              </a:ext>
-            </a:extLst>
-          </p:cNvPr>
-          <p:cNvSpPr/>
-          <p:nvPr/>
-        </p:nvSpPr>
-        <p:spPr>
-          <a:xfrm>
-            <a:off x="914400" y="5362479"/>
-            <a:ext cx="15087600" cy="4322460"/>
-          </a:xfrm>
-          <a:prstGeom prst="rect">
-            <a:avLst/>
-          </a:prstGeom>
-          <a:noFill/>
-          <a:ln>
-            <a:solidFill>
-              <a:srgbClr val="002A5C"/>
-            </a:solidFill>
-          </a:ln>
-        </p:spPr>
-        <p:style>
-          <a:lnRef idx="2">
-            <a:schemeClr val="accent1">
-              <a:shade val="15000"/>
-            </a:schemeClr>
-          </a:lnRef>
-          <a:fillRef idx="1">
-            <a:schemeClr val="accent1"/>
-          </a:fillRef>
-          <a:effectRef idx="0">
-            <a:schemeClr val="accent1"/>
-          </a:effectRef>
-          <a:fontRef idx="minor">
-            <a:schemeClr val="lt1"/>
-          </a:fontRef>
-        </p:style>
-        <p:txBody>
-          <a:bodyPr rtlCol="0" anchor="ctr"/>
-          <a:lstStyle/>
-          <a:p>
-            <a:pPr algn="ctr"/>
-            <a:endParaRPr lang="en-US"/>
-          </a:p>
-        </p:txBody>
-      </p:sp>
-      <p:sp>
-        <p:nvSpPr>
-          <p:cNvPr id="72" name="Title 18">
-            <a:extLst>
-              <a:ext uri="{FF2B5EF4-FFF2-40B4-BE49-F238E27FC236}">
-                <a16:creationId xmlns:a16="http://schemas.microsoft.com/office/drawing/2014/main" id="{6D9DC137-E8CF-8FC7-F26F-A7759AD2C396}"/>
-              </a:ext>
-            </a:extLst>
-          </p:cNvPr>
-          <p:cNvSpPr txBox="1">
-            <a:spLocks/>
-          </p:cNvSpPr>
-          <p:nvPr/>
-        </p:nvSpPr>
-        <p:spPr>
-          <a:xfrm>
-            <a:off x="914400" y="10184457"/>
-            <a:ext cx="15087600" cy="960120"/>
-          </a:xfrm>
-          <a:prstGeom prst="rect">
-            <a:avLst/>
-          </a:prstGeom>
-          <a:solidFill>
-            <a:srgbClr val="002A5C"/>
-          </a:solidFill>
-          <a:ln>
-            <a:solidFill>
-              <a:srgbClr val="09306B"/>
-            </a:solidFill>
-          </a:ln>
-        </p:spPr>
-        <p:txBody>
-          <a:bodyPr vert="horz" lIns="78373" tIns="39187" rIns="78373" bIns="39187" rtlCol="0" anchor="ctr" anchorCtr="1">
-            <a:normAutofit/>
-          </a:bodyPr>
-          <a:lstStyle>
-            <a:lvl1pPr algn="l" defTabSz="4389120" rtl="0" eaLnBrk="1" latinLnBrk="0" hangingPunct="1">
-              <a:lnSpc>
-                <a:spcPct val="90000"/>
-              </a:lnSpc>
-              <a:spcBef>
-                <a:spcPct val="0"/>
-              </a:spcBef>
-              <a:buNone/>
-              <a:defRPr sz="6200" b="1" kern="1200">
-                <a:solidFill>
-                  <a:schemeClr val="bg1"/>
-                </a:solidFill>
-                <a:latin typeface="Arial"/>
-                <a:ea typeface="+mj-ea"/>
-                <a:cs typeface="Arial"/>
-              </a:defRPr>
-            </a:lvl1pPr>
-          </a:lstStyle>
-          <a:p>
-            <a:pPr algn="ctr"/>
-            <a:r>
-              <a:rPr lang="en-US" sz="5000" dirty="0"/>
-              <a:t>Methods</a:t>
-            </a:r>
-          </a:p>
-        </p:txBody>
-      </p:sp>
-      <mc:AlternateContent xmlns:mc="http://schemas.openxmlformats.org/markup-compatibility/2006" xmlns:a14="http://schemas.microsoft.com/office/drawing/2010/main">
-        <mc:Choice Requires="a14">
-          <p:sp>
-            <p:nvSpPr>
-              <p:cNvPr id="73" name="TextBox 72">
-                <a:extLst>
-                  <a:ext uri="{FF2B5EF4-FFF2-40B4-BE49-F238E27FC236}">
-                    <a16:creationId xmlns:a16="http://schemas.microsoft.com/office/drawing/2014/main" id="{88C51BF9-B81A-ECF4-F01D-305CA1CE9DD1}"/>
-                  </a:ext>
-                </a:extLst>
-              </p:cNvPr>
-              <p:cNvSpPr txBox="1"/>
-              <p:nvPr/>
-            </p:nvSpPr>
-            <p:spPr>
-              <a:xfrm>
-                <a:off x="1463040" y="11559248"/>
-                <a:ext cx="14173200" cy="12808443"/>
-              </a:xfrm>
-              <a:prstGeom prst="rect">
-                <a:avLst/>
-              </a:prstGeom>
-              <a:noFill/>
-            </p:spPr>
-            <p:txBody>
-              <a:bodyPr wrap="square" rtlCol="0">
-                <a:spAutoFit/>
-              </a:bodyPr>
-              <a:lstStyle/>
-              <a:p>
-                <a:pPr>
-                  <a:spcAft>
-                    <a:spcPts val="500"/>
-                  </a:spcAft>
-                  <a:buNone/>
-                </a:pPr>
-                <a:r>
-                  <a:rPr lang="en-CA" sz="3300" b="1" dirty="0">
-                    <a:latin typeface="Aptos"/>
-                  </a:rPr>
-                  <a:t>Catalogue: </a:t>
-                </a:r>
-                <a:r>
-                  <a:rPr lang="en-CA" sz="3300" b="0" dirty="0">
-                    <a:latin typeface="Aptos"/>
-                  </a:rPr>
-                  <a:t>Compiled 350 measurements from 32 publication groups at z ≥ 4. Selected 1 mass per object and retained alternatives. Primary: 220 objects with broad Balmer-line masses [1]. Expanded: 234 objects, including tentative candidates and GN-z11 [2].</a:t>
-                </a:r>
-              </a:p>
-              <a:p>
-                <a:pPr>
-                  <a:spcAft>
-                    <a:spcPts val="500"/>
-                  </a:spcAft>
-                  <a:buNone/>
-                </a:pPr>
-                <a:r>
-                  <a:rPr lang="en-CA" sz="3300" b="1" dirty="0">
-                    <a:latin typeface="Aptos"/>
-                  </a:rPr>
-                  <a:t>Reference model: </a:t>
-                </a:r>
-                <a:r>
-                  <a:rPr lang="en-CA" sz="3300" b="0" dirty="0">
-                    <a:latin typeface="Aptos"/>
-                  </a:rPr>
-                  <a:t>Assumed 100 M⊙ seeds at z = 30, radiative efficiency </a:t>
-                </a:r>
-                <a:r>
-                  <a:rPr lang="en-CA" sz="3300" b="0" dirty="0" err="1">
-                    <a:latin typeface="Aptos"/>
-                  </a:rPr>
-                  <a:t>ε</a:t>
-                </a:r>
-                <a:r>
-                  <a:rPr lang="en-CA" sz="3300" b="0" dirty="0">
-                    <a:latin typeface="Aptos"/>
-                  </a:rPr>
-                  <a:t> = 0.1, no mergers (</a:t>
-                </a:r>
-                <a:r>
-                  <a:rPr lang="en-CA" sz="3300" b="0" dirty="0" err="1">
-                    <a:latin typeface="Aptos"/>
-                  </a:rPr>
-                  <a:t>B</a:t>
-                </a:r>
-                <a:r>
-                  <a:rPr lang="en-CA" sz="3300" b="0" baseline="-25000" dirty="0" err="1">
-                    <a:latin typeface="Aptos"/>
-                  </a:rPr>
-                  <a:t>merge</a:t>
-                </a:r>
-                <a:r>
-                  <a:rPr lang="en-CA" sz="3300" b="0" dirty="0">
-                    <a:latin typeface="Aptos"/>
-                  </a:rPr>
-                  <a:t> = 1), and </a:t>
-                </a:r>
-                <a:r>
-                  <a:rPr lang="en-CA" sz="3300" b="0" dirty="0" err="1">
-                    <a:latin typeface="Aptos"/>
-                  </a:rPr>
-                  <a:t>t</a:t>
-                </a:r>
-                <a:r>
-                  <a:rPr lang="en-CA" sz="3300" b="0" baseline="-25000" dirty="0" err="1">
-                    <a:latin typeface="Aptos"/>
-                  </a:rPr>
-                  <a:t>Edd</a:t>
-                </a:r>
-                <a:r>
-                  <a:rPr lang="en-CA" sz="3300" b="0" dirty="0">
-                    <a:latin typeface="Aptos"/>
-                  </a:rPr>
-                  <a:t> ≈ 0.45 Gyr [3].</a:t>
-                </a:r>
-              </a:p>
-              <a:p>
-                <a:pPr>
-                  <a:spcAft>
-                    <a:spcPts val="500"/>
-                  </a:spcAft>
-                  <a:buNone/>
-                </a:pPr>
-                <a:r>
-                  <a:rPr lang="en-CA" sz="3300" b="1" dirty="0">
-                    <a:latin typeface="Aptos"/>
-                  </a:rPr>
-                  <a:t>Model tests: </a:t>
-                </a:r>
-                <a:r>
-                  <a:rPr lang="en-CA" sz="3300" b="0" dirty="0">
-                    <a:latin typeface="Aptos"/>
-                  </a:rPr>
-                  <a:t>Calculated and ranked required lifetime-average Eddington ratios. Compared them with assumed maximum averages: 1 (reference) and 0.3, 1, or 2 (earlier onset).</a:t>
-                </a:r>
-              </a:p>
-              <a:p>
-                <a:pPr>
-                  <a:spcBef>
-                    <a:spcPts val="600"/>
-                  </a:spcBef>
-                </a:pPr>
-                <a14:m>
-                  <m:oMathPara xmlns:m="http://schemas.openxmlformats.org/officeDocument/2006/math">
-                    <m:oMathParaPr>
-                      <m:jc m:val="left"/>
-                    </m:oMathParaPr>
-                    <m:oMath>
-                      <m:sSub>
-                        <m:sSubPr>
-                          <m:ctrlPr>
-                            <a:rPr lang="en-US" sz="3300" i="1">
-                              <a:latin typeface="Cambria Math" panose="02040503050406030204" pitchFamily="18" charset="0"/>
-                            </a:rPr>
-                          </m:ctrlPr>
-                        </m:sSubPr>
-                        <m:e>
-                          <m:bar>
-                            <m:barPr>
-                              <m:pos m:val="top"/>
-                              <m:ctrlPr>
-                                <a:rPr lang="en-US" sz="3300" i="1">
-                                  <a:latin typeface="Cambria Math"/>
-                                </a:rPr>
-                              </m:ctrlPr>
-                            </m:barPr>
-                            <m:e>
-                              <m:r>
-                                <a:rPr lang="en-US" sz="3300" i="1">
-                                  <a:latin typeface="Cambria Math"/>
-                                </a:rPr>
-                                <m:t>𝑓</m:t>
-                              </m:r>
-                            </m:e>
-                          </m:bar>
-                        </m:e>
-                        <m:sub>
-                          <m:r>
-                            <m:rPr>
-                              <m:sty m:val="p"/>
-                            </m:rPr>
-                            <a:rPr lang="en-US" sz="3300" i="0">
-                              <a:latin typeface="Cambria Math"/>
-                            </a:rPr>
-                            <m:t>Edd</m:t>
-                          </m:r>
-                          <m:r>
-                            <a:rPr lang="en-US" sz="3300" i="0">
-                              <a:latin typeface="Cambria Math"/>
-                            </a:rPr>
-                            <m:t>,</m:t>
-                          </m:r>
-                          <m:r>
-                            <m:rPr>
-                              <m:sty m:val="p"/>
-                            </m:rPr>
-                            <a:rPr lang="en-US" sz="3300" i="0">
-                              <a:latin typeface="Cambria Math"/>
-                            </a:rPr>
-                            <m:t>req</m:t>
-                          </m:r>
-                        </m:sub>
-                      </m:sSub>
-                      <m:r>
-                        <a:rPr lang="en-US" sz="3300" i="1">
-                          <a:latin typeface="Cambria Math"/>
-                        </a:rPr>
-                        <m:t>=</m:t>
-                      </m:r>
-                      <m:func>
-                        <m:funcPr>
-                          <m:ctrlPr>
-                            <a:rPr lang="en-US" sz="3300" i="0">
-                              <a:latin typeface="Cambria Math"/>
-                            </a:rPr>
-                          </m:ctrlPr>
-                        </m:funcPr>
-                        <m:fName>
-                          <m:r>
-                            <m:rPr>
-                              <m:sty m:val="p"/>
-                            </m:rPr>
-                            <a:rPr lang="en-US" sz="3300" i="0">
-                              <a:latin typeface="Cambria Math"/>
-                            </a:rPr>
-                            <m:t>max</m:t>
-                          </m:r>
-                        </m:fName>
-                        <m:e>
-                          <m:d>
-                            <m:dPr>
-                              <m:begChr m:val="["/>
-                              <m:endChr m:val="]"/>
-                              <m:ctrlPr>
-                                <a:rPr lang="en-US" sz="3300" i="1">
-                                  <a:latin typeface="Cambria Math"/>
-                                </a:rPr>
-                              </m:ctrlPr>
-                            </m:dPr>
-                            <m:e>
-                              <m:r>
-                                <a:rPr lang="en-US" sz="3300" i="1">
-                                  <a:latin typeface="Cambria Math"/>
-                                </a:rPr>
-                                <m:t>0,</m:t>
-                              </m:r>
-                              <m:f>
-                                <m:fPr>
-                                  <m:ctrlPr>
-                                    <a:rPr lang="en-US" sz="3300" i="1">
-                                      <a:latin typeface="Cambria Math"/>
-                                    </a:rPr>
-                                  </m:ctrlPr>
-                                </m:fPr>
-                                <m:num>
-                                  <m:r>
-                                    <a:rPr lang="en-US" sz="3300" i="1">
-                                      <a:latin typeface="Cambria Math"/>
-                                    </a:rPr>
-                                    <m:t>𝜀</m:t>
-                                  </m:r>
-                                </m:num>
-                                <m:den>
-                                  <m:r>
-                                    <a:rPr lang="en-US" sz="3300" i="1">
-                                      <a:latin typeface="Cambria Math"/>
-                                    </a:rPr>
-                                    <m:t>1−</m:t>
-                                  </m:r>
-                                  <m:r>
-                                    <a:rPr lang="en-US" sz="3300" i="1">
-                                      <a:latin typeface="Cambria Math"/>
-                                    </a:rPr>
-                                    <m:t>𝜀</m:t>
-                                  </m:r>
-                                </m:den>
-                              </m:f>
-                              <m:f>
-                                <m:fPr>
-                                  <m:ctrlPr>
-                                    <a:rPr lang="en-US" sz="3300" i="1">
-                                      <a:latin typeface="Cambria Math" panose="02040503050406030204" pitchFamily="18" charset="0"/>
-                                    </a:rPr>
-                                  </m:ctrlPr>
-                                </m:fPr>
-                                <m:num>
-                                  <m:sSub>
-                                    <m:sSubPr>
-                                      <m:ctrlPr>
-                                        <a:rPr lang="en-US" sz="3300" i="1">
-                                          <a:latin typeface="Cambria Math"/>
-                                        </a:rPr>
-                                      </m:ctrlPr>
-                                    </m:sSubPr>
-                                    <m:e>
-                                      <m:r>
-                                        <a:rPr lang="en-US" sz="3300" i="1">
-                                          <a:latin typeface="Cambria Math"/>
-                                        </a:rPr>
-                                        <m:t>𝑡</m:t>
-                                      </m:r>
-                                    </m:e>
-                                    <m:sub>
-                                      <m:r>
-                                        <m:rPr>
-                                          <m:sty m:val="p"/>
-                                        </m:rPr>
-                                        <a:rPr lang="en-US" sz="3300" i="0">
-                                          <a:latin typeface="Cambria Math"/>
-                                        </a:rPr>
-                                        <m:t>Edd</m:t>
-                                      </m:r>
-                                    </m:sub>
-                                  </m:sSub>
-                                </m:num>
-                                <m:den>
-                                  <m:r>
-                                    <a:rPr lang="en-US" sz="3300" i="1">
-                                      <a:latin typeface="Cambria Math"/>
-                                    </a:rPr>
-                                    <m:t>𝛥</m:t>
-                                  </m:r>
-                                  <m:r>
-                                    <a:rPr lang="en-US" sz="3300" i="1">
-                                      <a:latin typeface="Cambria Math"/>
-                                    </a:rPr>
-                                    <m:t>𝑡</m:t>
-                                  </m:r>
-                                </m:den>
-                              </m:f>
-                              <m:func>
-                                <m:funcPr>
-                                  <m:ctrlPr>
-                                    <a:rPr lang="en-US" sz="3300" i="0">
-                                      <a:latin typeface="Cambria Math"/>
-                                    </a:rPr>
-                                  </m:ctrlPr>
-                                </m:funcPr>
-                                <m:fName>
-                                  <m:r>
-                                    <m:rPr>
-                                      <m:sty m:val="p"/>
-                                    </m:rPr>
-                                    <a:rPr lang="en-US" sz="3300" i="0">
-                                      <a:latin typeface="Cambria Math"/>
-                                    </a:rPr>
-                                    <m:t>ln</m:t>
-                                  </m:r>
-                                </m:fName>
-                                <m:e>
-                                  <m:d>
-                                    <m:dPr>
-                                      <m:ctrlPr>
-                                        <a:rPr lang="en-US" sz="3300" i="1">
-                                          <a:latin typeface="Cambria Math" panose="02040503050406030204" pitchFamily="18" charset="0"/>
-                                        </a:rPr>
-                                      </m:ctrlPr>
-                                    </m:dPr>
-                                    <m:e>
-                                      <m:f>
-                                        <m:fPr>
-                                          <m:ctrlPr>
-                                            <a:rPr lang="en-US" sz="3300" i="1">
-                                              <a:latin typeface="Cambria Math" panose="02040503050406030204" pitchFamily="18" charset="0"/>
-                                            </a:rPr>
-                                          </m:ctrlPr>
-                                        </m:fPr>
-                                        <m:num>
-                                          <m:sSub>
-                                            <m:sSubPr>
-                                              <m:ctrlPr>
-                                                <a:rPr lang="en-US" sz="3300" i="1">
-                                                  <a:latin typeface="Cambria Math"/>
-                                                </a:rPr>
-                                              </m:ctrlPr>
-                                            </m:sSubPr>
-                                            <m:e>
-                                              <m:r>
-                                                <a:rPr lang="en-US" sz="3300" i="1">
-                                                  <a:latin typeface="Cambria Math"/>
-                                                </a:rPr>
-                                                <m:t>𝑀</m:t>
-                                              </m:r>
-                                            </m:e>
-                                            <m:sub>
-                                              <m:r>
-                                                <m:rPr>
-                                                  <m:sty m:val="p"/>
-                                                </m:rPr>
-                                                <a:rPr lang="en-US" sz="3300" i="0">
-                                                  <a:latin typeface="Cambria Math"/>
-                                                </a:rPr>
-                                                <m:t>BH</m:t>
-                                              </m:r>
-                                            </m:sub>
-                                          </m:sSub>
-                                        </m:num>
-                                        <m:den>
-                                          <m:sSub>
-                                            <m:sSubPr>
-                                              <m:ctrlPr>
-                                                <a:rPr lang="en-US" sz="3300" i="1">
-                                                  <a:latin typeface="Cambria Math"/>
-                                                </a:rPr>
-                                              </m:ctrlPr>
-                                            </m:sSubPr>
-                                            <m:e>
-                                              <m:r>
-                                                <a:rPr lang="en-US" sz="3300" i="1">
-                                                  <a:latin typeface="Cambria Math"/>
-                                                </a:rPr>
-                                                <m:t>𝐵</m:t>
-                                              </m:r>
-                                            </m:e>
-                                            <m:sub>
-                                              <m:r>
-                                                <m:rPr>
-                                                  <m:sty m:val="p"/>
-                                                </m:rPr>
-                                                <a:rPr lang="en-US" sz="3300" i="0">
-                                                  <a:latin typeface="Cambria Math"/>
-                                                </a:rPr>
-                                                <m:t>merge</m:t>
-                                              </m:r>
-                                            </m:sub>
-                                          </m:sSub>
-                                          <m:sSub>
-                                            <m:sSubPr>
-                                              <m:ctrlPr>
-                                                <a:rPr lang="en-US" sz="3300" i="1">
-                                                  <a:latin typeface="Cambria Math"/>
-                                                </a:rPr>
-                                              </m:ctrlPr>
-                                            </m:sSubPr>
-                                            <m:e>
-                                              <m:r>
-                                                <a:rPr lang="en-US" sz="3300" i="1">
-                                                  <a:latin typeface="Cambria Math"/>
-                                                </a:rPr>
-                                                <m:t>𝑀</m:t>
-                                              </m:r>
-                                            </m:e>
-                                            <m:sub>
-                                              <m:r>
-                                                <m:rPr>
-                                                  <m:sty m:val="p"/>
-                                                </m:rPr>
-                                                <a:rPr lang="en-US" sz="3300" i="0">
-                                                  <a:latin typeface="Cambria Math"/>
-                                                </a:rPr>
-                                                <m:t>seed</m:t>
-                                              </m:r>
-                                            </m:sub>
-                                          </m:sSub>
-                                        </m:den>
-                                      </m:f>
-                                    </m:e>
-                                  </m:d>
-                                </m:e>
-                              </m:func>
-                            </m:e>
-                          </m:d>
-                        </m:e>
-                      </m:func>
-                    </m:oMath>
-                  </m:oMathPara>
-                </a14:m>
-                <a:endParaRPr lang="en-CA" sz="3300" b="1" dirty="0">
-                  <a:latin typeface="Aptos"/>
-                </a:endParaRPr>
-              </a:p>
-              <a:p>
-                <a:pPr>
-                  <a:spcAft>
-                    <a:spcPts val="500"/>
-                  </a:spcAft>
-                  <a:buNone/>
-                </a:pPr>
-                <a:r>
-                  <a:rPr lang="en-CA" sz="3300" b="1" dirty="0">
-                    <a:latin typeface="Aptos"/>
-                  </a:rPr>
-                  <a:t>Symbols: </a:t>
-                </a:r>
-                <a:r>
-                  <a:rPr lang="en-CA" sz="3300" b="0" dirty="0">
-                    <a:latin typeface="Aptos"/>
-                  </a:rPr>
-                  <a:t>M⊙: solar mass. M</a:t>
-                </a:r>
-                <a:r>
-                  <a:rPr lang="en-CA" sz="2200" b="0" baseline="-25000" dirty="0">
-                    <a:latin typeface="Aptos"/>
-                  </a:rPr>
-                  <a:t>BH</a:t>
-                </a:r>
-                <a:r>
-                  <a:rPr lang="en-CA" sz="3300" b="0" dirty="0">
-                    <a:latin typeface="Aptos"/>
-                  </a:rPr>
-                  <a:t>: observed mass. </a:t>
-                </a:r>
-                <a:r>
-                  <a:rPr lang="en-CA" sz="3300" b="0" dirty="0" err="1">
-                    <a:latin typeface="Aptos"/>
-                  </a:rPr>
-                  <a:t>M</a:t>
-                </a:r>
-                <a:r>
-                  <a:rPr lang="en-CA" sz="2200" b="0" baseline="-25000" dirty="0" err="1">
-                    <a:latin typeface="Aptos"/>
-                  </a:rPr>
-                  <a:t>seed</a:t>
-                </a:r>
-                <a:r>
-                  <a:rPr lang="en-CA" sz="3300" b="0" dirty="0">
-                    <a:latin typeface="Aptos"/>
-                  </a:rPr>
-                  <a:t>: initial mass. </a:t>
-                </a:r>
-                <a:r>
-                  <a:rPr lang="en-CA" sz="3300" b="0" dirty="0" err="1">
-                    <a:latin typeface="Aptos"/>
-                  </a:rPr>
-                  <a:t>Δt</a:t>
-                </a:r>
-                <a:r>
-                  <a:rPr lang="en-CA" sz="3300" b="0" dirty="0">
-                    <a:latin typeface="Aptos"/>
-                  </a:rPr>
-                  <a:t>: growth time. </a:t>
-                </a:r>
-                <a:r>
-                  <a:rPr lang="en-CA" sz="3300" b="0" dirty="0" err="1">
-                    <a:latin typeface="Aptos"/>
-                  </a:rPr>
-                  <a:t>ε</a:t>
-                </a:r>
-                <a:r>
-                  <a:rPr lang="en-CA" sz="3300" b="0" dirty="0">
-                    <a:latin typeface="Aptos"/>
-                  </a:rPr>
-                  <a:t>: radiated fraction of inflowing rest-mass energy. Higher redshift z means earlier time.</a:t>
-                </a:r>
-              </a:p>
-              <a:p>
-                <a:pPr>
-                  <a:spcAft>
-                    <a:spcPts val="500"/>
-                  </a:spcAft>
-                  <a:buNone/>
-                </a:pPr>
-                <a:r>
-                  <a:rPr lang="en-CA" sz="3300" b="1" dirty="0">
-                    <a:latin typeface="Aptos"/>
-                  </a:rPr>
-                  <a:t>Eddington ratio: </a:t>
-                </a:r>
-                <a:r>
-                  <a:rPr lang="en-CA" sz="3300" b="0" dirty="0" err="1">
-                    <a:latin typeface="Aptos"/>
-                  </a:rPr>
-                  <a:t>f</a:t>
-                </a:r>
-                <a:r>
-                  <a:rPr lang="en-CA" sz="2200" b="0" baseline="-25000" dirty="0" err="1">
-                    <a:latin typeface="Aptos"/>
-                  </a:rPr>
-                  <a:t>Edd</a:t>
-                </a:r>
-                <a:r>
-                  <a:rPr lang="en-CA" sz="3300" b="0" dirty="0">
-                    <a:latin typeface="Aptos"/>
-                  </a:rPr>
-                  <a:t> = luminosity/Eddington luminosity. Radiation force balances gravity at this luminosity. </a:t>
-                </a:r>
-                <a:r>
-                  <a:rPr lang="en-CA" sz="3300" b="0" dirty="0" err="1">
-                    <a:latin typeface="Aptos"/>
-                  </a:rPr>
-                  <a:t>f̄</a:t>
-                </a:r>
-                <a:r>
-                  <a:rPr lang="en-CA" sz="2200" b="0" baseline="-25000" dirty="0" err="1">
-                    <a:latin typeface="Aptos"/>
-                  </a:rPr>
-                  <a:t>Edd,req</a:t>
-                </a:r>
-                <a:r>
-                  <a:rPr lang="en-CA" sz="3300" b="0" dirty="0">
-                    <a:latin typeface="Aptos"/>
-                  </a:rPr>
-                  <a:t> is the required lifetime average, including inactive periods. An average above 1 requires periods above the Eddington limit.</a:t>
-                </a:r>
-              </a:p>
-              <a:p>
-                <a:pPr>
-                  <a:spcAft>
-                    <a:spcPts val="500"/>
-                  </a:spcAft>
-                  <a:buNone/>
-                </a:pPr>
-                <a:r>
-                  <a:rPr lang="en-CA" sz="3300" b="1" dirty="0">
-                    <a:latin typeface="Aptos"/>
-                  </a:rPr>
-                  <a:t>Uncertainty: </a:t>
-                </a:r>
-                <a:r>
-                  <a:rPr lang="en-CA" sz="3300" b="0" dirty="0">
-                    <a:latin typeface="Aptos"/>
-                  </a:rPr>
-                  <a:t>Used 10,000 draws per object for reported asymmetric mass errors. The 12 objects without errors contributed only central mass estimates. Reported errors may omit calibration scatter.</a:t>
-                </a:r>
-              </a:p>
-              <a:p>
-                <a:pPr>
-                  <a:spcAft>
-                    <a:spcPts val="500"/>
-                  </a:spcAft>
-                  <a:buNone/>
-                </a:pPr>
-                <a:r>
-                  <a:rPr lang="en-CA" sz="3300" b="1" dirty="0">
-                    <a:latin typeface="Aptos"/>
-                  </a:rPr>
-                  <a:t>Sensitivity: </a:t>
-                </a:r>
-                <a:r>
-                  <a:rPr lang="en-CA" sz="3300" b="0" dirty="0">
-                    <a:latin typeface="Aptos"/>
-                  </a:rPr>
-                  <a:t>Varied mass scale, seed mass, growth start time, and efficiency separately.</a:t>
-                </a:r>
-              </a:p>
-              <a:p>
-                <a:pPr>
-                  <a:spcAft>
-                    <a:spcPts val="500"/>
-                  </a:spcAft>
-                  <a:buNone/>
-                </a:pPr>
-                <a:r>
-                  <a:rPr lang="en-CA" sz="3300" b="1" dirty="0">
-                    <a:latin typeface="Aptos"/>
-                  </a:rPr>
-                  <a:t>Earlier onset: </a:t>
-                </a:r>
-                <a:r>
-                  <a:rPr lang="en-CA" sz="3300" b="0" dirty="0">
-                    <a:latin typeface="Aptos"/>
-                  </a:rPr>
-                  <a:t>Solved minimum seed masses for the 4 plotted objects over 20 ≤ </a:t>
-                </a:r>
-                <a:r>
-                  <a:rPr lang="en-CA" sz="3300" b="0" dirty="0" err="1">
-                    <a:latin typeface="Aptos"/>
-                  </a:rPr>
-                  <a:t>z</a:t>
-                </a:r>
-                <a:r>
-                  <a:rPr lang="en-CA" sz="2200" b="0" baseline="-25000" dirty="0" err="1">
-                    <a:latin typeface="Aptos"/>
-                  </a:rPr>
-                  <a:t>acc</a:t>
-                </a:r>
-                <a:r>
-                  <a:rPr lang="en-CA" sz="3300" b="0" dirty="0">
-                    <a:latin typeface="Aptos"/>
-                  </a:rPr>
-                  <a:t> ≤ 3,400. Included radiation in cosmic ages. Assumed gas was available.</a:t>
-                </a:r>
-              </a:p>
-            </p:txBody>
-          </p:sp>
-        </mc:Choice>
-        <mc:Fallback xmlns="">
-          <p:sp>
-            <p:nvSpPr>
-              <p:cNvPr id="73" name="TextBox 72">
-                <a:extLst>
-                  <a:ext uri="{FF2B5EF4-FFF2-40B4-BE49-F238E27FC236}">
-                    <a16:creationId xmlns:a16="http://schemas.microsoft.com/office/drawing/2014/main" id="{88C51BF9-B81A-ECF4-F01D-305CA1CE9DD1}"/>
-                  </a:ext>
-                </a:extLst>
-              </p:cNvPr>
-              <p:cNvSpPr txBox="1">
-                <a:spLocks noRot="1" noChangeAspect="1" noMove="1" noResize="1" noEditPoints="1" noAdjustHandles="1" noChangeArrowheads="1" noChangeShapeType="1" noTextEdit="1"/>
-              </p:cNvSpPr>
-              <p:nvPr/>
-            </p:nvSpPr>
-            <p:spPr>
-              <a:xfrm>
-                <a:off x="1463040" y="11559248"/>
-                <a:ext cx="14173200" cy="12808443"/>
-              </a:xfrm>
-              <a:prstGeom prst="rect">
-                <a:avLst/>
-              </a:prstGeom>
-              <a:blipFill>
-                <a:blip r:embed="rId8"/>
-                <a:stretch>
-                  <a:fillRect l="-1164" t="-694" r="-1611" b="-5055"/>
-                </a:stretch>
-              </a:blipFill>
-            </p:spPr>
-            <p:txBody>
-              <a:bodyPr/>
-              <a:lstStyle/>
-              <a:p>
-                <a:r>
-                  <a:rPr lang="en-US">
-                    <a:noFill/>
-                  </a:rPr>
-                  <a:t> </a:t>
-                </a:r>
-              </a:p>
-            </p:txBody>
-          </p:sp>
-        </mc:Fallback>
-      </mc:AlternateContent>
-      <p:sp>
-        <p:nvSpPr>
-          <p:cNvPr id="74" name="Rectangle 73">
-            <a:extLst>
-              <a:ext uri="{FF2B5EF4-FFF2-40B4-BE49-F238E27FC236}">
-                <a16:creationId xmlns:a16="http://schemas.microsoft.com/office/drawing/2014/main" id="{F5F0E6D1-7308-2846-C555-5A8981E84E43}"/>
-              </a:ext>
-            </a:extLst>
-          </p:cNvPr>
-          <p:cNvSpPr/>
-          <p:nvPr/>
-        </p:nvSpPr>
-        <p:spPr>
-          <a:xfrm>
-            <a:off x="914400" y="10184458"/>
-            <a:ext cx="15087600" cy="14810682"/>
-          </a:xfrm>
-          <a:prstGeom prst="rect">
-            <a:avLst/>
-          </a:prstGeom>
-          <a:noFill/>
-          <a:ln>
-            <a:solidFill>
-              <a:srgbClr val="002A5C"/>
-            </a:solidFill>
-          </a:ln>
-        </p:spPr>
-        <p:style>
-          <a:lnRef idx="2">
-            <a:schemeClr val="accent1">
-              <a:shade val="15000"/>
-            </a:schemeClr>
-          </a:lnRef>
-          <a:fillRef idx="1">
-            <a:schemeClr val="accent1"/>
-          </a:fillRef>
-          <a:effectRef idx="0">
-            <a:schemeClr val="accent1"/>
-          </a:effectRef>
-          <a:fontRef idx="minor">
-            <a:schemeClr val="lt1"/>
-          </a:fontRef>
-        </p:style>
-        <p:txBody>
-          <a:bodyPr rtlCol="0" anchor="ctr"/>
-          <a:lstStyle/>
-          <a:p>
-            <a:pPr algn="ctr"/>
-            <a:endParaRPr lang="en-US"/>
-          </a:p>
-        </p:txBody>
-      </p:sp>
-      <p:sp>
-        <p:nvSpPr>
-          <p:cNvPr id="78" name="Title 18">
-            <a:extLst>
-              <a:ext uri="{FF2B5EF4-FFF2-40B4-BE49-F238E27FC236}">
-                <a16:creationId xmlns:a16="http://schemas.microsoft.com/office/drawing/2014/main" id="{D50205E6-BF86-6F08-991C-43F597FDF8DD}"/>
-              </a:ext>
-            </a:extLst>
-          </p:cNvPr>
-          <p:cNvSpPr txBox="1">
-            <a:spLocks/>
-          </p:cNvSpPr>
-          <p:nvPr/>
-        </p:nvSpPr>
-        <p:spPr>
-          <a:xfrm>
-            <a:off x="16550640" y="35503691"/>
-            <a:ext cx="15453360" cy="960120"/>
-          </a:xfrm>
-          <a:prstGeom prst="rect">
-            <a:avLst/>
-          </a:prstGeom>
-          <a:solidFill>
-            <a:srgbClr val="002A5C"/>
-          </a:solidFill>
-          <a:ln>
-            <a:solidFill>
-              <a:srgbClr val="09306B"/>
-            </a:solidFill>
-          </a:ln>
-        </p:spPr>
-        <p:txBody>
-          <a:bodyPr vert="horz" lIns="78373" tIns="39187" rIns="78373" bIns="39187" rtlCol="0" anchor="ctr" anchorCtr="1">
-            <a:normAutofit/>
-          </a:bodyPr>
-          <a:lstStyle>
-            <a:lvl1pPr algn="l" defTabSz="4389120" rtl="0" eaLnBrk="1" latinLnBrk="0" hangingPunct="1">
-              <a:lnSpc>
-                <a:spcPct val="90000"/>
-              </a:lnSpc>
-              <a:spcBef>
-                <a:spcPct val="0"/>
-              </a:spcBef>
-              <a:buNone/>
-              <a:defRPr sz="6200" b="1" kern="1200">
-                <a:solidFill>
-                  <a:schemeClr val="bg1"/>
-                </a:solidFill>
-                <a:latin typeface="Arial"/>
-                <a:ea typeface="+mj-ea"/>
-                <a:cs typeface="Arial"/>
-              </a:defRPr>
-            </a:lvl1pPr>
-          </a:lstStyle>
-          <a:p>
-            <a:pPr algn="ctr"/>
-            <a:r>
-              <a:rPr lang="en-US" sz="5000"/>
-              <a:t>Conclusions</a:t>
-            </a:r>
-          </a:p>
-        </p:txBody>
-      </p:sp>
-      <p:sp>
-        <p:nvSpPr>
-          <p:cNvPr id="79" name="TextBox 78">
-            <a:extLst>
-              <a:ext uri="{FF2B5EF4-FFF2-40B4-BE49-F238E27FC236}">
-                <a16:creationId xmlns:a16="http://schemas.microsoft.com/office/drawing/2014/main" id="{3DD5B540-2EC8-A5A1-200C-994C1D7C8BFD}"/>
-              </a:ext>
-            </a:extLst>
-          </p:cNvPr>
-          <p:cNvSpPr txBox="1"/>
-          <p:nvPr/>
-        </p:nvSpPr>
-        <p:spPr>
-          <a:xfrm>
-            <a:off x="16916402" y="36944923"/>
-            <a:ext cx="14996160" cy="6583680"/>
-          </a:xfrm>
-          <a:prstGeom prst="rect">
-            <a:avLst/>
-          </a:prstGeom>
-          <a:noFill/>
-        </p:spPr>
-        <p:txBody>
-          <a:bodyPr wrap="square" lIns="91440" tIns="45720" rIns="91440" bIns="45720" rtlCol="0" anchor="t">
-            <a:spAutoFit/>
-          </a:bodyPr>
-          <a:lstStyle/>
-          <a:p>
-            <a:pPr marL="285750" indent="-228600">
-              <a:spcAft>
-                <a:spcPts val="800"/>
-              </a:spcAft>
-              <a:buChar char="•"/>
-            </a:pPr>
-            <a:r>
-              <a:rPr lang="en-CA" sz="3300" b="1">
-                <a:latin typeface="Aptos"/>
-              </a:rPr>
-              <a:t>Seed masses: </a:t>
-            </a:r>
-            <a:r>
-              <a:rPr lang="en-CA" sz="3300" b="0">
-                <a:latin typeface="Aptos"/>
-              </a:rPr>
-              <a:t>Most adopted masses are compatible with growth from small stellar seeds under the reference assumptions.</a:t>
-            </a:r>
-          </a:p>
-          <a:p>
-            <a:pPr marL="285750" indent="-228600">
-              <a:spcAft>
-                <a:spcPts val="800"/>
-              </a:spcAft>
-              <a:buChar char="•"/>
-            </a:pPr>
-            <a:r>
-              <a:rPr lang="en-CA" sz="3300" b="1">
-                <a:latin typeface="Aptos"/>
-              </a:rPr>
-              <a:t>Accretion physics: </a:t>
-            </a:r>
-            <a:r>
-              <a:rPr lang="en-CA" sz="3300" b="0">
-                <a:latin typeface="Aptos"/>
-              </a:rPr>
-              <a:t>Lower radiative efficiency allows faster mass growth at the same Eddington ratio. Seed-mass requirements therefore depend on how efficiently accretion produces radiation.</a:t>
-            </a:r>
-          </a:p>
-          <a:p>
-            <a:pPr marL="285750" indent="-228600">
-              <a:spcAft>
-                <a:spcPts val="800"/>
-              </a:spcAft>
-              <a:buChar char="•"/>
-            </a:pPr>
-            <a:r>
-              <a:rPr lang="en-CA" sz="3300" b="1">
-                <a:latin typeface="Aptos"/>
-              </a:rPr>
-              <a:t>Earlier growth: </a:t>
-            </a:r>
-            <a:r>
-              <a:rPr lang="en-CA" sz="3300" b="0">
-                <a:latin typeface="Aptos"/>
-              </a:rPr>
-              <a:t>Even the earliest tested start leaves 100 M⊙ seeds insufficient for the 4 targets at ε = 0.1 and average ratio ≤ 1. Larger seeds or super-Eddington episodes remain possible.</a:t>
-            </a:r>
-          </a:p>
-          <a:p>
-            <a:pPr marL="285750" indent="-228600">
-              <a:spcAft>
-                <a:spcPts val="800"/>
-              </a:spcAft>
-              <a:buChar char="•"/>
-            </a:pPr>
-            <a:r>
-              <a:rPr lang="en-CA" sz="3300" b="1">
-                <a:latin typeface="Aptos"/>
-              </a:rPr>
-              <a:t>Further observations: </a:t>
-            </a:r>
-            <a:r>
-              <a:rPr lang="en-CA" sz="3300" b="0">
-                <a:latin typeface="Aptos"/>
-              </a:rPr>
-              <a:t>Independent mass measurements could change which objects require averages above 1. Counts from different surveys cannot establish how common these black holes are.</a:t>
-            </a:r>
-          </a:p>
-        </p:txBody>
-      </p:sp>
-      <p:sp>
-        <p:nvSpPr>
-          <p:cNvPr id="80" name="Rectangle 79">
-            <a:extLst>
-              <a:ext uri="{FF2B5EF4-FFF2-40B4-BE49-F238E27FC236}">
-                <a16:creationId xmlns:a16="http://schemas.microsoft.com/office/drawing/2014/main" id="{BBD5C8AB-335C-2E4D-00F6-4B0BF74BB013}"/>
-              </a:ext>
-            </a:extLst>
-          </p:cNvPr>
-          <p:cNvSpPr/>
-          <p:nvPr/>
-        </p:nvSpPr>
-        <p:spPr>
-          <a:xfrm>
-            <a:off x="16550640" y="35503691"/>
-            <a:ext cx="15453360" cy="7930309"/>
-          </a:xfrm>
-          <a:prstGeom prst="rect">
-            <a:avLst/>
-          </a:prstGeom>
-          <a:noFill/>
-          <a:ln>
-            <a:solidFill>
-              <a:srgbClr val="002A5C"/>
-            </a:solidFill>
-          </a:ln>
-        </p:spPr>
-        <p:style>
-          <a:lnRef idx="2">
-            <a:schemeClr val="accent1">
-              <a:shade val="15000"/>
-            </a:schemeClr>
-          </a:lnRef>
-          <a:fillRef idx="1">
-            <a:schemeClr val="accent1"/>
-          </a:fillRef>
-          <a:effectRef idx="0">
-            <a:schemeClr val="accent1"/>
-          </a:effectRef>
-          <a:fontRef idx="minor">
-            <a:schemeClr val="lt1"/>
-          </a:fontRef>
-        </p:style>
-        <p:txBody>
-          <a:bodyPr rtlCol="0" anchor="ctr"/>
-          <a:lstStyle/>
-          <a:p>
-            <a:pPr algn="ctr"/>
-            <a:endParaRPr lang="en-US"/>
-          </a:p>
-        </p:txBody>
-      </p:sp>
-      <p:sp>
-        <p:nvSpPr>
-          <p:cNvPr id="81" name="Title 18">
-            <a:extLst>
-              <a:ext uri="{FF2B5EF4-FFF2-40B4-BE49-F238E27FC236}">
-                <a16:creationId xmlns:a16="http://schemas.microsoft.com/office/drawing/2014/main" id="{8E773A53-2851-D565-B46F-D419BA57021E}"/>
-              </a:ext>
-            </a:extLst>
-          </p:cNvPr>
-          <p:cNvSpPr txBox="1">
-            <a:spLocks/>
-          </p:cNvSpPr>
-          <p:nvPr/>
-        </p:nvSpPr>
-        <p:spPr>
-          <a:xfrm>
-            <a:off x="914400" y="38218254"/>
-            <a:ext cx="15087600" cy="960120"/>
-          </a:xfrm>
-          <a:prstGeom prst="rect">
-            <a:avLst/>
-          </a:prstGeom>
-          <a:solidFill>
-            <a:srgbClr val="002A5C"/>
-          </a:solidFill>
-          <a:ln>
-            <a:solidFill>
-              <a:srgbClr val="09306B"/>
-            </a:solidFill>
-          </a:ln>
-        </p:spPr>
-        <p:txBody>
-          <a:bodyPr vert="horz" lIns="78373" tIns="39187" rIns="78373" bIns="39187" rtlCol="0" anchor="ctr" anchorCtr="1">
-            <a:normAutofit/>
-          </a:bodyPr>
-          <a:lstStyle>
-            <a:lvl1pPr algn="l" defTabSz="4389120" rtl="0" eaLnBrk="1" latinLnBrk="0" hangingPunct="1">
-              <a:lnSpc>
-                <a:spcPct val="90000"/>
-              </a:lnSpc>
-              <a:spcBef>
-                <a:spcPct val="0"/>
-              </a:spcBef>
-              <a:buNone/>
-              <a:defRPr sz="6200" b="1" kern="1200">
-                <a:solidFill>
-                  <a:schemeClr val="bg1"/>
-                </a:solidFill>
-                <a:latin typeface="Arial"/>
-                <a:ea typeface="+mj-ea"/>
-                <a:cs typeface="Arial"/>
-              </a:defRPr>
-            </a:lvl1pPr>
-          </a:lstStyle>
-          <a:p>
-            <a:pPr algn="ctr"/>
-            <a:r>
-              <a:rPr lang="en-US" sz="5000"/>
-              <a:t>References</a:t>
-            </a:r>
-          </a:p>
-        </p:txBody>
-      </p:sp>
-      <p:sp>
-        <p:nvSpPr>
-          <p:cNvPr id="82" name="TextBox 81">
-            <a:extLst>
-              <a:ext uri="{FF2B5EF4-FFF2-40B4-BE49-F238E27FC236}">
-                <a16:creationId xmlns:a16="http://schemas.microsoft.com/office/drawing/2014/main" id="{82B57F9D-B4AF-1E4D-7FBC-B8680CB4CAB8}"/>
-              </a:ext>
-            </a:extLst>
-          </p:cNvPr>
-          <p:cNvSpPr txBox="1"/>
-          <p:nvPr/>
-        </p:nvSpPr>
-        <p:spPr>
-          <a:xfrm>
-            <a:off x="1371600" y="39363981"/>
-            <a:ext cx="13898880" cy="3395801"/>
-          </a:xfrm>
-          <a:prstGeom prst="rect">
-            <a:avLst/>
-          </a:prstGeom>
-          <a:noFill/>
-        </p:spPr>
-        <p:txBody>
-          <a:bodyPr wrap="square" rtlCol="0">
-            <a:spAutoFit/>
-          </a:bodyPr>
-          <a:lstStyle/>
-          <a:p>
-            <a:pPr>
-              <a:spcBef>
-                <a:spcPts val="600"/>
-              </a:spcBef>
-            </a:pPr>
-            <a:r>
-              <a:rPr lang="en-CA" sz="3300" dirty="0"/>
-              <a:t>[1] Shen (2013), BASI, 41, 61.</a:t>
-            </a:r>
-            <a:endParaRPr lang="en-US" sz="3300" dirty="0"/>
-          </a:p>
-          <a:p>
-            <a:r>
-              <a:rPr lang="en-CA" sz="3300" dirty="0"/>
-              <a:t>[2] </a:t>
-            </a:r>
-            <a:r>
-              <a:rPr lang="en-CA" sz="3300" dirty="0" err="1"/>
-              <a:t>Maiolino</a:t>
-            </a:r>
-            <a:r>
-              <a:rPr lang="en-CA" sz="3300" dirty="0"/>
-              <a:t> et al. (2024), Nature, 627, 59.</a:t>
-            </a:r>
-          </a:p>
-          <a:p>
-            <a:r>
-              <a:rPr lang="en-CA" sz="3300" dirty="0"/>
-              <a:t>[3] Dayal (2024), A&amp;A, 690, A182.</a:t>
-            </a:r>
-            <a:endParaRPr lang="en-US" sz="3300" dirty="0"/>
-          </a:p>
-          <a:p>
-            <a:pPr>
-              <a:spcBef>
-                <a:spcPts val="600"/>
-              </a:spcBef>
-            </a:pPr>
-            <a:r>
-              <a:rPr lang="en-CA" sz="3300" dirty="0"/>
-              <a:t>[4] Bardeen et al. (1972), </a:t>
-            </a:r>
-            <a:r>
-              <a:rPr lang="en-CA" sz="3300" dirty="0" err="1"/>
-              <a:t>ApJ</a:t>
-            </a:r>
-            <a:r>
-              <a:rPr lang="en-CA" sz="3300" dirty="0"/>
-              <a:t>, 178, 347.</a:t>
-            </a:r>
-            <a:endParaRPr lang="en-US" sz="3300" dirty="0"/>
-          </a:p>
-          <a:p>
-            <a:pPr>
-              <a:spcAft>
-                <a:spcPts val="800"/>
-              </a:spcAft>
-              <a:buNone/>
-            </a:pPr>
-            <a:r>
-              <a:rPr lang="en-CA" sz="3300" b="0" dirty="0">
-                <a:latin typeface="Aptos"/>
-              </a:rPr>
-              <a:t>[5] </a:t>
-            </a:r>
-            <a:r>
-              <a:rPr lang="en-CA" sz="3300" b="0" dirty="0" err="1">
-                <a:latin typeface="Aptos"/>
-              </a:rPr>
-              <a:t>Juodzbalis</a:t>
-            </a:r>
-            <a:r>
-              <a:rPr lang="en-CA" sz="3300" b="0" dirty="0">
-                <a:latin typeface="Aptos"/>
-              </a:rPr>
-              <a:t> et al. (2025), arXiv:2508.21748.</a:t>
-            </a:r>
-          </a:p>
-          <a:p>
-            <a:pPr>
-              <a:spcBef>
-                <a:spcPts val="600"/>
-              </a:spcBef>
-            </a:pPr>
-            <a:r>
-              <a:rPr lang="en-CA" sz="3300" dirty="0"/>
-              <a:t>Catalogue sources and code: QR link above.</a:t>
-            </a:r>
-            <a:endParaRPr lang="en-US" sz="3300" dirty="0"/>
-          </a:p>
-        </p:txBody>
-      </p:sp>
-      <p:sp>
-        <p:nvSpPr>
-          <p:cNvPr id="83" name="Rectangle 82">
-            <a:extLst>
-              <a:ext uri="{FF2B5EF4-FFF2-40B4-BE49-F238E27FC236}">
-                <a16:creationId xmlns:a16="http://schemas.microsoft.com/office/drawing/2014/main" id="{7156AF1B-4C0F-9637-8495-BA5941742B85}"/>
-              </a:ext>
-            </a:extLst>
-          </p:cNvPr>
-          <p:cNvSpPr/>
-          <p:nvPr/>
-        </p:nvSpPr>
-        <p:spPr>
-          <a:xfrm>
-            <a:off x="914400" y="38218254"/>
-            <a:ext cx="15087600" cy="5215746"/>
-          </a:xfrm>
-          <a:prstGeom prst="rect">
-            <a:avLst/>
-          </a:prstGeom>
-          <a:noFill/>
-          <a:ln>
-            <a:solidFill>
-              <a:srgbClr val="002A5C"/>
-            </a:solidFill>
-          </a:ln>
-        </p:spPr>
-        <p:style>
-          <a:lnRef idx="2">
-            <a:schemeClr val="accent1">
-              <a:shade val="15000"/>
-            </a:schemeClr>
-          </a:lnRef>
-          <a:fillRef idx="1">
-            <a:schemeClr val="accent1"/>
-          </a:fillRef>
-          <a:effectRef idx="0">
-            <a:schemeClr val="accent1"/>
-          </a:effectRef>
-          <a:fontRef idx="minor">
-            <a:schemeClr val="lt1"/>
-          </a:fontRef>
-        </p:style>
-        <p:txBody>
-          <a:bodyPr rtlCol="0" anchor="ctr"/>
-          <a:lstStyle/>
-          <a:p>
-            <a:pPr algn="ctr"/>
-            <a:endParaRPr lang="en-US"/>
-          </a:p>
-        </p:txBody>
-      </p:sp>
-      <p:pic>
-        <p:nvPicPr>
-          <p:cNvPr id="4" name="Picture 3">
-            <a:extLst>
-              <a:ext uri="{FF2B5EF4-FFF2-40B4-BE49-F238E27FC236}">
-                <a16:creationId xmlns:a16="http://schemas.microsoft.com/office/drawing/2014/main" id="{C4337658-2539-7C1B-497A-E1769149148E}"/>
-              </a:ext>
-            </a:extLst>
-          </p:cNvPr>
-          <p:cNvPicPr>
-            <a:picLocks noChangeAspect="1"/>
-          </p:cNvPicPr>
-          <p:nvPr/>
-        </p:nvPicPr>
-        <p:blipFill>
-          <a:blip r:embed="rId9"/>
-          <a:stretch>
-            <a:fillRect/>
-          </a:stretch>
-        </p:blipFill>
-        <p:spPr>
-          <a:xfrm>
-            <a:off x="16962120" y="12298680"/>
-            <a:ext cx="14630400" cy="7863840"/>
-          </a:xfrm>
-          <a:prstGeom prst="rect">
-            <a:avLst/>
-          </a:prstGeom>
-        </p:spPr>
-      </p:pic>
-      <p:pic>
-        <p:nvPicPr>
-          <p:cNvPr id="5" name="Picture 4" descr="File:JWST spacecraft model 1.png - Wikimedia Commons">
-            <a:extLst>
-              <a:ext uri="{FF2B5EF4-FFF2-40B4-BE49-F238E27FC236}">
-                <a16:creationId xmlns:a16="http://schemas.microsoft.com/office/drawing/2014/main" id="{0BD845B3-DC16-6DC6-BFC8-2D65D247678D}"/>
-              </a:ext>
-            </a:extLst>
-          </p:cNvPr>
-          <p:cNvPicPr>
-            <a:picLocks noChangeAspect="1"/>
-          </p:cNvPicPr>
-          <p:nvPr/>
-        </p:nvPicPr>
-        <p:blipFill>
-          <a:blip r:embed="rId10"/>
-          <a:stretch>
-            <a:fillRect/>
-          </a:stretch>
-        </p:blipFill>
-        <p:spPr>
-          <a:xfrm>
-            <a:off x="22512863" y="2212116"/>
-            <a:ext cx="3968969" cy="2975113"/>
-          </a:xfrm>
-          <a:prstGeom prst="rect">
-            <a:avLst/>
-          </a:prstGeom>
-        </p:spPr>
-      </p:pic>
-      <p:pic>
-        <p:nvPicPr>
-          <p:cNvPr id="6" name="Picture 5" descr="Eyes open clipart clipground #31495 - Free Transparent PNG Logos">
-            <a:extLst>
-              <a:ext uri="{FF2B5EF4-FFF2-40B4-BE49-F238E27FC236}">
-                <a16:creationId xmlns:a16="http://schemas.microsoft.com/office/drawing/2014/main" id="{9D3E6E2E-04C2-513B-0EE5-8C40F5B8F46A}"/>
-              </a:ext>
-            </a:extLst>
-          </p:cNvPr>
-          <p:cNvPicPr>
-            <a:picLocks noChangeAspect="1"/>
-          </p:cNvPicPr>
-          <p:nvPr/>
-        </p:nvPicPr>
-        <p:blipFill>
-          <a:blip r:embed="rId11"/>
-          <a:stretch>
-            <a:fillRect/>
-          </a:stretch>
-        </p:blipFill>
-        <p:spPr>
-          <a:xfrm rot="20443004">
-            <a:off x="23071504" y="2606120"/>
-            <a:ext cx="1527081" cy="735074"/>
-          </a:xfrm>
-          <a:prstGeom prst="rect">
-            <a:avLst/>
-          </a:prstGeom>
-        </p:spPr>
-      </p:pic>
-      <p:pic>
-        <p:nvPicPr>
-          <p:cNvPr id="10" name="Picture 9" descr="Nebula overlay color 26548388 PNG">
-            <a:extLst>
-              <a:ext uri="{FF2B5EF4-FFF2-40B4-BE49-F238E27FC236}">
-                <a16:creationId xmlns:a16="http://schemas.microsoft.com/office/drawing/2014/main" id="{FB4EBB94-758E-75A7-659C-BF66DBB0AEF6}"/>
-              </a:ext>
-            </a:extLst>
-          </p:cNvPr>
-          <p:cNvPicPr>
-            <a:picLocks noChangeAspect="1"/>
-          </p:cNvPicPr>
-          <p:nvPr/>
-        </p:nvPicPr>
-        <p:blipFill>
-          <a:blip r:embed="rId12"/>
-          <a:stretch>
-            <a:fillRect/>
-          </a:stretch>
-        </p:blipFill>
-        <p:spPr>
-          <a:xfrm rot="2098715">
-            <a:off x="23425759" y="-141307"/>
-            <a:ext cx="6097999" cy="3431350"/>
-          </a:xfrm>
-          <a:prstGeom prst="rect">
-            <a:avLst/>
-          </a:prstGeom>
-        </p:spPr>
-      </p:pic>
-      <p:sp>
-        <p:nvSpPr>
-          <p:cNvPr id="76" name="TextBox 75">
-            <a:extLst>
-              <a:ext uri="{FF2B5EF4-FFF2-40B4-BE49-F238E27FC236}">
-                <a16:creationId xmlns:a16="http://schemas.microsoft.com/office/drawing/2014/main" id="{8F4057E1-F618-63B3-DF3A-8B3B4948305D}"/>
-              </a:ext>
-            </a:extLst>
-          </p:cNvPr>
-          <p:cNvSpPr txBox="1"/>
-          <p:nvPr/>
-        </p:nvSpPr>
-        <p:spPr>
-          <a:xfrm>
-            <a:off x="17145000" y="20885748"/>
-            <a:ext cx="14630400" cy="1615827"/>
-          </a:xfrm>
-          <a:prstGeom prst="rect">
-            <a:avLst/>
-          </a:prstGeom>
-          <a:noFill/>
-        </p:spPr>
-        <p:txBody>
-          <a:bodyPr wrap="square" lIns="91440" tIns="45720" rIns="91440" bIns="45720" rtlCol="0" anchor="t">
-            <a:spAutoFit/>
-          </a:bodyPr>
-          <a:lstStyle/>
-          <a:p>
-            <a:pPr marL="457200" indent="-457200">
-              <a:spcAft>
-                <a:spcPts val="400"/>
-              </a:spcAft>
-              <a:buFont typeface="Arial" panose="020B0604020202020204" pitchFamily="34" charset="0"/>
-              <a:buChar char="•"/>
-            </a:pPr>
-            <a:r>
-              <a:rPr lang="en-CA" sz="3300" b="1" dirty="0">
-                <a:latin typeface="Aptos"/>
-              </a:rPr>
-              <a:t>Earlier-onset test: </a:t>
-            </a:r>
-            <a:r>
-              <a:rPr lang="en-CA" sz="3300" b="0" dirty="0">
-                <a:latin typeface="Aptos"/>
-              </a:rPr>
-              <a:t>Starting growth at z = 3,400 (matter–radiation equality) requires 270–1,200 M⊙ seeds for the 4 plotted objects (</a:t>
-            </a:r>
-            <a:r>
-              <a:rPr lang="en-CA" sz="3300" b="0" dirty="0" err="1">
-                <a:latin typeface="Aptos"/>
-              </a:rPr>
-              <a:t>ε</a:t>
-            </a:r>
-            <a:r>
-              <a:rPr lang="en-CA" sz="3300" b="0" dirty="0">
-                <a:latin typeface="Aptos"/>
-              </a:rPr>
-              <a:t> = 0.1, average ratio ≤ 1, no mergers).</a:t>
-            </a:r>
-          </a:p>
-        </p:txBody>
-      </p:sp>
-      <p:sp>
-        <p:nvSpPr>
-          <p:cNvPr id="2" name="TextBox 1">
-            <a:extLst>
-              <a:ext uri="{FF2B5EF4-FFF2-40B4-BE49-F238E27FC236}">
-                <a16:creationId xmlns:a16="http://schemas.microsoft.com/office/drawing/2014/main" id="{6F669F8B-BE33-0C82-515C-AF8D3B759FB3}"/>
-              </a:ext>
-            </a:extLst>
-          </p:cNvPr>
-          <p:cNvSpPr txBox="1"/>
-          <p:nvPr/>
-        </p:nvSpPr>
-        <p:spPr>
-          <a:xfrm>
-            <a:off x="17007840" y="6642638"/>
-            <a:ext cx="14767560" cy="5170646"/>
-          </a:xfrm>
-          <a:prstGeom prst="rect">
-            <a:avLst/>
-          </a:prstGeom>
-          <a:noFill/>
-        </p:spPr>
-        <p:txBody>
-          <a:bodyPr rot="0" spcFirstLastPara="0" vertOverflow="overflow" horzOverflow="overflow" vert="horz" wrap="square" lIns="91440" tIns="45720" rIns="91440" bIns="45720" numCol="1" spcCol="0" rtlCol="0" fromWordArt="0" anchor="t" anchorCtr="0" forceAA="0" compatLnSpc="1">
-            <a:prstTxWarp prst="textNoShape">
-              <a:avLst/>
-            </a:prstTxWarp>
-            <a:spAutoFit/>
-          </a:bodyPr>
-          <a:lstStyle/>
-          <a:p>
-            <a:pPr marL="285750" indent="-228600">
-              <a:buChar char="•"/>
-            </a:pPr>
-            <a:r>
-              <a:rPr lang="en-CA" sz="3300" b="1">
-                <a:latin typeface="Aptos"/>
-              </a:rPr>
-              <a:t>Reference: </a:t>
-            </a:r>
-            <a:r>
-              <a:rPr lang="en-CA" sz="3300" b="0">
-                <a:latin typeface="Aptos"/>
-              </a:rPr>
-              <a:t>212/220 primary objects require average Eddington ratios ≤ 1. The other 8 require averages above 1, including 5 in ≥ 95% of mass-error draws.</a:t>
-            </a:r>
-          </a:p>
-          <a:p>
-            <a:pPr marL="285750" indent="-228600">
-              <a:buChar char="•"/>
-            </a:pPr>
-            <a:r>
-              <a:rPr lang="en-CA" sz="3300" b="1">
-                <a:latin typeface="Aptos"/>
-              </a:rPr>
-              <a:t>Mass sensitivity: </a:t>
-            </a:r>
-            <a:r>
-              <a:rPr lang="en-CA" sz="3300" b="0">
-                <a:latin typeface="Aptos"/>
-              </a:rPr>
-              <a:t>After reducing masses by a factor of 3.2 (0.5 dex), UNCOVER-20466, COSMOS3D-13852, and RUBIES-EGS-55604 still require averages above 1 in ≥ 95% of mass-error draws.</a:t>
-            </a:r>
-          </a:p>
-          <a:p>
-            <a:pPr marL="285750" indent="-228600">
-              <a:buChar char="•"/>
-            </a:pPr>
-            <a:r>
-              <a:rPr lang="en-CA" sz="3300" b="1">
-                <a:latin typeface="Aptos"/>
-              </a:rPr>
-              <a:t>Seed mass: </a:t>
-            </a:r>
-            <a:r>
-              <a:rPr lang="en-CA" sz="3300" b="0">
-                <a:latin typeface="Aptos"/>
-              </a:rPr>
-              <a:t>1,000 M⊙ seeds leave 3/220 above 1. With 100,000 M⊙ seeds, no objects in either sample require averages above 1.</a:t>
-            </a:r>
-          </a:p>
-          <a:p>
-            <a:pPr marL="285750" indent="-228600">
-              <a:buChar char="•"/>
-            </a:pPr>
-            <a:r>
-              <a:rPr lang="en-CA" sz="3300" b="1">
-                <a:latin typeface="Aptos"/>
-              </a:rPr>
-              <a:t>Growth start time: </a:t>
-            </a:r>
-            <a:r>
-              <a:rPr lang="en-CA" sz="3300" b="0">
-                <a:latin typeface="Aptos"/>
-              </a:rPr>
-              <a:t>Starting later (z = 20) increases the primary count above 1 to 18/220. GN-z11 requires the highest average in the expanded sample.</a:t>
-            </a:r>
-          </a:p>
-          <a:p>
-            <a:pPr marL="285750" indent="-228600">
-              <a:buChar char="•"/>
-            </a:pPr>
-            <a:r>
-              <a:rPr lang="en-CA" sz="3300" b="1">
-                <a:latin typeface="Aptos"/>
-              </a:rPr>
-              <a:t>Efficiency: </a:t>
-            </a:r>
-            <a:r>
-              <a:rPr lang="en-CA" sz="3300" b="0">
-                <a:latin typeface="Aptos"/>
-              </a:rPr>
-              <a:t>At ε = 0.05719 (non-spinning thin disc) [4], all 234 central mass estimates require averages below 1 from 100 M⊙ seeds at z = 30.</a:t>
-            </a:r>
-          </a:p>
-        </p:txBody>
-      </p:sp>
-      <p:sp>
-        <p:nvSpPr>
-          <p:cNvPr id="7" name="Title 18">
-            <a:extLst>
-              <a:ext uri="{FF2B5EF4-FFF2-40B4-BE49-F238E27FC236}">
-                <a16:creationId xmlns:a16="http://schemas.microsoft.com/office/drawing/2014/main" id="{3AC78928-AF13-E1B9-F802-F1FD39D07D33}"/>
-              </a:ext>
-            </a:extLst>
-          </p:cNvPr>
-          <p:cNvSpPr txBox="1">
-            <a:spLocks/>
-          </p:cNvSpPr>
-          <p:nvPr/>
-        </p:nvSpPr>
-        <p:spPr>
-          <a:xfrm>
-            <a:off x="16550640" y="5362478"/>
-            <a:ext cx="15453360" cy="960120"/>
-          </a:xfrm>
-          <a:prstGeom prst="rect">
-            <a:avLst/>
-          </a:prstGeom>
-          <a:solidFill>
-            <a:srgbClr val="002A5C"/>
-          </a:solidFill>
-          <a:ln>
-            <a:solidFill>
-              <a:srgbClr val="09306B"/>
-            </a:solidFill>
-          </a:ln>
-        </p:spPr>
-        <p:txBody>
-          <a:bodyPr vert="horz" lIns="78373" tIns="39187" rIns="78373" bIns="39187" rtlCol="0" anchor="ctr" anchorCtr="1">
-            <a:normAutofit/>
-          </a:bodyPr>
-          <a:lstStyle>
-            <a:lvl1pPr algn="l" defTabSz="4389120" rtl="0" eaLnBrk="1" latinLnBrk="0" hangingPunct="1">
-              <a:lnSpc>
-                <a:spcPct val="90000"/>
-              </a:lnSpc>
-              <a:spcBef>
-                <a:spcPct val="0"/>
-              </a:spcBef>
-              <a:buNone/>
-              <a:defRPr sz="6200" b="1" kern="1200">
-                <a:solidFill>
-                  <a:schemeClr val="bg1"/>
-                </a:solidFill>
-                <a:latin typeface="Arial"/>
-                <a:ea typeface="+mj-ea"/>
-                <a:cs typeface="Arial"/>
-              </a:defRPr>
-            </a:lvl1pPr>
-          </a:lstStyle>
-          <a:p>
-            <a:pPr algn="ctr"/>
-            <a:r>
-              <a:rPr lang="en-US" sz="5000"/>
-              <a:t>Results</a:t>
-            </a:r>
-            <a:endParaRPr lang="en-US"/>
-          </a:p>
-        </p:txBody>
-      </p:sp>
-      <p:sp>
-        <p:nvSpPr>
-          <p:cNvPr id="11" name="Rectangle 10">
-            <a:extLst>
-              <a:ext uri="{FF2B5EF4-FFF2-40B4-BE49-F238E27FC236}">
-                <a16:creationId xmlns:a16="http://schemas.microsoft.com/office/drawing/2014/main" id="{AF7EDC07-606F-DD66-5973-0AE0D673B23B}"/>
-              </a:ext>
-            </a:extLst>
-          </p:cNvPr>
-          <p:cNvSpPr/>
-          <p:nvPr/>
-        </p:nvSpPr>
-        <p:spPr>
-          <a:xfrm>
-            <a:off x="16550640" y="5344777"/>
-            <a:ext cx="15453360" cy="29905343"/>
-          </a:xfrm>
-          <a:prstGeom prst="rect">
-            <a:avLst/>
-          </a:prstGeom>
-          <a:noFill/>
-          <a:ln>
-            <a:solidFill>
-              <a:srgbClr val="002A5C"/>
-            </a:solidFill>
-          </a:ln>
-        </p:spPr>
-        <p:style>
-          <a:lnRef idx="2">
-            <a:schemeClr val="accent1">
-              <a:shade val="15000"/>
-            </a:schemeClr>
-          </a:lnRef>
-          <a:fillRef idx="1">
-            <a:schemeClr val="accent1"/>
-          </a:fillRef>
-          <a:effectRef idx="0">
-            <a:schemeClr val="accent1"/>
-          </a:effectRef>
-          <a:fontRef idx="minor">
-            <a:schemeClr val="lt1"/>
-          </a:fontRef>
-        </p:style>
-        <p:txBody>
-          <a:bodyPr rtlCol="0" anchor="ctr"/>
-          <a:lstStyle/>
-          <a:p>
-            <a:pPr algn="ctr"/>
-            <a:endParaRPr lang="en-US"/>
-          </a:p>
-        </p:txBody>
-      </p:sp>
-      <p:sp>
-        <p:nvSpPr>
-          <p:cNvPr id="110" name="Figure takeaway 110"/>
-          <p:cNvSpPr txBox="1"/>
-          <p:nvPr/>
-        </p:nvSpPr>
-        <p:spPr>
-          <a:xfrm>
-            <a:off x="17190720" y="20162520"/>
-            <a:ext cx="14447520" cy="914400"/>
-          </a:xfrm>
-          <a:prstGeom prst="rect">
-            <a:avLst/>
-          </a:prstGeom>
-          <a:noFill/>
-        </p:spPr>
-        <p:txBody>
-          <a:bodyPr wrap="square" lIns="91440" tIns="45720" rIns="91440" bIns="45720" rtlCol="0" anchor="t">
-            <a:spAutoFit/>
-          </a:bodyPr>
-          <a:lstStyle/>
-          <a:p>
-            <a:pPr>
-              <a:spcAft>
-                <a:spcPts val="800"/>
-              </a:spcAft>
-              <a:buNone/>
-            </a:pPr>
-            <a:r>
-              <a:rPr lang="en-CA" sz="2400" b="0">
-                <a:latin typeface="Aptos"/>
-              </a:rPr>
-              <a:t>After lowering masses by 0.5 dex, 3 targets require averages above 1 in ≥ 95% of mass-error draws.</a:t>
-            </a:r>
-          </a:p>
-        </p:txBody>
-      </p:sp>
-      <p:sp>
-        <p:nvSpPr>
-          <p:cNvPr id="111" name="Figure takeaway 111"/>
-          <p:cNvSpPr txBox="1"/>
-          <p:nvPr/>
-        </p:nvSpPr>
-        <p:spPr>
-          <a:xfrm>
-            <a:off x="1188720" y="36859926"/>
-            <a:ext cx="14356080" cy="1051560"/>
-          </a:xfrm>
-          <a:prstGeom prst="rect">
-            <a:avLst/>
-          </a:prstGeom>
-          <a:noFill/>
-        </p:spPr>
-        <p:txBody>
-          <a:bodyPr wrap="square" lIns="91440" tIns="45720" rIns="91440" bIns="45720" rtlCol="0" anchor="t">
-            <a:spAutoFit/>
-          </a:bodyPr>
-          <a:lstStyle/>
-          <a:p>
-            <a:pPr>
-              <a:spcAft>
-                <a:spcPts val="800"/>
-              </a:spcAft>
-              <a:buNone/>
-            </a:pPr>
-            <a:r>
-              <a:rPr lang="en-CA" sz="2400" b="0" dirty="0">
-                <a:latin typeface="Aptos"/>
-              </a:rPr>
-              <a:t>Only efficiency changes between panels. Points below a curve can be reached with a lower average Eddington ratio.</a:t>
-            </a:r>
-          </a:p>
-        </p:txBody>
-      </p:sp>
-      <p:sp>
-        <p:nvSpPr>
-          <p:cNvPr id="112" name="Figure takeaway 112"/>
-          <p:cNvSpPr txBox="1"/>
-          <p:nvPr/>
-        </p:nvSpPr>
-        <p:spPr>
-          <a:xfrm>
-            <a:off x="17190720" y="32207899"/>
-            <a:ext cx="14447520" cy="548640"/>
-          </a:xfrm>
-          <a:prstGeom prst="rect">
-            <a:avLst/>
-          </a:prstGeom>
-          <a:noFill/>
-        </p:spPr>
-        <p:txBody>
-          <a:bodyPr wrap="square" lIns="91440" tIns="45720" rIns="91440" bIns="45720" rtlCol="0" anchor="t">
-            <a:spAutoFit/>
-          </a:bodyPr>
-          <a:lstStyle/>
-          <a:p>
-            <a:pPr>
-              <a:buNone/>
-            </a:pPr>
-            <a:r>
-              <a:rPr lang="en-CA" sz="2400" b="0" dirty="0">
-                <a:latin typeface="Aptos"/>
-              </a:rPr>
-              <a:t>Earlier starts lower the required seed mass, but the decrease becomes smaller.</a:t>
-            </a:r>
-          </a:p>
-        </p:txBody>
-      </p:sp>
-      <p:sp>
-        <p:nvSpPr>
-          <p:cNvPr id="15" name="TextBox 14">
-            <a:extLst>
-              <a:ext uri="{FF2B5EF4-FFF2-40B4-BE49-F238E27FC236}">
-                <a16:creationId xmlns:a16="http://schemas.microsoft.com/office/drawing/2014/main" id="{B71483CE-2A7E-6438-7E3B-E605C17C7099}"/>
-              </a:ext>
-            </a:extLst>
-          </p:cNvPr>
-          <p:cNvSpPr txBox="1"/>
-          <p:nvPr/>
-        </p:nvSpPr>
-        <p:spPr>
-          <a:xfrm>
-            <a:off x="17007840" y="32779973"/>
-            <a:ext cx="14767560" cy="2286000"/>
-          </a:xfrm>
-          <a:prstGeom prst="rect">
-            <a:avLst/>
-          </a:prstGeom>
-          <a:noFill/>
-        </p:spPr>
-        <p:txBody>
-          <a:bodyPr wrap="square">
-            <a:spAutoFit/>
-          </a:bodyPr>
-          <a:lstStyle/>
-          <a:p>
-            <a:pPr marL="457200" indent="-457200">
-              <a:spcAft>
-                <a:spcPts val="400"/>
-              </a:spcAft>
-              <a:buFont typeface="Arial" panose="020B0604020202020204" pitchFamily="34" charset="0"/>
-              <a:buChar char="•"/>
-            </a:pPr>
-            <a:r>
-              <a:rPr lang="en-CA" sz="3300" b="1" dirty="0">
-                <a:latin typeface="Aptos"/>
-              </a:rPr>
-              <a:t>Independent mass check: </a:t>
-            </a:r>
-            <a:r>
-              <a:rPr lang="en-CA" sz="3300" b="0" dirty="0">
-                <a:latin typeface="Aptos"/>
-              </a:rPr>
-              <a:t>Under the reference model, A2744-QSO1’s broad-line mass (2.0 × 10</a:t>
-            </a:r>
-            <a:r>
-              <a:rPr lang="en-CA" sz="2200" b="0" baseline="30000" dirty="0">
-                <a:latin typeface="Aptos"/>
-              </a:rPr>
-              <a:t>7</a:t>
-            </a:r>
-            <a:r>
-              <a:rPr lang="en-CA" sz="3300" b="0" dirty="0">
-                <a:latin typeface="Aptos"/>
-              </a:rPr>
-              <a:t> M⊙) requires an average Eddington ratio of 0.929. Its dynamical mass (5.0 × 10</a:t>
-            </a:r>
-            <a:r>
-              <a:rPr lang="en-CA" sz="2200" b="0" baseline="30000" dirty="0">
-                <a:latin typeface="Aptos"/>
-              </a:rPr>
-              <a:t>7</a:t>
-            </a:r>
-            <a:r>
-              <a:rPr lang="en-CA" sz="3300" b="0" dirty="0">
-                <a:latin typeface="Aptos"/>
-              </a:rPr>
-              <a:t> M⊙) requires 0.9996 (ratio’s 16th–84th percentiles: 0.947–1.052) [5]. This interval includes 1.</a:t>
-            </a:r>
-          </a:p>
-        </p:txBody>
-      </p:sp>
-      <p:sp>
-        <p:nvSpPr>
-          <p:cNvPr id="120" name="Efficiency comparison heading">
-            <a:extLst>
-              <a:ext uri="{FF2B5EF4-FFF2-40B4-BE49-F238E27FC236}">
-                <a16:creationId xmlns:a16="http://schemas.microsoft.com/office/drawing/2014/main" id="{3A05E1FE-512D-49F3-9C39-22D275F0EE18}"/>
-              </a:ext>
-            </a:extLst>
-          </p:cNvPr>
-          <p:cNvSpPr>
-            <a:spLocks noGrp="1"/>
-          </p:cNvSpPr>
-          <p:nvPr/>
-        </p:nvSpPr>
-        <p:spPr>
-          <a:xfrm>
-            <a:off x="1280160" y="25453836"/>
-            <a:ext cx="14356080" cy="640080"/>
-          </a:xfrm>
-          <a:prstGeom prst="rect">
-            <a:avLst/>
-          </a:prstGeom>
-          <a:noFill/>
-        </p:spPr>
-        <p:txBody>
-          <a:bodyPr wrap="square" lIns="91440" tIns="45720" rIns="91440" bIns="45720" anchor="t">
-            <a:spAutoFit/>
-          </a:bodyPr>
-          <a:lstStyle>
-            <a:defPPr>
-              <a:defRPr b="1">
-                <a:solidFill>
-                  <a:srgbClr val="002A5C"/>
-                </a:solidFill>
-              </a:defRPr>
-            </a:defPPr>
-          </a:lstStyle>
-          <a:p>
-            <a:pPr>
-              <a:spcAft>
-                <a:spcPts val="800"/>
-              </a:spcAft>
-              <a:buNone/>
-              <a:defRPr b="1">
-                <a:solidFill>
-                  <a:srgbClr val="002A5C"/>
-                </a:solidFill>
-              </a:defRPr>
-            </a:pPr>
-            <a:r>
-              <a:rPr lang="en-CA" sz="3600" b="1">
-                <a:solidFill>
-                  <a:srgbClr val="002A5C"/>
-                </a:solidFill>
-                <a:latin typeface="Aptos"/>
-              </a:rPr>
-              <a:t>Growth at two radiative efficiencies</a:t>
-            </a:r>
-          </a:p>
-        </p:txBody>
-      </p:sp>
-    </p:spTree>
-    <p:extLst>
-      <p:ext uri="{BB962C8B-B14F-4D97-AF65-F5344CB8AC3E}">
-        <p14:creationId xmlns:p14="http://schemas.microsoft.com/office/powerpoint/2010/main" val="868487171"/>
-      </p:ext>
-    </p:extLst>
-  </p:cSld>
-  <p:clrMapOvr>
-    <a:masterClrMapping/>
-  </p:clrMapOvr>
-</p:sld>
-</file>
-
-<file path=ppt/slides/slide2.xml><?xml version="1.0" encoding="utf-8"?>
-<p:sld xmlns:a="http://schemas.openxmlformats.org/drawingml/2006/main" xmlns:r="http://schemas.openxmlformats.org/officeDocument/2006/relationships" xmlns:p="http://schemas.openxmlformats.org/presentationml/2006/main">
-  <p:cSld>
-    <p:spTree>
-      <p:nvGrpSpPr>
-        <p:cNvPr id="1" name="">
-          <a:extLst>
-            <a:ext uri="{FF2B5EF4-FFF2-40B4-BE49-F238E27FC236}">
-              <a16:creationId xmlns:a16="http://schemas.microsoft.com/office/drawing/2014/main" id="{D9B17601-38BA-EEC6-B535-6199F2F271C7}"/>
-            </a:ext>
-          </a:extLst>
-        </p:cNvPr>
-        <p:cNvGrpSpPr/>
-        <p:nvPr/>
-      </p:nvGrpSpPr>
-      <p:grpSpPr>
-        <a:xfrm>
-          <a:off x="0" y="0"/>
-          <a:ext cx="0" cy="0"/>
-          <a:chOff x="0" y="0"/>
-          <a:chExt cx="0" cy="0"/>
-        </a:xfrm>
-      </p:grpSpPr>
-      <p:pic>
-        <p:nvPicPr>
           <p:cNvPr id="14" name="Minimum seed mass versus accretion onset" descr="Manuscript minimum seed masses under fixed growth caps for UNCOVER-20466, COSMOS3D-13852, RUBIES-EGS-55604, and GN-z11.">
             <a:extLst>
               <a:ext uri="{FF2B5EF4-FFF2-40B4-BE49-F238E27FC236}">
@@ -7456,7 +5118,7 @@
         </p:blipFill>
         <p:spPr>
           <a:xfrm>
-            <a:off x="16962120" y="22287711"/>
+            <a:off x="17190720" y="21970501"/>
             <a:ext cx="14630400" cy="9875520"/>
           </a:xfrm>
           <a:prstGeom prst="rect">
@@ -7754,7 +5416,19 @@
               <a:rPr lang="en-CA" sz="3300" b="0">
                 <a:latin typeface="Aptos"/>
               </a:rPr>
-              <a:t>The James Webb Space Telescope (JWST) has revealed massive black holes with little time to grow. I compiled published mass estimates and calculated the average accretion needed to reach each mass under different seed masses (initial masses), start times, and radiative efficiencies.</a:t>
+              <a:t>The James Webb Space Telescope (JWST) has revealed massive black holes with little time to grow.</a:t>
+            </a:r>
+            <a:r>
+              <a:rPr lang="en-CA" sz="2200" b="0" baseline="30000">
+                <a:latin typeface="Aptos"/>
+              </a:rPr>
+              <a:t>[2]</a:t>
+            </a:r>
+            <a:r>
+              <a:rPr lang="en-CA" sz="3300" b="0">
+                <a:latin typeface="Aptos"/>
+              </a:rPr>
+              <a:t> I compiled published mass estimates and calculated the average accretion needed to reach each mass under different seed masses (initial masses), start times, and radiative efficiencies.</a:t>
             </a:r>
           </a:p>
         </p:txBody>
@@ -7888,7 +5562,7 @@
         </p:nvSpPr>
         <p:spPr>
           <a:xfrm>
-            <a:off x="1463040" y="20116800"/>
+            <a:off x="1463040" y="20785342"/>
             <a:ext cx="13990320" cy="4114800"/>
           </a:xfrm>
           <a:prstGeom prst="rect">
@@ -7969,6 +5643,12 @@
                 <a:latin typeface="Aptos"/>
               </a:rPr>
               <a:t> = luminosity/Eddington luminosity, where radiation force balances gravity. Averages above 1 require super-Eddington episodes.</a:t>
+            </a:r>
+            <a:r>
+              <a:rPr lang="en-CA" sz="2200" b="0" dirty="0" baseline="30000">
+                <a:latin typeface="Aptos"/>
+              </a:rPr>
+              <a:t>[3]</a:t>
             </a:r>
           </a:p>
         </p:txBody>
@@ -7988,7 +5668,7 @@
         <p:spPr>
           <a:xfrm>
             <a:off x="914400" y="10184458"/>
-            <a:ext cx="15087600" cy="27359578"/>
+            <a:ext cx="15087600" cy="27190853"/>
           </a:xfrm>
           <a:prstGeom prst="rect">
             <a:avLst/>
@@ -8041,7 +5721,7 @@
         </p:nvSpPr>
         <p:spPr>
           <a:xfrm>
-            <a:off x="16550640" y="35503691"/>
+            <a:off x="16550640" y="35921521"/>
             <a:ext cx="15453360" cy="960120"/>
           </a:xfrm>
           <a:prstGeom prst="rect">
@@ -8102,8 +5782,8 @@
         </p:nvSpPr>
         <p:spPr>
           <a:xfrm>
-            <a:off x="16916402" y="36944923"/>
-            <a:ext cx="14996160" cy="6583680"/>
+            <a:off x="16916402" y="37375311"/>
+            <a:ext cx="14996160" cy="5478423"/>
           </a:xfrm>
           <a:prstGeom prst="rect">
             <a:avLst/>
@@ -8123,7 +5803,7 @@
               <a:buChar char="•"/>
             </a:pPr>
             <a:r>
-              <a:rPr sz="3300" b="1" lang="en-CA">
+              <a:rPr lang="en-CA" sz="3300" b="1" dirty="0">
                 <a:solidFill>
                   <a:srgbClr val="000000"/>
                 </a:solidFill>
@@ -8132,7 +5812,7 @@
               <a:t>Seed masses: </a:t>
             </a:r>
             <a:r>
-              <a:rPr sz="3300" b="0" lang="en-CA">
+              <a:rPr lang="en-CA" sz="3300" b="0" dirty="0">
                 <a:solidFill>
                   <a:srgbClr val="000000"/>
                 </a:solidFill>
@@ -8149,7 +5829,7 @@
               <a:buChar char="•"/>
             </a:pPr>
             <a:r>
-              <a:rPr sz="3300" b="1" lang="en-CA">
+              <a:rPr lang="en-CA" sz="3300" b="1" dirty="0">
                 <a:solidFill>
                   <a:srgbClr val="000000"/>
                 </a:solidFill>
@@ -8158,13 +5838,22 @@
               <a:t>Accretion physics: </a:t>
             </a:r>
             <a:r>
-              <a:rPr sz="3300" b="0" lang="en-CA">
+              <a:rPr lang="en-CA" sz="3300" b="0" dirty="0">
                 <a:solidFill>
                   <a:srgbClr val="000000"/>
                 </a:solidFill>
                 <a:latin typeface="Aptos"/>
               </a:rPr>
               <a:t>Lower radiative efficiency leaves more accreted mass in the black hole, allowing faster growth at the same Eddington ratio.</a:t>
+            </a:r>
+            <a:r>
+              <a:rPr lang="en-CA" sz="2200" b="0" dirty="0" baseline="30000">
+                <a:solidFill>
+                  <a:srgbClr val="000000"/>
+                </a:solidFill>
+                <a:latin typeface="Aptos"/>
+              </a:rPr>
+              <a:t>[3]</a:t>
             </a:r>
           </a:p>
           <a:p>
@@ -8175,7 +5864,7 @@
               <a:buChar char="•"/>
             </a:pPr>
             <a:r>
-              <a:rPr sz="3300" b="1" lang="en-CA">
+              <a:rPr lang="en-CA" sz="3300" b="1" dirty="0">
                 <a:solidFill>
                   <a:srgbClr val="000000"/>
                 </a:solidFill>
@@ -8184,13 +5873,31 @@
               <a:t>Earlier growth: </a:t>
             </a:r>
             <a:r>
-              <a:rPr sz="3300" b="0" lang="en-CA">
+              <a:rPr lang="en-CA" sz="3300" b="0" dirty="0">
                 <a:solidFill>
                   <a:srgbClr val="000000"/>
                 </a:solidFill>
                 <a:latin typeface="Aptos"/>
               </a:rPr>
-              <a:t>Even the earliest tested start leaves 100 M⊙ seeds insufficient for the 4 targets at ε = 0.1 and average ratio ≤ 1. Larger seeds or super-Eddington episodes remain possible.</a:t>
+              <a:t>Even the earliest tested start leaves 100 M⊙ seeds insufficient for the 4 targets at </a:t>
+            </a:r>
+            <a:r>
+              <a:rPr lang="en-CA" sz="3300" b="0" dirty="0" err="1">
+                <a:solidFill>
+                  <a:srgbClr val="000000"/>
+                </a:solidFill>
+                <a:latin typeface="Aptos"/>
+              </a:rPr>
+              <a:t>ε</a:t>
+            </a:r>
+            <a:r>
+              <a:rPr lang="en-CA" sz="3300" b="0" dirty="0">
+                <a:solidFill>
+                  <a:srgbClr val="000000"/>
+                </a:solidFill>
+                <a:latin typeface="Aptos"/>
+              </a:rPr>
+              <a:t> = 0.1 and average ratio ≤ 1. Larger seeds or super-Eddington episodes remain possible.</a:t>
             </a:r>
           </a:p>
           <a:p>
@@ -8201,7 +5908,7 @@
               <a:buChar char="•"/>
             </a:pPr>
             <a:r>
-              <a:rPr sz="3300" b="1" lang="en-CA">
+              <a:rPr lang="en-CA" sz="3300" b="1" dirty="0">
                 <a:solidFill>
                   <a:srgbClr val="000000"/>
                 </a:solidFill>
@@ -8210,7 +5917,7 @@
               <a:t>Further observations: </a:t>
             </a:r>
             <a:r>
-              <a:rPr sz="3300" b="0" lang="en-CA">
+              <a:rPr lang="en-CA" sz="3300" b="0" dirty="0">
                 <a:solidFill>
                   <a:srgbClr val="000000"/>
                 </a:solidFill>
@@ -8235,8 +5942,8 @@
         </p:nvSpPr>
         <p:spPr>
           <a:xfrm>
-            <a:off x="16550640" y="35503691"/>
-            <a:ext cx="15453360" cy="7930309"/>
+            <a:off x="16550640" y="35921521"/>
+            <a:ext cx="15453360" cy="7512479"/>
           </a:xfrm>
           <a:prstGeom prst="rect">
             <a:avLst/>
@@ -8289,7 +5996,7 @@
         </p:nvSpPr>
         <p:spPr>
           <a:xfrm>
-            <a:off x="914400" y="38218254"/>
+            <a:off x="914400" y="37796815"/>
             <a:ext cx="15087600" cy="960120"/>
           </a:xfrm>
           <a:prstGeom prst="rect">
@@ -8350,7 +6057,7 @@
         </p:nvSpPr>
         <p:spPr>
           <a:xfrm>
-            <a:off x="1371600" y="39363981"/>
+            <a:off x="1463040" y="39259762"/>
             <a:ext cx="13898880" cy="3395801"/>
           </a:xfrm>
           <a:prstGeom prst="rect">
@@ -8439,7 +6146,7 @@
               <a:rPr lang="en-CA" sz="3300" b="0" dirty="0">
                 <a:latin typeface="Aptos"/>
               </a:rPr>
-              <a:t> et al. (2025), arXiv:2508.21748.</a:t>
+              <a:t> et al. (2025), arXiv:2508.21748v2.</a:t>
             </a:r>
           </a:p>
           <a:p>
@@ -8470,8 +6177,8 @@
         </p:nvSpPr>
         <p:spPr>
           <a:xfrm>
-            <a:off x="914400" y="38218254"/>
-            <a:ext cx="15087600" cy="5215746"/>
+            <a:off x="914400" y="37811595"/>
+            <a:ext cx="15087600" cy="5622405"/>
           </a:xfrm>
           <a:prstGeom prst="rect">
             <a:avLst/>
@@ -8524,14 +6231,15 @@
         </p:nvPicPr>
         <p:blipFill>
           <a:blip r:embed="rId7"/>
+          <a:srcRect l="6709"/>
           <a:stretch>
             <a:fillRect/>
           </a:stretch>
         </p:blipFill>
         <p:spPr>
           <a:xfrm>
-            <a:off x="16962120" y="12298680"/>
-            <a:ext cx="14630400" cy="7863840"/>
+            <a:off x="17349367" y="12042092"/>
+            <a:ext cx="13648793" cy="7863840"/>
           </a:xfrm>
           <a:prstGeom prst="rect">
             <a:avLst/>
@@ -8642,7 +6350,7 @@
         </p:nvSpPr>
         <p:spPr>
           <a:xfrm>
-            <a:off x="17145000" y="20885748"/>
+            <a:off x="17145000" y="20434572"/>
             <a:ext cx="14630400" cy="1615827"/>
           </a:xfrm>
           <a:prstGeom prst="rect">
@@ -8713,16 +6421,16 @@
               <a:buChar char="•"/>
             </a:pPr>
             <a:r>
-              <a:rPr sz="3300" b="1" lang="en-CA">
+              <a:rPr lang="en-CA" sz="3300" b="1" dirty="0">
                 <a:solidFill>
                   <a:srgbClr val="000000"/>
                 </a:solidFill>
                 <a:latin typeface="Aptos"/>
               </a:rPr>
-              <a:t>Reference: </a:t>
-            </a:r>
-            <a:r>
-              <a:rPr sz="3300" b="0" lang="en-CA">
+              <a:t>Reference model: </a:t>
+            </a:r>
+            <a:r>
+              <a:rPr lang="en-CA" sz="3300" b="0" dirty="0">
                 <a:solidFill>
                   <a:srgbClr val="000000"/>
                 </a:solidFill>
@@ -8736,7 +6444,7 @@
               <a:buChar char="•"/>
             </a:pPr>
             <a:r>
-              <a:rPr sz="3300" b="1" lang="en-CA">
+              <a:rPr lang="en-CA" sz="3300" b="1" dirty="0">
                 <a:solidFill>
                   <a:srgbClr val="000000"/>
                 </a:solidFill>
@@ -8745,13 +6453,31 @@
               <a:t>Mass sensitivity: </a:t>
             </a:r>
             <a:r>
-              <a:rPr sz="3300" b="0" lang="en-CA">
+              <a:rPr lang="en-CA" sz="3300" b="0" dirty="0">
                 <a:solidFill>
                   <a:srgbClr val="000000"/>
                 </a:solidFill>
                 <a:latin typeface="Aptos"/>
               </a:rPr>
-              <a:t>Lowering masses by a factor of 3.2 leaves 3 primary objects requiring averages above 1 in ≥ 95% of draws.</a:t>
+              <a:t>Lowering masses by 0.5 </a:t>
+            </a:r>
+            <a:r>
+              <a:rPr lang="en-CA" sz="3300" b="0" dirty="0" err="1">
+                <a:solidFill>
+                  <a:srgbClr val="000000"/>
+                </a:solidFill>
+                <a:latin typeface="Aptos"/>
+              </a:rPr>
+              <a:t>dex</a:t>
+            </a:r>
+            <a:r>
+              <a:rPr lang="en-CA" sz="3300" b="0" dirty="0">
+                <a:solidFill>
+                  <a:srgbClr val="000000"/>
+                </a:solidFill>
+                <a:latin typeface="Aptos"/>
+              </a:rPr>
+              <a:t> (a factor of 3.2) leaves 3 primary objects requiring averages above 1 in ≥ 95% of draws.</a:t>
             </a:r>
           </a:p>
           <a:p>
@@ -8759,7 +6485,7 @@
               <a:buChar char="•"/>
             </a:pPr>
             <a:r>
-              <a:rPr sz="3300" b="1" lang="en-CA">
+              <a:rPr lang="en-CA" sz="3300" b="1" dirty="0">
                 <a:solidFill>
                   <a:srgbClr val="000000"/>
                 </a:solidFill>
@@ -8768,13 +6494,22 @@
               <a:t>Seed mass: </a:t>
             </a:r>
             <a:r>
-              <a:rPr sz="3300" b="0" lang="en-CA">
+              <a:rPr lang="en-CA" sz="3300" dirty="0">
                 <a:solidFill>
                   <a:srgbClr val="000000"/>
                 </a:solidFill>
                 <a:latin typeface="Aptos"/>
               </a:rPr>
-              <a:t>1,000 M⊙ seeds leave 3/220 above 1. With 100,000 M⊙ seeds, neither sample has objects above 1.</a:t>
+              <a:t>1,000 </a:t>
+            </a:r>
+            <a:r>
+              <a:rPr lang="en-CA" sz="3300" b="0" dirty="0">
+                <a:solidFill>
+                  <a:srgbClr val="000000"/>
+                </a:solidFill>
+                <a:latin typeface="Aptos"/>
+              </a:rPr>
+              <a:t>M⊙ seeds leave 3/220 above 1. With 100,000 M⊙ seeds, neither sample has objects above 1.</a:t>
             </a:r>
           </a:p>
           <a:p>
@@ -8782,7 +6517,7 @@
               <a:buChar char="•"/>
             </a:pPr>
             <a:r>
-              <a:rPr sz="3300" b="1" lang="en-CA">
+              <a:rPr lang="en-CA" sz="3300" b="1" dirty="0">
                 <a:solidFill>
                   <a:srgbClr val="000000"/>
                 </a:solidFill>
@@ -8791,7 +6526,7 @@
               <a:t>Growth start time: </a:t>
             </a:r>
             <a:r>
-              <a:rPr sz="3300" b="0" lang="en-CA">
+              <a:rPr lang="en-CA" sz="3300" b="0" dirty="0">
                 <a:solidFill>
                   <a:srgbClr val="000000"/>
                 </a:solidFill>
@@ -8805,7 +6540,7 @@
               <a:buChar char="•"/>
             </a:pPr>
             <a:r>
-              <a:rPr sz="3300" b="1" lang="en-CA">
+              <a:rPr lang="en-CA" sz="3300" b="1" dirty="0">
                 <a:solidFill>
                   <a:srgbClr val="000000"/>
                 </a:solidFill>
@@ -8814,13 +6549,49 @@
               <a:t>Efficiency: </a:t>
             </a:r>
             <a:r>
-              <a:rPr sz="3300" b="0" lang="en-CA">
+              <a:rPr lang="en-CA" sz="3300" b="0" dirty="0">
                 <a:solidFill>
                   <a:srgbClr val="000000"/>
                 </a:solidFill>
                 <a:latin typeface="Aptos"/>
               </a:rPr>
-              <a:t>At ε = 0.05719 (non-spinning thin disc) [4], all 234 central mass estimates require averages below 1 under the other reference assumptions.</a:t>
+              <a:t>At </a:t>
+            </a:r>
+            <a:r>
+              <a:rPr lang="en-CA" sz="3300" b="0" dirty="0" err="1">
+                <a:solidFill>
+                  <a:srgbClr val="000000"/>
+                </a:solidFill>
+                <a:latin typeface="Aptos"/>
+              </a:rPr>
+              <a:t>ε</a:t>
+            </a:r>
+            <a:r>
+              <a:rPr lang="en-CA" sz="3300" b="0" dirty="0">
+                <a:solidFill>
+                  <a:srgbClr val="000000"/>
+                </a:solidFill>
+                <a:latin typeface="Aptos"/>
+              </a:rPr>
+              <a:t> = 0.05719 (non-spinning thin disc) </a:t>
+            </a:r>
+            <a:r>
+              <a:rPr lang="en-CA" sz="2200" b="0" dirty="0" baseline="30000">
+                <a:solidFill>
+                  <a:srgbClr val="000000"/>
+                </a:solidFill>
+                <a:latin typeface="Aptos"/>
+              </a:rPr>
+              <a:t>[4]</a:t>
+            </a:r>
+            <a:r>
+              <a:rPr lang="en-CA" sz="3300" b="0" dirty="0">
+                <a:solidFill>
+                  <a:srgbClr val="000000"/>
+                </a:solidFill>
+                <a:latin typeface="Aptos"/>
+              </a:rPr>
+              <a:t>, all 234 central mass estimates require averages below 1 under the other reference assumptions.</a:t>
             </a:r>
           </a:p>
         </p:txBody>
@@ -8904,7 +6675,7 @@
         <p:spPr>
           <a:xfrm>
             <a:off x="16550640" y="5344777"/>
-            <a:ext cx="15453360" cy="29905343"/>
+            <a:ext cx="15453360" cy="30083074"/>
           </a:xfrm>
           <a:prstGeom prst="rect">
             <a:avLst/>
@@ -8943,43 +6714,6 @@
       </p:sp>
       <p:sp>
         <p:nvSpPr>
-          <p:cNvPr id="110" name="Figure takeaway 110"/>
-          <p:cNvSpPr txBox="1"/>
-          <p:nvPr/>
-        </p:nvSpPr>
-        <p:spPr>
-          <a:xfrm>
-            <a:off x="17190720" y="20162520"/>
-            <a:ext cx="14447520" cy="914400"/>
-          </a:xfrm>
-          <a:prstGeom prst="rect">
-            <a:avLst/>
-          </a:prstGeom>
-          <a:noFill/>
-        </p:spPr>
-        <p:txBody>
-          <a:bodyPr wrap="square" lIns="91440" tIns="45720" rIns="91440" bIns="45720" rtlCol="0" anchor="t">
-            <a:spAutoFit/>
-          </a:bodyPr>
-          <a:lstStyle/>
-          <a:p>
-            <a:pPr>
-              <a:spcAft>
-                <a:spcPts val="800"/>
-              </a:spcAft>
-              <a:buNone/>
-            </a:pPr>
-            <a:r>
-              <a:rPr lang="en-CA" sz="2400" b="0">
-                <a:latin typeface="Aptos"/>
-              </a:rPr>
-              <a:t>Orange points show the same objects after lowering masses by a factor of 3.2.</a:t>
-            </a:r>
-          </a:p>
-        </p:txBody>
-      </p:sp>
-      <p:sp>
-        <p:nvSpPr>
           <p:cNvPr id="112" name="Figure takeaway 112"/>
           <p:cNvSpPr txBox="1"/>
           <p:nvPr/>
@@ -9081,7 +6815,19 @@
               <a:rPr lang="en-CA" sz="3300" b="0" dirty="0">
                 <a:latin typeface="Aptos"/>
               </a:rPr>
-              <a:t> M⊙) requires 0.9996 [5]. Its required average spans 0.947–1.052 (16th–84th percentiles), including 1.</a:t>
+              <a:t> M⊙)</a:t>
+            </a:r>
+            <a:r>
+              <a:rPr lang="en-CA" sz="2200" b="0" dirty="0" baseline="30000">
+                <a:latin typeface="Aptos"/>
+              </a:rPr>
+              <a:t>[5]</a:t>
+            </a:r>
+            <a:r>
+              <a:rPr lang="en-CA" sz="3300" b="0" dirty="0">
+                <a:latin typeface="Aptos"/>
+              </a:rPr>
+              <a:t> requires 0.9996. Its required average spans 0.947–1.052 (16th–84th percentiles), including 1.</a:t>
             </a:r>
           </a:p>
         </p:txBody>
@@ -9102,7 +6848,7 @@
         </p:nvSpPr>
         <p:spPr>
           <a:xfrm>
-            <a:off x="1371600" y="23400083"/>
+            <a:off x="1371600" y="24068625"/>
             <a:ext cx="14356080" cy="640080"/>
           </a:xfrm>
           <a:prstGeom prst="rect">
@@ -9163,7 +6909,7 @@
         </p:nvSpPr>
         <p:spPr>
           <a:xfrm>
-            <a:off x="1463040" y="11612880"/>
+            <a:off x="1471598" y="12390206"/>
             <a:ext cx="13990320" cy="1143000"/>
           </a:xfrm>
           <a:prstGeom prst="rect">
@@ -9223,7 +6969,7 @@
         </p:nvSpPr>
         <p:spPr>
           <a:xfrm>
-            <a:off x="8284464" y="12838176"/>
+            <a:off x="8309610" y="13412218"/>
             <a:ext cx="347472" cy="329184"/>
           </a:xfrm>
           <a:prstGeom prst="downArrow">
@@ -9260,7 +7006,7 @@
         </p:nvSpPr>
         <p:spPr>
           <a:xfrm>
-            <a:off x="1463040" y="13286232"/>
+            <a:off x="1463040" y="13858659"/>
             <a:ext cx="13990320" cy="914400"/>
           </a:xfrm>
           <a:prstGeom prst="rect">
@@ -9324,7 +7070,7 @@
         </p:nvSpPr>
         <p:spPr>
           <a:xfrm>
-            <a:off x="5626303" y="14310360"/>
+            <a:off x="5626303" y="14997396"/>
             <a:ext cx="347472" cy="329184"/>
           </a:xfrm>
           <a:prstGeom prst="downArrow">
@@ -9361,7 +7107,7 @@
         </p:nvSpPr>
         <p:spPr>
           <a:xfrm>
-            <a:off x="12827203" y="14310360"/>
+            <a:off x="12827203" y="14978902"/>
             <a:ext cx="347472" cy="329184"/>
           </a:xfrm>
           <a:prstGeom prst="downArrow">
@@ -9398,7 +7144,7 @@
         </p:nvSpPr>
         <p:spPr>
           <a:xfrm>
-            <a:off x="1463040" y="14813280"/>
+            <a:off x="1463040" y="15472678"/>
             <a:ext cx="8673998" cy="4709160"/>
           </a:xfrm>
           <a:prstGeom prst="rect">
@@ -9435,7 +7181,7 @@
         </p:nvSpPr>
         <p:spPr>
           <a:xfrm>
-            <a:off x="1517904" y="14886432"/>
+            <a:off x="1517904" y="15554974"/>
             <a:ext cx="8564270" cy="822960"/>
           </a:xfrm>
           <a:prstGeom prst="rect">
@@ -9495,7 +7241,7 @@
         </p:nvSpPr>
         <p:spPr>
           <a:xfrm>
-            <a:off x="1645920" y="15892272"/>
+            <a:off x="1645920" y="16320217"/>
             <a:ext cx="8308238" cy="1261872"/>
           </a:xfrm>
           <a:prstGeom prst="rect">
@@ -9530,7 +7276,7 @@
               </a:defRPr>
             </a:pPr>
             <a:r>
-              <a:rPr sz="3000" b="1">
+              <a:rPr sz="3000" b="1" dirty="0">
                 <a:solidFill>
                   <a:srgbClr val="111111"/>
                 </a:solidFill>
@@ -9549,7 +7295,7 @@
               </a:defRPr>
             </a:pPr>
             <a:r>
-              <a:rPr sz="3000" b="1">
+              <a:rPr sz="3000" b="1" dirty="0">
                 <a:solidFill>
                   <a:srgbClr val="111111"/>
                 </a:solidFill>
@@ -9557,6 +7303,30 @@
               </a:rPr>
               <a:t>Broad hydrogen (Balmer) line masses</a:t>
             </a:r>
+            <a:r>
+              <a:rPr lang="en-CA" sz="3000" b="1" dirty="0">
+                <a:solidFill>
+                  <a:srgbClr val="111111"/>
+                </a:solidFill>
+                <a:latin typeface="Aptos"/>
+              </a:rPr>
+              <a:t> </a:t>
+            </a:r>
+            <a:r>
+              <a:rPr lang="en-CA" sz="2000" b="0" dirty="0" baseline="30000">
+                <a:solidFill>
+                  <a:srgbClr val="111111"/>
+                </a:solidFill>
+                <a:latin typeface="Aptos"/>
+              </a:rPr>
+              <a:t>[1]</a:t>
+            </a:r>
+            <a:endParaRPr sz="3000" b="1" dirty="0">
+              <a:solidFill>
+                <a:srgbClr val="111111"/>
+              </a:solidFill>
+              <a:latin typeface="Aptos"/>
+            </a:endParaRPr>
           </a:p>
         </p:txBody>
       </p:sp>
@@ -9576,8 +7346,8 @@
         </p:nvSpPr>
         <p:spPr>
           <a:xfrm>
-            <a:off x="1645920" y="17309592"/>
-            <a:ext cx="8308238" cy="1920240"/>
+            <a:off x="1645920" y="17788070"/>
+            <a:ext cx="8308238" cy="2202048"/>
           </a:xfrm>
           <a:prstGeom prst="rect">
             <a:avLst/>
@@ -9611,7 +7381,7 @@
               </a:defRPr>
             </a:pPr>
             <a:r>
-              <a:rPr sz="2700" b="0">
+              <a:rPr sz="2700" b="0" dirty="0">
                 <a:solidFill>
                   <a:srgbClr val="111111"/>
                 </a:solidFill>
@@ -9630,7 +7400,7 @@
               </a:defRPr>
             </a:pPr>
             <a:r>
-              <a:rPr sz="2700" b="0">
+              <a:rPr sz="2700" b="0" dirty="0">
                 <a:solidFill>
                   <a:srgbClr val="111111"/>
                 </a:solidFill>
@@ -9649,7 +7419,7 @@
               </a:defRPr>
             </a:pPr>
             <a:r>
-              <a:rPr sz="2700" b="0">
+              <a:rPr sz="2700" b="0" dirty="0">
                 <a:solidFill>
                   <a:srgbClr val="111111"/>
                 </a:solidFill>
@@ -9668,13 +7438,22 @@
               </a:defRPr>
             </a:pPr>
             <a:r>
-              <a:rPr sz="2700" b="0">
+              <a:rPr sz="2700" b="0" dirty="0">
                 <a:solidFill>
                   <a:srgbClr val="111111"/>
                 </a:solidFill>
                 <a:latin typeface="Aptos"/>
               </a:rPr>
-              <a:t>GN-z11: ultraviolet-line mass [2]</a:t>
+              <a:t>GN-z11: ultraviolet-line mass </a:t>
+            </a:r>
+            <a:r>
+              <a:rPr sz="1800" b="0" dirty="0" baseline="30000">
+                <a:solidFill>
+                  <a:srgbClr val="111111"/>
+                </a:solidFill>
+                <a:latin typeface="Aptos"/>
+              </a:rPr>
+              <a:t>[2]</a:t>
             </a:r>
           </a:p>
         </p:txBody>
@@ -9695,7 +7474,7 @@
         </p:nvSpPr>
         <p:spPr>
           <a:xfrm>
-            <a:off x="10548518" y="14813280"/>
+            <a:off x="10548518" y="15481822"/>
             <a:ext cx="4904842" cy="4709160"/>
           </a:xfrm>
           <a:prstGeom prst="rect">
@@ -9732,7 +7511,7 @@
               </a:defRPr>
             </a:pPr>
             <a:r>
-              <a:rPr sz="2900" b="0">
+              <a:rPr sz="2900" b="0" dirty="0">
                 <a:solidFill>
                   <a:srgbClr val="111111"/>
                 </a:solidFill>
@@ -9751,7 +7530,7 @@
               </a:defRPr>
             </a:pPr>
             <a:r>
-              <a:rPr sz="2900" b="0">
+              <a:rPr sz="2900" b="0" dirty="0">
                 <a:solidFill>
                   <a:srgbClr val="111111"/>
                 </a:solidFill>
@@ -9761,7 +7540,7 @@
             </a:r>
           </a:p>
           <a:p>
-            <a:endParaRPr sz="2900" b="0">
+            <a:endParaRPr sz="2900" b="0" dirty="0">
               <a:solidFill>
                 <a:srgbClr val="111111"/>
               </a:solidFill>
@@ -9778,7 +7557,7 @@
               </a:defRPr>
             </a:pPr>
             <a:r>
-              <a:rPr sz="2900" b="0">
+              <a:rPr sz="2900" b="0" dirty="0">
                 <a:solidFill>
                   <a:srgbClr val="111111"/>
                 </a:solidFill>
@@ -9797,7 +7576,7 @@
               </a:defRPr>
             </a:pPr>
             <a:r>
-              <a:rPr sz="2900" b="0">
+              <a:rPr sz="2900" b="0" dirty="0">
                 <a:solidFill>
                   <a:srgbClr val="111111"/>
                 </a:solidFill>
@@ -9807,7 +7586,7 @@
             </a:r>
           </a:p>
           <a:p>
-            <a:endParaRPr sz="2900" b="0">
+            <a:endParaRPr sz="2900" b="0" dirty="0">
               <a:solidFill>
                 <a:srgbClr val="111111"/>
               </a:solidFill>
@@ -9824,7 +7603,7 @@
               </a:defRPr>
             </a:pPr>
             <a:r>
-              <a:rPr sz="2900" b="0">
+              <a:rPr sz="2900" b="0" dirty="0">
                 <a:solidFill>
                   <a:srgbClr val="111111"/>
                 </a:solidFill>
@@ -9843,7 +7622,7 @@
               </a:defRPr>
             </a:pPr>
             <a:r>
-              <a:rPr sz="2900" b="0">
+              <a:rPr sz="2900" b="0" dirty="0">
                 <a:solidFill>
                   <a:srgbClr val="111111"/>
                 </a:solidFill>
@@ -9870,7 +7649,7 @@
         </p:nvSpPr>
         <p:spPr>
           <a:xfrm>
-            <a:off x="1463040" y="24418127"/>
+            <a:off x="1463040" y="25086669"/>
             <a:ext cx="14173200" cy="1051560"/>
           </a:xfrm>
           <a:prstGeom prst="rect">
@@ -9911,6 +7690,21 @@
               </a:rPr>
               <a:t>Standardized mass, redshift and reported errors</a:t>
             </a:r>
+            <a:r>
+              <a:rPr lang="en-CA" sz="3000" b="1" dirty="0">
+                <a:solidFill>
+                  <a:srgbClr val="111111"/>
+                </a:solidFill>
+                <a:latin typeface="Aptos"/>
+              </a:rPr>
+              <a:t>;</a:t>
+            </a:r>
+            <a:endParaRPr sz="3000" b="1" dirty="0">
+              <a:solidFill>
+                <a:srgbClr val="111111"/>
+              </a:solidFill>
+              <a:latin typeface="Aptos"/>
+            </a:endParaRPr>
           </a:p>
           <a:p>
             <a:pPr algn="ctr">
@@ -9949,7 +7743,7 @@
         </p:nvSpPr>
         <p:spPr>
           <a:xfrm>
-            <a:off x="4695444" y="25515407"/>
+            <a:off x="4695444" y="26183949"/>
             <a:ext cx="347472" cy="329184"/>
           </a:xfrm>
           <a:prstGeom prst="downArrow">
@@ -9986,7 +7780,7 @@
         </p:nvSpPr>
         <p:spPr>
           <a:xfrm>
-            <a:off x="12056364" y="25515407"/>
+            <a:off x="12056364" y="26183949"/>
             <a:ext cx="347472" cy="329184"/>
           </a:xfrm>
           <a:prstGeom prst="downArrow">
@@ -10023,7 +7817,7 @@
         </p:nvSpPr>
         <p:spPr>
           <a:xfrm>
-            <a:off x="1463040" y="25990895"/>
+            <a:off x="1463040" y="26659437"/>
             <a:ext cx="6812280" cy="914400"/>
           </a:xfrm>
           <a:prstGeom prst="rect">
@@ -10087,7 +7881,7 @@
         </p:nvSpPr>
         <p:spPr>
           <a:xfrm>
-            <a:off x="8823960" y="25990895"/>
+            <a:off x="8823960" y="26659437"/>
             <a:ext cx="6812280" cy="914400"/>
           </a:xfrm>
           <a:prstGeom prst="rect">
@@ -10170,7 +7964,7 @@
         </p:nvSpPr>
         <p:spPr>
           <a:xfrm>
-            <a:off x="4695444" y="27042455"/>
+            <a:off x="4695444" y="27710997"/>
             <a:ext cx="347472" cy="329184"/>
           </a:xfrm>
           <a:prstGeom prst="downArrow">
@@ -10207,7 +8001,7 @@
         </p:nvSpPr>
         <p:spPr>
           <a:xfrm>
-            <a:off x="12056364" y="27042455"/>
+            <a:off x="12056364" y="27710997"/>
             <a:ext cx="347472" cy="329184"/>
           </a:xfrm>
           <a:prstGeom prst="downArrow">
@@ -10244,7 +8038,7 @@
         </p:nvSpPr>
         <p:spPr>
           <a:xfrm>
-            <a:off x="1463040" y="27545375"/>
+            <a:off x="1463040" y="28213917"/>
             <a:ext cx="14173200" cy="2057400"/>
           </a:xfrm>
           <a:prstGeom prst="rect">
@@ -10306,7 +8100,16 @@
                 </a:solidFill>
                 <a:latin typeface="Aptos"/>
               </a:rPr>
-              <a:t>Eddington ratio, including inactive periods</a:t>
+              <a:t>Eddington ratio, including inactive periods </a:t>
+            </a:r>
+            <a:r>
+              <a:rPr sz="2067" b="0" baseline="30000">
+                <a:solidFill>
+                  <a:srgbClr val="111111"/>
+                </a:solidFill>
+                <a:latin typeface="Aptos"/>
+              </a:rPr>
+              <a:t>[3]</a:t>
             </a:r>
           </a:p>
         </p:txBody>
@@ -10327,7 +8130,7 @@
         </p:nvSpPr>
         <p:spPr>
           <a:xfrm>
-            <a:off x="1463040" y="28642655"/>
+            <a:off x="1463040" y="29311197"/>
             <a:ext cx="14173200" cy="914400"/>
           </a:xfrm>
           <a:prstGeom prst="rect">
@@ -10394,7 +8197,7 @@
                 </a:solidFill>
                 <a:latin typeface="Aptos"/>
               </a:rPr>
-              <a:t> = 0.1, no mergers [3]</a:t>
+              <a:t> = 0.1, no mergers</a:t>
             </a:r>
           </a:p>
         </p:txBody>
@@ -10415,7 +8218,7 @@
         </p:nvSpPr>
         <p:spPr>
           <a:xfrm>
-            <a:off x="4695444" y="29703359"/>
+            <a:off x="4695444" y="30371901"/>
             <a:ext cx="347472" cy="329184"/>
           </a:xfrm>
           <a:prstGeom prst="downArrow">
@@ -10452,7 +8255,7 @@
         </p:nvSpPr>
         <p:spPr>
           <a:xfrm>
-            <a:off x="12056364" y="29703359"/>
+            <a:off x="12056364" y="30371901"/>
             <a:ext cx="347472" cy="329184"/>
           </a:xfrm>
           <a:prstGeom prst="downArrow">
@@ -10489,7 +8292,7 @@
         </p:nvSpPr>
         <p:spPr>
           <a:xfrm>
-            <a:off x="1463040" y="30178847"/>
+            <a:off x="1463040" y="30847389"/>
             <a:ext cx="6812280" cy="1143000"/>
           </a:xfrm>
           <a:prstGeom prst="rect">
@@ -10526,7 +8329,7 @@
               </a:defRPr>
             </a:pPr>
             <a:r>
-              <a:rPr sz="2900" b="0">
+              <a:rPr sz="2900" b="0" dirty="0">
                 <a:solidFill>
                   <a:srgbClr val="111111"/>
                 </a:solidFill>
@@ -10545,7 +8348,7 @@
               </a:defRPr>
             </a:pPr>
             <a:r>
-              <a:rPr sz="2900" b="0">
+              <a:rPr sz="2900" b="0" dirty="0">
                 <a:solidFill>
                   <a:srgbClr val="111111"/>
                 </a:solidFill>
@@ -10572,7 +8375,7 @@
         </p:nvSpPr>
         <p:spPr>
           <a:xfrm>
-            <a:off x="8823960" y="30178847"/>
+            <a:off x="8823960" y="30847389"/>
             <a:ext cx="6812280" cy="1143000"/>
           </a:xfrm>
           <a:prstGeom prst="rect">
@@ -10609,7 +8412,7 @@
               </a:defRPr>
             </a:pPr>
             <a:r>
-              <a:rPr sz="2900" b="0">
+              <a:rPr sz="2900" b="0" dirty="0">
                 <a:solidFill>
                   <a:srgbClr val="111111"/>
                 </a:solidFill>
@@ -10628,7 +8431,7 @@
               </a:defRPr>
             </a:pPr>
             <a:r>
-              <a:rPr sz="2900" b="0">
+              <a:rPr sz="2900" b="0" dirty="0">
                 <a:solidFill>
                   <a:srgbClr val="111111"/>
                 </a:solidFill>
@@ -10655,7 +8458,7 @@
         </p:nvSpPr>
         <p:spPr>
           <a:xfrm>
-            <a:off x="1463040" y="31964970"/>
+            <a:off x="1463040" y="33147208"/>
             <a:ext cx="14173200" cy="1600200"/>
           </a:xfrm>
           <a:prstGeom prst="rect">
@@ -10677,7 +8480,7 @@
               <a:buNone/>
             </a:pPr>
             <a:r>
-              <a:rPr sz="3300" b="1" lang="en-CA">
+              <a:rPr lang="en-CA" sz="3300" b="1" dirty="0">
                 <a:solidFill>
                   <a:srgbClr val="000000"/>
                 </a:solidFill>
@@ -10686,13 +8489,22 @@
               <a:t>Uncertainty: </a:t>
             </a:r>
             <a:r>
-              <a:rPr sz="3300" b="0" lang="en-CA">
+              <a:rPr lang="en-CA" sz="3300" b="0" dirty="0">
                 <a:solidFill>
                   <a:srgbClr val="000000"/>
                 </a:solidFill>
                 <a:latin typeface="Aptos"/>
               </a:rPr>
               <a:t>208 primary / 222 expanded objects. The other 12 enter central-mass tests only. Reported errors may omit calibration scatter.</a:t>
+            </a:r>
+            <a:r>
+              <a:rPr lang="en-CA" sz="2200" b="0" dirty="0" baseline="30000">
+                <a:solidFill>
+                  <a:srgbClr val="000000"/>
+                </a:solidFill>
+                <a:latin typeface="Aptos"/>
+              </a:rPr>
+              <a:t>[1]</a:t>
             </a:r>
           </a:p>
         </p:txBody>
@@ -10713,7 +8525,7 @@
         </p:nvSpPr>
         <p:spPr>
           <a:xfrm>
-            <a:off x="1371600" y="33966423"/>
+            <a:off x="1371600" y="35148661"/>
             <a:ext cx="14173200" cy="1600200"/>
           </a:xfrm>
           <a:prstGeom prst="rect">
@@ -10735,7 +8547,7 @@
               <a:buNone/>
             </a:pPr>
             <a:r>
-              <a:rPr sz="3300" b="1" lang="en-CA">
+              <a:rPr lang="en-CA" sz="3300" b="1" dirty="0">
                 <a:solidFill>
                   <a:srgbClr val="000000"/>
                 </a:solidFill>
@@ -10744,13 +8556,74 @@
               <a:t>Earlier onset: </a:t>
             </a:r>
             <a:r>
-              <a:rPr sz="3300" b="0" lang="en-CA">
+              <a:rPr lang="en-CA" sz="3300" b="0" dirty="0">
                 <a:solidFill>
                   <a:srgbClr val="000000"/>
                 </a:solidFill>
                 <a:latin typeface="Aptos"/>
               </a:rPr>
               <a:t>Solved minimum seed masses for 4 targets at start redshifts 20–3,400. Included radiation in cosmic ages and assumed gas was available.</a:t>
+            </a:r>
+          </a:p>
+        </p:txBody>
+      </p:sp>
+      <p:sp>
+        <p:nvSpPr>
+          <p:cNvPr id="3" name="Efficiency comparison heading">
+            <a:extLst>
+              <a:ext uri="{FF2B5EF4-FFF2-40B4-BE49-F238E27FC236}">
+                <a16:creationId xmlns:a16="http://schemas.microsoft.com/office/drawing/2014/main" id="{9C7CDCE8-5361-4FEF-24D8-015D90D4280A}"/>
+              </a:ext>
+            </a:extLst>
+          </p:cNvPr>
+          <p:cNvSpPr>
+            <a:spLocks noGrp="1"/>
+          </p:cNvSpPr>
+          <p:nvPr/>
+        </p:nvSpPr>
+        <p:spPr>
+          <a:xfrm>
+            <a:off x="1645920" y="11771027"/>
+            <a:ext cx="14356080" cy="640080"/>
+          </a:xfrm>
+          <a:prstGeom prst="rect">
+            <a:avLst/>
+          </a:prstGeom>
+          <a:noFill/>
+        </p:spPr>
+        <p:txBody>
+          <a:bodyPr wrap="square" lIns="91440" tIns="45720" rIns="91440" bIns="45720" anchor="t">
+            <a:spAutoFit/>
+          </a:bodyPr>
+          <a:lstStyle>
+            <a:defPPr>
+              <a:defRPr b="1">
+                <a:solidFill>
+                  <a:srgbClr val="002A5C"/>
+                </a:solidFill>
+              </a:defRPr>
+            </a:defPPr>
+          </a:lstStyle>
+          <a:p>
+            <a:pPr>
+              <a:spcAft>
+                <a:spcPts val="800"/>
+              </a:spcAft>
+              <a:buNone/>
+              <a:defRPr b="1">
+                <a:solidFill>
+                  <a:srgbClr val="002A5C"/>
+                </a:solidFill>
+              </a:defRPr>
+            </a:pPr>
+            <a:r>
+              <a:rPr lang="en-CA" sz="3600" b="1" dirty="0">
+                <a:solidFill>
+                  <a:srgbClr val="002A5C"/>
+                </a:solidFill>
+                <a:latin typeface="Aptos"/>
+              </a:rPr>
+              <a:t>Catalogue creation and sampling</a:t>
             </a:r>
           </a:p>
         </p:txBody>

</xml_diff>

<commit_message>
Refine poster interpretation, wording, and presentation consistency
</commit_message>
<xml_diff>
--- a/posters/36x48.pptx
+++ b/posters/36x48.pptx
@@ -129,109 +129,22 @@
   <pc:docChgLst>
     <pc:chgData name="Nicole Jiang" userId="09ef0fc0f6f473b5" providerId="LiveId" clId="{EB8F4A53-0964-5BF1-90AD-931457E28E1A}"/>
     <pc:docChg chg="undo redo custSel addSld delSld modSld">
-      <pc:chgData name="Nicole Jiang" userId="09ef0fc0f6f473b5" providerId="LiveId" clId="{EB8F4A53-0964-5BF1-90AD-931457E28E1A}" dt="2026-10-14T20:17:12.227" v="2827" actId="2696"/>
+      <pc:chgData name="Nicole Jiang" userId="09ef0fc0f6f473b5" providerId="LiveId" clId="{EB8F4A53-0964-5BF1-90AD-931457E28E1A}" dt="2026-10-15T05:12:53.627" v="3358" actId="14100"/>
       <pc:docMkLst>
         <pc:docMk/>
       </pc:docMkLst>
-      <pc:sldChg chg="addSp delSp modSp add del mod">
-        <pc:chgData name="Nicole Jiang" userId="09ef0fc0f6f473b5" providerId="LiveId" clId="{EB8F4A53-0964-5BF1-90AD-931457E28E1A}" dt="2026-10-13T17:24:31.699" v="2580" actId="2696"/>
-        <pc:sldMkLst>
-          <pc:docMk/>
-          <pc:sldMk cId="868487171" sldId="259"/>
-        </pc:sldMkLst>
-      </pc:sldChg>
       <pc:sldChg chg="addSp delSp modSp del mod">
         <pc:chgData name="Nicole Jiang" userId="09ef0fc0f6f473b5" providerId="LiveId" clId="{EB8F4A53-0964-5BF1-90AD-931457E28E1A}" dt="2026-10-14T20:17:12.227" v="2827" actId="2696"/>
         <pc:sldMkLst>
           <pc:docMk/>
           <pc:sldMk cId="868487171" sldId="260"/>
         </pc:sldMkLst>
-        <pc:spChg chg="mod">
-          <ac:chgData name="Nicole Jiang" userId="09ef0fc0f6f473b5" providerId="LiveId" clId="{EB8F4A53-0964-5BF1-90AD-931457E28E1A}" dt="2026-10-13T21:07:08.915" v="2657" actId="255"/>
-          <ac:spMkLst>
-            <pc:docMk/>
-            <pc:sldMk cId="868487171" sldId="260"/>
-            <ac:spMk id="2" creationId="{6F669F8B-BE33-0C82-515C-AF8D3B759FB3}"/>
-          </ac:spMkLst>
-        </pc:spChg>
-        <pc:spChg chg="mod">
-          <ac:chgData name="Nicole Jiang" userId="09ef0fc0f6f473b5" providerId="LiveId" clId="{EB8F4A53-0964-5BF1-90AD-931457E28E1A}" dt="2026-10-13T04:31:08.200" v="2544" actId="14100"/>
-          <ac:spMkLst>
-            <pc:docMk/>
-            <pc:sldMk cId="868487171" sldId="260"/>
-            <ac:spMk id="7" creationId="{3AC78928-AF13-E1B9-F802-F1FD39D07D33}"/>
-          </ac:spMkLst>
-        </pc:spChg>
-        <pc:spChg chg="add del mod">
-          <ac:chgData name="Nicole Jiang" userId="09ef0fc0f6f473b5" providerId="LiveId" clId="{EB8F4A53-0964-5BF1-90AD-931457E28E1A}" dt="2026-10-13T04:24:36.137" v="2460" actId="478"/>
-          <ac:spMkLst>
-            <pc:docMk/>
-            <pc:sldMk cId="868487171" sldId="260"/>
-            <ac:spMk id="8" creationId="{75C85530-E1D2-AF34-1B2C-F56DD2AFE4AF}"/>
-          </ac:spMkLst>
-        </pc:spChg>
-        <pc:spChg chg="add del">
-          <ac:chgData name="Nicole Jiang" userId="09ef0fc0f6f473b5" providerId="LiveId" clId="{EB8F4A53-0964-5BF1-90AD-931457E28E1A}" dt="2026-10-13T17:35:09.918" v="2597" actId="22"/>
-          <ac:spMkLst>
-            <pc:docMk/>
-            <pc:sldMk cId="868487171" sldId="260"/>
-            <ac:spMk id="9" creationId="{BC255E84-3920-83B2-B909-E002B21CB45A}"/>
-          </ac:spMkLst>
-        </pc:spChg>
-        <pc:spChg chg="mod">
-          <ac:chgData name="Nicole Jiang" userId="09ef0fc0f6f473b5" providerId="LiveId" clId="{EB8F4A53-0964-5BF1-90AD-931457E28E1A}" dt="2026-10-13T04:33:36.816" v="2572" actId="14100"/>
-          <ac:spMkLst>
-            <pc:docMk/>
-            <pc:sldMk cId="868487171" sldId="260"/>
-            <ac:spMk id="11" creationId="{AF7EDC07-606F-DD66-5973-0AE0D673B23B}"/>
-          </ac:spMkLst>
-        </pc:spChg>
-        <pc:spChg chg="add del mod">
-          <ac:chgData name="Nicole Jiang" userId="09ef0fc0f6f473b5" providerId="LiveId" clId="{EB8F4A53-0964-5BF1-90AD-931457E28E1A}" dt="2026-10-13T04:24:48.767" v="2466"/>
-          <ac:spMkLst>
-            <pc:docMk/>
-            <pc:sldMk cId="868487171" sldId="260"/>
-            <ac:spMk id="12" creationId="{C0849F7A-B4A3-9284-9FFE-EB9FFC54D4D3}"/>
-          </ac:spMkLst>
-        </pc:spChg>
         <pc:spChg chg="add mod">
           <ac:chgData name="Nicole Jiang" userId="09ef0fc0f6f473b5" providerId="LiveId" clId="{EB8F4A53-0964-5BF1-90AD-931457E28E1A}" dt="2026-10-14T03:42:59.952" v="2687" actId="1076"/>
           <ac:spMkLst>
             <pc:docMk/>
             <pc:sldMk cId="868487171" sldId="260"/>
             <ac:spMk id="15" creationId="{B71483CE-2A7E-6438-7E3B-E605C17C7099}"/>
-          </ac:spMkLst>
-        </pc:spChg>
-        <pc:spChg chg="add mod">
-          <ac:chgData name="Nicole Jiang" userId="09ef0fc0f6f473b5" providerId="LiveId" clId="{EB8F4A53-0964-5BF1-90AD-931457E28E1A}" dt="2026-10-13T04:33:20.708" v="2567" actId="571"/>
-          <ac:spMkLst>
-            <pc:docMk/>
-            <pc:sldMk cId="868487171" sldId="260"/>
-            <ac:spMk id="17" creationId="{84ACFD66-AC45-B0B3-9E6F-FC9D5909992E}"/>
-          </ac:spMkLst>
-        </pc:spChg>
-        <pc:spChg chg="mod">
-          <ac:chgData name="Nicole Jiang" userId="09ef0fc0f6f473b5" providerId="LiveId" clId="{EB8F4A53-0964-5BF1-90AD-931457E28E1A}" dt="2026-10-13T17:25:16.831" v="2589" actId="1076"/>
-          <ac:spMkLst>
-            <pc:docMk/>
-            <pc:sldMk cId="868487171" sldId="260"/>
-            <ac:spMk id="32" creationId="{F8D50A2A-9B61-AD34-B9C2-8944BB27426C}"/>
-          </ac:spMkLst>
-        </pc:spChg>
-        <pc:spChg chg="mod">
-          <ac:chgData name="Nicole Jiang" userId="09ef0fc0f6f473b5" providerId="LiveId" clId="{EB8F4A53-0964-5BF1-90AD-931457E28E1A}" dt="2026-10-13T04:30:28.608" v="2535" actId="14100"/>
-          <ac:spMkLst>
-            <pc:docMk/>
-            <pc:sldMk cId="868487171" sldId="260"/>
-            <ac:spMk id="69" creationId="{D8B6836B-DAF1-F68F-D717-73D3A454BC2E}"/>
-          </ac:spMkLst>
-        </pc:spChg>
-        <pc:spChg chg="mod">
-          <ac:chgData name="Nicole Jiang" userId="09ef0fc0f6f473b5" providerId="LiveId" clId="{EB8F4A53-0964-5BF1-90AD-931457E28E1A}" dt="2026-10-13T21:07:12.551" v="2658" actId="255"/>
-          <ac:spMkLst>
-            <pc:docMk/>
-            <pc:sldMk cId="868487171" sldId="260"/>
-            <ac:spMk id="70" creationId="{7842EAEC-0FF9-516A-6712-19E0D19D0354}"/>
           </ac:spMkLst>
         </pc:spChg>
         <pc:spChg chg="mod">
@@ -266,36 +179,12 @@
             <ac:spMk id="74" creationId="{F5F0E6D1-7308-2846-C555-5A8981E84E43}"/>
           </ac:spMkLst>
         </pc:spChg>
-        <pc:spChg chg="del">
-          <ac:chgData name="Nicole Jiang" userId="09ef0fc0f6f473b5" providerId="LiveId" clId="{EB8F4A53-0964-5BF1-90AD-931457E28E1A}" dt="2026-10-13T04:15:58.561" v="2424" actId="478"/>
-          <ac:spMkLst>
-            <pc:docMk/>
-            <pc:sldMk cId="868487171" sldId="260"/>
-            <ac:spMk id="75" creationId="{1321580B-F01F-0657-4172-18EB0518DB94}"/>
-          </ac:spMkLst>
-        </pc:spChg>
         <pc:spChg chg="mod">
           <ac:chgData name="Nicole Jiang" userId="09ef0fc0f6f473b5" providerId="LiveId" clId="{EB8F4A53-0964-5BF1-90AD-931457E28E1A}" dt="2026-10-14T03:42:44.386" v="2685" actId="1076"/>
           <ac:spMkLst>
             <pc:docMk/>
             <pc:sldMk cId="868487171" sldId="260"/>
             <ac:spMk id="76" creationId="{8F4057E1-F618-63B3-DF3A-8B3B4948305D}"/>
-          </ac:spMkLst>
-        </pc:spChg>
-        <pc:spChg chg="del mod">
-          <ac:chgData name="Nicole Jiang" userId="09ef0fc0f6f473b5" providerId="LiveId" clId="{EB8F4A53-0964-5BF1-90AD-931457E28E1A}" dt="2026-10-13T04:15:59.780" v="2425" actId="478"/>
-          <ac:spMkLst>
-            <pc:docMk/>
-            <pc:sldMk cId="868487171" sldId="260"/>
-            <ac:spMk id="77" creationId="{7A1E6EC0-2FA9-D0FD-7275-799C6E89A662}"/>
-          </ac:spMkLst>
-        </pc:spChg>
-        <pc:spChg chg="mod">
-          <ac:chgData name="Nicole Jiang" userId="09ef0fc0f6f473b5" providerId="LiveId" clId="{EB8F4A53-0964-5BF1-90AD-931457E28E1A}" dt="2026-10-13T04:33:24.947" v="2569" actId="1076"/>
-          <ac:spMkLst>
-            <pc:docMk/>
-            <pc:sldMk cId="868487171" sldId="260"/>
-            <ac:spMk id="78" creationId="{D50205E6-BF86-6F08-991C-43F597FDF8DD}"/>
           </ac:spMkLst>
         </pc:spChg>
         <pc:spChg chg="mod">
@@ -307,54 +196,6 @@
           </ac:spMkLst>
         </pc:spChg>
         <pc:spChg chg="mod">
-          <ac:chgData name="Nicole Jiang" userId="09ef0fc0f6f473b5" providerId="LiveId" clId="{EB8F4A53-0964-5BF1-90AD-931457E28E1A}" dt="2026-10-13T04:33:28.472" v="2570" actId="14100"/>
-          <ac:spMkLst>
-            <pc:docMk/>
-            <pc:sldMk cId="868487171" sldId="260"/>
-            <ac:spMk id="80" creationId="{BBD5C8AB-335C-2E4D-00F6-4B0BF74BB013}"/>
-          </ac:spMkLst>
-        </pc:spChg>
-        <pc:spChg chg="mod">
-          <ac:chgData name="Nicole Jiang" userId="09ef0fc0f6f473b5" providerId="LiveId" clId="{EB8F4A53-0964-5BF1-90AD-931457E28E1A}" dt="2026-10-13T17:25:54.657" v="2593" actId="1076"/>
-          <ac:spMkLst>
-            <pc:docMk/>
-            <pc:sldMk cId="868487171" sldId="260"/>
-            <ac:spMk id="81" creationId="{8E773A53-2851-D565-B46F-D419BA57021E}"/>
-          </ac:spMkLst>
-        </pc:spChg>
-        <pc:spChg chg="mod">
-          <ac:chgData name="Nicole Jiang" userId="09ef0fc0f6f473b5" providerId="LiveId" clId="{EB8F4A53-0964-5BF1-90AD-931457E28E1A}" dt="2026-10-13T21:07:31.461" v="2663" actId="255"/>
-          <ac:spMkLst>
-            <pc:docMk/>
-            <pc:sldMk cId="868487171" sldId="260"/>
-            <ac:spMk id="82" creationId="{82B57F9D-B4AF-1E4D-7FBC-B8680CB4CAB8}"/>
-          </ac:spMkLst>
-        </pc:spChg>
-        <pc:spChg chg="mod">
-          <ac:chgData name="Nicole Jiang" userId="09ef0fc0f6f473b5" providerId="LiveId" clId="{EB8F4A53-0964-5BF1-90AD-931457E28E1A}" dt="2026-10-13T17:25:58.232" v="2594" actId="14100"/>
-          <ac:spMkLst>
-            <pc:docMk/>
-            <pc:sldMk cId="868487171" sldId="260"/>
-            <ac:spMk id="83" creationId="{7156AF1B-4C0F-9637-8495-BA5941742B85}"/>
-          </ac:spMkLst>
-        </pc:spChg>
-        <pc:spChg chg="mod">
-          <ac:chgData name="Nicole Jiang" userId="09ef0fc0f6f473b5" providerId="LiveId" clId="{EB8F4A53-0964-5BF1-90AD-931457E28E1A}" dt="2026-10-13T04:25:23.126" v="2472" actId="1076"/>
-          <ac:spMkLst>
-            <pc:docMk/>
-            <pc:sldMk cId="868487171" sldId="260"/>
-            <ac:spMk id="110" creationId="{00000000-0000-0000-0000-000000000000}"/>
-          </ac:spMkLst>
-        </pc:spChg>
-        <pc:spChg chg="mod">
-          <ac:chgData name="Nicole Jiang" userId="09ef0fc0f6f473b5" providerId="LiveId" clId="{EB8F4A53-0964-5BF1-90AD-931457E28E1A}" dt="2026-10-13T21:03:27.266" v="2618" actId="1076"/>
-          <ac:spMkLst>
-            <pc:docMk/>
-            <pc:sldMk cId="868487171" sldId="260"/>
-            <ac:spMk id="111" creationId="{00000000-0000-0000-0000-000000000000}"/>
-          </ac:spMkLst>
-        </pc:spChg>
-        <pc:spChg chg="mod">
           <ac:chgData name="Nicole Jiang" userId="09ef0fc0f6f473b5" providerId="LiveId" clId="{EB8F4A53-0964-5BF1-90AD-931457E28E1A}" dt="2026-10-14T03:43:03.391" v="2688" actId="1076"/>
           <ac:spMkLst>
             <pc:docMk/>
@@ -362,62 +203,6 @@
             <ac:spMk id="112" creationId="{00000000-0000-0000-0000-000000000000}"/>
           </ac:spMkLst>
         </pc:spChg>
-        <pc:spChg chg="mod">
-          <ac:chgData name="Nicole Jiang" userId="09ef0fc0f6f473b5" providerId="LiveId" clId="{EB8F4A53-0964-5BF1-90AD-931457E28E1A}" dt="2026-10-13T21:03:36.169" v="2620" actId="1076"/>
-          <ac:spMkLst>
-            <pc:docMk/>
-            <pc:sldMk cId="868487171" sldId="260"/>
-            <ac:spMk id="120" creationId="{3A05E1FE-512D-49F3-9C39-22D275F0EE18}"/>
-          </ac:spMkLst>
-        </pc:spChg>
-        <pc:picChg chg="mod">
-          <ac:chgData name="Nicole Jiang" userId="09ef0fc0f6f473b5" providerId="LiveId" clId="{EB8F4A53-0964-5BF1-90AD-931457E28E1A}" dt="2026-10-13T21:03:29.514" v="2619" actId="1076"/>
-          <ac:picMkLst>
-            <pc:docMk/>
-            <pc:sldMk cId="868487171" sldId="260"/>
-            <ac:picMk id="3" creationId="{535E2EF0-72FB-E9D0-1E82-C65E26ED9E91}"/>
-          </ac:picMkLst>
-        </pc:picChg>
-        <pc:picChg chg="mod">
-          <ac:chgData name="Nicole Jiang" userId="09ef0fc0f6f473b5" providerId="LiveId" clId="{EB8F4A53-0964-5BF1-90AD-931457E28E1A}" dt="2026-10-13T04:31:29.384" v="2549" actId="1076"/>
-          <ac:picMkLst>
-            <pc:docMk/>
-            <pc:sldMk cId="868487171" sldId="260"/>
-            <ac:picMk id="4" creationId="{C4337658-2539-7C1B-497A-E1769149148E}"/>
-          </ac:picMkLst>
-        </pc:picChg>
-        <pc:picChg chg="mod">
-          <ac:chgData name="Nicole Jiang" userId="09ef0fc0f6f473b5" providerId="LiveId" clId="{EB8F4A53-0964-5BF1-90AD-931457E28E1A}" dt="2026-10-13T03:53:35.490" v="2389" actId="1076"/>
-          <ac:picMkLst>
-            <pc:docMk/>
-            <pc:sldMk cId="868487171" sldId="260"/>
-            <ac:picMk id="5" creationId="{0BD845B3-DC16-6DC6-BFC8-2D65D247678D}"/>
-          </ac:picMkLst>
-        </pc:picChg>
-        <pc:picChg chg="mod">
-          <ac:chgData name="Nicole Jiang" userId="09ef0fc0f6f473b5" providerId="LiveId" clId="{EB8F4A53-0964-5BF1-90AD-931457E28E1A}" dt="2026-10-13T03:53:38.080" v="2390" actId="1076"/>
-          <ac:picMkLst>
-            <pc:docMk/>
-            <pc:sldMk cId="868487171" sldId="260"/>
-            <ac:picMk id="6" creationId="{9D3E6E2E-04C2-513B-0EE5-8C40F5B8F46A}"/>
-          </ac:picMkLst>
-        </pc:picChg>
-        <pc:picChg chg="add mod">
-          <ac:chgData name="Nicole Jiang" userId="09ef0fc0f6f473b5" providerId="LiveId" clId="{EB8F4A53-0964-5BF1-90AD-931457E28E1A}" dt="2026-10-13T04:25:48.062" v="2478" actId="1076"/>
-          <ac:picMkLst>
-            <pc:docMk/>
-            <pc:sldMk cId="868487171" sldId="260"/>
-            <ac:picMk id="9" creationId="{DA4F04D1-71C4-D0BB-D2B5-DFFC4A124624}"/>
-          </ac:picMkLst>
-        </pc:picChg>
-        <pc:picChg chg="mod">
-          <ac:chgData name="Nicole Jiang" userId="09ef0fc0f6f473b5" providerId="LiveId" clId="{EB8F4A53-0964-5BF1-90AD-931457E28E1A}" dt="2026-10-13T03:52:22.696" v="2378" actId="1076"/>
-          <ac:picMkLst>
-            <pc:docMk/>
-            <pc:sldMk cId="868487171" sldId="260"/>
-            <ac:picMk id="10" creationId="{FB4EBB94-758E-75A7-659C-BF66DBB0AEF6}"/>
-          </ac:picMkLst>
-        </pc:picChg>
         <pc:picChg chg="mod">
           <ac:chgData name="Nicole Jiang" userId="09ef0fc0f6f473b5" providerId="LiveId" clId="{EB8F4A53-0964-5BF1-90AD-931457E28E1A}" dt="2026-10-14T03:42:55.489" v="2686" actId="1076"/>
           <ac:picMkLst>
@@ -426,33 +211,9 @@
             <ac:picMk id="14" creationId="{C3CA3027-10C5-D39A-05B0-82DB2540F9D3}"/>
           </ac:picMkLst>
         </pc:picChg>
-        <pc:picChg chg="add mod">
-          <ac:chgData name="Nicole Jiang" userId="09ef0fc0f6f473b5" providerId="LiveId" clId="{EB8F4A53-0964-5BF1-90AD-931457E28E1A}" dt="2026-10-13T04:30:22.385" v="2519" actId="571"/>
-          <ac:picMkLst>
-            <pc:docMk/>
-            <pc:sldMk cId="868487171" sldId="260"/>
-            <ac:picMk id="16" creationId="{0E987B6D-2DAC-5699-DEFF-718AA7AF9224}"/>
-          </ac:picMkLst>
-        </pc:picChg>
-        <pc:picChg chg="mod">
-          <ac:chgData name="Nicole Jiang" userId="09ef0fc0f6f473b5" providerId="LiveId" clId="{EB8F4A53-0964-5BF1-90AD-931457E28E1A}" dt="2026-10-13T03:52:53.768" v="2384" actId="1076"/>
-          <ac:picMkLst>
-            <pc:docMk/>
-            <pc:sldMk cId="868487171" sldId="260"/>
-            <ac:picMk id="33" creationId="{42BD33B9-86B6-8B04-8AA1-E72E85543563}"/>
-          </ac:picMkLst>
-        </pc:picChg>
-        <pc:picChg chg="mod">
-          <ac:chgData name="Nicole Jiang" userId="09ef0fc0f6f473b5" providerId="LiveId" clId="{EB8F4A53-0964-5BF1-90AD-931457E28E1A}" dt="2026-10-13T03:52:51.190" v="2383" actId="1076"/>
-          <ac:picMkLst>
-            <pc:docMk/>
-            <pc:sldMk cId="868487171" sldId="260"/>
-            <ac:picMk id="36" creationId="{8C2E503F-9CF2-EBE6-29B0-458691A7DFB1}"/>
-          </ac:picMkLst>
-        </pc:picChg>
       </pc:sldChg>
       <pc:sldChg chg="addSp delSp modSp mod">
-        <pc:chgData name="Nicole Jiang" userId="09ef0fc0f6f473b5" providerId="LiveId" clId="{EB8F4A53-0964-5BF1-90AD-931457E28E1A}" dt="2026-10-14T20:15:48.652" v="2826" actId="20577"/>
+        <pc:chgData name="Nicole Jiang" userId="09ef0fc0f6f473b5" providerId="LiveId" clId="{EB8F4A53-0964-5BF1-90AD-931457E28E1A}" dt="2026-10-15T05:12:53.627" v="3358" actId="14100"/>
         <pc:sldMkLst>
           <pc:docMk/>
           <pc:sldMk cId="868487171" sldId="261"/>
@@ -466,7 +227,7 @@
           </ac:spMkLst>
         </pc:spChg>
         <pc:spChg chg="add mod">
-          <ac:chgData name="Nicole Jiang" userId="09ef0fc0f6f473b5" providerId="LiveId" clId="{EB8F4A53-0964-5BF1-90AD-931457E28E1A}" dt="2026-10-14T19:36:26.018" v="2769" actId="1076"/>
+          <ac:chgData name="Nicole Jiang" userId="09ef0fc0f6f473b5" providerId="LiveId" clId="{EB8F4A53-0964-5BF1-90AD-931457E28E1A}" dt="2026-10-15T01:51:13.591" v="2854" actId="1076"/>
           <ac:spMkLst>
             <pc:docMk/>
             <pc:sldMk cId="868487171" sldId="261"/>
@@ -479,6 +240,22 @@
             <pc:docMk/>
             <pc:sldMk cId="868487171" sldId="261"/>
             <ac:spMk id="11" creationId="{AF7EDC07-606F-DD66-5973-0AE0D673B23B}"/>
+          </ac:spMkLst>
+        </pc:spChg>
+        <pc:spChg chg="mod">
+          <ac:chgData name="Nicole Jiang" userId="09ef0fc0f6f473b5" providerId="LiveId" clId="{EB8F4A53-0964-5BF1-90AD-931457E28E1A}" dt="2026-10-15T02:59:01.507" v="2900" actId="1076"/>
+          <ac:spMkLst>
+            <pc:docMk/>
+            <pc:sldMk cId="868487171" sldId="261"/>
+            <ac:spMk id="32" creationId="{F8D50A2A-9B61-AD34-B9C2-8944BB27426C}"/>
+          </ac:spMkLst>
+        </pc:spChg>
+        <pc:spChg chg="mod">
+          <ac:chgData name="Nicole Jiang" userId="09ef0fc0f6f473b5" providerId="LiveId" clId="{EB8F4A53-0964-5BF1-90AD-931457E28E1A}" dt="2026-10-15T05:12:53.627" v="3358" actId="14100"/>
+          <ac:spMkLst>
+            <pc:docMk/>
+            <pc:sldMk cId="868487171" sldId="261"/>
+            <ac:spMk id="71" creationId="{ABB03D82-A209-1440-3180-9DD4419EFCBF}"/>
           </ac:spMkLst>
         </pc:spChg>
         <pc:spChg chg="mod">
@@ -506,7 +283,7 @@
           </ac:spMkLst>
         </pc:spChg>
         <pc:spChg chg="mod">
-          <ac:chgData name="Nicole Jiang" userId="09ef0fc0f6f473b5" providerId="LiveId" clId="{EB8F4A53-0964-5BF1-90AD-931457E28E1A}" dt="2026-10-14T19:46:59.840" v="2818" actId="20577"/>
+          <ac:chgData name="Nicole Jiang" userId="09ef0fc0f6f473b5" providerId="LiveId" clId="{EB8F4A53-0964-5BF1-90AD-931457E28E1A}" dt="2026-10-15T03:51:02.451" v="3351" actId="255"/>
           <ac:spMkLst>
             <pc:docMk/>
             <pc:sldMk cId="868487171" sldId="261"/>
@@ -530,7 +307,7 @@
           </ac:spMkLst>
         </pc:spChg>
         <pc:spChg chg="mod">
-          <ac:chgData name="Nicole Jiang" userId="09ef0fc0f6f473b5" providerId="LiveId" clId="{EB8F4A53-0964-5BF1-90AD-931457E28E1A}" dt="2026-10-14T19:34:17.017" v="2721" actId="1076"/>
+          <ac:chgData name="Nicole Jiang" userId="09ef0fc0f6f473b5" providerId="LiveId" clId="{EB8F4A53-0964-5BF1-90AD-931457E28E1A}" dt="2026-10-15T03:54:00.898" v="3354" actId="1076"/>
           <ac:spMkLst>
             <pc:docMk/>
             <pc:sldMk cId="868487171" sldId="261"/>
@@ -610,11 +387,19 @@
           </ac:spMkLst>
         </pc:spChg>
         <pc:spChg chg="mod">
-          <ac:chgData name="Nicole Jiang" userId="09ef0fc0f6f473b5" providerId="LiveId" clId="{EB8F4A53-0964-5BF1-90AD-931457E28E1A}" dt="2026-10-14T19:32:05.427" v="2710" actId="14100"/>
+          <ac:chgData name="Nicole Jiang" userId="09ef0fc0f6f473b5" providerId="LiveId" clId="{EB8F4A53-0964-5BF1-90AD-931457E28E1A}" dt="2026-10-15T01:40:30.896" v="2846" actId="5793"/>
           <ac:spMkLst>
             <pc:docMk/>
             <pc:sldMk cId="868487171" sldId="261"/>
             <ac:spMk id="208" creationId="{FAA325B6-AF3F-4391-B001-5CEA6C0D3BA1}"/>
+          </ac:spMkLst>
+        </pc:spChg>
+        <pc:spChg chg="mod">
+          <ac:chgData name="Nicole Jiang" userId="09ef0fc0f6f473b5" providerId="LiveId" clId="{EB8F4A53-0964-5BF1-90AD-931457E28E1A}" dt="2026-10-15T03:33:49.879" v="3312" actId="12"/>
+          <ac:spMkLst>
+            <pc:docMk/>
+            <pc:sldMk cId="868487171" sldId="261"/>
+            <ac:spMk id="209" creationId="{67E72EF7-28FB-420D-A9DC-6606EEB93072}"/>
           </ac:spMkLst>
         </pc:spChg>
         <pc:spChg chg="mod">
@@ -698,6 +483,14 @@
           </ac:spMkLst>
         </pc:spChg>
         <pc:spChg chg="mod">
+          <ac:chgData name="Nicole Jiang" userId="09ef0fc0f6f473b5" providerId="LiveId" clId="{EB8F4A53-0964-5BF1-90AD-931457E28E1A}" dt="2026-10-15T01:42:21.472" v="2853" actId="20577"/>
+          <ac:spMkLst>
+            <pc:docMk/>
+            <pc:sldMk cId="868487171" sldId="261"/>
+            <ac:spMk id="221" creationId="{03BB0CC6-89F0-4BB8-91C2-A18697FB4691}"/>
+          </ac:spMkLst>
+        </pc:spChg>
+        <pc:spChg chg="mod">
           <ac:chgData name="Nicole Jiang" userId="09ef0fc0f6f473b5" providerId="LiveId" clId="{EB8F4A53-0964-5BF1-90AD-931457E28E1A}" dt="2026-10-14T19:48:25.703" v="2821" actId="1076"/>
           <ac:spMkLst>
             <pc:docMk/>
@@ -729,21 +522,6 @@
             <ac:picMk id="14" creationId="{C3CA3027-10C5-D39A-05B0-82DB2540F9D3}"/>
           </ac:picMkLst>
         </pc:picChg>
-      </pc:sldChg>
-      <pc:sldChg chg="modSp add del mod">
-        <pc:chgData name="Nicole Jiang" userId="09ef0fc0f6f473b5" providerId="LiveId" clId="{EB8F4A53-0964-5BF1-90AD-931457E28E1A}" dt="2026-10-13T17:35:40.898" v="2607" actId="2696"/>
-        <pc:sldMkLst>
-          <pc:docMk/>
-          <pc:sldMk cId="1945540972" sldId="261"/>
-        </pc:sldMkLst>
-        <pc:spChg chg="mod">
-          <ac:chgData name="Nicole Jiang" userId="09ef0fc0f6f473b5" providerId="LiveId" clId="{EB8F4A53-0964-5BF1-90AD-931457E28E1A}" dt="2026-10-13T17:35:28.310" v="2606" actId="20577"/>
-          <ac:spMkLst>
-            <pc:docMk/>
-            <pc:sldMk cId="1945540972" sldId="261"/>
-            <ac:spMk id="73" creationId="{69833F19-D0F2-FA5A-D1B8-216186ACC37F}"/>
-          </ac:spMkLst>
-        </pc:spChg>
       </pc:sldChg>
     </pc:docChg>
   </pc:docChgLst>
@@ -1118,149 +896,149 @@
 </file>
 
 <file path=ppt/notesSlides/notesSlide1.xml><?xml version="1.0" encoding="utf-8"?>
-<ns0:notes xmlns:ns0="http://schemas.openxmlformats.org/presentationml/2006/main" xmlns:ns1="http://schemas.openxmlformats.org/drawingml/2006/main" xmlns:ns2="http://schemas.microsoft.com/office/drawing/2014/main" xmlns:ns3="http://schemas.microsoft.com/office/powerpoint/2010/main">
-  <ns0:cSld>
-    <ns0:spTree>
-      <ns0:nvGrpSpPr>
-        <ns0:cNvPr id="1" name="">
-          <ns1:extLst>
-            <ns1:ext uri="{FF2B5EF4-FFF2-40B4-BE49-F238E27FC236}">
-              <ns2:creationId id="{9FC4C11B-3281-61F5-AEEC-E5F2B2984717}"/>
-            </ns1:ext>
-          </ns1:extLst>
-        </ns0:cNvPr>
-        <ns0:cNvGrpSpPr/>
-        <ns0:nvPr/>
-      </ns0:nvGrpSpPr>
-      <ns0:grpSpPr>
-        <ns1:xfrm>
-          <ns1:off x="0" y="0"/>
-          <ns1:ext cx="0" cy="0"/>
-          <ns1:chOff x="0" y="0"/>
-          <ns1:chExt cx="0" cy="0"/>
-        </ns1:xfrm>
-      </ns0:grpSpPr>
-      <ns0:sp>
-        <ns0:nvSpPr>
-          <ns0:cNvPr id="2" name="Slide Image Placeholder 1">
-            <ns1:extLst>
-              <ns1:ext uri="{FF2B5EF4-FFF2-40B4-BE49-F238E27FC236}">
-                <ns2:creationId id="{C975FC8B-F564-04EA-26FD-6F8FBA438751}"/>
-              </ns1:ext>
-            </ns1:extLst>
-          </ns0:cNvPr>
-          <ns0:cNvSpPr>
-            <ns1:spLocks noGrp="1" noRot="1" noChangeAspect="1"/>
-          </ns0:cNvSpPr>
-          <ns0:nvPr>
-            <ns0:ph type="sldImg"/>
-          </ns0:nvPr>
-        </ns0:nvSpPr>
-        <ns0:spPr>
-          <ns1:xfrm>
-            <ns1:off x="2271713" y="1143000"/>
-            <ns1:ext cx="2314575" cy="3086100"/>
-          </ns1:xfrm>
-        </ns0:spPr>
-      </ns0:sp>
-      <ns0:sp>
-        <ns0:nvSpPr>
-          <ns0:cNvPr id="3" name="Notes Placeholder 2">
-            <ns1:extLst>
-              <ns1:ext uri="{FF2B5EF4-FFF2-40B4-BE49-F238E27FC236}">
-                <ns2:creationId id="{78ACB9E4-9956-85CD-1D61-2F397B472319}"/>
-              </ns1:ext>
-            </ns1:extLst>
-          </ns0:cNvPr>
-          <ns0:cNvSpPr>
-            <ns1:spLocks noGrp="1"/>
-          </ns0:cNvSpPr>
-          <ns0:nvPr>
-            <ns0:ph type="body" idx="1"/>
-          </ns0:nvPr>
-        </ns0:nvSpPr>
-        <ns0:spPr/>
-        <ns0:txBody>
-          <ns1:bodyPr/>
-          <ns1:lstStyle/>
-          <ns1:p>
-            <ns1:r>
-              <ns1:rPr sz="1200"/>
-              <ns1:t>Poster figure inputs: results/for_manuscript/tables/publication_object_selection.csv; results/for_manuscript/tables/mass_offset_object_sensitivity.csv; results/v3/tables/v3_object_point_ranking.csv; results/v3/tables/v3_object_uncertainty_ranking.csv; results/v4/tables/v4_minimum_seed_mass.csv. Scientific inputs are pinned in data/poster_inputs.json. The uncertainty panel is generated by src.internal.poster_figures. The earlier-onset panel holds the stated average cap and radiative efficiency constant along each track. The external dynamical comparison uses the adopted arXiv v2 measurement; the required ratios and intervals are calculated by this project.</ns1:t>
-            </ns1:r>
-          </ns1:p>
-          <ns1:p>
-            <ns1:r>
-              <ns1:rPr sz="1200"/>
-              <ns1:t>[1] Shen (2013), The Mass of Quasars: https://arxiv.org/abs/1302.2643 — broad-line virial mass methods and calibration scatter.</ns1:t>
-            </ns1:r>
-          </ns1:p>
-          <ns1:p>
-            <ns1:r>
-              <ns1:rPr sz="1200"/>
-              <ns1:t>[2] Maiolino et al. (2024), A small and vigorous black hole in the early Universe: https://doi.org/10.1038/s41586-024-07052-5 — GN-z11 ultraviolet-line mass and early JWST context.</ns1:t>
-            </ns1:r>
-          </ns1:p>
-          <ns1:p>
-            <ns1:r>
-              <ns1:rPr sz="1200"/>
-              <ns1:t>[3] Dayal (2024), Exploring a primordial solution for early black holes detected with JWST: https://doi.org/10.1051/0004-6361/202451481 — exponential accretion growth relation. The project inverts the growth relation; its reference seed and growth-test thresholds are analysis assumptions.</ns1:t>
-            </ns1:r>
-          </ns1:p>
-          <ns1:p>
-            <ns1:r>
-              <ns1:rPr sz="1200"/>
-              <ns1:t>[4] Bardeen, Press &amp; Teukolsky (1972): https://doi.org/10.1086/151796 — ideal thin-disc efficiency for a non-spinning black hole, 1-sqrt(8/9).</ns1:t>
-            </ns1:r>
-          </ns1:p>
-          <ns1:p>
-            <ns1:r>
-              <ns1:rPr sz="1200"/>
-              <ns1:t>[5] Juodzbalis et al. (2025): https://arxiv.org/abs/2508.21748v2 — adopted independent A2744-QSO1 dynamical mass. The poster's average Eddington ratios are project calculations, not measurements quoted from this paper.</ns1:t>
-            </ns1:r>
-          </ns1:p>
-        </ns0:txBody>
-      </ns0:sp>
-      <ns0:sp>
-        <ns0:nvSpPr>
-          <ns0:cNvPr id="4" name="Slide Number Placeholder 3">
-            <ns1:extLst>
-              <ns1:ext uri="{FF2B5EF4-FFF2-40B4-BE49-F238E27FC236}">
-                <ns2:creationId id="{A8B3E2F2-BDDF-9490-DE7B-11CDCE91017C}"/>
-              </ns1:ext>
-            </ns1:extLst>
-          </ns0:cNvPr>
-          <ns0:cNvSpPr>
-            <ns1:spLocks noGrp="1"/>
-          </ns0:cNvSpPr>
-          <ns0:nvPr>
-            <ns0:ph type="sldNum" sz="quarter" idx="5"/>
-          </ns0:nvPr>
-        </ns0:nvSpPr>
-        <ns0:spPr/>
-        <ns0:txBody>
-          <ns1:bodyPr/>
-          <ns1:lstStyle/>
-          <ns1:p>
-            <ns1:fld id="{490DA246-DE01-5046-81A0-D7E93C87400D}" type="slidenum">
-              <ns1:rPr lang="en-US" smtClean="0"/>
-              <ns1:t>1</ns1:t>
-            </ns1:fld>
-            <ns1:endParaRPr lang="en-US"/>
-          </ns1:p>
-        </ns0:txBody>
-      </ns0:sp>
-    </ns0:spTree>
-    <ns0:extLst>
-      <ns0:ext uri="{BB962C8B-B14F-4D97-AF65-F5344CB8AC3E}">
-        <ns3:creationId val="3600152407"/>
-      </ns0:ext>
-    </ns0:extLst>
-  </ns0:cSld>
-  <ns0:clrMapOvr>
-    <ns1:masterClrMapping/>
-  </ns0:clrMapOvr>
-</ns0:notes>
+<p:notes xmlns:a="http://schemas.openxmlformats.org/drawingml/2006/main" xmlns:r="http://schemas.openxmlformats.org/officeDocument/2006/relationships" xmlns:p="http://schemas.openxmlformats.org/presentationml/2006/main">
+  <p:cSld>
+    <p:spTree>
+      <p:nvGrpSpPr>
+        <p:cNvPr id="1" name="">
+          <a:extLst>
+            <a:ext uri="{FF2B5EF4-FFF2-40B4-BE49-F238E27FC236}">
+              <a16:creationId xmlns:a16="http://schemas.microsoft.com/office/drawing/2014/main" id="{9FC4C11B-3281-61F5-AEEC-E5F2B2984717}"/>
+            </a:ext>
+          </a:extLst>
+        </p:cNvPr>
+        <p:cNvGrpSpPr/>
+        <p:nvPr/>
+      </p:nvGrpSpPr>
+      <p:grpSpPr>
+        <a:xfrm>
+          <a:off x="0" y="0"/>
+          <a:ext cx="0" cy="0"/>
+          <a:chOff x="0" y="0"/>
+          <a:chExt cx="0" cy="0"/>
+        </a:xfrm>
+      </p:grpSpPr>
+      <p:sp>
+        <p:nvSpPr>
+          <p:cNvPr id="2" name="Slide Image Placeholder 1">
+            <a:extLst>
+              <a:ext uri="{FF2B5EF4-FFF2-40B4-BE49-F238E27FC236}">
+                <a16:creationId xmlns:a16="http://schemas.microsoft.com/office/drawing/2014/main" id="{C975FC8B-F564-04EA-26FD-6F8FBA438751}"/>
+              </a:ext>
+            </a:extLst>
+          </p:cNvPr>
+          <p:cNvSpPr>
+            <a:spLocks noGrp="1" noRot="1" noChangeAspect="1"/>
+          </p:cNvSpPr>
+          <p:nvPr>
+            <p:ph type="sldImg"/>
+          </p:nvPr>
+        </p:nvSpPr>
+        <p:spPr>
+          <a:xfrm>
+            <a:off x="2271713" y="1143000"/>
+            <a:ext cx="2314575" cy="3086100"/>
+          </a:xfrm>
+        </p:spPr>
+      </p:sp>
+      <p:sp>
+        <p:nvSpPr>
+          <p:cNvPr id="3" name="Notes Placeholder 2">
+            <a:extLst>
+              <a:ext uri="{FF2B5EF4-FFF2-40B4-BE49-F238E27FC236}">
+                <a16:creationId xmlns:a16="http://schemas.microsoft.com/office/drawing/2014/main" id="{78ACB9E4-9956-85CD-1D61-2F397B472319}"/>
+              </a:ext>
+            </a:extLst>
+          </p:cNvPr>
+          <p:cNvSpPr>
+            <a:spLocks noGrp="1"/>
+          </p:cNvSpPr>
+          <p:nvPr>
+            <p:ph type="body" idx="1"/>
+          </p:nvPr>
+        </p:nvSpPr>
+        <p:spPr/>
+        <p:txBody>
+          <a:bodyPr/>
+          <a:lstStyle/>
+          <a:p>
+            <a:r>
+              <a:rPr sz="1200"/>
+              <a:t>Poster figure inputs: results/for_manuscript/tables/publication_object_selection.csv; results/for_manuscript/tables/mass_offset_object_sensitivity.csv; results/v3/tables/v3_object_point_ranking.csv; results/v3/tables/v3_object_uncertainty_ranking.csv; results/v4/tables/v4_minimum_seed_mass.csv. Scientific inputs are pinned in data/poster_inputs.json. The uncertainty panel is generated by src.internal.poster_figures. The earlier-onset panel holds the stated average cap and radiative efficiency constant along each track. The external dynamical comparison uses the adopted arXiv v2 measurement; the required ratios and intervals are calculated by this project.</a:t>
+            </a:r>
+          </a:p>
+          <a:p>
+            <a:r>
+              <a:rPr sz="1200"/>
+              <a:t>[1] Shen (2013), The Mass of Quasars: https://arxiv.org/abs/1302.2643 — broad-line virial mass methods and calibration scatter.</a:t>
+            </a:r>
+          </a:p>
+          <a:p>
+            <a:r>
+              <a:rPr sz="1200"/>
+              <a:t>[2] Maiolino et al. (2024), A small and vigorous black hole in the early Universe: https://doi.org/10.1038/s41586-024-07052-5 — GN-z11 ultraviolet-line mass and early JWST context.</a:t>
+            </a:r>
+          </a:p>
+          <a:p>
+            <a:r>
+              <a:rPr sz="1200"/>
+              <a:t>[3] Dayal (2024), Exploring a primordial solution for early black holes detected with JWST: https://doi.org/10.1051/0004-6361/202451481 — exponential accretion growth relation. The project inverts the growth relation; its reference seed and growth-test thresholds are analysis assumptions.</a:t>
+            </a:r>
+          </a:p>
+          <a:p>
+            <a:r>
+              <a:rPr sz="1200"/>
+              <a:t>[4] Bardeen, Press &amp; Teukolsky (1972): https://doi.org/10.1086/151796 — ideal thin-disc efficiency for a non-spinning black hole, 1-sqrt(8/9).</a:t>
+            </a:r>
+          </a:p>
+          <a:p>
+            <a:r>
+              <a:rPr sz="1200"/>
+              <a:t>[5] Juodzbalis et al. (2025): https://arxiv.org/abs/2508.21748v2 — adopted independent A2744-QSO1 dynamical mass. The poster's average Eddington ratios are project calculations, not measurements quoted from this paper.</a:t>
+            </a:r>
+          </a:p>
+        </p:txBody>
+      </p:sp>
+      <p:sp>
+        <p:nvSpPr>
+          <p:cNvPr id="4" name="Slide Number Placeholder 3">
+            <a:extLst>
+              <a:ext uri="{FF2B5EF4-FFF2-40B4-BE49-F238E27FC236}">
+                <a16:creationId xmlns:a16="http://schemas.microsoft.com/office/drawing/2014/main" id="{A8B3E2F2-BDDF-9490-DE7B-11CDCE91017C}"/>
+              </a:ext>
+            </a:extLst>
+          </p:cNvPr>
+          <p:cNvSpPr>
+            <a:spLocks noGrp="1"/>
+          </p:cNvSpPr>
+          <p:nvPr>
+            <p:ph type="sldNum" sz="quarter" idx="5"/>
+          </p:nvPr>
+        </p:nvSpPr>
+        <p:spPr/>
+        <p:txBody>
+          <a:bodyPr/>
+          <a:lstStyle/>
+          <a:p>
+            <a:fld id="{490DA246-DE01-5046-81A0-D7E93C87400D}" type="slidenum">
+              <a:rPr lang="en-US" smtClean="0"/>
+              <a:t>1</a:t>
+            </a:fld>
+            <a:endParaRPr lang="en-US"/>
+          </a:p>
+        </p:txBody>
+      </p:sp>
+    </p:spTree>
+    <p:extLst>
+      <p:ext uri="{BB962C8B-B14F-4D97-AF65-F5344CB8AC3E}">
+        <p14:creationId xmlns:p14="http://schemas.microsoft.com/office/powerpoint/2010/main" val="3600152407"/>
+      </p:ext>
+    </p:extLst>
+  </p:cSld>
+  <p:clrMapOvr>
+    <a:masterClrMapping/>
+  </p:clrMapOvr>
+</p:notes>
 </file>
 
 <file path=ppt/slideLayouts/slideLayout1.xml><?xml version="1.0" encoding="utf-8"?>
@@ -5144,7 +4922,7 @@
         </p:nvSpPr>
         <p:spPr>
           <a:xfrm>
-            <a:off x="-384048" y="-168958"/>
+            <a:off x="-292608" y="-106306"/>
             <a:ext cx="33686496" cy="4842334"/>
           </a:xfrm>
           <a:solidFill>
@@ -5164,7 +4942,7 @@
           <a:p>
             <a:pPr algn="ctr"/>
             <a:br>
-              <a:rPr lang="en-US" sz="4200" b="0" dirty="0">
+              <a:rPr lang="en-US" sz="6000" b="0" dirty="0">
                 <a:solidFill>
                   <a:schemeClr val="bg1"/>
                 </a:solidFill>
@@ -5173,7 +4951,7 @@
               </a:rPr>
             </a:br>
             <a:r>
-              <a:rPr lang="en-US" sz="6800" b="1" dirty="0">
+              <a:rPr lang="en-US" sz="6000" b="1" dirty="0">
                 <a:solidFill>
                   <a:schemeClr val="bg1"/>
                 </a:solidFill>
@@ -5184,7 +4962,7 @@
 Constraints from JWST</a:t>
             </a:r>
             <a:br>
-              <a:rPr lang="en-US" sz="6800" b="0" dirty="0">
+              <a:rPr lang="en-US" sz="6000" b="0" dirty="0">
                 <a:solidFill>
                   <a:schemeClr val="bg1"/>
                 </a:solidFill>
@@ -5193,7 +4971,7 @@
               </a:rPr>
             </a:br>
             <a:r>
-              <a:rPr lang="en-US" sz="6800" b="0" dirty="0">
+              <a:rPr lang="en-US" sz="6000" b="0" dirty="0">
                 <a:solidFill>
                   <a:schemeClr val="bg1"/>
                 </a:solidFill>
@@ -5203,7 +4981,7 @@
               <a:t>Nicole Jiang; University of Toronto</a:t>
             </a:r>
             <a:br>
-              <a:rPr lang="en-US" sz="4200" b="0" dirty="0">
+              <a:rPr lang="en-US" sz="6000" b="0" dirty="0">
                 <a:solidFill>
                   <a:schemeClr val="bg1"/>
                 </a:solidFill>
@@ -5211,7 +4989,7 @@
                 <a:cs typeface="Arial" panose="020B0604020202020204" pitchFamily="34" charset="0"/>
               </a:rPr>
             </a:br>
-            <a:endParaRPr lang="en-US" sz="6800" b="0" dirty="0">
+            <a:endParaRPr lang="en-US" sz="6000" b="0" dirty="0">
               <a:solidFill>
                 <a:schemeClr val="bg1"/>
               </a:solidFill>
@@ -5422,13 +5200,13 @@
               <a:rPr lang="en-CA" sz="2200" b="0" baseline="30000">
                 <a:latin typeface="Aptos"/>
               </a:rPr>
-              <a:t>[2]</a:t>
+              <a:t>[1]</a:t>
             </a:r>
             <a:r>
               <a:rPr lang="en-CA" sz="3300" b="0">
                 <a:latin typeface="Aptos"/>
               </a:rPr>
-              <a:t> I compiled published mass estimates and calculated the average accretion needed to reach each mass under different seed masses (initial masses), start times, and radiative efficiencies.</a:t>
+              <a:t> I compiled a catalogue of published black-hole mass estimates and compared their growth requirements, testing sensitivity to mass errors, seed mass, growth onset, and radiative efficiency.</a:t>
             </a:r>
           </a:p>
         </p:txBody>
@@ -5645,7 +5423,7 @@
               <a:t> = luminosity/Eddington luminosity, where radiation force balances gravity. Averages above 1 require super-Eddington episodes.</a:t>
             </a:r>
             <a:r>
-              <a:rPr lang="en-CA" sz="2200" b="0" dirty="0" baseline="30000">
+              <a:rPr lang="en-CA" sz="2200" b="0" baseline="30000" dirty="0">
                 <a:latin typeface="Aptos"/>
               </a:rPr>
               <a:t>[3]</a:t>
@@ -5782,8 +5560,8 @@
         </p:nvSpPr>
         <p:spPr>
           <a:xfrm>
-            <a:off x="16916402" y="37375311"/>
-            <a:ext cx="14996160" cy="5478423"/>
+            <a:off x="17099280" y="37166215"/>
+            <a:ext cx="14538960" cy="6017032"/>
           </a:xfrm>
           <a:prstGeom prst="rect">
             <a:avLst/>
@@ -5796,134 +5574,173 @@
           </a:bodyPr>
           <a:lstStyle/>
           <a:p>
-            <a:pPr marL="285750" indent="-228600">
+            <a:pPr marL="457200" lvl="0" indent="-457200">
               <a:spcAft>
                 <a:spcPts val="800"/>
               </a:spcAft>
+              <a:buFont typeface="Arial" panose="020B0604020202020204" pitchFamily="34" charset="0"/>
               <a:buChar char="•"/>
             </a:pPr>
             <a:r>
               <a:rPr lang="en-CA" sz="3300" b="1" dirty="0">
-                <a:solidFill>
-                  <a:srgbClr val="000000"/>
-                </a:solidFill>
-                <a:latin typeface="Aptos"/>
-              </a:rPr>
-              <a:t>Seed masses: </a:t>
-            </a:r>
-            <a:r>
-              <a:rPr lang="en-CA" sz="3300" b="0" dirty="0">
-                <a:solidFill>
-                  <a:srgbClr val="000000"/>
-                </a:solidFill>
-                <a:latin typeface="Aptos"/>
-              </a:rPr>
-              <a:t>Most adopted masses allow growth from 100 M⊙ seeds under the reference assumptions.</a:t>
-            </a:r>
-          </a:p>
-          <a:p>
-            <a:pPr marL="285750" indent="-228600">
+                <a:latin typeface="Aptos" panose="020B0004020202020204" pitchFamily="34" charset="0"/>
+              </a:rPr>
+              <a:t>Catalogue:</a:t>
+            </a:r>
+            <a:r>
+              <a:rPr lang="en-CA" sz="3300" dirty="0">
+                <a:latin typeface="Aptos" panose="020B0004020202020204" pitchFamily="34" charset="0"/>
+              </a:rPr>
+              <a:t> The reproducible catalogue identifies the strongest targets for growth tests by comparing published masses under the same assumptions.</a:t>
+            </a:r>
+          </a:p>
+          <a:p>
+            <a:pPr marL="457200" lvl="0" indent="-457200">
               <a:spcAft>
                 <a:spcPts val="800"/>
               </a:spcAft>
+              <a:buFont typeface="Arial" panose="020B0604020202020204" pitchFamily="34" charset="0"/>
               <a:buChar char="•"/>
             </a:pPr>
-            <a:r>
-              <a:rPr lang="en-CA" sz="3300" b="1" dirty="0">
-                <a:solidFill>
-                  <a:srgbClr val="000000"/>
-                </a:solidFill>
-                <a:latin typeface="Aptos"/>
-              </a:rPr>
-              <a:t>Accretion physics: </a:t>
-            </a:r>
-            <a:r>
-              <a:rPr lang="en-CA" sz="3300" b="0" dirty="0">
-                <a:solidFill>
-                  <a:srgbClr val="000000"/>
-                </a:solidFill>
-                <a:latin typeface="Aptos"/>
-              </a:rPr>
-              <a:t>Lower radiative efficiency leaves more accreted mass in the black hole, allowing faster growth at the same Eddington ratio.</a:t>
-            </a:r>
-            <a:r>
-              <a:rPr lang="en-CA" sz="2200" b="0" dirty="0" baseline="30000">
-                <a:solidFill>
-                  <a:srgbClr val="000000"/>
-                </a:solidFill>
-                <a:latin typeface="Aptos"/>
-              </a:rPr>
-              <a:t>[3]</a:t>
-            </a:r>
-          </a:p>
-          <a:p>
-            <a:pPr marL="285750" indent="-228600">
+            <a:endParaRPr lang="en-CA" sz="500" dirty="0">
+              <a:latin typeface="Aptos" panose="020B0004020202020204" pitchFamily="34" charset="0"/>
+            </a:endParaRPr>
+          </a:p>
+          <a:p>
+            <a:pPr marL="457200" lvl="0" indent="-457200">
               <a:spcAft>
                 <a:spcPts val="800"/>
               </a:spcAft>
+              <a:buFont typeface="Arial" panose="020B0604020202020204" pitchFamily="34" charset="0"/>
               <a:buChar char="•"/>
             </a:pPr>
             <a:r>
               <a:rPr lang="en-CA" sz="3300" b="1" dirty="0">
-                <a:solidFill>
-                  <a:srgbClr val="000000"/>
-                </a:solidFill>
-                <a:latin typeface="Aptos"/>
-              </a:rPr>
-              <a:t>Earlier growth: </a:t>
-            </a:r>
-            <a:r>
-              <a:rPr lang="en-CA" sz="3300" b="0" dirty="0">
-                <a:solidFill>
-                  <a:srgbClr val="000000"/>
-                </a:solidFill>
-                <a:latin typeface="Aptos"/>
-              </a:rPr>
-              <a:t>Even the earliest tested start leaves 100 M⊙ seeds insufficient for the 4 targets at </a:t>
-            </a:r>
-            <a:r>
-              <a:rPr lang="en-CA" sz="3300" b="0" dirty="0" err="1">
-                <a:solidFill>
-                  <a:srgbClr val="000000"/>
-                </a:solidFill>
-                <a:latin typeface="Aptos"/>
-              </a:rPr>
-              <a:t>ε</a:t>
-            </a:r>
-            <a:r>
-              <a:rPr lang="en-CA" sz="3300" b="0" dirty="0">
-                <a:solidFill>
-                  <a:srgbClr val="000000"/>
-                </a:solidFill>
-                <a:latin typeface="Aptos"/>
-              </a:rPr>
-              <a:t> = 0.1 and average ratio ≤ 1. Larger seeds or super-Eddington episodes remain possible.</a:t>
-            </a:r>
-          </a:p>
-          <a:p>
-            <a:pPr marL="285750" indent="-228600">
+                <a:latin typeface="Aptos" panose="020B0004020202020204" pitchFamily="34" charset="0"/>
+              </a:rPr>
+              <a:t>Growth physics:</a:t>
+            </a:r>
+            <a:r>
+              <a:rPr lang="en-CA" sz="3300" dirty="0">
+                <a:latin typeface="Aptos" panose="020B0004020202020204" pitchFamily="34" charset="0"/>
+              </a:rPr>
+              <a:t> The efficiency test shows that difficulty growing from small seeds does not imply a need for heavier seeds or super-Eddington accretion.</a:t>
+            </a:r>
+          </a:p>
+          <a:p>
+            <a:pPr marL="457200" lvl="0" indent="-457200">
               <a:spcAft>
                 <a:spcPts val="800"/>
               </a:spcAft>
+              <a:buFont typeface="Arial" panose="020B0604020202020204" pitchFamily="34" charset="0"/>
               <a:buChar char="•"/>
             </a:pPr>
+            <a:endParaRPr lang="en-CA" sz="500" dirty="0">
+              <a:latin typeface="Aptos" panose="020B0004020202020204" pitchFamily="34" charset="0"/>
+            </a:endParaRPr>
+          </a:p>
+          <a:p>
+            <a:pPr marL="457200" lvl="0" indent="-457200">
+              <a:spcAft>
+                <a:spcPts val="800"/>
+              </a:spcAft>
+              <a:buFont typeface="Arial" panose="020B0604020202020204" pitchFamily="34" charset="0"/>
+              <a:buChar char="•"/>
+            </a:pPr>
             <a:r>
               <a:rPr lang="en-CA" sz="3300" b="1" dirty="0">
                 <a:solidFill>
                   <a:srgbClr val="000000"/>
                 </a:solidFill>
-                <a:latin typeface="Aptos"/>
-              </a:rPr>
-              <a:t>Further observations: </a:t>
-            </a:r>
-            <a:r>
-              <a:rPr lang="en-CA" sz="3300" b="0" dirty="0">
+              </a:rPr>
+              <a:t>Earlier growth: </a:t>
+            </a:r>
+            <a:r>
+              <a:rPr lang="en-CA" sz="3300" dirty="0">
                 <a:solidFill>
                   <a:srgbClr val="000000"/>
                 </a:solidFill>
-                <a:latin typeface="Aptos"/>
-              </a:rPr>
-              <a:t>Independent mass measurements could change which objects require averages above 1. Counts from different surveys cannot establish how common these black holes are.</a:t>
+              </a:rPr>
+              <a:t>Earlier onset alone cannot explain the four target masses from 100 M⊙ seeds at </a:t>
+            </a:r>
+            <a:r>
+              <a:rPr lang="en-CA" sz="3300" dirty="0" err="1">
+                <a:solidFill>
+                  <a:srgbClr val="000000"/>
+                </a:solidFill>
+              </a:rPr>
+              <a:t>ε</a:t>
+            </a:r>
+            <a:r>
+              <a:rPr lang="en-CA" sz="3300" dirty="0">
+                <a:solidFill>
+                  <a:srgbClr val="000000"/>
+                </a:solidFill>
+              </a:rPr>
+              <a:t> = 0.1 and average ratio ≤ 1, without mergers.</a:t>
+            </a:r>
+          </a:p>
+          <a:p>
+            <a:pPr marL="457200" lvl="0" indent="-457200">
+              <a:spcAft>
+                <a:spcPts val="800"/>
+              </a:spcAft>
+              <a:buFont typeface="Arial" panose="020B0604020202020204" pitchFamily="34" charset="0"/>
+              <a:buChar char="•"/>
+            </a:pPr>
+            <a:endParaRPr lang="en-CA" sz="500" dirty="0">
+              <a:solidFill>
+                <a:srgbClr val="000000"/>
+              </a:solidFill>
+            </a:endParaRPr>
+          </a:p>
+          <a:p>
+            <a:pPr marL="457200" indent="-457200">
+              <a:spcAft>
+                <a:spcPts val="800"/>
+              </a:spcAft>
+              <a:buFont typeface="Arial" panose="020B0604020202020204" pitchFamily="34" charset="0"/>
+              <a:buChar char="•"/>
+            </a:pPr>
+            <a:r>
+              <a:rPr lang="en-CA" sz="3300" b="1" dirty="0">
+                <a:solidFill>
+                  <a:srgbClr val="000000"/>
+                </a:solidFill>
+              </a:rPr>
+              <a:t>Future observations: </a:t>
+            </a:r>
+            <a:r>
+              <a:rPr lang="en-CA" sz="3300" dirty="0">
+                <a:solidFill>
+                  <a:srgbClr val="000000"/>
+                </a:solidFill>
+              </a:rPr>
+              <a:t>The independent </a:t>
+            </a:r>
+            <a:r>
+              <a:rPr lang="en-CA" sz="3300" dirty="0">
+                <a:solidFill>
+                  <a:srgbClr val="000000"/>
+                </a:solidFill>
+                <a:latin typeface="Aptos" panose="020B0004020202020204" pitchFamily="34" charset="0"/>
+              </a:rPr>
+              <a:t>mass check shows that the inferred growth difficulty depends on the mass estimate. </a:t>
+            </a:r>
+            <a:r>
+              <a:rPr lang="en-CA" sz="3300" dirty="0">
+                <a:latin typeface="Aptos" panose="020B0004020202020204" pitchFamily="34" charset="0"/>
+              </a:rPr>
+              <a:t>Independent masses and checks on lensing and line broadening would test whether the strongest outliers </a:t>
+            </a:r>
+            <a:r>
+              <a:rPr lang="en-CA" sz="3300" dirty="0">
+                <a:solidFill>
+                  <a:srgbClr val="000000"/>
+                </a:solidFill>
+                <a:latin typeface="Aptos" panose="020B0004020202020204" pitchFamily="34" charset="0"/>
+              </a:rPr>
+              <a:t>truly challenge the reference growth model.</a:t>
             </a:r>
           </a:p>
         </p:txBody>
@@ -6057,8 +5874,8 @@
         </p:nvSpPr>
         <p:spPr>
           <a:xfrm>
-            <a:off x="1463040" y="39259762"/>
-            <a:ext cx="13898880" cy="3395801"/>
+            <a:off x="1748025" y="39376529"/>
+            <a:ext cx="13054590" cy="3395801"/>
           </a:xfrm>
           <a:prstGeom prst="rect">
             <a:avLst/>
@@ -6078,22 +5895,14 @@
             </a:pPr>
             <a:r>
               <a:rPr lang="en-CA" sz="3300" dirty="0"/>
-              <a:t>[1] Shen (2013), BASI, 41, 61.</a:t>
+              <a:t>[1] Maiolino et al. (2024), Nature, 627, 59.</a:t>
             </a:r>
             <a:endParaRPr lang="en-US" sz="3300" dirty="0"/>
           </a:p>
           <a:p>
             <a:r>
               <a:rPr lang="en-CA" sz="3300" dirty="0"/>
-              <a:t>[2] </a:t>
-            </a:r>
-            <a:r>
-              <a:rPr lang="en-CA" sz="3300" dirty="0" err="1"/>
-              <a:t>Maiolino</a:t>
-            </a:r>
-            <a:r>
-              <a:rPr lang="en-CA" sz="3300" dirty="0"/>
-              <a:t> et al. (2024), Nature, 627, 59.</a:t>
+              <a:t>[2] Shen (2013), BASI, 41, 61.</a:t>
             </a:r>
           </a:p>
           <a:p>
@@ -6576,7 +6385,7 @@
               <a:t> = 0.05719 (non-spinning thin disc) </a:t>
             </a:r>
             <a:r>
-              <a:rPr lang="en-CA" sz="2200" b="0" dirty="0" baseline="30000">
+              <a:rPr lang="en-CA" sz="2200" b="0" baseline="30000" dirty="0">
                 <a:solidFill>
                   <a:srgbClr val="000000"/>
                 </a:solidFill>
@@ -6818,7 +6627,7 @@
               <a:t> M⊙)</a:t>
             </a:r>
             <a:r>
-              <a:rPr lang="en-CA" sz="2200" b="0" dirty="0" baseline="30000">
+              <a:rPr lang="en-CA" sz="2200" b="0" baseline="30000" dirty="0">
                 <a:latin typeface="Aptos"/>
               </a:rPr>
               <a:t>[5]</a:t>
@@ -7313,13 +7122,13 @@
               <a:t> </a:t>
             </a:r>
             <a:r>
-              <a:rPr lang="en-CA" sz="2000" b="0" dirty="0" baseline="30000">
+              <a:rPr lang="en-CA" sz="2000" b="0" baseline="30000" dirty="0">
                 <a:solidFill>
                   <a:srgbClr val="111111"/>
                 </a:solidFill>
                 <a:latin typeface="Aptos"/>
               </a:rPr>
-              <a:t>[1]</a:t>
+              <a:t>[2]</a:t>
             </a:r>
             <a:endParaRPr sz="3000" b="1" dirty="0">
               <a:solidFill>
@@ -7389,6 +7198,48 @@
               </a:rPr>
               <a:t>14 additional</a:t>
             </a:r>
+            <a:r>
+              <a:rPr lang="en-CA" sz="2700" b="0" dirty="0">
+                <a:solidFill>
+                  <a:srgbClr val="111111"/>
+                </a:solidFill>
+                <a:latin typeface="Aptos"/>
+              </a:rPr>
+              <a:t>:</a:t>
+            </a:r>
+            <a:endParaRPr sz="2700" b="0" dirty="0">
+              <a:solidFill>
+                <a:srgbClr val="111111"/>
+              </a:solidFill>
+              <a:latin typeface="Aptos"/>
+            </a:endParaRPr>
+          </a:p>
+          <a:p>
+            <a:pPr marL="457200" indent="-457200" algn="ctr">
+              <a:buFont typeface="Arial" panose="020B0604020202020204" pitchFamily="34" charset="0"/>
+              <a:buChar char="•"/>
+              <a:defRPr sz="2700" b="0">
+                <a:solidFill>
+                  <a:srgbClr val="111111"/>
+                </a:solidFill>
+                <a:latin typeface="Aptos"/>
+              </a:defRPr>
+            </a:pPr>
+            <a:r>
+              <a:rPr sz="2700" b="0" dirty="0">
+                <a:solidFill>
+                  <a:srgbClr val="111111"/>
+                </a:solidFill>
+                <a:latin typeface="Aptos"/>
+              </a:rPr>
+              <a:t>7 masses with uncertain line origins, </a:t>
+            </a:r>
+            <a:endParaRPr lang="en-CA" sz="2700" b="0" dirty="0">
+              <a:solidFill>
+                <a:srgbClr val="111111"/>
+              </a:solidFill>
+              <a:latin typeface="Aptos"/>
+            </a:endParaRPr>
           </a:p>
           <a:p>
             <a:pPr algn="ctr">
@@ -7406,11 +7257,19 @@
                 </a:solidFill>
                 <a:latin typeface="Aptos"/>
               </a:rPr>
-              <a:t>7 masses with uncertain line origins, assuming gas orbiting the black hole</a:t>
-            </a:r>
-          </a:p>
-          <a:p>
-            <a:pPr algn="ctr">
+              <a:t>assuming gas orbiting the black hole</a:t>
+            </a:r>
+            <a:endParaRPr lang="en-CA" sz="2700" b="0" dirty="0">
+              <a:solidFill>
+                <a:srgbClr val="111111"/>
+              </a:solidFill>
+              <a:latin typeface="Aptos"/>
+            </a:endParaRPr>
+          </a:p>
+          <a:p>
+            <a:pPr marL="457200" indent="-457200" algn="ctr">
+              <a:buFont typeface="Arial" panose="020B0604020202020204" pitchFamily="34" charset="0"/>
+              <a:buChar char="•"/>
               <a:defRPr sz="2700" b="0">
                 <a:solidFill>
                   <a:srgbClr val="111111"/>
@@ -7419,6 +7278,15 @@
               </a:defRPr>
             </a:pPr>
             <a:r>
+              <a:rPr lang="en-CA" sz="2700" b="0" dirty="0">
+                <a:solidFill>
+                  <a:srgbClr val="111111"/>
+                </a:solidFill>
+                <a:latin typeface="Aptos"/>
+              </a:rPr>
+              <a:t> </a:t>
+            </a:r>
+            <a:r>
               <a:rPr sz="2700" b="0" dirty="0">
                 <a:solidFill>
                   <a:srgbClr val="111111"/>
@@ -7427,9 +7295,17 @@
               </a:rPr>
               <a:t>6 tentative broad-line detections</a:t>
             </a:r>
-          </a:p>
-          <a:p>
-            <a:pPr algn="ctr">
+            <a:endParaRPr lang="en-CA" sz="2700" b="0" dirty="0">
+              <a:solidFill>
+                <a:srgbClr val="111111"/>
+              </a:solidFill>
+              <a:latin typeface="Aptos"/>
+            </a:endParaRPr>
+          </a:p>
+          <a:p>
+            <a:pPr marL="457200" indent="-457200" algn="ctr">
+              <a:buFont typeface="Arial" panose="020B0604020202020204" pitchFamily="34" charset="0"/>
+              <a:buChar char="•"/>
               <a:defRPr sz="2700" b="0">
                 <a:solidFill>
                   <a:srgbClr val="111111"/>
@@ -7447,13 +7323,13 @@
               <a:t>GN-z11: ultraviolet-line mass </a:t>
             </a:r>
             <a:r>
-              <a:rPr sz="1800" b="0" dirty="0" baseline="30000">
+              <a:rPr sz="1800" b="0" baseline="30000" dirty="0">
                 <a:solidFill>
                   <a:srgbClr val="111111"/>
                 </a:solidFill>
                 <a:latin typeface="Aptos"/>
               </a:rPr>
-              <a:t>[2]</a:t>
+              <a:t>[1]</a:t>
             </a:r>
           </a:p>
         </p:txBody>
@@ -7538,8 +7414,15 @@
               </a:rPr>
               <a:t>growth sample</a:t>
             </a:r>
-          </a:p>
-          <a:p>
+            <a:r>
+              <a:rPr lang="en-CA" sz="2900" dirty="0">
+                <a:solidFill>
+                  <a:srgbClr val="111111"/>
+                </a:solidFill>
+                <a:latin typeface="Aptos"/>
+              </a:rPr>
+              <a:t>:</a:t>
+            </a:r>
             <a:endParaRPr sz="2900" b="0" dirty="0">
               <a:solidFill>
                 <a:srgbClr val="111111"/>
@@ -7548,44 +7431,6 @@
             </a:endParaRPr>
           </a:p>
           <a:p>
-            <a:pPr algn="ctr">
-              <a:defRPr sz="2900" b="0">
-                <a:solidFill>
-                  <a:srgbClr val="111111"/>
-                </a:solidFill>
-                <a:latin typeface="Aptos"/>
-              </a:defRPr>
-            </a:pPr>
-            <a:r>
-              <a:rPr sz="2900" b="0" dirty="0">
-                <a:solidFill>
-                  <a:srgbClr val="111111"/>
-                </a:solidFill>
-                <a:latin typeface="Aptos"/>
-              </a:rPr>
-              <a:t>98 without an</a:t>
-            </a:r>
-          </a:p>
-          <a:p>
-            <a:pPr algn="ctr">
-              <a:defRPr sz="2900" b="0">
-                <a:solidFill>
-                  <a:srgbClr val="111111"/>
-                </a:solidFill>
-                <a:latin typeface="Aptos"/>
-              </a:defRPr>
-            </a:pPr>
-            <a:r>
-              <a:rPr sz="2900" b="0" dirty="0">
-                <a:solidFill>
-                  <a:srgbClr val="111111"/>
-                </a:solidFill>
-                <a:latin typeface="Aptos"/>
-              </a:rPr>
-              <a:t>eligible mass</a:t>
-            </a:r>
-          </a:p>
-          <a:p>
             <a:endParaRPr sz="2900" b="0" dirty="0">
               <a:solidFill>
                 <a:srgbClr val="111111"/>
@@ -7594,7 +7439,71 @@
             </a:endParaRPr>
           </a:p>
           <a:p>
+            <a:pPr marL="457200" indent="-457200" algn="ctr">
+              <a:buFont typeface="Arial" panose="020B0604020202020204" pitchFamily="34" charset="0"/>
+              <a:buChar char="•"/>
+              <a:defRPr sz="2900" b="0">
+                <a:solidFill>
+                  <a:srgbClr val="111111"/>
+                </a:solidFill>
+                <a:latin typeface="Aptos"/>
+              </a:defRPr>
+            </a:pPr>
+            <a:r>
+              <a:rPr sz="2900" b="0" dirty="0">
+                <a:solidFill>
+                  <a:srgbClr val="111111"/>
+                </a:solidFill>
+                <a:latin typeface="Aptos"/>
+              </a:rPr>
+              <a:t>98 without an</a:t>
+            </a:r>
+          </a:p>
+          <a:p>
             <a:pPr algn="ctr">
+              <a:defRPr sz="2900" b="0">
+                <a:solidFill>
+                  <a:srgbClr val="111111"/>
+                </a:solidFill>
+                <a:latin typeface="Aptos"/>
+              </a:defRPr>
+            </a:pPr>
+            <a:r>
+              <a:rPr sz="2900" b="0" dirty="0">
+                <a:solidFill>
+                  <a:srgbClr val="111111"/>
+                </a:solidFill>
+                <a:latin typeface="Aptos"/>
+              </a:rPr>
+              <a:t>eligible mass</a:t>
+            </a:r>
+            <a:endParaRPr lang="en-CA" sz="2900" dirty="0">
+              <a:solidFill>
+                <a:srgbClr val="111111"/>
+              </a:solidFill>
+              <a:latin typeface="Aptos"/>
+            </a:endParaRPr>
+          </a:p>
+          <a:p>
+            <a:pPr algn="ctr">
+              <a:defRPr sz="2900" b="0">
+                <a:solidFill>
+                  <a:srgbClr val="111111"/>
+                </a:solidFill>
+                <a:latin typeface="Aptos"/>
+              </a:defRPr>
+            </a:pPr>
+            <a:endParaRPr lang="en-CA" sz="2900" b="0" dirty="0">
+              <a:solidFill>
+                <a:srgbClr val="111111"/>
+              </a:solidFill>
+              <a:latin typeface="Aptos"/>
+            </a:endParaRPr>
+          </a:p>
+          <a:p>
+            <a:pPr marL="457200" indent="-457200" algn="ctr">
+              <a:buFont typeface="Arial" panose="020B0604020202020204" pitchFamily="34" charset="0"/>
+              <a:buChar char="•"/>
               <a:defRPr sz="2900" b="0">
                 <a:solidFill>
                   <a:srgbClr val="111111"/>
@@ -8337,6 +8246,21 @@
               </a:rPr>
               <a:t>Ranked central estimates</a:t>
             </a:r>
+            <a:r>
+              <a:rPr lang="en-CA" sz="2900" b="0">
+                <a:solidFill>
+                  <a:srgbClr val="111111"/>
+                </a:solidFill>
+                <a:latin typeface="Aptos"/>
+              </a:rPr>
+              <a:t>;</a:t>
+            </a:r>
+            <a:endParaRPr sz="2900" b="0" dirty="0">
+              <a:solidFill>
+                <a:srgbClr val="111111"/>
+              </a:solidFill>
+              <a:latin typeface="Aptos"/>
+            </a:endParaRPr>
           </a:p>
           <a:p>
             <a:pPr algn="ctr">
@@ -8495,16 +8419,7 @@
                 </a:solidFill>
                 <a:latin typeface="Aptos"/>
               </a:rPr>
-              <a:t>208 primary / 222 expanded objects. The other 12 enter central-mass tests only. Reported errors may omit calibration scatter.</a:t>
-            </a:r>
-            <a:r>
-              <a:rPr lang="en-CA" sz="2200" b="0" dirty="0" baseline="30000">
-                <a:solidFill>
-                  <a:srgbClr val="000000"/>
-                </a:solidFill>
-                <a:latin typeface="Aptos"/>
-              </a:rPr>
-              <a:t>[1]</a:t>
+              <a:t>Mass errors cover 208 primary / 222 expanded objects. The other 12 enter central-mass tests only. Reported mass errors do not consistently include calibration uncertainty.</a:t>
             </a:r>
           </a:p>
         </p:txBody>
@@ -8583,7 +8498,7 @@
         </p:nvSpPr>
         <p:spPr>
           <a:xfrm>
-            <a:off x="1645920" y="11771027"/>
+            <a:off x="1371600" y="11668069"/>
             <a:ext cx="14356080" cy="640080"/>
           </a:xfrm>
           <a:prstGeom prst="rect">

</xml_diff>

<commit_message>
Update poster margins and link reviewed exports from README
</commit_message>
<xml_diff>
--- a/posters/36x48.pptx
+++ b/posters/36x48.pptx
@@ -129,7 +129,7 @@
   <pc:docChgLst>
     <pc:chgData name="Nicole Jiang" userId="09ef0fc0f6f473b5" providerId="LiveId" clId="{EB8F4A53-0964-5BF1-90AD-931457E28E1A}"/>
     <pc:docChg chg="undo redo custSel addSld delSld modSld">
-      <pc:chgData name="Nicole Jiang" userId="09ef0fc0f6f473b5" providerId="LiveId" clId="{EB8F4A53-0964-5BF1-90AD-931457E28E1A}" dt="2026-10-15T05:12:53.627" v="3358" actId="14100"/>
+      <pc:chgData name="Nicole Jiang" userId="09ef0fc0f6f473b5" providerId="LiveId" clId="{EB8F4A53-0964-5BF1-90AD-931457E28E1A}" dt="2026-10-15T19:28:14.983" v="3361" actId="14100"/>
       <pc:docMkLst>
         <pc:docMk/>
       </pc:docMkLst>
@@ -213,7 +213,7 @@
         </pc:picChg>
       </pc:sldChg>
       <pc:sldChg chg="addSp delSp modSp mod">
-        <pc:chgData name="Nicole Jiang" userId="09ef0fc0f6f473b5" providerId="LiveId" clId="{EB8F4A53-0964-5BF1-90AD-931457E28E1A}" dt="2026-10-15T05:12:53.627" v="3358" actId="14100"/>
+        <pc:chgData name="Nicole Jiang" userId="09ef0fc0f6f473b5" providerId="LiveId" clId="{EB8F4A53-0964-5BF1-90AD-931457E28E1A}" dt="2026-10-15T19:28:14.983" v="3361" actId="14100"/>
         <pc:sldMkLst>
           <pc:docMk/>
           <pc:sldMk cId="868487171" sldId="261"/>
@@ -235,11 +235,27 @@
           </ac:spMkLst>
         </pc:spChg>
         <pc:spChg chg="mod">
-          <ac:chgData name="Nicole Jiang" userId="09ef0fc0f6f473b5" providerId="LiveId" clId="{EB8F4A53-0964-5BF1-90AD-931457E28E1A}" dt="2026-10-14T19:37:10.349" v="2776" actId="14100"/>
+          <ac:chgData name="Nicole Jiang" userId="09ef0fc0f6f473b5" providerId="LiveId" clId="{EB8F4A53-0964-5BF1-90AD-931457E28E1A}" dt="2026-10-15T19:28:07.346" v="3360" actId="14100"/>
+          <ac:spMkLst>
+            <pc:docMk/>
+            <pc:sldMk cId="868487171" sldId="261"/>
+            <ac:spMk id="7" creationId="{3AC78928-AF13-E1B9-F802-F1FD39D07D33}"/>
+          </ac:spMkLst>
+        </pc:spChg>
+        <pc:spChg chg="mod">
+          <ac:chgData name="Nicole Jiang" userId="09ef0fc0f6f473b5" providerId="LiveId" clId="{EB8F4A53-0964-5BF1-90AD-931457E28E1A}" dt="2026-10-15T19:28:14.983" v="3361" actId="14100"/>
           <ac:spMkLst>
             <pc:docMk/>
             <pc:sldMk cId="868487171" sldId="261"/>
             <ac:spMk id="11" creationId="{AF7EDC07-606F-DD66-5973-0AE0D673B23B}"/>
+          </ac:spMkLst>
+        </pc:spChg>
+        <pc:spChg chg="mod">
+          <ac:chgData name="Nicole Jiang" userId="09ef0fc0f6f473b5" providerId="LiveId" clId="{EB8F4A53-0964-5BF1-90AD-931457E28E1A}" dt="2026-10-15T19:27:48.134" v="3359" actId="1076"/>
+          <ac:spMkLst>
+            <pc:docMk/>
+            <pc:sldMk cId="868487171" sldId="261"/>
+            <ac:spMk id="15" creationId="{B71483CE-2A7E-6438-7E3B-E605C17C7099}"/>
           </ac:spMkLst>
         </pc:spChg>
         <pc:spChg chg="mod">
@@ -259,6 +275,14 @@
           </ac:spMkLst>
         </pc:spChg>
         <pc:spChg chg="mod">
+          <ac:chgData name="Nicole Jiang" userId="09ef0fc0f6f473b5" providerId="LiveId" clId="{EB8F4A53-0964-5BF1-90AD-931457E28E1A}" dt="2026-10-15T19:27:48.134" v="3359" actId="1076"/>
+          <ac:spMkLst>
+            <pc:docMk/>
+            <pc:sldMk cId="868487171" sldId="261"/>
+            <ac:spMk id="73" creationId="{88C51BF9-B81A-ECF4-F01D-305CA1CE9DD1}"/>
+          </ac:spMkLst>
+        </pc:spChg>
+        <pc:spChg chg="mod">
           <ac:chgData name="Nicole Jiang" userId="09ef0fc0f6f473b5" providerId="LiveId" clId="{EB8F4A53-0964-5BF1-90AD-931457E28E1A}" dt="2026-10-14T19:47:28.525" v="2819" actId="14100"/>
           <ac:spMkLst>
             <pc:docMk/>
@@ -267,7 +291,7 @@
           </ac:spMkLst>
         </pc:spChg>
         <pc:spChg chg="mod">
-          <ac:chgData name="Nicole Jiang" userId="09ef0fc0f6f473b5" providerId="LiveId" clId="{EB8F4A53-0964-5BF1-90AD-931457E28E1A}" dt="2026-10-14T19:45:57.461" v="2814" actId="1076"/>
+          <ac:chgData name="Nicole Jiang" userId="09ef0fc0f6f473b5" providerId="LiveId" clId="{EB8F4A53-0964-5BF1-90AD-931457E28E1A}" dt="2026-10-15T19:27:48.134" v="3359" actId="1076"/>
           <ac:spMkLst>
             <pc:docMk/>
             <pc:sldMk cId="868487171" sldId="261"/>
@@ -291,7 +315,7 @@
           </ac:spMkLst>
         </pc:spChg>
         <pc:spChg chg="mod">
-          <ac:chgData name="Nicole Jiang" userId="09ef0fc0f6f473b5" providerId="LiveId" clId="{EB8F4A53-0964-5BF1-90AD-931457E28E1A}" dt="2026-10-14T19:37:07.538" v="2775" actId="14100"/>
+          <ac:chgData name="Nicole Jiang" userId="09ef0fc0f6f473b5" providerId="LiveId" clId="{EB8F4A53-0964-5BF1-90AD-931457E28E1A}" dt="2026-10-15T19:27:48.134" v="3359" actId="1076"/>
           <ac:spMkLst>
             <pc:docMk/>
             <pc:sldMk cId="868487171" sldId="261"/>
@@ -315,7 +339,7 @@
           </ac:spMkLst>
         </pc:spChg>
         <pc:spChg chg="mod">
-          <ac:chgData name="Nicole Jiang" userId="09ef0fc0f6f473b5" providerId="LiveId" clId="{EB8F4A53-0964-5BF1-90AD-931457E28E1A}" dt="2026-10-14T19:34:13.753" v="2720" actId="14100"/>
+          <ac:chgData name="Nicole Jiang" userId="09ef0fc0f6f473b5" providerId="LiveId" clId="{EB8F4A53-0964-5BF1-90AD-931457E28E1A}" dt="2026-10-15T19:27:48.134" v="3359" actId="1076"/>
           <ac:spMkLst>
             <pc:docMk/>
             <pc:sldMk cId="868487171" sldId="261"/>
@@ -339,7 +363,7 @@
           </ac:spMkLst>
         </pc:spChg>
         <pc:spChg chg="mod">
-          <ac:chgData name="Nicole Jiang" userId="09ef0fc0f6f473b5" providerId="LiveId" clId="{EB8F4A53-0964-5BF1-90AD-931457E28E1A}" dt="2026-10-14T19:48:25.703" v="2821" actId="1076"/>
+          <ac:chgData name="Nicole Jiang" userId="09ef0fc0f6f473b5" providerId="LiveId" clId="{EB8F4A53-0964-5BF1-90AD-931457E28E1A}" dt="2026-10-15T19:27:48.134" v="3359" actId="1076"/>
           <ac:spMkLst>
             <pc:docMk/>
             <pc:sldMk cId="868487171" sldId="261"/>
@@ -427,7 +451,7 @@
           </ac:spMkLst>
         </pc:spChg>
         <pc:spChg chg="mod">
-          <ac:chgData name="Nicole Jiang" userId="09ef0fc0f6f473b5" providerId="LiveId" clId="{EB8F4A53-0964-5BF1-90AD-931457E28E1A}" dt="2026-10-14T19:48:25.703" v="2821" actId="1076"/>
+          <ac:chgData name="Nicole Jiang" userId="09ef0fc0f6f473b5" providerId="LiveId" clId="{EB8F4A53-0964-5BF1-90AD-931457E28E1A}" dt="2026-10-15T19:27:48.134" v="3359" actId="1076"/>
           <ac:spMkLst>
             <pc:docMk/>
             <pc:sldMk cId="868487171" sldId="261"/>
@@ -451,7 +475,7 @@
           </ac:spMkLst>
         </pc:spChg>
         <pc:spChg chg="mod">
-          <ac:chgData name="Nicole Jiang" userId="09ef0fc0f6f473b5" providerId="LiveId" clId="{EB8F4A53-0964-5BF1-90AD-931457E28E1A}" dt="2026-10-14T19:48:25.703" v="2821" actId="1076"/>
+          <ac:chgData name="Nicole Jiang" userId="09ef0fc0f6f473b5" providerId="LiveId" clId="{EB8F4A53-0964-5BF1-90AD-931457E28E1A}" dt="2026-10-15T19:27:48.134" v="3359" actId="1076"/>
           <ac:spMkLst>
             <pc:docMk/>
             <pc:sldMk cId="868487171" sldId="261"/>
@@ -475,7 +499,7 @@
           </ac:spMkLst>
         </pc:spChg>
         <pc:spChg chg="mod">
-          <ac:chgData name="Nicole Jiang" userId="09ef0fc0f6f473b5" providerId="LiveId" clId="{EB8F4A53-0964-5BF1-90AD-931457E28E1A}" dt="2026-10-14T19:48:25.703" v="2821" actId="1076"/>
+          <ac:chgData name="Nicole Jiang" userId="09ef0fc0f6f473b5" providerId="LiveId" clId="{EB8F4A53-0964-5BF1-90AD-931457E28E1A}" dt="2026-10-15T19:27:48.134" v="3359" actId="1076"/>
           <ac:spMkLst>
             <pc:docMk/>
             <pc:sldMk cId="868487171" sldId="261"/>
@@ -499,7 +523,7 @@
           </ac:spMkLst>
         </pc:spChg>
         <pc:spChg chg="mod">
-          <ac:chgData name="Nicole Jiang" userId="09ef0fc0f6f473b5" providerId="LiveId" clId="{EB8F4A53-0964-5BF1-90AD-931457E28E1A}" dt="2026-10-14T19:33:45.038" v="2717" actId="1076"/>
+          <ac:chgData name="Nicole Jiang" userId="09ef0fc0f6f473b5" providerId="LiveId" clId="{EB8F4A53-0964-5BF1-90AD-931457E28E1A}" dt="2026-10-15T19:27:48.134" v="3359" actId="1076"/>
           <ac:spMkLst>
             <pc:docMk/>
             <pc:sldMk cId="868487171" sldId="261"/>
@@ -628,7 +652,7 @@
           <a:p>
             <a:fld id="{88D8F461-2A77-BA43-9B12-25195C3EB239}" type="datetimeFigureOut">
               <a:rPr lang="en-US" smtClean="0"/>
-              <a:t>10/14/26</a:t>
+              <a:t>10/15/26</a:t>
             </a:fld>
             <a:endParaRPr lang="en-US"/>
           </a:p>
@@ -1170,7 +1194,7 @@
           <a:p>
             <a:fld id="{9ED62D96-B761-444F-9627-07D69EF59102}" type="datetimeFigureOut">
               <a:rPr lang="en-US" smtClean="0"/>
-              <a:t>10/14/26</a:t>
+              <a:t>10/15/26</a:t>
             </a:fld>
             <a:endParaRPr lang="en-US"/>
           </a:p>
@@ -1338,7 +1362,7 @@
           <a:p>
             <a:fld id="{9ED62D96-B761-444F-9627-07D69EF59102}" type="datetimeFigureOut">
               <a:rPr lang="en-US" smtClean="0"/>
-              <a:t>10/14/26</a:t>
+              <a:t>10/15/26</a:t>
             </a:fld>
             <a:endParaRPr lang="en-US"/>
           </a:p>
@@ -1516,7 +1540,7 @@
           <a:p>
             <a:fld id="{9ED62D96-B761-444F-9627-07D69EF59102}" type="datetimeFigureOut">
               <a:rPr lang="en-US" smtClean="0"/>
-              <a:t>10/14/26</a:t>
+              <a:t>10/15/26</a:t>
             </a:fld>
             <a:endParaRPr lang="en-US"/>
           </a:p>
@@ -2674,7 +2698,7 @@
           <a:p>
             <a:fld id="{9ED62D96-B761-444F-9627-07D69EF59102}" type="datetimeFigureOut">
               <a:rPr lang="en-US" smtClean="0"/>
-              <a:t>10/14/26</a:t>
+              <a:t>10/15/26</a:t>
             </a:fld>
             <a:endParaRPr lang="en-US"/>
           </a:p>
@@ -2919,7 +2943,7 @@
           <a:p>
             <a:fld id="{9ED62D96-B761-444F-9627-07D69EF59102}" type="datetimeFigureOut">
               <a:rPr lang="en-US" smtClean="0"/>
-              <a:t>10/14/26</a:t>
+              <a:t>10/15/26</a:t>
             </a:fld>
             <a:endParaRPr lang="en-US"/>
           </a:p>
@@ -3148,7 +3172,7 @@
           <a:p>
             <a:fld id="{9ED62D96-B761-444F-9627-07D69EF59102}" type="datetimeFigureOut">
               <a:rPr lang="en-US" smtClean="0"/>
-              <a:t>10/14/26</a:t>
+              <a:t>10/15/26</a:t>
             </a:fld>
             <a:endParaRPr lang="en-US"/>
           </a:p>
@@ -3512,7 +3536,7 @@
           <a:p>
             <a:fld id="{9ED62D96-B761-444F-9627-07D69EF59102}" type="datetimeFigureOut">
               <a:rPr lang="en-US" smtClean="0"/>
-              <a:t>10/14/26</a:t>
+              <a:t>10/15/26</a:t>
             </a:fld>
             <a:endParaRPr lang="en-US"/>
           </a:p>
@@ -3629,7 +3653,7 @@
           <a:p>
             <a:fld id="{9ED62D96-B761-444F-9627-07D69EF59102}" type="datetimeFigureOut">
               <a:rPr lang="en-US" smtClean="0"/>
-              <a:t>10/14/26</a:t>
+              <a:t>10/15/26</a:t>
             </a:fld>
             <a:endParaRPr lang="en-US"/>
           </a:p>
@@ -3724,7 +3748,7 @@
           <a:p>
             <a:fld id="{9ED62D96-B761-444F-9627-07D69EF59102}" type="datetimeFigureOut">
               <a:rPr lang="en-US" smtClean="0"/>
-              <a:t>10/14/26</a:t>
+              <a:t>10/15/26</a:t>
             </a:fld>
             <a:endParaRPr lang="en-US"/>
           </a:p>
@@ -3999,7 +4023,7 @@
           <a:p>
             <a:fld id="{9ED62D96-B761-444F-9627-07D69EF59102}" type="datetimeFigureOut">
               <a:rPr lang="en-US" smtClean="0"/>
-              <a:t>10/14/26</a:t>
+              <a:t>10/15/26</a:t>
             </a:fld>
             <a:endParaRPr lang="en-US"/>
           </a:p>
@@ -4251,7 +4275,7 @@
           <a:p>
             <a:fld id="{9ED62D96-B761-444F-9627-07D69EF59102}" type="datetimeFigureOut">
               <a:rPr lang="en-US" smtClean="0"/>
-              <a:t>10/14/26</a:t>
+              <a:t>10/15/26</a:t>
             </a:fld>
             <a:endParaRPr lang="en-US"/>
           </a:p>
@@ -4462,7 +4486,7 @@
           <a:p>
             <a:fld id="{9ED62D96-B761-444F-9627-07D69EF59102}" type="datetimeFigureOut">
               <a:rPr lang="en-US" smtClean="0"/>
-              <a:t>10/14/26</a:t>
+              <a:t>10/15/26</a:t>
             </a:fld>
             <a:endParaRPr lang="en-US"/>
           </a:p>
@@ -4896,7 +4920,7 @@
         </p:blipFill>
         <p:spPr>
           <a:xfrm>
-            <a:off x="17190720" y="21970501"/>
+            <a:off x="17190720" y="21812953"/>
             <a:ext cx="14630400" cy="9875520"/>
           </a:xfrm>
           <a:prstGeom prst="rect">
@@ -5106,7 +5130,7 @@
         </p:nvSpPr>
         <p:spPr>
           <a:xfrm>
-            <a:off x="914400" y="5362478"/>
+            <a:off x="914400" y="5204930"/>
             <a:ext cx="15087600" cy="960120"/>
           </a:xfrm>
           <a:prstGeom prst="rect">
@@ -5167,7 +5191,7 @@
         </p:nvSpPr>
         <p:spPr>
           <a:xfrm>
-            <a:off x="1371600" y="6642638"/>
+            <a:off x="1371600" y="6485090"/>
             <a:ext cx="14173200" cy="2631490"/>
           </a:xfrm>
           <a:prstGeom prst="rect">
@@ -5225,7 +5249,7 @@
         </p:nvSpPr>
         <p:spPr>
           <a:xfrm>
-            <a:off x="914400" y="5362479"/>
+            <a:off x="914400" y="5204931"/>
             <a:ext cx="15087600" cy="4322460"/>
           </a:xfrm>
           <a:prstGeom prst="rect">
@@ -5279,7 +5303,7 @@
         </p:nvSpPr>
         <p:spPr>
           <a:xfrm>
-            <a:off x="914400" y="10184457"/>
+            <a:off x="914400" y="10026909"/>
             <a:ext cx="15087600" cy="960120"/>
           </a:xfrm>
           <a:prstGeom prst="rect">
@@ -5340,7 +5364,7 @@
         </p:nvSpPr>
         <p:spPr>
           <a:xfrm>
-            <a:off x="1463040" y="20785342"/>
+            <a:off x="1463040" y="20627794"/>
             <a:ext cx="13990320" cy="4114800"/>
           </a:xfrm>
           <a:prstGeom prst="rect">
@@ -5445,7 +5469,7 @@
         </p:nvSpPr>
         <p:spPr>
           <a:xfrm>
-            <a:off x="914400" y="10184458"/>
+            <a:off x="914400" y="10026910"/>
             <a:ext cx="15087600" cy="27190853"/>
           </a:xfrm>
           <a:prstGeom prst="rect">
@@ -5499,7 +5523,7 @@
         </p:nvSpPr>
         <p:spPr>
           <a:xfrm>
-            <a:off x="16550640" y="35921521"/>
+            <a:off x="16550640" y="35763973"/>
             <a:ext cx="15453360" cy="960120"/>
           </a:xfrm>
           <a:prstGeom prst="rect">
@@ -5560,7 +5584,7 @@
         </p:nvSpPr>
         <p:spPr>
           <a:xfrm>
-            <a:off x="17099280" y="37166215"/>
+            <a:off x="17099280" y="37008667"/>
             <a:ext cx="14538960" cy="6017032"/>
           </a:xfrm>
           <a:prstGeom prst="rect">
@@ -5759,7 +5783,7 @@
         </p:nvSpPr>
         <p:spPr>
           <a:xfrm>
-            <a:off x="16550640" y="35921521"/>
+            <a:off x="16550640" y="35763973"/>
             <a:ext cx="15453360" cy="7512479"/>
           </a:xfrm>
           <a:prstGeom prst="rect">
@@ -5813,7 +5837,7 @@
         </p:nvSpPr>
         <p:spPr>
           <a:xfrm>
-            <a:off x="914400" y="37796815"/>
+            <a:off x="914400" y="37639267"/>
             <a:ext cx="15087600" cy="960120"/>
           </a:xfrm>
           <a:prstGeom prst="rect">
@@ -5874,7 +5898,7 @@
         </p:nvSpPr>
         <p:spPr>
           <a:xfrm>
-            <a:off x="1748025" y="39376529"/>
+            <a:off x="1748025" y="39218981"/>
             <a:ext cx="13054590" cy="3395801"/>
           </a:xfrm>
           <a:prstGeom prst="rect">
@@ -5986,7 +6010,7 @@
         </p:nvSpPr>
         <p:spPr>
           <a:xfrm>
-            <a:off x="914400" y="37811595"/>
+            <a:off x="914400" y="37654047"/>
             <a:ext cx="15087600" cy="5622405"/>
           </a:xfrm>
           <a:prstGeom prst="rect">
@@ -6047,7 +6071,7 @@
         </p:blipFill>
         <p:spPr>
           <a:xfrm>
-            <a:off x="17349367" y="12042092"/>
+            <a:off x="17349367" y="11884544"/>
             <a:ext cx="13648793" cy="7863840"/>
           </a:xfrm>
           <a:prstGeom prst="rect">
@@ -6159,7 +6183,7 @@
         </p:nvSpPr>
         <p:spPr>
           <a:xfrm>
-            <a:off x="17145000" y="20434572"/>
+            <a:off x="17145000" y="20277024"/>
             <a:ext cx="14630400" cy="1615827"/>
           </a:xfrm>
           <a:prstGeom prst="rect">
@@ -6209,7 +6233,7 @@
         </p:nvSpPr>
         <p:spPr>
           <a:xfrm>
-            <a:off x="17007840" y="6642638"/>
+            <a:off x="17007840" y="6485090"/>
             <a:ext cx="14767560" cy="5170646"/>
           </a:xfrm>
           <a:prstGeom prst="rect">
@@ -6421,8 +6445,8 @@
         </p:nvSpPr>
         <p:spPr>
           <a:xfrm>
-            <a:off x="16550640" y="5362478"/>
-            <a:ext cx="15453360" cy="960120"/>
+            <a:off x="16550640" y="5187229"/>
+            <a:ext cx="15453360" cy="977821"/>
           </a:xfrm>
           <a:prstGeom prst="rect">
             <a:avLst/>
@@ -6483,7 +6507,7 @@
         </p:nvSpPr>
         <p:spPr>
           <a:xfrm>
-            <a:off x="16550640" y="5344777"/>
+            <a:off x="16550640" y="5187229"/>
             <a:ext cx="15453360" cy="30083074"/>
           </a:xfrm>
           <a:prstGeom prst="rect">
@@ -6529,7 +6553,7 @@
         </p:nvSpPr>
         <p:spPr>
           <a:xfrm>
-            <a:off x="17190720" y="32207899"/>
+            <a:off x="17190720" y="32050351"/>
             <a:ext cx="14447520" cy="548640"/>
           </a:xfrm>
           <a:prstGeom prst="rect">
@@ -6569,7 +6593,7 @@
         </p:nvSpPr>
         <p:spPr>
           <a:xfrm>
-            <a:off x="17007840" y="32779973"/>
+            <a:off x="17007840" y="32622425"/>
             <a:ext cx="14767560" cy="2286000"/>
           </a:xfrm>
           <a:prstGeom prst="rect">
@@ -6657,7 +6681,7 @@
         </p:nvSpPr>
         <p:spPr>
           <a:xfrm>
-            <a:off x="1371600" y="24068625"/>
+            <a:off x="1371600" y="23911077"/>
             <a:ext cx="14356080" cy="640080"/>
           </a:xfrm>
           <a:prstGeom prst="rect">
@@ -6718,7 +6742,7 @@
         </p:nvSpPr>
         <p:spPr>
           <a:xfrm>
-            <a:off x="1471598" y="12390206"/>
+            <a:off x="1471598" y="12232658"/>
             <a:ext cx="13990320" cy="1143000"/>
           </a:xfrm>
           <a:prstGeom prst="rect">
@@ -6778,7 +6802,7 @@
         </p:nvSpPr>
         <p:spPr>
           <a:xfrm>
-            <a:off x="8309610" y="13412218"/>
+            <a:off x="8309610" y="13254670"/>
             <a:ext cx="347472" cy="329184"/>
           </a:xfrm>
           <a:prstGeom prst="downArrow">
@@ -6815,7 +6839,7 @@
         </p:nvSpPr>
         <p:spPr>
           <a:xfrm>
-            <a:off x="1463040" y="13858659"/>
+            <a:off x="1463040" y="13701111"/>
             <a:ext cx="13990320" cy="914400"/>
           </a:xfrm>
           <a:prstGeom prst="rect">
@@ -6879,7 +6903,7 @@
         </p:nvSpPr>
         <p:spPr>
           <a:xfrm>
-            <a:off x="5626303" y="14997396"/>
+            <a:off x="5626303" y="14839848"/>
             <a:ext cx="347472" cy="329184"/>
           </a:xfrm>
           <a:prstGeom prst="downArrow">
@@ -6916,7 +6940,7 @@
         </p:nvSpPr>
         <p:spPr>
           <a:xfrm>
-            <a:off x="12827203" y="14978902"/>
+            <a:off x="12827203" y="14821354"/>
             <a:ext cx="347472" cy="329184"/>
           </a:xfrm>
           <a:prstGeom prst="downArrow">
@@ -6953,7 +6977,7 @@
         </p:nvSpPr>
         <p:spPr>
           <a:xfrm>
-            <a:off x="1463040" y="15472678"/>
+            <a:off x="1463040" y="15315130"/>
             <a:ext cx="8673998" cy="4709160"/>
           </a:xfrm>
           <a:prstGeom prst="rect">
@@ -6990,7 +7014,7 @@
         </p:nvSpPr>
         <p:spPr>
           <a:xfrm>
-            <a:off x="1517904" y="15554974"/>
+            <a:off x="1517904" y="15397426"/>
             <a:ext cx="8564270" cy="822960"/>
           </a:xfrm>
           <a:prstGeom prst="rect">
@@ -7050,7 +7074,7 @@
         </p:nvSpPr>
         <p:spPr>
           <a:xfrm>
-            <a:off x="1645920" y="16320217"/>
+            <a:off x="1645920" y="16162669"/>
             <a:ext cx="8308238" cy="1261872"/>
           </a:xfrm>
           <a:prstGeom prst="rect">
@@ -7155,7 +7179,7 @@
         </p:nvSpPr>
         <p:spPr>
           <a:xfrm>
-            <a:off x="1645920" y="17788070"/>
+            <a:off x="1645920" y="17630522"/>
             <a:ext cx="8308238" cy="2202048"/>
           </a:xfrm>
           <a:prstGeom prst="rect">
@@ -7350,7 +7374,7 @@
         </p:nvSpPr>
         <p:spPr>
           <a:xfrm>
-            <a:off x="10548518" y="15481822"/>
+            <a:off x="10548518" y="15324274"/>
             <a:ext cx="4904842" cy="4709160"/>
           </a:xfrm>
           <a:prstGeom prst="rect">
@@ -7558,7 +7582,7 @@
         </p:nvSpPr>
         <p:spPr>
           <a:xfrm>
-            <a:off x="1463040" y="25086669"/>
+            <a:off x="1463040" y="24929121"/>
             <a:ext cx="14173200" cy="1051560"/>
           </a:xfrm>
           <a:prstGeom prst="rect">
@@ -7652,7 +7676,7 @@
         </p:nvSpPr>
         <p:spPr>
           <a:xfrm>
-            <a:off x="4695444" y="26183949"/>
+            <a:off x="4695444" y="26026401"/>
             <a:ext cx="347472" cy="329184"/>
           </a:xfrm>
           <a:prstGeom prst="downArrow">
@@ -7689,7 +7713,7 @@
         </p:nvSpPr>
         <p:spPr>
           <a:xfrm>
-            <a:off x="12056364" y="26183949"/>
+            <a:off x="12056364" y="26026401"/>
             <a:ext cx="347472" cy="329184"/>
           </a:xfrm>
           <a:prstGeom prst="downArrow">
@@ -7726,7 +7750,7 @@
         </p:nvSpPr>
         <p:spPr>
           <a:xfrm>
-            <a:off x="1463040" y="26659437"/>
+            <a:off x="1463040" y="26501889"/>
             <a:ext cx="6812280" cy="914400"/>
           </a:xfrm>
           <a:prstGeom prst="rect">
@@ -7790,7 +7814,7 @@
         </p:nvSpPr>
         <p:spPr>
           <a:xfrm>
-            <a:off x="8823960" y="26659437"/>
+            <a:off x="8823960" y="26501889"/>
             <a:ext cx="6812280" cy="914400"/>
           </a:xfrm>
           <a:prstGeom prst="rect">
@@ -7873,7 +7897,7 @@
         </p:nvSpPr>
         <p:spPr>
           <a:xfrm>
-            <a:off x="4695444" y="27710997"/>
+            <a:off x="4695444" y="27553449"/>
             <a:ext cx="347472" cy="329184"/>
           </a:xfrm>
           <a:prstGeom prst="downArrow">
@@ -7910,7 +7934,7 @@
         </p:nvSpPr>
         <p:spPr>
           <a:xfrm>
-            <a:off x="12056364" y="27710997"/>
+            <a:off x="12056364" y="27553449"/>
             <a:ext cx="347472" cy="329184"/>
           </a:xfrm>
           <a:prstGeom prst="downArrow">
@@ -7947,7 +7971,7 @@
         </p:nvSpPr>
         <p:spPr>
           <a:xfrm>
-            <a:off x="1463040" y="28213917"/>
+            <a:off x="1463040" y="28056369"/>
             <a:ext cx="14173200" cy="2057400"/>
           </a:xfrm>
           <a:prstGeom prst="rect">
@@ -8039,7 +8063,7 @@
         </p:nvSpPr>
         <p:spPr>
           <a:xfrm>
-            <a:off x="1463040" y="29311197"/>
+            <a:off x="1463040" y="29153649"/>
             <a:ext cx="14173200" cy="914400"/>
           </a:xfrm>
           <a:prstGeom prst="rect">
@@ -8127,7 +8151,7 @@
         </p:nvSpPr>
         <p:spPr>
           <a:xfrm>
-            <a:off x="4695444" y="30371901"/>
+            <a:off x="4695444" y="30214353"/>
             <a:ext cx="347472" cy="329184"/>
           </a:xfrm>
           <a:prstGeom prst="downArrow">
@@ -8164,7 +8188,7 @@
         </p:nvSpPr>
         <p:spPr>
           <a:xfrm>
-            <a:off x="12056364" y="30371901"/>
+            <a:off x="12056364" y="30214353"/>
             <a:ext cx="347472" cy="329184"/>
           </a:xfrm>
           <a:prstGeom prst="downArrow">
@@ -8201,7 +8225,7 @@
         </p:nvSpPr>
         <p:spPr>
           <a:xfrm>
-            <a:off x="1463040" y="30847389"/>
+            <a:off x="1463040" y="30689841"/>
             <a:ext cx="6812280" cy="1143000"/>
           </a:xfrm>
           <a:prstGeom prst="rect">
@@ -8299,7 +8323,7 @@
         </p:nvSpPr>
         <p:spPr>
           <a:xfrm>
-            <a:off x="8823960" y="30847389"/>
+            <a:off x="8823960" y="30689841"/>
             <a:ext cx="6812280" cy="1143000"/>
           </a:xfrm>
           <a:prstGeom prst="rect">
@@ -8382,7 +8406,7 @@
         </p:nvSpPr>
         <p:spPr>
           <a:xfrm>
-            <a:off x="1463040" y="33147208"/>
+            <a:off x="1463040" y="32989660"/>
             <a:ext cx="14173200" cy="1600200"/>
           </a:xfrm>
           <a:prstGeom prst="rect">
@@ -8440,7 +8464,7 @@
         </p:nvSpPr>
         <p:spPr>
           <a:xfrm>
-            <a:off x="1371600" y="35148661"/>
+            <a:off x="1371600" y="34991113"/>
             <a:ext cx="14173200" cy="1600200"/>
           </a:xfrm>
           <a:prstGeom prst="rect">
@@ -8498,7 +8522,7 @@
         </p:nvSpPr>
         <p:spPr>
           <a:xfrm>
-            <a:off x="1371600" y="11668069"/>
+            <a:off x="1371600" y="11510521"/>
             <a:ext cx="14356080" cy="640080"/>
           </a:xfrm>
           <a:prstGeom prst="rect">

</xml_diff>

<commit_message>
Save revised posters and verify reviewed export sources
</commit_message>
<xml_diff>
--- a/posters/36x48.pptx
+++ b/posters/36x48.pptx
@@ -8,7 +8,7 @@
     <p:notesMasterId r:id="rId3"/>
   </p:notesMasterIdLst>
   <p:sldIdLst>
-    <p:sldId id="261" r:id="rId2"/>
+    <p:sldId id="262" r:id="rId2"/>
   </p:sldIdLst>
   <p:sldSz cx="32918400" cy="43891200"/>
   <p:notesSz cx="6858000" cy="9144000"/>
@@ -129,91 +129,12 @@
   <pc:docChgLst>
     <pc:chgData name="Nicole Jiang" userId="09ef0fc0f6f473b5" providerId="LiveId" clId="{EB8F4A53-0964-5BF1-90AD-931457E28E1A}"/>
     <pc:docChg chg="undo redo custSel addSld delSld modSld">
-      <pc:chgData name="Nicole Jiang" userId="09ef0fc0f6f473b5" providerId="LiveId" clId="{EB8F4A53-0964-5BF1-90AD-931457E28E1A}" dt="2026-10-15T19:28:14.983" v="3361" actId="14100"/>
+      <pc:chgData name="Nicole Jiang" userId="09ef0fc0f6f473b5" providerId="LiveId" clId="{EB8F4A53-0964-5BF1-90AD-931457E28E1A}" dt="2026-10-16T03:55:09.242" v="3398" actId="2696"/>
       <pc:docMkLst>
         <pc:docMk/>
       </pc:docMkLst>
       <pc:sldChg chg="addSp delSp modSp del mod">
-        <pc:chgData name="Nicole Jiang" userId="09ef0fc0f6f473b5" providerId="LiveId" clId="{EB8F4A53-0964-5BF1-90AD-931457E28E1A}" dt="2026-10-14T20:17:12.227" v="2827" actId="2696"/>
-        <pc:sldMkLst>
-          <pc:docMk/>
-          <pc:sldMk cId="868487171" sldId="260"/>
-        </pc:sldMkLst>
-        <pc:spChg chg="add mod">
-          <ac:chgData name="Nicole Jiang" userId="09ef0fc0f6f473b5" providerId="LiveId" clId="{EB8F4A53-0964-5BF1-90AD-931457E28E1A}" dt="2026-10-14T03:42:59.952" v="2687" actId="1076"/>
-          <ac:spMkLst>
-            <pc:docMk/>
-            <pc:sldMk cId="868487171" sldId="260"/>
-            <ac:spMk id="15" creationId="{B71483CE-2A7E-6438-7E3B-E605C17C7099}"/>
-          </ac:spMkLst>
-        </pc:spChg>
-        <pc:spChg chg="mod">
-          <ac:chgData name="Nicole Jiang" userId="09ef0fc0f6f473b5" providerId="LiveId" clId="{EB8F4A53-0964-5BF1-90AD-931457E28E1A}" dt="2026-10-14T03:41:54.177" v="2679" actId="14100"/>
-          <ac:spMkLst>
-            <pc:docMk/>
-            <pc:sldMk cId="868487171" sldId="260"/>
-            <ac:spMk id="71" creationId="{ABB03D82-A209-1440-3180-9DD4419EFCBF}"/>
-          </ac:spMkLst>
-        </pc:spChg>
-        <pc:spChg chg="mod">
-          <ac:chgData name="Nicole Jiang" userId="09ef0fc0f6f473b5" providerId="LiveId" clId="{EB8F4A53-0964-5BF1-90AD-931457E28E1A}" dt="2026-10-14T03:42:00.062" v="2680" actId="1076"/>
-          <ac:spMkLst>
-            <pc:docMk/>
-            <pc:sldMk cId="868487171" sldId="260"/>
-            <ac:spMk id="72" creationId="{6D9DC137-E8CF-8FC7-F26F-A7759AD2C396}"/>
-          </ac:spMkLst>
-        </pc:spChg>
-        <pc:spChg chg="mod">
-          <ac:chgData name="Nicole Jiang" userId="09ef0fc0f6f473b5" providerId="LiveId" clId="{EB8F4A53-0964-5BF1-90AD-931457E28E1A}" dt="2026-10-14T03:42:12.339" v="2683" actId="1076"/>
-          <ac:spMkLst>
-            <pc:docMk/>
-            <pc:sldMk cId="868487171" sldId="260"/>
-            <ac:spMk id="73" creationId="{88C51BF9-B81A-ECF4-F01D-305CA1CE9DD1}"/>
-          </ac:spMkLst>
-        </pc:spChg>
-        <pc:spChg chg="mod">
-          <ac:chgData name="Nicole Jiang" userId="09ef0fc0f6f473b5" providerId="LiveId" clId="{EB8F4A53-0964-5BF1-90AD-931457E28E1A}" dt="2026-10-14T03:42:03.960" v="2681" actId="14100"/>
-          <ac:spMkLst>
-            <pc:docMk/>
-            <pc:sldMk cId="868487171" sldId="260"/>
-            <ac:spMk id="74" creationId="{F5F0E6D1-7308-2846-C555-5A8981E84E43}"/>
-          </ac:spMkLst>
-        </pc:spChg>
-        <pc:spChg chg="mod">
-          <ac:chgData name="Nicole Jiang" userId="09ef0fc0f6f473b5" providerId="LiveId" clId="{EB8F4A53-0964-5BF1-90AD-931457E28E1A}" dt="2026-10-14T03:42:44.386" v="2685" actId="1076"/>
-          <ac:spMkLst>
-            <pc:docMk/>
-            <pc:sldMk cId="868487171" sldId="260"/>
-            <ac:spMk id="76" creationId="{8F4057E1-F618-63B3-DF3A-8B3B4948305D}"/>
-          </ac:spMkLst>
-        </pc:spChg>
-        <pc:spChg chg="mod">
-          <ac:chgData name="Nicole Jiang" userId="09ef0fc0f6f473b5" providerId="LiveId" clId="{EB8F4A53-0964-5BF1-90AD-931457E28E1A}" dt="2026-10-14T03:42:26.737" v="2684" actId="1076"/>
-          <ac:spMkLst>
-            <pc:docMk/>
-            <pc:sldMk cId="868487171" sldId="260"/>
-            <ac:spMk id="79" creationId="{3DD5B540-2EC8-A5A1-200C-994C1D7C8BFD}"/>
-          </ac:spMkLst>
-        </pc:spChg>
-        <pc:spChg chg="mod">
-          <ac:chgData name="Nicole Jiang" userId="09ef0fc0f6f473b5" providerId="LiveId" clId="{EB8F4A53-0964-5BF1-90AD-931457E28E1A}" dt="2026-10-14T03:43:03.391" v="2688" actId="1076"/>
-          <ac:spMkLst>
-            <pc:docMk/>
-            <pc:sldMk cId="868487171" sldId="260"/>
-            <ac:spMk id="112" creationId="{00000000-0000-0000-0000-000000000000}"/>
-          </ac:spMkLst>
-        </pc:spChg>
-        <pc:picChg chg="mod">
-          <ac:chgData name="Nicole Jiang" userId="09ef0fc0f6f473b5" providerId="LiveId" clId="{EB8F4A53-0964-5BF1-90AD-931457E28E1A}" dt="2026-10-14T03:42:55.489" v="2686" actId="1076"/>
-          <ac:picMkLst>
-            <pc:docMk/>
-            <pc:sldMk cId="868487171" sldId="260"/>
-            <ac:picMk id="14" creationId="{C3CA3027-10C5-D39A-05B0-82DB2540F9D3}"/>
-          </ac:picMkLst>
-        </pc:picChg>
-      </pc:sldChg>
-      <pc:sldChg chg="addSp delSp modSp mod">
-        <pc:chgData name="Nicole Jiang" userId="09ef0fc0f6f473b5" providerId="LiveId" clId="{EB8F4A53-0964-5BF1-90AD-931457E28E1A}" dt="2026-10-15T19:28:14.983" v="3361" actId="14100"/>
+        <pc:chgData name="Nicole Jiang" userId="09ef0fc0f6f473b5" providerId="LiveId" clId="{EB8F4A53-0964-5BF1-90AD-931457E28E1A}" dt="2026-10-16T03:55:09.242" v="3398" actId="2696"/>
         <pc:sldMkLst>
           <pc:docMk/>
           <pc:sldMk cId="868487171" sldId="261"/>
@@ -344,14 +265,6 @@
             <pc:docMk/>
             <pc:sldMk cId="868487171" sldId="261"/>
             <ac:spMk id="83" creationId="{7156AF1B-4C0F-9637-8495-BA5941742B85}"/>
-          </ac:spMkLst>
-        </pc:spChg>
-        <pc:spChg chg="del">
-          <ac:chgData name="Nicole Jiang" userId="09ef0fc0f6f473b5" providerId="LiveId" clId="{EB8F4A53-0964-5BF1-90AD-931457E28E1A}" dt="2026-10-14T19:45:53.892" v="2813" actId="478"/>
-          <ac:spMkLst>
-            <pc:docMk/>
-            <pc:sldMk cId="868487171" sldId="261"/>
-            <ac:spMk id="110" creationId="{00000000-0000-0000-0000-000000000000}"/>
           </ac:spMkLst>
         </pc:spChg>
         <pc:spChg chg="mod">
@@ -544,6 +457,69 @@
             <pc:docMk/>
             <pc:sldMk cId="868487171" sldId="261"/>
             <ac:picMk id="14" creationId="{C3CA3027-10C5-D39A-05B0-82DB2540F9D3}"/>
+          </ac:picMkLst>
+        </pc:picChg>
+      </pc:sldChg>
+      <pc:sldChg chg="modSp mod">
+        <pc:chgData name="Nicole Jiang" userId="09ef0fc0f6f473b5" providerId="LiveId" clId="{EB8F4A53-0964-5BF1-90AD-931457E28E1A}" dt="2026-10-16T03:54:41.122" v="3397" actId="1076"/>
+        <pc:sldMkLst>
+          <pc:docMk/>
+          <pc:sldMk cId="868487171" sldId="262"/>
+        </pc:sldMkLst>
+        <pc:spChg chg="mod">
+          <ac:chgData name="Nicole Jiang" userId="09ef0fc0f6f473b5" providerId="LiveId" clId="{EB8F4A53-0964-5BF1-90AD-931457E28E1A}" dt="2026-10-16T03:52:38.760" v="3377" actId="14100"/>
+          <ac:spMkLst>
+            <pc:docMk/>
+            <pc:sldMk cId="868487171" sldId="262"/>
+            <ac:spMk id="32" creationId="{F8D50A2A-9B61-AD34-B9C2-8944BB27426C}"/>
+          </ac:spMkLst>
+        </pc:spChg>
+        <pc:picChg chg="mod">
+          <ac:chgData name="Nicole Jiang" userId="09ef0fc0f6f473b5" providerId="LiveId" clId="{EB8F4A53-0964-5BF1-90AD-931457E28E1A}" dt="2026-10-16T03:53:41.249" v="3393" actId="14100"/>
+          <ac:picMkLst>
+            <pc:docMk/>
+            <pc:sldMk cId="868487171" sldId="262"/>
+            <ac:picMk id="5" creationId="{0BD845B3-DC16-6DC6-BFC8-2D65D247678D}"/>
+          </ac:picMkLst>
+        </pc:picChg>
+        <pc:picChg chg="mod">
+          <ac:chgData name="Nicole Jiang" userId="09ef0fc0f6f473b5" providerId="LiveId" clId="{EB8F4A53-0964-5BF1-90AD-931457E28E1A}" dt="2026-10-16T03:54:04.478" v="3395" actId="1076"/>
+          <ac:picMkLst>
+            <pc:docMk/>
+            <pc:sldMk cId="868487171" sldId="262"/>
+            <ac:picMk id="6" creationId="{9D3E6E2E-04C2-513B-0EE5-8C40F5B8F46A}"/>
+          </ac:picMkLst>
+        </pc:picChg>
+        <pc:picChg chg="mod">
+          <ac:chgData name="Nicole Jiang" userId="09ef0fc0f6f473b5" providerId="LiveId" clId="{EB8F4A53-0964-5BF1-90AD-931457E28E1A}" dt="2026-10-16T03:53:21.746" v="3388" actId="14100"/>
+          <ac:picMkLst>
+            <pc:docMk/>
+            <pc:sldMk cId="868487171" sldId="262"/>
+            <ac:picMk id="10" creationId="{FB4EBB94-758E-75A7-659C-BF66DBB0AEF6}"/>
+          </ac:picMkLst>
+        </pc:picChg>
+        <pc:picChg chg="mod">
+          <ac:chgData name="Nicole Jiang" userId="09ef0fc0f6f473b5" providerId="LiveId" clId="{EB8F4A53-0964-5BF1-90AD-931457E28E1A}" dt="2026-10-16T03:53:02.539" v="3384" actId="1076"/>
+          <ac:picMkLst>
+            <pc:docMk/>
+            <pc:sldMk cId="868487171" sldId="262"/>
+            <ac:picMk id="33" creationId="{42BD33B9-86B6-8B04-8AA1-E72E85543563}"/>
+          </ac:picMkLst>
+        </pc:picChg>
+        <pc:picChg chg="mod">
+          <ac:chgData name="Nicole Jiang" userId="09ef0fc0f6f473b5" providerId="LiveId" clId="{EB8F4A53-0964-5BF1-90AD-931457E28E1A}" dt="2026-10-16T03:54:41.122" v="3397" actId="1076"/>
+          <ac:picMkLst>
+            <pc:docMk/>
+            <pc:sldMk cId="868487171" sldId="262"/>
+            <ac:picMk id="36" creationId="{8C2E503F-9CF2-EBE6-29B0-458691A7DFB1}"/>
+          </ac:picMkLst>
+        </pc:picChg>
+        <pc:picChg chg="mod">
+          <ac:chgData name="Nicole Jiang" userId="09ef0fc0f6f473b5" providerId="LiveId" clId="{EB8F4A53-0964-5BF1-90AD-931457E28E1A}" dt="2026-10-16T03:53:16.271" v="3386" actId="14100"/>
+          <ac:picMkLst>
+            <pc:docMk/>
+            <pc:sldMk cId="868487171" sldId="262"/>
+            <ac:picMk id="37" creationId="{2C65ED58-816C-A2B5-F6CB-4326B0858DDD}"/>
           </ac:picMkLst>
         </pc:picChg>
       </pc:sldChg>
@@ -4920,8 +4896,8 @@
         </p:blipFill>
         <p:spPr>
           <a:xfrm>
-            <a:off x="17190720" y="21812953"/>
-            <a:ext cx="14630400" cy="9875520"/>
+            <a:off x="17605552" y="21543053"/>
+            <a:ext cx="14355126" cy="9689710"/>
           </a:xfrm>
           <a:prstGeom prst="rect">
             <a:avLst/>
@@ -4946,8 +4922,8 @@
         </p:nvSpPr>
         <p:spPr>
           <a:xfrm>
-            <a:off x="-292608" y="-106306"/>
-            <a:ext cx="33686496" cy="4842334"/>
+            <a:off x="-818606" y="-224692"/>
+            <a:ext cx="34006971" cy="4893622"/>
           </a:xfrm>
           <a:solidFill>
             <a:srgbClr val="002A5C"/>
@@ -4959,7 +4935,7 @@
           </a:ln>
         </p:spPr>
         <p:txBody>
-          <a:bodyPr lIns="7680960" tIns="457200" rIns="8869680">
+          <a:bodyPr lIns="7315200" tIns="457200" rIns="7955280">
             <a:normAutofit/>
           </a:bodyPr>
           <a:lstStyle/>
@@ -5045,8 +5021,8 @@
         </p:blipFill>
         <p:spPr>
           <a:xfrm>
-            <a:off x="914400" y="774808"/>
-            <a:ext cx="2377440" cy="2377440"/>
+            <a:off x="914400" y="946662"/>
+            <a:ext cx="2207800" cy="2207800"/>
           </a:xfrm>
           <a:prstGeom prst="rect">
             <a:avLst/>
@@ -5076,8 +5052,8 @@
         </p:blipFill>
         <p:spPr>
           <a:xfrm>
-            <a:off x="2961848" y="1118870"/>
-            <a:ext cx="4937760" cy="1781207"/>
+            <a:off x="2787274" y="1084044"/>
+            <a:ext cx="4756880" cy="1715958"/>
           </a:xfrm>
           <a:prstGeom prst="rect">
             <a:avLst/>
@@ -5106,8 +5082,8 @@
         </p:blipFill>
         <p:spPr>
           <a:xfrm>
-            <a:off x="29443680" y="502920"/>
-            <a:ext cx="2743200" cy="2743200"/>
+            <a:off x="29581579" y="899899"/>
+            <a:ext cx="2788181" cy="2788181"/>
           </a:xfrm>
           <a:prstGeom prst="rect">
             <a:avLst/>
@@ -5130,8 +5106,8 @@
         </p:nvSpPr>
         <p:spPr>
           <a:xfrm>
-            <a:off x="914400" y="5204930"/>
-            <a:ext cx="15087600" cy="960120"/>
+            <a:off x="548640" y="5212080"/>
+            <a:ext cx="15636240" cy="960120"/>
           </a:xfrm>
           <a:prstGeom prst="rect">
             <a:avLst/>
@@ -5191,8 +5167,8 @@
         </p:nvSpPr>
         <p:spPr>
           <a:xfrm>
-            <a:off x="1371600" y="6485090"/>
-            <a:ext cx="14173200" cy="2631490"/>
+            <a:off x="914400" y="6537960"/>
+            <a:ext cx="14904720" cy="2880360"/>
           </a:xfrm>
           <a:prstGeom prst="rect">
             <a:avLst/>
@@ -5249,8 +5225,8 @@
         </p:nvSpPr>
         <p:spPr>
           <a:xfrm>
-            <a:off x="914400" y="5204931"/>
-            <a:ext cx="15087600" cy="4322460"/>
+            <a:off x="548640" y="5212080"/>
+            <a:ext cx="15636240" cy="4572000"/>
           </a:xfrm>
           <a:prstGeom prst="rect">
             <a:avLst/>
@@ -5303,8 +5279,8 @@
         </p:nvSpPr>
         <p:spPr>
           <a:xfrm>
-            <a:off x="914400" y="10026909"/>
-            <a:ext cx="15087600" cy="960120"/>
+            <a:off x="548640" y="10332720"/>
+            <a:ext cx="15636240" cy="960120"/>
           </a:xfrm>
           <a:prstGeom prst="rect">
             <a:avLst/>
@@ -5364,8 +5340,8 @@
         </p:nvSpPr>
         <p:spPr>
           <a:xfrm>
-            <a:off x="1463040" y="20627794"/>
-            <a:ext cx="13990320" cy="4114800"/>
+            <a:off x="914400" y="20820589"/>
+            <a:ext cx="14904720" cy="4066564"/>
           </a:xfrm>
           <a:prstGeom prst="rect">
             <a:avLst/>
@@ -5469,8 +5445,8 @@
         </p:nvSpPr>
         <p:spPr>
           <a:xfrm>
-            <a:off x="914400" y="10026910"/>
-            <a:ext cx="15087600" cy="27190853"/>
+            <a:off x="548640" y="10332720"/>
+            <a:ext cx="15636240" cy="26883360"/>
           </a:xfrm>
           <a:prstGeom prst="rect">
             <a:avLst/>
@@ -5523,8 +5499,8 @@
         </p:nvSpPr>
         <p:spPr>
           <a:xfrm>
-            <a:off x="16550640" y="35763973"/>
-            <a:ext cx="15453360" cy="960120"/>
+            <a:off x="16733520" y="35295840"/>
+            <a:ext cx="15636240" cy="960120"/>
           </a:xfrm>
           <a:prstGeom prst="rect">
             <a:avLst/>
@@ -5584,8 +5560,8 @@
         </p:nvSpPr>
         <p:spPr>
           <a:xfrm>
-            <a:off x="17099280" y="37008667"/>
-            <a:ext cx="14538960" cy="6017032"/>
+            <a:off x="17099280" y="36621720"/>
+            <a:ext cx="14904720" cy="6355080"/>
           </a:xfrm>
           <a:prstGeom prst="rect">
             <a:avLst/>
@@ -5600,7 +5576,7 @@
           <a:p>
             <a:pPr marL="457200" lvl="0" indent="-457200">
               <a:spcAft>
-                <a:spcPts val="800"/>
+                <a:spcPts val="2000"/>
               </a:spcAft>
               <a:buFont typeface="Arial" panose="020B0604020202020204" pitchFamily="34" charset="0"/>
               <a:buChar char="•"/>
@@ -5621,63 +5597,55 @@
           <a:p>
             <a:pPr marL="457200" lvl="0" indent="-457200">
               <a:spcAft>
-                <a:spcPts val="800"/>
+                <a:spcPts val="2000"/>
               </a:spcAft>
               <a:buFont typeface="Arial" panose="020B0604020202020204" pitchFamily="34" charset="0"/>
               <a:buChar char="•"/>
             </a:pPr>
-            <a:endParaRPr lang="en-CA" sz="500" dirty="0">
-              <a:latin typeface="Aptos" panose="020B0004020202020204" pitchFamily="34" charset="0"/>
-            </a:endParaRPr>
+            <a:r>
+              <a:rPr lang="en-CA" sz="3300" b="1" dirty="0">
+                <a:latin typeface="Aptos" panose="020B0004020202020204" pitchFamily="34" charset="0"/>
+              </a:rPr>
+              <a:t>Growth physics:</a:t>
+            </a:r>
+            <a:r>
+              <a:rPr lang="en-CA" sz="3300" dirty="0">
+                <a:latin typeface="Aptos" panose="020B0004020202020204" pitchFamily="34" charset="0"/>
+              </a:rPr>
+              <a:t> The efficiency test shows that difficulty growing from small seeds does not imply a need for heavier seeds or super-Eddington accretion.</a:t>
+            </a:r>
           </a:p>
           <a:p>
             <a:pPr marL="457200" lvl="0" indent="-457200">
               <a:spcAft>
-                <a:spcPts val="800"/>
+                <a:spcPts val="2000"/>
               </a:spcAft>
               <a:buFont typeface="Arial" panose="020B0604020202020204" pitchFamily="34" charset="0"/>
               <a:buChar char="•"/>
             </a:pPr>
             <a:r>
               <a:rPr lang="en-CA" sz="3300" b="1" dirty="0">
-                <a:latin typeface="Aptos" panose="020B0004020202020204" pitchFamily="34" charset="0"/>
-              </a:rPr>
-              <a:t>Growth physics:</a:t>
+                <a:solidFill>
+                  <a:srgbClr val="000000"/>
+                </a:solidFill>
+              </a:rPr>
+              <a:t>Earlier growth: </a:t>
             </a:r>
             <a:r>
               <a:rPr lang="en-CA" sz="3300" dirty="0">
-                <a:latin typeface="Aptos" panose="020B0004020202020204" pitchFamily="34" charset="0"/>
-              </a:rPr>
-              <a:t> The efficiency test shows that difficulty growing from small seeds does not imply a need for heavier seeds or super-Eddington accretion.</a:t>
-            </a:r>
-          </a:p>
-          <a:p>
-            <a:pPr marL="457200" lvl="0" indent="-457200">
-              <a:spcAft>
-                <a:spcPts val="800"/>
-              </a:spcAft>
-              <a:buFont typeface="Arial" panose="020B0604020202020204" pitchFamily="34" charset="0"/>
-              <a:buChar char="•"/>
-            </a:pPr>
-            <a:endParaRPr lang="en-CA" sz="500" dirty="0">
-              <a:latin typeface="Aptos" panose="020B0004020202020204" pitchFamily="34" charset="0"/>
-            </a:endParaRPr>
-          </a:p>
-          <a:p>
-            <a:pPr marL="457200" lvl="0" indent="-457200">
-              <a:spcAft>
-                <a:spcPts val="800"/>
-              </a:spcAft>
-              <a:buFont typeface="Arial" panose="020B0604020202020204" pitchFamily="34" charset="0"/>
-              <a:buChar char="•"/>
-            </a:pPr>
-            <a:r>
-              <a:rPr lang="en-CA" sz="3300" b="1" dirty="0">
                 <a:solidFill>
                   <a:srgbClr val="000000"/>
                 </a:solidFill>
               </a:rPr>
-              <a:t>Earlier growth: </a:t>
+              <a:t>Earlier onset alone cannot explain the four target masses from 100 M⊙ seeds at </a:t>
+            </a:r>
+            <a:r>
+              <a:rPr lang="en-CA" sz="3300" dirty="0" err="1">
+                <a:solidFill>
+                  <a:srgbClr val="000000"/>
+                </a:solidFill>
+              </a:rPr>
+              <a:t>ε</a:t>
             </a:r>
             <a:r>
               <a:rPr lang="en-CA" sz="3300" dirty="0">
@@ -5685,43 +5653,13 @@
                   <a:srgbClr val="000000"/>
                 </a:solidFill>
               </a:rPr>
-              <a:t>Earlier onset alone cannot explain the four target masses from 100 M⊙ seeds at </a:t>
-            </a:r>
-            <a:r>
-              <a:rPr lang="en-CA" sz="3300" dirty="0" err="1">
-                <a:solidFill>
-                  <a:srgbClr val="000000"/>
-                </a:solidFill>
-              </a:rPr>
-              <a:t>ε</a:t>
-            </a:r>
-            <a:r>
-              <a:rPr lang="en-CA" sz="3300" dirty="0">
-                <a:solidFill>
-                  <a:srgbClr val="000000"/>
-                </a:solidFill>
-              </a:rPr>
               <a:t> = 0.1 and average ratio ≤ 1, without mergers.</a:t>
             </a:r>
-          </a:p>
-          <a:p>
-            <a:pPr marL="457200" lvl="0" indent="-457200">
-              <a:spcAft>
-                <a:spcPts val="800"/>
-              </a:spcAft>
-              <a:buFont typeface="Arial" panose="020B0604020202020204" pitchFamily="34" charset="0"/>
-              <a:buChar char="•"/>
-            </a:pPr>
-            <a:endParaRPr lang="en-CA" sz="500" dirty="0">
-              <a:solidFill>
-                <a:srgbClr val="000000"/>
-              </a:solidFill>
-            </a:endParaRPr>
           </a:p>
           <a:p>
             <a:pPr marL="457200" indent="-457200">
               <a:spcAft>
-                <a:spcPts val="800"/>
+                <a:spcPts val="2000"/>
               </a:spcAft>
               <a:buFont typeface="Arial" panose="020B0604020202020204" pitchFamily="34" charset="0"/>
               <a:buChar char="•"/>
@@ -5783,8 +5721,8 @@
         </p:nvSpPr>
         <p:spPr>
           <a:xfrm>
-            <a:off x="16550640" y="35763973"/>
-            <a:ext cx="15453360" cy="7512479"/>
+            <a:off x="16733520" y="35295840"/>
+            <a:ext cx="15636240" cy="8046720"/>
           </a:xfrm>
           <a:prstGeom prst="rect">
             <a:avLst/>
@@ -5837,8 +5775,8 @@
         </p:nvSpPr>
         <p:spPr>
           <a:xfrm>
-            <a:off x="914400" y="37639267"/>
-            <a:ext cx="15087600" cy="960120"/>
+            <a:off x="548640" y="37764720"/>
+            <a:ext cx="15636240" cy="960120"/>
           </a:xfrm>
           <a:prstGeom prst="rect">
             <a:avLst/>
@@ -5898,8 +5836,8 @@
         </p:nvSpPr>
         <p:spPr>
           <a:xfrm>
-            <a:off x="1748025" y="39218981"/>
-            <a:ext cx="13054590" cy="3395801"/>
+            <a:off x="914400" y="39090600"/>
+            <a:ext cx="14904720" cy="3886200"/>
           </a:xfrm>
           <a:prstGeom prst="rect">
             <a:avLst/>
@@ -6010,8 +5948,8 @@
         </p:nvSpPr>
         <p:spPr>
           <a:xfrm>
-            <a:off x="914400" y="37654047"/>
-            <a:ext cx="15087600" cy="5622405"/>
+            <a:off x="548640" y="37764720"/>
+            <a:ext cx="15636240" cy="5577840"/>
           </a:xfrm>
           <a:prstGeom prst="rect">
             <a:avLst/>
@@ -6071,8 +6009,8 @@
         </p:blipFill>
         <p:spPr>
           <a:xfrm>
-            <a:off x="17349367" y="11884544"/>
-            <a:ext cx="13648793" cy="7863840"/>
+            <a:off x="17750787" y="11801449"/>
+            <a:ext cx="13391988" cy="7715880"/>
           </a:xfrm>
           <a:prstGeom prst="rect">
             <a:avLst/>
@@ -6101,8 +6039,8 @@
         </p:blipFill>
         <p:spPr>
           <a:xfrm>
-            <a:off x="22512863" y="2212116"/>
-            <a:ext cx="3968969" cy="2975113"/>
+            <a:off x="22235160" y="1942023"/>
+            <a:ext cx="4161135" cy="3119160"/>
           </a:xfrm>
           <a:prstGeom prst="rect">
             <a:avLst/>
@@ -6131,8 +6069,8 @@
         </p:blipFill>
         <p:spPr>
           <a:xfrm rot="20443004">
-            <a:off x="23071504" y="2606120"/>
-            <a:ext cx="1527081" cy="735074"/>
+            <a:off x="23095726" y="2449570"/>
+            <a:ext cx="1500172" cy="722121"/>
           </a:xfrm>
           <a:prstGeom prst="rect">
             <a:avLst/>
@@ -6161,8 +6099,8 @@
         </p:blipFill>
         <p:spPr>
           <a:xfrm rot="2098715">
-            <a:off x="23425759" y="-141307"/>
-            <a:ext cx="6097999" cy="3431350"/>
+            <a:off x="24428886" y="-131287"/>
+            <a:ext cx="5324354" cy="2996019"/>
           </a:xfrm>
           <a:prstGeom prst="rect">
             <a:avLst/>
@@ -6183,8 +6121,8 @@
         </p:nvSpPr>
         <p:spPr>
           <a:xfrm>
-            <a:off x="17145000" y="20277024"/>
-            <a:ext cx="14630400" cy="1615827"/>
+            <a:off x="17329605" y="20036022"/>
+            <a:ext cx="14814430" cy="1585425"/>
           </a:xfrm>
           <a:prstGeom prst="rect">
             <a:avLst/>
@@ -6233,8 +6171,8 @@
         </p:nvSpPr>
         <p:spPr>
           <a:xfrm>
-            <a:off x="17007840" y="6485090"/>
-            <a:ext cx="14767560" cy="5170646"/>
+            <a:off x="17190720" y="6503586"/>
+            <a:ext cx="14953315" cy="5073359"/>
           </a:xfrm>
           <a:prstGeom prst="rect">
             <a:avLst/>
@@ -6445,8 +6383,8 @@
         </p:nvSpPr>
         <p:spPr>
           <a:xfrm>
-            <a:off x="16550640" y="5187229"/>
-            <a:ext cx="15453360" cy="977821"/>
+            <a:off x="16733520" y="5212080"/>
+            <a:ext cx="15636240" cy="960120"/>
           </a:xfrm>
           <a:prstGeom prst="rect">
             <a:avLst/>
@@ -6507,8 +6445,8 @@
         </p:nvSpPr>
         <p:spPr>
           <a:xfrm>
-            <a:off x="16550640" y="5187229"/>
-            <a:ext cx="15453360" cy="30083074"/>
+            <a:off x="16733520" y="5212080"/>
+            <a:ext cx="15636240" cy="29535120"/>
           </a:xfrm>
           <a:prstGeom prst="rect">
             <a:avLst/>
@@ -6553,8 +6491,8 @@
         </p:nvSpPr>
         <p:spPr>
           <a:xfrm>
-            <a:off x="17190720" y="32050351"/>
-            <a:ext cx="14447520" cy="548640"/>
+            <a:off x="17375900" y="31587832"/>
+            <a:ext cx="14629250" cy="538317"/>
           </a:xfrm>
           <a:prstGeom prst="rect">
             <a:avLst/>
@@ -6593,8 +6531,8 @@
         </p:nvSpPr>
         <p:spPr>
           <a:xfrm>
-            <a:off x="17007840" y="32622425"/>
-            <a:ext cx="14767560" cy="2286000"/>
+            <a:off x="17190720" y="32149142"/>
+            <a:ext cx="14953315" cy="2242988"/>
           </a:xfrm>
           <a:prstGeom prst="rect">
             <a:avLst/>
@@ -6681,8 +6619,8 @@
         </p:nvSpPr>
         <p:spPr>
           <a:xfrm>
-            <a:off x="1371600" y="23911077"/>
-            <a:ext cx="14356080" cy="640080"/>
+            <a:off x="914400" y="24065383"/>
+            <a:ext cx="14904720" cy="632577"/>
           </a:xfrm>
           <a:prstGeom prst="rect">
             <a:avLst/>
@@ -6742,8 +6680,8 @@
         </p:nvSpPr>
         <p:spPr>
           <a:xfrm>
-            <a:off x="1471598" y="12232658"/>
-            <a:ext cx="13990320" cy="1143000"/>
+            <a:off x="1109709" y="12523866"/>
+            <a:ext cx="14531881" cy="1129601"/>
           </a:xfrm>
           <a:prstGeom prst="rect">
             <a:avLst/>
@@ -6802,8 +6740,8 @@
         </p:nvSpPr>
         <p:spPr>
           <a:xfrm>
-            <a:off x="8309610" y="13254670"/>
-            <a:ext cx="347472" cy="329184"/>
+            <a:off x="8212418" y="13533897"/>
+            <a:ext cx="360923" cy="325325"/>
           </a:xfrm>
           <a:prstGeom prst="downArrow">
             <a:avLst/>
@@ -6839,8 +6777,8 @@
         </p:nvSpPr>
         <p:spPr>
           <a:xfrm>
-            <a:off x="1463040" y="13701111"/>
-            <a:ext cx="13990320" cy="914400"/>
+            <a:off x="1100820" y="13975105"/>
+            <a:ext cx="14531881" cy="903681"/>
           </a:xfrm>
           <a:prstGeom prst="rect">
             <a:avLst/>
@@ -6903,8 +6841,8 @@
         </p:nvSpPr>
         <p:spPr>
           <a:xfrm>
-            <a:off x="5626303" y="14839848"/>
-            <a:ext cx="347472" cy="329184"/>
+            <a:off x="5425241" y="15100493"/>
+            <a:ext cx="360923" cy="325325"/>
           </a:xfrm>
           <a:prstGeom prst="downArrow">
             <a:avLst/>
@@ -6940,8 +6878,8 @@
         </p:nvSpPr>
         <p:spPr>
           <a:xfrm>
-            <a:off x="12827203" y="14821354"/>
-            <a:ext cx="347472" cy="329184"/>
+            <a:off x="12904886" y="15082216"/>
+            <a:ext cx="360923" cy="325325"/>
           </a:xfrm>
           <a:prstGeom prst="downArrow">
             <a:avLst/>
@@ -6977,8 +6915,8 @@
         </p:nvSpPr>
         <p:spPr>
           <a:xfrm>
-            <a:off x="1463040" y="15315130"/>
-            <a:ext cx="8673998" cy="4709160"/>
+            <a:off x="1100820" y="15570203"/>
+            <a:ext cx="9009766" cy="4653956"/>
           </a:xfrm>
           <a:prstGeom prst="rect">
             <a:avLst/>
@@ -7014,8 +6952,8 @@
         </p:nvSpPr>
         <p:spPr>
           <a:xfrm>
-            <a:off x="1517904" y="15397426"/>
-            <a:ext cx="8564270" cy="822960"/>
+            <a:off x="1157807" y="15651535"/>
+            <a:ext cx="8895790" cy="813313"/>
           </a:xfrm>
           <a:prstGeom prst="rect">
             <a:avLst/>
@@ -7074,8 +7012,8 @@
         </p:nvSpPr>
         <p:spPr>
           <a:xfrm>
-            <a:off x="1645920" y="16162669"/>
-            <a:ext cx="8308238" cy="1261872"/>
+            <a:off x="1290779" y="16407807"/>
+            <a:ext cx="8629847" cy="1247080"/>
           </a:xfrm>
           <a:prstGeom prst="rect">
             <a:avLst/>
@@ -7179,8 +7117,8 @@
         </p:nvSpPr>
         <p:spPr>
           <a:xfrm>
-            <a:off x="1645920" y="17630522"/>
-            <a:ext cx="8308238" cy="2202048"/>
+            <a:off x="1290779" y="17858453"/>
+            <a:ext cx="8629847" cy="2176234"/>
           </a:xfrm>
           <a:prstGeom prst="rect">
             <a:avLst/>
@@ -7374,8 +7312,8 @@
         </p:nvSpPr>
         <p:spPr>
           <a:xfrm>
-            <a:off x="10548518" y="15324274"/>
-            <a:ext cx="4904842" cy="4709160"/>
+            <a:off x="10537994" y="15579240"/>
+            <a:ext cx="5094707" cy="4653956"/>
           </a:xfrm>
           <a:prstGeom prst="rect">
             <a:avLst/>
@@ -7582,8 +7520,8 @@
         </p:nvSpPr>
         <p:spPr>
           <a:xfrm>
-            <a:off x="1463040" y="24929121"/>
-            <a:ext cx="14173200" cy="1051560"/>
+            <a:off x="1100820" y="25071493"/>
+            <a:ext cx="14721840" cy="1039233"/>
           </a:xfrm>
           <a:prstGeom prst="rect">
             <a:avLst/>
@@ -7676,8 +7614,8 @@
         </p:nvSpPr>
         <p:spPr>
           <a:xfrm>
-            <a:off x="4695444" y="26026401"/>
-            <a:ext cx="347472" cy="329184"/>
+            <a:off x="4458349" y="26155910"/>
+            <a:ext cx="360923" cy="325325"/>
           </a:xfrm>
           <a:prstGeom prst="downArrow">
             <a:avLst/>
@@ -7713,8 +7651,8 @@
         </p:nvSpPr>
         <p:spPr>
           <a:xfrm>
-            <a:off x="12056364" y="26026401"/>
-            <a:ext cx="347472" cy="329184"/>
+            <a:off x="12104208" y="26155910"/>
+            <a:ext cx="360923" cy="325325"/>
           </a:xfrm>
           <a:prstGeom prst="downArrow">
             <a:avLst/>
@@ -7750,8 +7688,8 @@
         </p:nvSpPr>
         <p:spPr>
           <a:xfrm>
-            <a:off x="1463040" y="26501889"/>
-            <a:ext cx="6812280" cy="914400"/>
+            <a:off x="1100820" y="26625824"/>
+            <a:ext cx="7075981" cy="903681"/>
           </a:xfrm>
           <a:prstGeom prst="rect">
             <a:avLst/>
@@ -7814,8 +7752,8 @@
         </p:nvSpPr>
         <p:spPr>
           <a:xfrm>
-            <a:off x="8823960" y="26501889"/>
-            <a:ext cx="6812280" cy="914400"/>
+            <a:off x="8746678" y="26625824"/>
+            <a:ext cx="7075981" cy="903681"/>
           </a:xfrm>
           <a:prstGeom prst="rect">
             <a:avLst/>
@@ -7897,8 +7835,8 @@
         </p:nvSpPr>
         <p:spPr>
           <a:xfrm>
-            <a:off x="4695444" y="27553449"/>
-            <a:ext cx="347472" cy="329184"/>
+            <a:off x="4458349" y="27665057"/>
+            <a:ext cx="360923" cy="325325"/>
           </a:xfrm>
           <a:prstGeom prst="downArrow">
             <a:avLst/>
@@ -7934,8 +7872,8 @@
         </p:nvSpPr>
         <p:spPr>
           <a:xfrm>
-            <a:off x="12056364" y="27553449"/>
-            <a:ext cx="347472" cy="329184"/>
+            <a:off x="12104208" y="27665057"/>
+            <a:ext cx="360923" cy="325325"/>
           </a:xfrm>
           <a:prstGeom prst="downArrow">
             <a:avLst/>
@@ -7971,8 +7909,8 @@
         </p:nvSpPr>
         <p:spPr>
           <a:xfrm>
-            <a:off x="1463040" y="28056369"/>
-            <a:ext cx="14173200" cy="2057400"/>
+            <a:off x="1100820" y="28162082"/>
+            <a:ext cx="14721840" cy="2033282"/>
           </a:xfrm>
           <a:prstGeom prst="rect">
             <a:avLst/>
@@ -8063,8 +8001,8 @@
         </p:nvSpPr>
         <p:spPr>
           <a:xfrm>
-            <a:off x="1463040" y="29153649"/>
-            <a:ext cx="14173200" cy="914400"/>
+            <a:off x="1100820" y="29246499"/>
+            <a:ext cx="14721840" cy="903681"/>
           </a:xfrm>
           <a:prstGeom prst="rect">
             <a:avLst/>
@@ -8151,8 +8089,8 @@
         </p:nvSpPr>
         <p:spPr>
           <a:xfrm>
-            <a:off x="4695444" y="30214353"/>
-            <a:ext cx="347472" cy="329184"/>
+            <a:off x="4458349" y="30294768"/>
+            <a:ext cx="360923" cy="325325"/>
           </a:xfrm>
           <a:prstGeom prst="downArrow">
             <a:avLst/>
@@ -8188,8 +8126,8 @@
         </p:nvSpPr>
         <p:spPr>
           <a:xfrm>
-            <a:off x="12056364" y="30214353"/>
-            <a:ext cx="347472" cy="329184"/>
+            <a:off x="12104208" y="30294768"/>
+            <a:ext cx="360923" cy="325325"/>
           </a:xfrm>
           <a:prstGeom prst="downArrow">
             <a:avLst/>
@@ -8225,8 +8163,8 @@
         </p:nvSpPr>
         <p:spPr>
           <a:xfrm>
-            <a:off x="1463040" y="30689841"/>
-            <a:ext cx="6812280" cy="1143000"/>
+            <a:off x="1100820" y="30764682"/>
+            <a:ext cx="7075981" cy="1129601"/>
           </a:xfrm>
           <a:prstGeom prst="rect">
             <a:avLst/>
@@ -8323,8 +8261,8 @@
         </p:nvSpPr>
         <p:spPr>
           <a:xfrm>
-            <a:off x="8823960" y="30689841"/>
-            <a:ext cx="6812280" cy="1143000"/>
+            <a:off x="8746678" y="30764682"/>
+            <a:ext cx="7075981" cy="1129601"/>
           </a:xfrm>
           <a:prstGeom prst="rect">
             <a:avLst/>
@@ -8406,8 +8344,8 @@
         </p:nvSpPr>
         <p:spPr>
           <a:xfrm>
-            <a:off x="1463040" y="32989660"/>
-            <a:ext cx="14173200" cy="1600200"/>
+            <a:off x="914400" y="33037541"/>
+            <a:ext cx="14904720" cy="1581441"/>
           </a:xfrm>
           <a:prstGeom prst="rect">
             <a:avLst/>
@@ -8464,8 +8402,8 @@
         </p:nvSpPr>
         <p:spPr>
           <a:xfrm>
-            <a:off x="1371600" y="34991113"/>
-            <a:ext cx="14173200" cy="1600200"/>
+            <a:off x="914400" y="35015532"/>
+            <a:ext cx="14904720" cy="1581441"/>
           </a:xfrm>
           <a:prstGeom prst="rect">
             <a:avLst/>
@@ -8522,8 +8460,8 @@
         </p:nvSpPr>
         <p:spPr>
           <a:xfrm>
-            <a:off x="1371600" y="11510521"/>
-            <a:ext cx="14356080" cy="640080"/>
+            <a:off x="914400" y="11810194"/>
+            <a:ext cx="14904720" cy="632577"/>
           </a:xfrm>
           <a:prstGeom prst="rect">
             <a:avLst/>

</xml_diff>

<commit_message>
Synchronize documentation and posters with expanded catalogue
</commit_message>
<xml_diff>
--- a/posters/36x48.pptx
+++ b/posters/36x48.pptx
@@ -997,6 +997,11 @@
               <a:t>[5] Juodzbalis et al. (2025): https://arxiv.org/abs/2508.21748v2 — adopted independent A2744-QSO1 dynamical mass. The poster's average Eddington ratios are project calculations, not measurements quoted from this paper.</a:t>
             </a:r>
           </a:p>
+          <a:p>
+            <a:r>
+              <a:t>Catalogue edition: 17 October 2026; scientific revision a1bef516db5c76a92b6848eb12bccabdeb5804b9. New source references: Taylor/CAPERS https://arxiv.org/abs/2505.04609v4; Tripodi/CANUCS https://doi.org/10.1038/s41467-025-65070-x; Schindler/J1007 https://doi.org/10.1038/s41550-025-02660-1; Takechi/Y1 https://arxiv.org/abs/2605.14922v1; Fudamoto/SAPPHIRES https://arxiv.org/abs/2503.15597v1. SAPPHIRES has no numerical BH mass; Y1 is expanded-only. CAPERS and J1007 dust alternatives are correlated. Three unresolved identity groups remain excluded. Tables: results/for_manuscript/tables/ and results/v4/tables/. All probabilities are conditional on fixed growth assumptions and reported-error approximations.</a:t>
+            </a:r>
+          </a:p>
         </p:txBody>
       </p:sp>
       <p:sp>
@@ -5928,7 +5933,7 @@
             </a:pPr>
             <a:r>
               <a:rPr lang="en-CA" sz="3300" dirty="0"/>
-              <a:t>Catalogue sources and code: QR link above.</a:t>
+              <a:t>Catalogue sources and code (17 Oct 2026): QR link above.</a:t>
             </a:r>
             <a:endParaRPr lang="en-US" sz="3300" dirty="0"/>
           </a:p>
@@ -6207,7 +6212,7 @@
                 </a:solidFill>
                 <a:latin typeface="Aptos"/>
               </a:rPr>
-              <a:t>8/220 primary objects require average Eddington ratios above 1, including 5 in ≥ 95% of mass-error draws.</a:t>
+              <a:t>11/223 primary objects require average Eddington ratios above 1, including 8 in ≥ 95% of mass-error draws.</a:t>
             </a:r>
           </a:p>
           <a:p>
@@ -6248,7 +6253,7 @@
                 </a:solidFill>
                 <a:latin typeface="Aptos"/>
               </a:rPr>
-              <a:t> (a factor of 3.2) leaves 3 primary objects requiring averages above 1 in ≥ 95% of draws.</a:t>
+              <a:t> (a factor of 3.2) leaves 5 primary objects requiring averages above 1 in ≥ 95% of draws.</a:t>
             </a:r>
           </a:p>
           <a:p>
@@ -6280,7 +6285,7 @@
                 </a:solidFill>
                 <a:latin typeface="Aptos"/>
               </a:rPr>
-              <a:t>M⊙ seeds leave 3/220 above 1. With 100,000 M⊙ seeds, neither sample has objects above 1.</a:t>
+              <a:t>M⊙ seeds leave 5/223 above 1. With 100,000 M⊙ seeds, neither sample has objects above 1.</a:t>
             </a:r>
           </a:p>
           <a:p>
@@ -6303,7 +6308,7 @@
                 </a:solidFill>
                 <a:latin typeface="Aptos"/>
               </a:rPr>
-              <a:t>At z = 20, 18/220 primary objects require averages above 1, and GN-z11 requires the highest average in the expanded sample.</a:t>
+              <a:t>At z = 20, 21/223 primary objects require averages above 1, and GN-z11 requires the highest average in the expanded sample.</a:t>
             </a:r>
           </a:p>
           <a:p>
@@ -6362,7 +6367,7 @@
                 </a:solidFill>
                 <a:latin typeface="Aptos"/>
               </a:rPr>
-              <a:t>, all 234 central mass estimates require averages below 1 under the other reference assumptions.</a:t>
+              <a:t>, all 238 central mass estimates require averages below 1 under the other reference assumptions.</a:t>
             </a:r>
           </a:p>
         </p:txBody>
@@ -6719,7 +6724,7 @@
                 </a:solidFill>
                 <a:latin typeface="Aptos"/>
               </a:rPr>
-              <a:t>350 measurements from 32 source families at z ≥ 4</a:t>
+              <a:t>355 measurements from 37 source families at z ≥ 4</a:t>
             </a:r>
           </a:p>
         </p:txBody>
@@ -6820,7 +6825,7 @@
                 </a:solidFill>
                 <a:latin typeface="Aptos"/>
               </a:rPr>
-              <a:t>338 provisional objects</a:t>
+              <a:t>343 provisional objects</a:t>
             </a:r>
           </a:p>
         </p:txBody>
@@ -6991,7 +6996,7 @@
                 </a:solidFill>
                 <a:latin typeface="Aptos"/>
               </a:rPr>
-              <a:t>234 expanded-sample objects</a:t>
+              <a:t>238 expanded-sample objects</a:t>
             </a:r>
           </a:p>
         </p:txBody>
@@ -7053,7 +7058,7 @@
                 </a:solidFill>
                 <a:latin typeface="Aptos"/>
               </a:rPr>
-              <a:t>220 primary</a:t>
+              <a:t>223 primary</a:t>
             </a:r>
           </a:p>
           <a:p>
@@ -7158,7 +7163,7 @@
                 </a:solidFill>
                 <a:latin typeface="Aptos"/>
               </a:rPr>
-              <a:t>14 additional</a:t>
+              <a:t>15 additional</a:t>
             </a:r>
             <a:r>
               <a:rPr lang="en-CA" sz="2700" b="0" dirty="0">
@@ -7255,7 +7260,7 @@
                 </a:solidFill>
                 <a:latin typeface="Aptos"/>
               </a:rPr>
-              <a:t>6 tentative broad-line detections</a:t>
+              <a:t>7 tentative broad-line detections</a:t>
             </a:r>
             <a:endParaRPr lang="en-CA" sz="2700" b="0" dirty="0">
               <a:solidFill>
@@ -7418,7 +7423,7 @@
                 </a:solidFill>
                 <a:latin typeface="Aptos"/>
               </a:rPr>
-              <a:t>98 without an</a:t>
+              <a:t>99 without an</a:t>
             </a:r>
           </a:p>
           <a:p>
@@ -8381,7 +8386,7 @@
                 </a:solidFill>
                 <a:latin typeface="Aptos"/>
               </a:rPr>
-              <a:t>Mass errors cover 208 primary / 222 expanded objects. The other 12 enter central-mass tests only. Reported mass errors do not consistently include calibration uncertainty.</a:t>
+              <a:t>Mass errors cover 211 primary / 226 expanded objects. The other 12 enter central-mass tests only. Reported mass errors do not consistently include calibration uncertainty.</a:t>
             </a:r>
           </a:p>
         </p:txBody>

</xml_diff>